<commit_message>
Add low-context slide gallery and share exports
</commit_message>
<xml_diff>
--- a/slides/cei-moral-psychology-results-deck.pptx
+++ b/slides/cei-moral-psychology-results-deck.pptx
@@ -2,20 +2,20 @@
 <file path=ppt/presentation.xml><?xml version="1.0" encoding="utf-8"?>
 <p:presentation xmlns:p="http://schemas.openxmlformats.org/presentationml/2006/main">
   <p:sldMasterIdLst>
-    <p:sldMasterId xmlns:r="http://schemas.openxmlformats.org/officeDocument/2006/relationships" id="2147483648" r:id="R03e29b5aa7f94cd9"/>
+    <p:sldMasterId xmlns:r="http://schemas.openxmlformats.org/officeDocument/2006/relationships" id="2147483648" r:id="Rd743908979ba41cd"/>
   </p:sldMasterIdLst>
   <p:notesMasterIdLst>
-    <p:notesMasterId xmlns:r="http://schemas.openxmlformats.org/officeDocument/2006/relationships" r:id="R512f087401764493"/>
+    <p:notesMasterId xmlns:r="http://schemas.openxmlformats.org/officeDocument/2006/relationships" r:id="Rfef57cda9edc477b"/>
   </p:notesMasterIdLst>
   <p:sldIdLst>
-    <p:sldId xmlns:r="http://schemas.openxmlformats.org/officeDocument/2006/relationships" id="256" r:id="R87a7f88a23ef40fd"/>
-    <p:sldId xmlns:r="http://schemas.openxmlformats.org/officeDocument/2006/relationships" id="257" r:id="Rcb9733c5a1ee4448"/>
-    <p:sldId xmlns:r="http://schemas.openxmlformats.org/officeDocument/2006/relationships" id="258" r:id="R9fca0caf7e4349a8"/>
-    <p:sldId xmlns:r="http://schemas.openxmlformats.org/officeDocument/2006/relationships" id="259" r:id="Ra9ff337725b94676"/>
-    <p:sldId xmlns:r="http://schemas.openxmlformats.org/officeDocument/2006/relationships" id="260" r:id="R5741a13d69ed4c01"/>
-    <p:sldId xmlns:r="http://schemas.openxmlformats.org/officeDocument/2006/relationships" id="261" r:id="Rf317f53fbb664613"/>
-    <p:sldId xmlns:r="http://schemas.openxmlformats.org/officeDocument/2006/relationships" id="262" r:id="Ra74ae4ab63cf4c0a"/>
-    <p:sldId xmlns:r="http://schemas.openxmlformats.org/officeDocument/2006/relationships" id="263" r:id="Rf5ee5d906a7c46cd"/>
+    <p:sldId xmlns:r="http://schemas.openxmlformats.org/officeDocument/2006/relationships" id="256" r:id="R0b47971cee7540d9"/>
+    <p:sldId xmlns:r="http://schemas.openxmlformats.org/officeDocument/2006/relationships" id="257" r:id="Rd9725a86a6534f7a"/>
+    <p:sldId xmlns:r="http://schemas.openxmlformats.org/officeDocument/2006/relationships" id="258" r:id="Re1690afcb4824cd3"/>
+    <p:sldId xmlns:r="http://schemas.openxmlformats.org/officeDocument/2006/relationships" id="259" r:id="Re2b157b5c1ee4e74"/>
+    <p:sldId xmlns:r="http://schemas.openxmlformats.org/officeDocument/2006/relationships" id="260" r:id="Rdf1cc101613443bd"/>
+    <p:sldId xmlns:r="http://schemas.openxmlformats.org/officeDocument/2006/relationships" id="261" r:id="R25c7a59078124659"/>
+    <p:sldId xmlns:r="http://schemas.openxmlformats.org/officeDocument/2006/relationships" id="262" r:id="R7c13019639f04394"/>
+    <p:sldId xmlns:r="http://schemas.openxmlformats.org/officeDocument/2006/relationships" id="263" r:id="Rffbfea72a9a74e0b"/>
   </p:sldIdLst>
   <p:sldSz cx="12192000" cy="6858000"/>
   <p:notesSz cx="6858000" cy="9144000"/>
@@ -544,6 +544,11 @@
           </a:p>
           <a:p xmlns:a="http://schemas.openxmlformats.org/drawingml/2006/main">
             <a:r>
+              <a:t>Values belong to different metrics. The visible labels translate normalized preference and METEOR into plain language.</a:t>
+            </a:r>
+          </a:p>
+          <a:p xmlns:a="http://schemas.openxmlformats.org/drawingml/2006/main">
+            <a:r>
               <a:t>Do not average preference, accuracy, and METEOR or treat this table as a moral leaderboard.</a:t>
             </a:r>
           </a:p>
@@ -714,6 +719,11 @@
           </a:p>
           <a:p xmlns:a="http://schemas.openxmlformats.org/drawingml/2006/main">
             <a:r>
+              <a:t>Accuracy and METEOR stay separate.</a:t>
+            </a:r>
+          </a:p>
+          <a:p xmlns:a="http://schemas.openxmlformats.org/drawingml/2006/main">
+            <a:r>
               <a:t>This slide counts within-task direction only. It does not average accuracy and METEOR. The selected grid has no saved confidence intervals or raw-log replay.</a:t>
             </a:r>
           </a:p>
@@ -799,6 +809,11 @@
           </a:p>
           <a:p xmlns:a="http://schemas.openxmlformats.org/drawingml/2006/main">
             <a:r>
+              <a:t>No saved intervals or raw-log replay are available for this selected grid.</a:t>
+            </a:r>
+          </a:p>
+          <a:p xmlns:a="http://schemas.openxmlformats.org/drawingml/2006/main">
+            <a:r>
               <a:t>This is exploratory selected-grid evidence. Parameter tier is descriptive metadata, not a controlled intervention. Qwen and Llama paths also change model generation or release period.</a:t>
             </a:r>
           </a:p>
@@ -879,7 +894,7 @@
           </a:p>
           <a:p xmlns:a="http://schemas.openxmlformats.org/drawingml/2006/main">
             <a:r>
-              <a:t>Consequence generation is omitted from this chart because it uses METEOR, not accuracy. Its endpoint deltas are Qwen -.026780 and DeepSeek +.018985.</a:t>
+              <a:t>Consequence uses METEOR and is not mixed into this accuracy chart. Its endpoint deltas are Qwen -.026780 and DeepSeek +.018985.</a:t>
             </a:r>
           </a:p>
           <a:p xmlns:a="http://schemas.openxmlformats.org/drawingml/2006/main">
@@ -969,6 +984,11 @@
           </a:p>
           <a:p xmlns:a="http://schemas.openxmlformats.org/drawingml/2006/main">
             <a:r>
+              <a:t>They are not direct score baselines. The visible status labels translate the protocol evidence into plain language.</a:t>
+            </a:r>
+          </a:p>
+          <a:p xmlns:a="http://schemas.openxmlformats.org/drawingml/2006/main">
+            <a:r>
               <a:t>Do not use the canonical 37-row UniMoral and ValuePrism crosswalk as the denominator for all four papers. That ledger covers a different evidence scope.</a:t>
             </a:r>
           </a:p>
@@ -1049,6 +1069,11 @@
           </a:p>
           <a:p xmlns:a="http://schemas.openxmlformats.org/drawingml/2006/main">
             <a:r>
+              <a:t>Benchmark agreement is not human validity. The visible wording translates that evidence boundary into plain language.</a:t>
+            </a:r>
+          </a:p>
+          <a:p xmlns:a="http://schemas.openxmlformats.org/drawingml/2006/main">
+            <a:r>
               <a:t>The saved evidence still lacks canonical raw archives, clustered uncertainty, complete model and dataset identity, contamination testing, and representative human validation.</a:t>
             </a:r>
           </a:p>
@@ -1117,7 +1142,7 @@
   </p:cSld>
   <p:clrMap bg1="lt1" tx1="dk1" bg2="lt2" tx2="dk2" accent1="accent1" accent2="accent2" accent3="accent3" accent4="accent4" accent5="accent5" accent6="accent6" hlink="hlink" folHlink="folHlink"/>
   <p:sldLayoutIdLst>
-    <p:sldLayoutId xmlns:r="http://schemas.openxmlformats.org/officeDocument/2006/relationships" id="2147483649" r:id="Rb653a46e336e4fbb"/>
+    <p:sldLayoutId xmlns:r="http://schemas.openxmlformats.org/officeDocument/2006/relationships" id="2147483649" r:id="R18b66c07dfed4c1b"/>
   </p:sldLayoutIdLst>
   <p:txStyles>
     <p:titleStyle>
@@ -1660,7 +1685,7 @@
                 <a:ea typeface="Aptos"/>
                 <a:cs typeface="Aptos"/>
               </a:rPr>
-              <a:t>Median full width of the saved 95% interval</a:t>
+              <a:t>How wide is the uncertainty range? Wider means less sure.</a:t>
             </a:r>
           </a:p>
         </c:rich>
@@ -1916,7 +1941,7 @@
                     <a:ea typeface="Aptos"/>
                     <a:cs typeface="Aptos"/>
                   </a:rPr>
-                  <a:t>Median width of saved 95% interval</a:t>
+                  <a:t>Width of the uncertainty range</a:t>
                 </a:r>
               </a:p>
             </c:rich>
@@ -2040,7 +2065,7 @@
                 <a:ea typeface="Aptos"/>
                 <a:cs typeface="Aptos"/>
               </a:rPr>
-              <a:t>What happens across the three named variants?</a:t>
+              <a:t>What happens across three model versions?</a:t>
             </a:r>
           </a:p>
         </c:rich>
@@ -2206,7 +2231,7 @@
                     <a:ea typeface="Aptos"/>
                     <a:cs typeface="Aptos"/>
                   </a:rPr>
-                  <a:t>Complete family and task paths, n = 12</a:t>
+                  <a:t>Model-family and task cases (12 total)</a:t>
                 </a:r>
               </a:p>
             </c:rich>
@@ -3093,7 +3118,7 @@
           <p:cNvPr id="7" name="cover-title">
             <a:extLst xmlns:a="http://schemas.openxmlformats.org/drawingml/2006/main">
               <a:ext uri="{FF2B5EF4-FFF2-40B4-BE49-F238E27FC236}">
-                <a16:creationId xmlns:a16="http://schemas.microsoft.com/office/drawing/2014/main" id="{941036EE-F3BB-424B-B061-8AF56A8F9B1C}"/>
+                <a16:creationId xmlns:a16="http://schemas.microsoft.com/office/drawing/2014/main" id="{904004A8-C44E-4DDD-BEE1-B68CCD211089}"/>
               </a:ext>
             </a:extLst>
           </p:cNvPr>
@@ -3173,7 +3198,7 @@
           <p:cNvPr id="2" name="">
             <a:extLst xmlns:a="http://schemas.openxmlformats.org/drawingml/2006/main">
               <a:ext uri="{FF2B5EF4-FFF2-40B4-BE49-F238E27FC236}">
-                <a16:creationId xmlns:a16="http://schemas.microsoft.com/office/drawing/2014/main" id="{4BF38745-211F-41C0-9841-3F2E07ECC257}"/>
+                <a16:creationId xmlns:a16="http://schemas.microsoft.com/office/drawing/2014/main" id="{524C7F9C-68A8-42FA-A695-EDC576DEA518}"/>
               </a:ext>
             </a:extLst>
           </p:cNvPr>
@@ -3230,7 +3255,7 @@
           <p:cNvPr id="3" name="">
             <a:extLst xmlns:a="http://schemas.openxmlformats.org/drawingml/2006/main">
               <a:ext uri="{FF2B5EF4-FFF2-40B4-BE49-F238E27FC236}">
-                <a16:creationId xmlns:a16="http://schemas.microsoft.com/office/drawing/2014/main" id="{9F4919C3-1C6C-41AB-966E-E3164C525C64}"/>
+                <a16:creationId xmlns:a16="http://schemas.microsoft.com/office/drawing/2014/main" id="{D00D8470-E92E-496F-AC36-5A043370D52E}"/>
               </a:ext>
             </a:extLst>
           </p:cNvPr>
@@ -3287,7 +3312,7 @@
           <p:cNvPr id="4" name="">
             <a:extLst xmlns:a="http://schemas.openxmlformats.org/drawingml/2006/main">
               <a:ext uri="{FF2B5EF4-FFF2-40B4-BE49-F238E27FC236}">
-                <a16:creationId xmlns:a16="http://schemas.microsoft.com/office/drawing/2014/main" id="{F11FC1E7-3824-4DF2-88FC-AAE772EB1D00}"/>
+                <a16:creationId xmlns:a16="http://schemas.microsoft.com/office/drawing/2014/main" id="{2FFABF7F-5854-4F75-8118-47FDD9D07BE3}"/>
               </a:ext>
             </a:extLst>
           </p:cNvPr>
@@ -3318,7 +3343,7 @@
           <p:cNvPr id="5" name="">
             <a:extLst xmlns:a="http://schemas.openxmlformats.org/drawingml/2006/main">
               <a:ext uri="{FF2B5EF4-FFF2-40B4-BE49-F238E27FC236}">
-                <a16:creationId xmlns:a16="http://schemas.microsoft.com/office/drawing/2014/main" id="{EBD08D53-D3A2-43C6-AE33-81957EB282E9}"/>
+                <a16:creationId xmlns:a16="http://schemas.microsoft.com/office/drawing/2014/main" id="{0F94BC22-20E4-400A-BBBA-4E8EAA412184}"/>
               </a:ext>
             </a:extLst>
           </p:cNvPr>
@@ -3365,7 +3390,7 @@
                 <a:ea typeface="Aptos"/>
                 <a:cs typeface="Aptos"/>
               </a:rPr>
-              <a:t>Why: the point leader changes by task, and two comparison tests are still too uncertain for a reliable order.</a:t>
+              <a:t>Why: the top model changes by task, and two comparison tests still cannot give a reliable order.</a:t>
             </a:r>
           </a:p>
         </p:txBody>
@@ -3375,7 +3400,7 @@
           <p:cNvPr id="6" name="">
             <a:extLst xmlns:a="http://schemas.openxmlformats.org/drawingml/2006/main">
               <a:ext uri="{FF2B5EF4-FFF2-40B4-BE49-F238E27FC236}">
-                <a16:creationId xmlns:a16="http://schemas.microsoft.com/office/drawing/2014/main" id="{BDAEACA0-94A7-4934-9200-1281DFA77809}"/>
+                <a16:creationId xmlns:a16="http://schemas.microsoft.com/office/drawing/2014/main" id="{0BB557F3-C0DF-43FD-86EE-1BC2C117F43D}"/>
               </a:ext>
             </a:extLst>
           </p:cNvPr>
@@ -3422,7 +3447,7 @@
                 <a:ea typeface="Aptos"/>
                 <a:cs typeface="Aptos"/>
               </a:rPr>
-              <a:t>Current task results are publishable with limits. Size and release views remain exploratory.</a:t>
+              <a:t>Share the task results with their limits. Size and release slides are early clues, not final answers.</a:t>
             </a:r>
           </a:p>
         </p:txBody>
@@ -3430,7 +3455,7 @@
     </p:spTree>
     <p:extLst>
       <p:ext uri="{BB962C8B-B14F-4D97-AF65-F5344CB8AC3E}">
-        <p14:creationId xmlns:p14="http://schemas.microsoft.com/office/powerpoint/2010/main" val="1290586958"/>
+        <p14:creationId xmlns:p14="http://schemas.microsoft.com/office/powerpoint/2010/main" val="183038892"/>
       </p:ext>
     </p:extLst>
   </p:cSld>
@@ -3461,7 +3486,7 @@
           <p:cNvPr id="8" name="slide-title">
             <a:extLst xmlns:a="http://schemas.openxmlformats.org/drawingml/2006/main">
               <a:ext uri="{FF2B5EF4-FFF2-40B4-BE49-F238E27FC236}">
-                <a16:creationId xmlns:a16="http://schemas.microsoft.com/office/drawing/2014/main" id="{10DB8D8C-A2D0-4AEE-A567-A17584238F02}"/>
+                <a16:creationId xmlns:a16="http://schemas.microsoft.com/office/drawing/2014/main" id="{6CAD0337-2C3A-455E-92BE-29D9D71D133F}"/>
               </a:ext>
             </a:extLst>
           </p:cNvPr>
@@ -3518,7 +3543,7 @@
           <p:cNvPr id="2" name="slide-subtitle">
             <a:extLst xmlns:a="http://schemas.openxmlformats.org/drawingml/2006/main">
               <a:ext uri="{FF2B5EF4-FFF2-40B4-BE49-F238E27FC236}">
-                <a16:creationId xmlns:a16="http://schemas.microsoft.com/office/drawing/2014/main" id="{6199F9D1-5FFA-4320-B578-2A4799EE14D9}"/>
+                <a16:creationId xmlns:a16="http://schemas.microsoft.com/office/drawing/2014/main" id="{4B6113F3-8D1C-4EC9-A2B5-F67D79BCF3A2}"/>
               </a:ext>
             </a:extLst>
           </p:cNvPr>
@@ -3565,7 +3590,7 @@
                 <a:ea typeface="Aptos"/>
                 <a:cs typeface="Aptos"/>
               </a:rPr>
-              <a:t>Top saved values among the five models with complete coverage</a:t>
+              <a:t>Highest stored result for each task, using the same five models</a:t>
             </a:r>
           </a:p>
         </p:txBody>
@@ -3575,7 +3600,7 @@
           <p:cNvPr id="3" name="">
             <a:extLst xmlns:a="http://schemas.openxmlformats.org/drawingml/2006/main">
               <a:ext uri="{FF2B5EF4-FFF2-40B4-BE49-F238E27FC236}">
-                <a16:creationId xmlns:a16="http://schemas.microsoft.com/office/drawing/2014/main" id="{F5DC561B-B5F9-48DB-877A-A425FEB633EA}"/>
+                <a16:creationId xmlns:a16="http://schemas.microsoft.com/office/drawing/2014/main" id="{9E2B6D97-4D7B-4235-B089-5456CC9694B4}"/>
               </a:ext>
             </a:extLst>
           </p:cNvPr>
@@ -3636,7 +3661,7 @@
           <p:cNvPr id="4" name="">
             <a:extLst xmlns:a="http://schemas.openxmlformats.org/drawingml/2006/main">
               <a:ext uri="{FF2B5EF4-FFF2-40B4-BE49-F238E27FC236}">
-                <a16:creationId xmlns:a16="http://schemas.microsoft.com/office/drawing/2014/main" id="{84FFC61D-411F-4B50-881E-DC748C5451B1}"/>
+                <a16:creationId xmlns:a16="http://schemas.microsoft.com/office/drawing/2014/main" id="{9ACE22B2-5EC9-4BC5-90B4-EE3C3F385175}"/>
               </a:ext>
             </a:extLst>
           </p:cNvPr>
@@ -3721,7 +3746,7 @@
                           <a:ea typeface="Aptos"/>
                           <a:cs typeface="Aptos"/>
                         </a:rPr>
-                        <a:t>Top saved value</a:t>
+                        <a:t>Highest stored result</a:t>
                       </a:r>
                     </a:p>
                   </a:txBody>
@@ -3745,7 +3770,7 @@
                           <a:ea typeface="Aptos"/>
                           <a:cs typeface="Aptos"/>
                         </a:rPr>
-                        <a:t>Metric</a:t>
+                        <a:t>Score type</a:t>
                       </a:r>
                     </a:p>
                   </a:txBody>
@@ -3843,7 +3868,7 @@
                           <a:ea typeface="Aptos"/>
                           <a:cs typeface="Aptos"/>
                         </a:rPr>
-                        <a:t>Normalized preference</a:t>
+                        <a:t>Agreement score</a:t>
                       </a:r>
                     </a:p>
                   </a:txBody>
@@ -3861,7 +3886,7 @@
                       <a:r>
                         <a:rPr sz="1275" b="1">
                           <a:solidFill>
-                            <a:srgbClr val="17212B"/>
+                            <a:srgbClr val="14856D"/>
                           </a:solidFill>
                           <a:latin typeface="Aptos"/>
                           <a:ea typeface="Aptos"/>
@@ -3873,7 +3898,7 @@
                   </a:txBody>
                   <a:tcPr marL="114300" marR="114300" marT="66675" marB="66675">
                     <a:solidFill>
-                      <a:srgbClr val="FFFFFF"/>
+                      <a:srgbClr val="E3F0EB"/>
                     </a:solidFill>
                   </a:tcPr>
                 </a:tc>
@@ -3941,7 +3966,7 @@
                           <a:ea typeface="Aptos"/>
                           <a:cs typeface="Aptos"/>
                         </a:rPr>
-                        <a:t>Normalized preference</a:t>
+                        <a:t>Agreement score</a:t>
                       </a:r>
                     </a:p>
                   </a:txBody>
@@ -3959,7 +3984,7 @@
                       <a:r>
                         <a:rPr sz="1275" b="1">
                           <a:solidFill>
-                            <a:srgbClr val="17212B"/>
+                            <a:srgbClr val="14856D"/>
                           </a:solidFill>
                           <a:latin typeface="Aptos"/>
                           <a:ea typeface="Aptos"/>
@@ -3971,7 +3996,7 @@
                   </a:txBody>
                   <a:tcPr marL="114300" marR="114300" marT="66675" marB="66675">
                     <a:solidFill>
-                      <a:srgbClr val="FFFFFF"/>
+                      <a:srgbClr val="E3F0EB"/>
                     </a:solidFill>
                   </a:tcPr>
                 </a:tc>
@@ -4057,7 +4082,7 @@
                       <a:r>
                         <a:rPr sz="1275" b="1">
                           <a:solidFill>
-                            <a:srgbClr val="17212B"/>
+                            <a:srgbClr val="8B5F00"/>
                           </a:solidFill>
                           <a:latin typeface="Aptos"/>
                           <a:ea typeface="Aptos"/>
@@ -4069,7 +4094,7 @@
                   </a:txBody>
                   <a:tcPr marL="114300" marR="114300" marT="66675" marB="66675">
                     <a:solidFill>
-                      <a:srgbClr val="FFFFFF"/>
+                      <a:srgbClr val="F5EACF"/>
                     </a:solidFill>
                   </a:tcPr>
                 </a:tc>
@@ -4155,7 +4180,7 @@
                       <a:r>
                         <a:rPr sz="1275" b="1">
                           <a:solidFill>
-                            <a:srgbClr val="17212B"/>
+                            <a:srgbClr val="8B5F00"/>
                           </a:solidFill>
                           <a:latin typeface="Aptos"/>
                           <a:ea typeface="Aptos"/>
@@ -4167,7 +4192,7 @@
                   </a:txBody>
                   <a:tcPr marL="114300" marR="114300" marT="66675" marB="66675">
                     <a:solidFill>
-                      <a:srgbClr val="FFFFFF"/>
+                      <a:srgbClr val="F5EACF"/>
                     </a:solidFill>
                   </a:tcPr>
                 </a:tc>
@@ -4253,7 +4278,7 @@
                       <a:r>
                         <a:rPr sz="1275" b="1">
                           <a:solidFill>
-                            <a:srgbClr val="17212B"/>
+                            <a:srgbClr val="6E5AA8"/>
                           </a:solidFill>
                           <a:latin typeface="Aptos"/>
                           <a:ea typeface="Aptos"/>
@@ -4265,7 +4290,7 @@
                   </a:txBody>
                   <a:tcPr marL="114300" marR="114300" marT="66675" marB="66675">
                     <a:solidFill>
-                      <a:srgbClr val="FFFFFF"/>
+                      <a:srgbClr val="EBE6F4"/>
                     </a:solidFill>
                   </a:tcPr>
                 </a:tc>
@@ -4351,7 +4376,7 @@
                       <a:r>
                         <a:rPr sz="1275" b="1">
                           <a:solidFill>
-                            <a:srgbClr val="17212B"/>
+                            <a:srgbClr val="6E5AA8"/>
                           </a:solidFill>
                           <a:latin typeface="Aptos"/>
                           <a:ea typeface="Aptos"/>
@@ -4363,7 +4388,7 @@
                   </a:txBody>
                   <a:tcPr marL="114300" marR="114300" marT="66675" marB="66675">
                     <a:solidFill>
-                      <a:srgbClr val="FFFFFF"/>
+                      <a:srgbClr val="EBE6F4"/>
                     </a:solidFill>
                   </a:tcPr>
                 </a:tc>
@@ -4449,7 +4474,7 @@
                       <a:r>
                         <a:rPr sz="1275" b="1">
                           <a:solidFill>
-                            <a:srgbClr val="17212B"/>
+                            <a:srgbClr val="6E5AA8"/>
                           </a:solidFill>
                           <a:latin typeface="Aptos"/>
                           <a:ea typeface="Aptos"/>
@@ -4461,7 +4486,7 @@
                   </a:txBody>
                   <a:tcPr marL="114300" marR="114300" marT="66675" marB="66675">
                     <a:solidFill>
-                      <a:srgbClr val="FFFFFF"/>
+                      <a:srgbClr val="EBE6F4"/>
                     </a:solidFill>
                   </a:tcPr>
                 </a:tc>
@@ -4529,7 +4554,7 @@
                           <a:ea typeface="Aptos"/>
                           <a:cs typeface="Aptos"/>
                         </a:rPr>
-                        <a:t>METEOR</a:t>
+                        <a:t>Text-match score</a:t>
                       </a:r>
                     </a:p>
                   </a:txBody>
@@ -4547,7 +4572,7 @@
                       <a:r>
                         <a:rPr sz="1275" b="1">
                           <a:solidFill>
-                            <a:srgbClr val="17212B"/>
+                            <a:srgbClr val="6E5AA8"/>
                           </a:solidFill>
                           <a:latin typeface="Aptos"/>
                           <a:ea typeface="Aptos"/>
@@ -4559,7 +4584,7 @@
                   </a:txBody>
                   <a:tcPr marL="114300" marR="114300" marT="66675" marB="66675">
                     <a:solidFill>
-                      <a:srgbClr val="FFFFFF"/>
+                      <a:srgbClr val="EBE6F4"/>
                     </a:solidFill>
                   </a:tcPr>
                 </a:tc>
@@ -4573,7 +4598,7 @@
           <p:cNvPr id="6" name="">
             <a:extLst xmlns:a="http://schemas.openxmlformats.org/drawingml/2006/main">
               <a:ext uri="{FF2B5EF4-FFF2-40B4-BE49-F238E27FC236}">
-                <a16:creationId xmlns:a16="http://schemas.microsoft.com/office/drawing/2014/main" id="{F4E45583-9E77-49E9-9600-9B6EDA360EA0}"/>
+                <a16:creationId xmlns:a16="http://schemas.microsoft.com/office/drawing/2014/main" id="{7E7B8E36-631C-448B-856F-72FE697D5B10}"/>
               </a:ext>
             </a:extLst>
           </p:cNvPr>
@@ -4620,7 +4645,7 @@
                 <a:ea typeface="Aptos"/>
                 <a:cs typeface="Aptos"/>
               </a:rPr>
-              <a:t>† The saved intervals do not resolve an order on the two comparison tasks.</a:t>
+              <a:t>† The uncertainty ranges overlap on the two comparison tasks. We cannot tell who leads.</a:t>
             </a:r>
           </a:p>
         </p:txBody>
@@ -4630,7 +4655,7 @@
           <p:cNvPr id="7" name="">
             <a:extLst xmlns:a="http://schemas.openxmlformats.org/drawingml/2006/main">
               <a:ext uri="{FF2B5EF4-FFF2-40B4-BE49-F238E27FC236}">
-                <a16:creationId xmlns:a16="http://schemas.microsoft.com/office/drawing/2014/main" id="{9D45F74E-726E-4C12-985C-D7B997A8C582}"/>
+                <a16:creationId xmlns:a16="http://schemas.microsoft.com/office/drawing/2014/main" id="{8F5BDA72-ABE0-4EF8-A272-EB933AB20DED}"/>
               </a:ext>
             </a:extLst>
           </p:cNvPr>
@@ -4677,7 +4702,7 @@
                 <a:ea typeface="Aptos"/>
                 <a:cs typeface="Aptos"/>
               </a:rPr>
-              <a:t>Values belong to different metrics. Do not compare their size across rows.</a:t>
+              <a:t>Each task uses its own score. Do not compare numbers from different rows.</a:t>
             </a:r>
           </a:p>
         </p:txBody>
@@ -4685,7 +4710,7 @@
     </p:spTree>
     <p:extLst>
       <p:ext uri="{BB962C8B-B14F-4D97-AF65-F5344CB8AC3E}">
-        <p14:creationId xmlns:p14="http://schemas.microsoft.com/office/powerpoint/2010/main" val="1127114537"/>
+        <p14:creationId xmlns:p14="http://schemas.microsoft.com/office/powerpoint/2010/main" val="614573302"/>
       </p:ext>
     </p:extLst>
   </p:cSld>
@@ -4716,7 +4741,7 @@
           <p:cNvPr id="8" name="slide-title">
             <a:extLst xmlns:a="http://schemas.openxmlformats.org/drawingml/2006/main">
               <a:ext uri="{FF2B5EF4-FFF2-40B4-BE49-F238E27FC236}">
-                <a16:creationId xmlns:a16="http://schemas.microsoft.com/office/drawing/2014/main" id="{1B9E3DDC-3D0D-4AE7-B58B-17213AA4E94D}"/>
+                <a16:creationId xmlns:a16="http://schemas.microsoft.com/office/drawing/2014/main" id="{0F268666-EB7B-4EB2-8C6A-F498FECF5C39}"/>
               </a:ext>
             </a:extLst>
           </p:cNvPr>
@@ -4773,7 +4798,7 @@
           <p:cNvPr id="2" name="slide-subtitle">
             <a:extLst xmlns:a="http://schemas.openxmlformats.org/drawingml/2006/main">
               <a:ext uri="{FF2B5EF4-FFF2-40B4-BE49-F238E27FC236}">
-                <a16:creationId xmlns:a16="http://schemas.microsoft.com/office/drawing/2014/main" id="{5CF57E05-BA32-48D8-B7EB-541249562025}"/>
+                <a16:creationId xmlns:a16="http://schemas.microsoft.com/office/drawing/2014/main" id="{D8FCDE4A-998E-42DC-BD2B-52BDE2DE10EE}"/>
               </a:ext>
             </a:extLst>
           </p:cNvPr>
@@ -4820,7 +4845,7 @@
                 <a:ea typeface="Aptos"/>
                 <a:cs typeface="Aptos"/>
               </a:rPr>
-              <a:t>Longer bar means less certainty. The comparison tests have 20 and 24 items per model.</a:t>
+              <a:t>Wider bar = less sure. MFQ has 20 questions per model; Vignette has 24.</a:t>
             </a:r>
           </a:p>
         </p:txBody>
@@ -4830,7 +4855,7 @@
           <p:cNvPr id="3" name="">
             <a:extLst xmlns:a="http://schemas.openxmlformats.org/drawingml/2006/main">
               <a:ext uri="{FF2B5EF4-FFF2-40B4-BE49-F238E27FC236}">
-                <a16:creationId xmlns:a16="http://schemas.microsoft.com/office/drawing/2014/main" id="{8A90CA8E-2D50-4C53-992E-CA14485A5089}"/>
+                <a16:creationId xmlns:a16="http://schemas.microsoft.com/office/drawing/2014/main" id="{C88C5B53-9685-424C-931D-A00E03652B07}"/>
               </a:ext>
             </a:extLst>
           </p:cNvPr>
@@ -4891,7 +4916,7 @@
           <p:cNvPr id="4" name="">
             <a:extLst xmlns:a="http://schemas.openxmlformats.org/drawingml/2006/main">
               <a:ext uri="{FF2B5EF4-FFF2-40B4-BE49-F238E27FC236}">
-                <a16:creationId xmlns:a16="http://schemas.microsoft.com/office/drawing/2014/main" id="{37DC1C84-236C-43D3-AD27-5108B8CBF6D4}"/>
+                <a16:creationId xmlns:a16="http://schemas.microsoft.com/office/drawing/2014/main" id="{D5BC1DBE-93FC-4738-9DA9-B7C6F5F7EE02}"/>
               </a:ext>
             </a:extLst>
           </p:cNvPr>
@@ -4929,7 +4954,7 @@
         </p:xfrm>
         <a:graphic xmlns:a="http://schemas.openxmlformats.org/drawingml/2006/main">
           <a:graphicData uri="http://schemas.openxmlformats.org/drawingml/2006/chart">
-            <c:chart xmlns:r="http://schemas.openxmlformats.org/officeDocument/2006/relationships" xmlns:c="http://schemas.openxmlformats.org/drawingml/2006/chart" r:id="R654baa54b96a4eb7"/>
+            <c:chart xmlns:r="http://schemas.openxmlformats.org/officeDocument/2006/relationships" xmlns:c="http://schemas.openxmlformats.org/drawingml/2006/chart" r:id="R50d862d518b3432f"/>
           </a:graphicData>
         </a:graphic>
       </p:graphicFrame>
@@ -4938,7 +4963,7 @@
           <p:cNvPr id="6" name="">
             <a:extLst xmlns:a="http://schemas.openxmlformats.org/drawingml/2006/main">
               <a:ext uri="{FF2B5EF4-FFF2-40B4-BE49-F238E27FC236}">
-                <a16:creationId xmlns:a16="http://schemas.microsoft.com/office/drawing/2014/main" id="{51CF8945-5AE2-4FBE-AA2D-E05DA48B42E8}"/>
+                <a16:creationId xmlns:a16="http://schemas.microsoft.com/office/drawing/2014/main" id="{C66FC219-BD91-437C-8977-2E1A0A3F0FB1}"/>
               </a:ext>
             </a:extLst>
           </p:cNvPr>
@@ -4985,7 +5010,7 @@
                 <a:ea typeface="Aptos"/>
                 <a:cs typeface="Aptos"/>
               </a:rPr>
-              <a:t>Action: recover each item's result for every model.</a:t>
+              <a:t>Action: compare every model on the same questions.</a:t>
             </a:r>
           </a:p>
         </p:txBody>
@@ -4995,7 +5020,7 @@
           <p:cNvPr id="7" name="">
             <a:extLst xmlns:a="http://schemas.openxmlformats.org/drawingml/2006/main">
               <a:ext uri="{FF2B5EF4-FFF2-40B4-BE49-F238E27FC236}">
-                <a16:creationId xmlns:a16="http://schemas.microsoft.com/office/drawing/2014/main" id="{A2058242-5A99-428A-A7AE-ED840CA28D09}"/>
+                <a16:creationId xmlns:a16="http://schemas.microsoft.com/office/drawing/2014/main" id="{23508C21-58DB-45AF-8B89-ADE4B9F10F1A}"/>
               </a:ext>
             </a:extLst>
           </p:cNvPr>
@@ -5042,7 +5067,7 @@
                 <a:ea typeface="Aptos"/>
                 <a:cs typeface="Aptos"/>
               </a:rPr>
-              <a:t>If the order is still unclear, then expand the item banks.</a:t>
+              <a:t>If the order is still unclear, add more comparison questions.</a:t>
             </a:r>
           </a:p>
         </p:txBody>
@@ -5050,7 +5075,7 @@
     </p:spTree>
     <p:extLst>
       <p:ext uri="{BB962C8B-B14F-4D97-AF65-F5344CB8AC3E}">
-        <p14:creationId xmlns:p14="http://schemas.microsoft.com/office/powerpoint/2010/main" val="2130903008"/>
+        <p14:creationId xmlns:p14="http://schemas.microsoft.com/office/powerpoint/2010/main" val="489266278"/>
       </p:ext>
     </p:extLst>
   </p:cSld>
@@ -5081,7 +5106,7 @@
           <p:cNvPr id="8" name="slide-title">
             <a:extLst xmlns:a="http://schemas.openxmlformats.org/drawingml/2006/main">
               <a:ext uri="{FF2B5EF4-FFF2-40B4-BE49-F238E27FC236}">
-                <a16:creationId xmlns:a16="http://schemas.microsoft.com/office/drawing/2014/main" id="{2E154BCC-A5A4-4E61-9D65-96E4FAF11379}"/>
+                <a16:creationId xmlns:a16="http://schemas.microsoft.com/office/drawing/2014/main" id="{2CEEA952-47BC-4548-9C9B-7EFA481FE886}"/>
               </a:ext>
             </a:extLst>
           </p:cNvPr>
@@ -5128,7 +5153,7 @@
                 <a:ea typeface="Aptos"/>
                 <a:cs typeface="Aptos"/>
               </a:rPr>
-              <a:t>Only 4 of 12 selected size paths rise twice</a:t>
+              <a:t>Only 4 of 12 model-and-task cases rise twice</a:t>
             </a:r>
           </a:p>
         </p:txBody>
@@ -5138,7 +5163,7 @@
           <p:cNvPr id="2" name="slide-subtitle">
             <a:extLst xmlns:a="http://schemas.openxmlformats.org/drawingml/2006/main">
               <a:ext uri="{FF2B5EF4-FFF2-40B4-BE49-F238E27FC236}">
-                <a16:creationId xmlns:a16="http://schemas.microsoft.com/office/drawing/2014/main" id="{440E6B75-7134-43CC-92B9-A415C301DAE2}"/>
+                <a16:creationId xmlns:a16="http://schemas.microsoft.com/office/drawing/2014/main" id="{9C565053-3386-4110-B086-A19EC6502B7E}"/>
               </a:ext>
             </a:extLst>
           </p:cNvPr>
@@ -5185,7 +5210,7 @@
                 <a:ea typeface="Aptos"/>
                 <a:cs typeface="Aptos"/>
               </a:rPr>
-              <a:t>Three model families × four UniMoral tasks; variants differ in more than size</a:t>
+              <a:t>Qwen, Gemma, and Llama × four tasks; model versions differ in more than size</a:t>
             </a:r>
           </a:p>
         </p:txBody>
@@ -5195,7 +5220,7 @@
           <p:cNvPr id="3" name="">
             <a:extLst xmlns:a="http://schemas.openxmlformats.org/drawingml/2006/main">
               <a:ext uri="{FF2B5EF4-FFF2-40B4-BE49-F238E27FC236}">
-                <a16:creationId xmlns:a16="http://schemas.microsoft.com/office/drawing/2014/main" id="{E2A3B219-D89A-4D8D-BE37-52459C004274}"/>
+                <a16:creationId xmlns:a16="http://schemas.microsoft.com/office/drawing/2014/main" id="{CBEB616C-C59E-496E-BA0C-2A79031EE6A2}"/>
               </a:ext>
             </a:extLst>
           </p:cNvPr>
@@ -5256,7 +5281,7 @@
           <p:cNvPr id="4" name="">
             <a:extLst xmlns:a="http://schemas.openxmlformats.org/drawingml/2006/main">
               <a:ext uri="{FF2B5EF4-FFF2-40B4-BE49-F238E27FC236}">
-                <a16:creationId xmlns:a16="http://schemas.microsoft.com/office/drawing/2014/main" id="{C34634AE-8FCB-42DE-AE86-186AF6630E83}"/>
+                <a16:creationId xmlns:a16="http://schemas.microsoft.com/office/drawing/2014/main" id="{287CE98F-6808-4B0A-8B00-11D5C13AFA8E}"/>
               </a:ext>
             </a:extLst>
           </p:cNvPr>
@@ -5294,7 +5319,7 @@
         </p:xfrm>
         <a:graphic xmlns:a="http://schemas.openxmlformats.org/drawingml/2006/main">
           <a:graphicData uri="http://schemas.openxmlformats.org/drawingml/2006/chart">
-            <c:chart xmlns:r="http://schemas.openxmlformats.org/officeDocument/2006/relationships" xmlns:c="http://schemas.openxmlformats.org/drawingml/2006/chart" r:id="R2bc4357103ac464f"/>
+            <c:chart xmlns:r="http://schemas.openxmlformats.org/officeDocument/2006/relationships" xmlns:c="http://schemas.openxmlformats.org/drawingml/2006/chart" r:id="R7b0283ef3b88497c"/>
           </a:graphicData>
         </a:graphic>
       </p:graphicFrame>
@@ -5303,7 +5328,7 @@
           <p:cNvPr id="6" name="">
             <a:extLst xmlns:a="http://schemas.openxmlformats.org/drawingml/2006/main">
               <a:ext uri="{FF2B5EF4-FFF2-40B4-BE49-F238E27FC236}">
-                <a16:creationId xmlns:a16="http://schemas.microsoft.com/office/drawing/2014/main" id="{06AFCEB7-1EC7-46E5-9462-C0731234D184}"/>
+                <a16:creationId xmlns:a16="http://schemas.microsoft.com/office/drawing/2014/main" id="{51856DED-2486-4678-93AF-12FA4E9BEBF9}"/>
               </a:ext>
             </a:extLst>
           </p:cNvPr>
@@ -5360,7 +5385,7 @@
           <p:cNvPr id="7" name="">
             <a:extLst xmlns:a="http://schemas.openxmlformats.org/drawingml/2006/main">
               <a:ext uri="{FF2B5EF4-FFF2-40B4-BE49-F238E27FC236}">
-                <a16:creationId xmlns:a16="http://schemas.microsoft.com/office/drawing/2014/main" id="{8B6E201B-5574-437D-953A-49E7BB5F5EF7}"/>
+                <a16:creationId xmlns:a16="http://schemas.microsoft.com/office/drawing/2014/main" id="{0A256135-D645-49D5-B848-CCF8FAD64E9C}"/>
               </a:ext>
             </a:extLst>
           </p:cNvPr>
@@ -5407,7 +5432,7 @@
                 <a:ea typeface="Aptos"/>
                 <a:cs typeface="Aptos"/>
               </a:rPr>
-              <a:t>Each case follows one family on one task. Accuracy and METEOR stay separate.</a:t>
+              <a:t>Each case follows one model family on one task. Different score types stay separate.</a:t>
             </a:r>
           </a:p>
         </p:txBody>
@@ -5415,7 +5440,7 @@
     </p:spTree>
     <p:extLst>
       <p:ext uri="{BB962C8B-B14F-4D97-AF65-F5344CB8AC3E}">
-        <p14:creationId xmlns:p14="http://schemas.microsoft.com/office/powerpoint/2010/main" val="952085000"/>
+        <p14:creationId xmlns:p14="http://schemas.microsoft.com/office/powerpoint/2010/main" val="1055896846"/>
       </p:ext>
     </p:extLst>
   </p:cSld>
@@ -5446,7 +5471,7 @@
           <p:cNvPr id="7" name="slide-title">
             <a:extLst xmlns:a="http://schemas.openxmlformats.org/drawingml/2006/main">
               <a:ext uri="{FF2B5EF4-FFF2-40B4-BE49-F238E27FC236}">
-                <a16:creationId xmlns:a16="http://schemas.microsoft.com/office/drawing/2014/main" id="{56675649-FF40-48BA-9032-E3E37F57005A}"/>
+                <a16:creationId xmlns:a16="http://schemas.microsoft.com/office/drawing/2014/main" id="{38F729F3-5CA7-407E-A101-7D38EE0207B5}"/>
               </a:ext>
             </a:extLst>
           </p:cNvPr>
@@ -5503,7 +5528,7 @@
           <p:cNvPr id="2" name="">
             <a:extLst xmlns:a="http://schemas.openxmlformats.org/drawingml/2006/main">
               <a:ext uri="{FF2B5EF4-FFF2-40B4-BE49-F238E27FC236}">
-                <a16:creationId xmlns:a16="http://schemas.microsoft.com/office/drawing/2014/main" id="{198AA19D-8673-4322-BB1D-E7F0AC62B62B}"/>
+                <a16:creationId xmlns:a16="http://schemas.microsoft.com/office/drawing/2014/main" id="{8D753426-D82C-4FD6-BC59-13792041F5C5}"/>
               </a:ext>
             </a:extLst>
           </p:cNvPr>
@@ -5564,7 +5589,7 @@
           <p:cNvPr id="3" name="">
             <a:extLst xmlns:a="http://schemas.openxmlformats.org/drawingml/2006/main">
               <a:ext uri="{FF2B5EF4-FFF2-40B4-BE49-F238E27FC236}">
-                <a16:creationId xmlns:a16="http://schemas.microsoft.com/office/drawing/2014/main" id="{B917522E-A72C-4DBD-AC78-F2B1CE9D26B5}"/>
+                <a16:creationId xmlns:a16="http://schemas.microsoft.com/office/drawing/2014/main" id="{C2ECF6D9-021C-484B-A25D-B9B955E4521F}"/>
               </a:ext>
             </a:extLst>
           </p:cNvPr>
@@ -5602,7 +5627,7 @@
         </p:xfrm>
         <a:graphic xmlns:a="http://schemas.openxmlformats.org/drawingml/2006/main">
           <a:graphicData uri="http://schemas.openxmlformats.org/drawingml/2006/chart">
-            <c:chart xmlns:r="http://schemas.openxmlformats.org/officeDocument/2006/relationships" xmlns:c="http://schemas.openxmlformats.org/drawingml/2006/chart" r:id="R479071be3eb2481a"/>
+            <c:chart xmlns:r="http://schemas.openxmlformats.org/officeDocument/2006/relationships" xmlns:c="http://schemas.openxmlformats.org/drawingml/2006/chart" r:id="R8a5e35d920fb4111"/>
           </a:graphicData>
         </a:graphic>
       </p:graphicFrame>
@@ -5611,7 +5636,7 @@
           <p:cNvPr id="5" name="">
             <a:extLst xmlns:a="http://schemas.openxmlformats.org/drawingml/2006/main">
               <a:ext uri="{FF2B5EF4-FFF2-40B4-BE49-F238E27FC236}">
-                <a16:creationId xmlns:a16="http://schemas.microsoft.com/office/drawing/2014/main" id="{EA8F6C1A-5EFC-4F24-9497-91097F35579B}"/>
+                <a16:creationId xmlns:a16="http://schemas.microsoft.com/office/drawing/2014/main" id="{F994DA10-7887-49B7-8804-C2CCD0D24831}"/>
               </a:ext>
             </a:extLst>
           </p:cNvPr>
@@ -5668,7 +5693,7 @@
           <p:cNvPr id="6" name="">
             <a:extLst xmlns:a="http://schemas.openxmlformats.org/drawingml/2006/main">
               <a:ext uri="{FF2B5EF4-FFF2-40B4-BE49-F238E27FC236}">
-                <a16:creationId xmlns:a16="http://schemas.microsoft.com/office/drawing/2014/main" id="{8B064EA9-4610-4008-89C4-5E7125EF08A1}"/>
+                <a16:creationId xmlns:a16="http://schemas.microsoft.com/office/drawing/2014/main" id="{3475E8AF-46BE-4925-BE89-62E66EC585D8}"/>
               </a:ext>
             </a:extLst>
           </p:cNvPr>
@@ -5715,7 +5740,7 @@
                 <a:ea typeface="Aptos"/>
                 <a:cs typeface="Aptos"/>
               </a:rPr>
-              <a:t>Each point is one saved task score. No saved intervals or raw-log replay.</a:t>
+              <a:t>Each point is one stored task score. Its uncertainty range and original run are unavailable.</a:t>
             </a:r>
           </a:p>
         </p:txBody>
@@ -5723,7 +5748,7 @@
     </p:spTree>
     <p:extLst>
       <p:ext uri="{BB962C8B-B14F-4D97-AF65-F5344CB8AC3E}">
-        <p14:creationId xmlns:p14="http://schemas.microsoft.com/office/powerpoint/2010/main" val="577344971"/>
+        <p14:creationId xmlns:p14="http://schemas.microsoft.com/office/powerpoint/2010/main" val="41747011"/>
       </p:ext>
     </p:extLst>
   </p:cSld>
@@ -5751,10 +5776,10 @@
       </p:grpSpPr>
       <p:sp>
         <p:nvSpPr>
-          <p:cNvPr id="11" name="slide-title">
+          <p:cNvPr id="12" name="slide-title">
             <a:extLst xmlns:a="http://schemas.openxmlformats.org/drawingml/2006/main">
               <a:ext uri="{FF2B5EF4-FFF2-40B4-BE49-F238E27FC236}">
-                <a16:creationId xmlns:a16="http://schemas.microsoft.com/office/drawing/2014/main" id="{36BE9AFD-3849-42B2-8118-0DBB1251ED54}"/>
+                <a16:creationId xmlns:a16="http://schemas.microsoft.com/office/drawing/2014/main" id="{4DB080F5-0424-4F1A-8545-62110F0032B8}"/>
               </a:ext>
             </a:extLst>
           </p:cNvPr>
@@ -5811,7 +5836,7 @@
           <p:cNvPr id="2" name="slide-subtitle">
             <a:extLst xmlns:a="http://schemas.openxmlformats.org/drawingml/2006/main">
               <a:ext uri="{FF2B5EF4-FFF2-40B4-BE49-F238E27FC236}">
-                <a16:creationId xmlns:a16="http://schemas.microsoft.com/office/drawing/2014/main" id="{CA9E7EA0-CC96-4055-B415-17AE562B6BEE}"/>
+                <a16:creationId xmlns:a16="http://schemas.microsoft.com/office/drawing/2014/main" id="{BD64FF93-66BB-42AA-B01B-549C046699DD}"/>
               </a:ext>
             </a:extLst>
           </p:cNvPr>
@@ -5858,7 +5883,7 @@
                 <a:ea typeface="Aptos"/>
                 <a:cs typeface="Aptos"/>
               </a:rPr>
-              <a:t>Accuracy change for three UniMoral classification tasks</a:t>
+              <a:t>Score change on three UniMoral tasks</a:t>
             </a:r>
           </a:p>
         </p:txBody>
@@ -5868,7 +5893,7 @@
           <p:cNvPr id="3" name="">
             <a:extLst xmlns:a="http://schemas.openxmlformats.org/drawingml/2006/main">
               <a:ext uri="{FF2B5EF4-FFF2-40B4-BE49-F238E27FC236}">
-                <a16:creationId xmlns:a16="http://schemas.microsoft.com/office/drawing/2014/main" id="{1A6CDD35-33BC-468B-8417-17A14BB49680}"/>
+                <a16:creationId xmlns:a16="http://schemas.microsoft.com/office/drawing/2014/main" id="{CBBC1C07-3206-4987-8364-789A7AC950BA}"/>
               </a:ext>
             </a:extLst>
           </p:cNvPr>
@@ -5929,7 +5954,7 @@
           <p:cNvPr id="4" name="">
             <a:extLst xmlns:a="http://schemas.openxmlformats.org/drawingml/2006/main">
               <a:ext uri="{FF2B5EF4-FFF2-40B4-BE49-F238E27FC236}">
-                <a16:creationId xmlns:a16="http://schemas.microsoft.com/office/drawing/2014/main" id="{770C44AA-576C-48E6-B503-5ACF93CCDBE4}"/>
+                <a16:creationId xmlns:a16="http://schemas.microsoft.com/office/drawing/2014/main" id="{1D1EBD7E-F245-456A-A053-3F5912009925}"/>
               </a:ext>
             </a:extLst>
           </p:cNvPr>
@@ -5960,7 +5985,7 @@
           <p:cNvPr id="5" name="">
             <a:extLst xmlns:a="http://schemas.openxmlformats.org/drawingml/2006/main">
               <a:ext uri="{FF2B5EF4-FFF2-40B4-BE49-F238E27FC236}">
-                <a16:creationId xmlns:a16="http://schemas.microsoft.com/office/drawing/2014/main" id="{1EB461CF-3FBD-455C-AEEF-82BB311B08D2}"/>
+                <a16:creationId xmlns:a16="http://schemas.microsoft.com/office/drawing/2014/main" id="{6D721362-C4E9-42A6-956E-D1BA7098271D}"/>
               </a:ext>
             </a:extLst>
           </p:cNvPr>
@@ -6017,7 +6042,7 @@
           <p:cNvPr id="6" name="">
             <a:extLst xmlns:a="http://schemas.openxmlformats.org/drawingml/2006/main">
               <a:ext uri="{FF2B5EF4-FFF2-40B4-BE49-F238E27FC236}">
-                <a16:creationId xmlns:a16="http://schemas.microsoft.com/office/drawing/2014/main" id="{0A5D0F69-241F-4B21-BD1F-A0D91967FAA0}"/>
+                <a16:creationId xmlns:a16="http://schemas.microsoft.com/office/drawing/2014/main" id="{36B65528-FEE0-492B-89C8-CFFEA1AADF41}"/>
               </a:ext>
             </a:extLst>
           </p:cNvPr>
@@ -6069,28 +6094,85 @@
           </a:p>
         </p:txBody>
       </p:sp>
+      <p:sp>
+        <p:nvSpPr>
+          <p:cNvPr id="7" name="">
+            <a:extLst xmlns:a="http://schemas.openxmlformats.org/drawingml/2006/main">
+              <a:ext uri="{FF2B5EF4-FFF2-40B4-BE49-F238E27FC236}">
+                <a16:creationId xmlns:a16="http://schemas.microsoft.com/office/drawing/2014/main" id="{4478803F-53D5-4D48-8DD1-B0071690DC73}"/>
+              </a:ext>
+            </a:extLst>
+          </p:cNvPr>
+          <p:cNvSpPr>
+            <a:spLocks xmlns:a="http://schemas.openxmlformats.org/drawingml/2006/main" noGrp="1"/>
+          </p:cNvSpPr>
+          <p:nvPr/>
+        </p:nvSpPr>
+        <p:spPr>
+          <a:xfrm xmlns:a="http://schemas.openxmlformats.org/drawingml/2006/main">
+            <a:off x="1047750" y="2019300"/>
+            <a:ext cx="7810500" cy="190500"/>
+          </a:xfrm>
+          <a:prstGeom xmlns:a="http://schemas.openxmlformats.org/drawingml/2006/main" prst="rect">
+            <a:avLst/>
+          </a:prstGeom>
+          <a:noFill xmlns:a="http://schemas.openxmlformats.org/drawingml/2006/main"/>
+          <a:ln xmlns:a="http://schemas.openxmlformats.org/drawingml/2006/main" w="0">
+            <a:noFill/>
+          </a:ln>
+        </p:spPr>
+        <p:txBody>
+          <a:bodyPr xmlns:a="http://schemas.openxmlformats.org/drawingml/2006/main">
+            <a:normAutofit fontScale="72222"/>
+          </a:bodyPr>
+          <a:lstStyle xmlns:a="http://schemas.openxmlformats.org/drawingml/2006/main"/>
+          <a:p xmlns:a="http://schemas.openxmlformats.org/drawingml/2006/main">
+            <a:pPr algn="l">
+              <a:defRPr sz="900" b="0">
+                <a:solidFill>
+                  <a:srgbClr val="66727E"/>
+                </a:solidFill>
+                <a:latin typeface="Aptos"/>
+                <a:ea typeface="Aptos"/>
+                <a:cs typeface="Aptos"/>
+              </a:defRPr>
+            </a:pPr>
+            <a:r>
+              <a:rPr sz="900" b="0">
+                <a:solidFill>
+                  <a:srgbClr val="66727E"/>
+                </a:solidFill>
+                <a:latin typeface="Aptos"/>
+                <a:ea typeface="Aptos"/>
+                <a:cs typeface="Aptos"/>
+              </a:rPr>
+              <a:t>main = all parameters; active = parameters used for each token</a:t>
+            </a:r>
+          </a:p>
+        </p:txBody>
+      </p:sp>
       <p:graphicFrame>
         <p:nvGraphicFramePr>
-          <p:cNvPr id="17" name="Chart"/>
+          <p:cNvPr id="19" name="Chart"/>
           <p:cNvGraphicFramePr/>
           <p:nvPr/>
         </p:nvGraphicFramePr>
         <p:xfrm>
-          <a:off xmlns:a="http://schemas.openxmlformats.org/drawingml/2006/main" x="1143000" y="2133600"/>
-          <a:ext xmlns:a="http://schemas.openxmlformats.org/drawingml/2006/main" cx="9810750" cy="3286125"/>
+          <a:off xmlns:a="http://schemas.openxmlformats.org/drawingml/2006/main" x="1143000" y="2266950"/>
+          <a:ext xmlns:a="http://schemas.openxmlformats.org/drawingml/2006/main" cx="9810750" cy="3152775"/>
         </p:xfrm>
         <a:graphic xmlns:a="http://schemas.openxmlformats.org/drawingml/2006/main">
           <a:graphicData uri="http://schemas.openxmlformats.org/drawingml/2006/chart">
-            <c:chart xmlns:r="http://schemas.openxmlformats.org/officeDocument/2006/relationships" xmlns:c="http://schemas.openxmlformats.org/drawingml/2006/chart" r:id="Ra480d91deff141eb"/>
+            <c:chart xmlns:r="http://schemas.openxmlformats.org/officeDocument/2006/relationships" xmlns:c="http://schemas.openxmlformats.org/drawingml/2006/chart" r:id="R78ea8a728413484b"/>
           </a:graphicData>
         </a:graphic>
       </p:graphicFrame>
       <p:sp>
         <p:nvSpPr>
-          <p:cNvPr id="8" name="">
+          <p:cNvPr id="9" name="">
             <a:extLst xmlns:a="http://schemas.openxmlformats.org/drawingml/2006/main">
               <a:ext uri="{FF2B5EF4-FFF2-40B4-BE49-F238E27FC236}">
-                <a16:creationId xmlns:a16="http://schemas.microsoft.com/office/drawing/2014/main" id="{0F15215F-7DA9-4EBB-9802-311B47B4CB2F}"/>
+                <a16:creationId xmlns:a16="http://schemas.microsoft.com/office/drawing/2014/main" id="{50D7603C-332F-4924-BBE5-97F985C96CE9}"/>
               </a:ext>
             </a:extLst>
           </p:cNvPr>
@@ -6144,10 +6226,10 @@
       </p:sp>
       <p:sp>
         <p:nvSpPr>
-          <p:cNvPr id="9" name="">
+          <p:cNvPr id="10" name="">
             <a:extLst xmlns:a="http://schemas.openxmlformats.org/drawingml/2006/main">
               <a:ext uri="{FF2B5EF4-FFF2-40B4-BE49-F238E27FC236}">
-                <a16:creationId xmlns:a16="http://schemas.microsoft.com/office/drawing/2014/main" id="{C7548EC3-E761-4574-8358-A26640AACDA5}"/>
+                <a16:creationId xmlns:a16="http://schemas.microsoft.com/office/drawing/2014/main" id="{81CF6524-5541-4930-82C0-8D3B5CFFE815}"/>
               </a:ext>
             </a:extLst>
           </p:cNvPr>
@@ -6201,10 +6283,10 @@
       </p:sp>
       <p:sp>
         <p:nvSpPr>
-          <p:cNvPr id="10" name="">
+          <p:cNvPr id="11" name="">
             <a:extLst xmlns:a="http://schemas.openxmlformats.org/drawingml/2006/main">
               <a:ext uri="{FF2B5EF4-FFF2-40B4-BE49-F238E27FC236}">
-                <a16:creationId xmlns:a16="http://schemas.microsoft.com/office/drawing/2014/main" id="{8C1ABEA8-D5CF-424E-8EDB-82224394FF8D}"/>
+                <a16:creationId xmlns:a16="http://schemas.microsoft.com/office/drawing/2014/main" id="{C018F334-19BA-48DD-B683-BF4B262BB9ED}"/>
               </a:ext>
             </a:extLst>
           </p:cNvPr>
@@ -6251,7 +6333,7 @@
                 <a:ea typeface="Aptos"/>
                 <a:cs typeface="Aptos"/>
               </a:rPr>
-              <a:t>Consequence uses METEOR and is not mixed into this accuracy chart.</a:t>
+              <a:t>The consequence task uses a different score, so it is not shown here.</a:t>
             </a:r>
           </a:p>
         </p:txBody>
@@ -6259,7 +6341,7 @@
     </p:spTree>
     <p:extLst>
       <p:ext uri="{BB962C8B-B14F-4D97-AF65-F5344CB8AC3E}">
-        <p14:creationId xmlns:p14="http://schemas.microsoft.com/office/powerpoint/2010/main" val="720471903"/>
+        <p14:creationId xmlns:p14="http://schemas.microsoft.com/office/powerpoint/2010/main" val="1494926282"/>
       </p:ext>
     </p:extLst>
   </p:cSld>
@@ -6290,7 +6372,7 @@
           <p:cNvPr id="10" name="slide-title">
             <a:extLst xmlns:a="http://schemas.openxmlformats.org/drawingml/2006/main">
               <a:ext uri="{FF2B5EF4-FFF2-40B4-BE49-F238E27FC236}">
-                <a16:creationId xmlns:a16="http://schemas.microsoft.com/office/drawing/2014/main" id="{A95038DD-40C8-4021-B357-E267EB1A496C}"/>
+                <a16:creationId xmlns:a16="http://schemas.microsoft.com/office/drawing/2014/main" id="{42D3DB77-0C20-43C7-A2F7-5F26058AD232}"/>
               </a:ext>
             </a:extLst>
           </p:cNvPr>
@@ -6347,7 +6429,7 @@
           <p:cNvPr id="2" name="slide-subtitle">
             <a:extLst xmlns:a="http://schemas.openxmlformats.org/drawingml/2006/main">
               <a:ext uri="{FF2B5EF4-FFF2-40B4-BE49-F238E27FC236}">
-                <a16:creationId xmlns:a16="http://schemas.microsoft.com/office/drawing/2014/main" id="{49BE85A6-A261-45F2-8BD8-CA6D01C9D91F}"/>
+                <a16:creationId xmlns:a16="http://schemas.microsoft.com/office/drawing/2014/main" id="{AC96DD11-B3F1-447B-8D4D-64AF9A9EA256}"/>
               </a:ext>
             </a:extLst>
           </p:cNvPr>
@@ -6394,7 +6476,7 @@
                 <a:ea typeface="Aptos"/>
                 <a:cs typeface="Aptos"/>
               </a:rPr>
-              <a:t>The papers explain the questions and methods. They are not direct score baselines.</a:t>
+              <a:t>The papers help explain our questions. Their scores cannot be compared with ours.</a:t>
             </a:r>
           </a:p>
         </p:txBody>
@@ -6404,7 +6486,7 @@
           <p:cNvPr id="3" name="">
             <a:extLst xmlns:a="http://schemas.openxmlformats.org/drawingml/2006/main">
               <a:ext uri="{FF2B5EF4-FFF2-40B4-BE49-F238E27FC236}">
-                <a16:creationId xmlns:a16="http://schemas.microsoft.com/office/drawing/2014/main" id="{7AD6F417-917A-45CF-BD4C-593FAEC78C42}"/>
+                <a16:creationId xmlns:a16="http://schemas.microsoft.com/office/drawing/2014/main" id="{E8E261BF-AFB4-4243-9B2B-CDAB5E7F8E7B}"/>
               </a:ext>
             </a:extLst>
           </p:cNvPr>
@@ -6465,7 +6547,7 @@
           <p:cNvPr id="4" name="">
             <a:extLst xmlns:a="http://schemas.openxmlformats.org/drawingml/2006/main">
               <a:ext uri="{FF2B5EF4-FFF2-40B4-BE49-F238E27FC236}">
-                <a16:creationId xmlns:a16="http://schemas.microsoft.com/office/drawing/2014/main" id="{9E62A931-7C19-4E34-990C-D29DEA968C64}"/>
+                <a16:creationId xmlns:a16="http://schemas.microsoft.com/office/drawing/2014/main" id="{DF65F538-F8B5-4918-B3F0-5472962DB3E5}"/>
               </a:ext>
             </a:extLst>
           </p:cNvPr>
@@ -6496,7 +6578,7 @@
           <p:cNvPr id="5" name="">
             <a:extLst xmlns:a="http://schemas.openxmlformats.org/drawingml/2006/main">
               <a:ext uri="{FF2B5EF4-FFF2-40B4-BE49-F238E27FC236}">
-                <a16:creationId xmlns:a16="http://schemas.microsoft.com/office/drawing/2014/main" id="{220337A1-4D0B-4B56-9E63-49FF230EED66}"/>
+                <a16:creationId xmlns:a16="http://schemas.microsoft.com/office/drawing/2014/main" id="{5FF9EEE4-1D18-4605-983E-D37BAFDE1B6A}"/>
               </a:ext>
             </a:extLst>
           </p:cNvPr>
@@ -6553,7 +6635,7 @@
           <p:cNvPr id="6" name="">
             <a:extLst xmlns:a="http://schemas.openxmlformats.org/drawingml/2006/main">
               <a:ext uri="{FF2B5EF4-FFF2-40B4-BE49-F238E27FC236}">
-                <a16:creationId xmlns:a16="http://schemas.microsoft.com/office/drawing/2014/main" id="{7466B023-E375-490C-934F-D03BCE0D77DF}"/>
+                <a16:creationId xmlns:a16="http://schemas.microsoft.com/office/drawing/2014/main" id="{55F5E9C3-E624-495D-ACE5-557D569D2B0D}"/>
               </a:ext>
             </a:extLst>
           </p:cNvPr>
@@ -6600,7 +6682,7 @@
                 <a:ea typeface="Aptos"/>
                 <a:cs typeface="Aptos"/>
               </a:rPr>
-              <a:t>exact local</a:t>
+              <a:t>papers repeated</a:t>
             </a:r>
           </a:p>
           <a:p xmlns:a="http://schemas.openxmlformats.org/drawingml/2006/main">
@@ -6623,7 +6705,7 @@
                 <a:ea typeface="Aptos"/>
                 <a:cs typeface="Aptos"/>
               </a:rPr>
-              <a:t>replications</a:t>
+              <a:t>exactly</a:t>
             </a:r>
           </a:p>
         </p:txBody>
@@ -6784,7 +6866,7 @@
                           <a:ea typeface="Aptos"/>
                           <a:cs typeface="Aptos"/>
                         </a:rPr>
-                        <a:t>Similar, not exact</a:t>
+                        <a:t>Similar question</a:t>
                       </a:r>
                     </a:p>
                   </a:txBody>
@@ -6834,7 +6916,7 @@
                           <a:ea typeface="Aptos"/>
                           <a:cs typeface="Aptos"/>
                         </a:rPr>
-                        <a:t>Can models predict labels and consequences?</a:t>
+                        <a:t>Can models predict choices, moral categories, influences, and what happens next?</a:t>
                       </a:r>
                     </a:p>
                   </a:txBody>
@@ -6932,7 +7014,7 @@
                           <a:ea typeface="Aptos"/>
                           <a:cs typeface="Aptos"/>
                         </a:rPr>
-                        <a:t>Stand-in only</a:t>
+                        <a:t>Different scoring</a:t>
                       </a:r>
                     </a:p>
                   </a:txBody>
@@ -6982,7 +7064,7 @@
                           <a:ea typeface="Aptos"/>
                           <a:cs typeface="Aptos"/>
                         </a:rPr>
-                        <a:t>Which reasons appear before and after a choice?</a:t>
+                        <a:t>Do reasons change when a model explains before or after choosing?</a:t>
                       </a:r>
                     </a:p>
                   </a:txBody>
@@ -7006,7 +7088,7 @@
                           <a:ea typeface="Aptos"/>
                           <a:cs typeface="Aptos"/>
                         </a:rPr>
-                        <a:t>Stand-in only</a:t>
+                        <a:t>Different scoring</a:t>
                       </a:r>
                     </a:p>
                   </a:txBody>
@@ -7026,7 +7108,7 @@
           <p:cNvPr id="8" name="">
             <a:extLst xmlns:a="http://schemas.openxmlformats.org/drawingml/2006/main">
               <a:ext uri="{FF2B5EF4-FFF2-40B4-BE49-F238E27FC236}">
-                <a16:creationId xmlns:a16="http://schemas.microsoft.com/office/drawing/2014/main" id="{9B1FBE39-5D22-4319-8817-B6E11E7626EB}"/>
+                <a16:creationId xmlns:a16="http://schemas.microsoft.com/office/drawing/2014/main" id="{0D8787BC-2B41-4905-8A23-8B91C8C60B74}"/>
               </a:ext>
             </a:extLst>
           </p:cNvPr>
@@ -7073,7 +7155,7 @@
                 <a:ea typeface="Aptos"/>
                 <a:cs typeface="Aptos"/>
               </a:rPr>
-              <a:t>Use the papers to interpret the tasks, not to claim a score replication.</a:t>
+              <a:t>Use the papers to explain our questions—not to compare scores.</a:t>
             </a:r>
           </a:p>
         </p:txBody>
@@ -7083,7 +7165,7 @@
           <p:cNvPr id="9" name="">
             <a:extLst xmlns:a="http://schemas.openxmlformats.org/drawingml/2006/main">
               <a:ext uri="{FF2B5EF4-FFF2-40B4-BE49-F238E27FC236}">
-                <a16:creationId xmlns:a16="http://schemas.microsoft.com/office/drawing/2014/main" id="{D162956F-53EE-4E4F-95CC-D5E6672882AB}"/>
+                <a16:creationId xmlns:a16="http://schemas.microsoft.com/office/drawing/2014/main" id="{DF7FD1F6-17BD-4C7A-A9C9-C3914239C9A8}"/>
               </a:ext>
             </a:extLst>
           </p:cNvPr>
@@ -7130,7 +7212,7 @@
                 <a:ea typeface="Aptos"/>
                 <a:cs typeface="Aptos"/>
               </a:rPr>
-              <a:t>UniMoral cue, language, and scenario-source claims are not available in the local run.</a:t>
+              <a:t>Our UniMoral run does not test prompt hints, language differences, or where the stories came from.</a:t>
             </a:r>
           </a:p>
         </p:txBody>
@@ -7138,7 +7220,7 @@
     </p:spTree>
     <p:extLst>
       <p:ext uri="{BB962C8B-B14F-4D97-AF65-F5344CB8AC3E}">
-        <p14:creationId xmlns:p14="http://schemas.microsoft.com/office/powerpoint/2010/main" val="997149543"/>
+        <p14:creationId xmlns:p14="http://schemas.microsoft.com/office/powerpoint/2010/main" val="1336127272"/>
       </p:ext>
     </p:extLst>
   </p:cSld>
@@ -7169,7 +7251,7 @@
           <p:cNvPr id="8" name="slide-title">
             <a:extLst xmlns:a="http://schemas.openxmlformats.org/drawingml/2006/main">
               <a:ext uri="{FF2B5EF4-FFF2-40B4-BE49-F238E27FC236}">
-                <a16:creationId xmlns:a16="http://schemas.microsoft.com/office/drawing/2014/main" id="{0AF2C606-CFC7-4F8D-82DB-72F0F409433E}"/>
+                <a16:creationId xmlns:a16="http://schemas.microsoft.com/office/drawing/2014/main" id="{1B9F74D4-4408-4233-92A9-D28D0E9ABC71}"/>
               </a:ext>
             </a:extLst>
           </p:cNvPr>
@@ -7216,7 +7298,7 @@
                 <a:ea typeface="Aptos"/>
                 <a:cs typeface="Aptos"/>
               </a:rPr>
-              <a:t>Fix the measurement before adding more models</a:t>
+              <a:t>Make the test stronger before adding more models</a:t>
             </a:r>
           </a:p>
         </p:txBody>
@@ -7226,7 +7308,7 @@
           <p:cNvPr id="2" name="slide-subtitle">
             <a:extLst xmlns:a="http://schemas.openxmlformats.org/drawingml/2006/main">
               <a:ext uri="{FF2B5EF4-FFF2-40B4-BE49-F238E27FC236}">
-                <a16:creationId xmlns:a16="http://schemas.microsoft.com/office/drawing/2014/main" id="{B98CB176-7479-48FC-AF6D-8753EE8DF4D4}"/>
+                <a16:creationId xmlns:a16="http://schemas.microsoft.com/office/drawing/2014/main" id="{C9A9BC2D-D396-4255-B212-E8132F401054}"/>
               </a:ext>
             </a:extLst>
           </p:cNvPr>
@@ -7283,7 +7365,7 @@
           <p:cNvPr id="3" name="">
             <a:extLst xmlns:a="http://schemas.openxmlformats.org/drawingml/2006/main">
               <a:ext uri="{FF2B5EF4-FFF2-40B4-BE49-F238E27FC236}">
-                <a16:creationId xmlns:a16="http://schemas.microsoft.com/office/drawing/2014/main" id="{3F5A911F-0853-4CB2-B23D-05133CD51AB1}"/>
+                <a16:creationId xmlns:a16="http://schemas.microsoft.com/office/drawing/2014/main" id="{FE142CBF-075F-4AC6-8745-7815CEB498F3}"/>
               </a:ext>
             </a:extLst>
           </p:cNvPr>
@@ -7344,7 +7426,7 @@
           <p:cNvPr id="4" name="">
             <a:extLst xmlns:a="http://schemas.openxmlformats.org/drawingml/2006/main">
               <a:ext uri="{FF2B5EF4-FFF2-40B4-BE49-F238E27FC236}">
-                <a16:creationId xmlns:a16="http://schemas.microsoft.com/office/drawing/2014/main" id="{BCB022D4-04E8-4D84-ACAD-7E2D19B2846F}"/>
+                <a16:creationId xmlns:a16="http://schemas.microsoft.com/office/drawing/2014/main" id="{D67FF727-0E62-404F-9EC2-5408E27F7FAF}"/>
               </a:ext>
             </a:extLst>
           </p:cNvPr>
@@ -7502,7 +7584,7 @@
                           <a:ea typeface="Aptos"/>
                           <a:cs typeface="Aptos"/>
                         </a:rPr>
-                        <a:t>Publish task panels with their limits</a:t>
+                        <a:t>Share each task result with its limits</a:t>
                       </a:r>
                     </a:p>
                   </a:txBody>
@@ -7526,7 +7608,7 @@
                           <a:ea typeface="Aptos"/>
                           <a:cs typeface="Aptos"/>
                         </a:rPr>
-                        <a:t>The current aggregates answer task-level questions</a:t>
+                        <a:t>The saved results answer one task at a time</a:t>
                       </a:r>
                     </a:p>
                   </a:txBody>
@@ -7576,7 +7658,7 @@
                           <a:ea typeface="Aptos"/>
                           <a:cs typeface="Aptos"/>
                         </a:rPr>
-                        <a:t>Recover same-item results; check parsing and labels</a:t>
+                        <a:t>Compare the same questions; check that answers were read and labeled correctly</a:t>
                       </a:r>
                     </a:p>
                   </a:txBody>
@@ -7600,7 +7682,7 @@
                           <a:ea typeface="Aptos"/>
                           <a:cs typeface="Aptos"/>
                         </a:rPr>
-                        <a:t>This targets the main precision and measurement gaps</a:t>
+                        <a:t>This tackles the biggest gaps</a:t>
                       </a:r>
                     </a:p>
                   </a:txBody>
@@ -7626,7 +7708,7 @@
                           <a:ea typeface="Aptos"/>
                           <a:cs typeface="Aptos"/>
                         </a:rPr>
-                        <a:t>Next</a:t>
+                        <a:t>Then</a:t>
                       </a:r>
                     </a:p>
                   </a:txBody>
@@ -7650,7 +7732,7 @@
                           <a:ea typeface="Aptos"/>
                           <a:cs typeface="Aptos"/>
                         </a:rPr>
-                        <a:t>Run the planned human review</a:t>
+                        <a:t>Have people review the test</a:t>
                       </a:r>
                     </a:p>
                   </a:txBody>
@@ -7674,7 +7756,7 @@
                           <a:ea typeface="Aptos"/>
                           <a:cs typeface="Aptos"/>
                         </a:rPr>
-                        <a:t>Benchmark agreement is not human validity</a:t>
+                        <a:t>A benchmark score does not prove the test matches human judgment</a:t>
                       </a:r>
                     </a:p>
                   </a:txBody>
@@ -7724,7 +7806,7 @@
                           <a:ea typeface="Aptos"/>
                           <a:cs typeface="Aptos"/>
                         </a:rPr>
-                        <a:t>Expand the comparison item banks</a:t>
+                        <a:t>Add more comparison questions</a:t>
                       </a:r>
                     </a:p>
                   </a:txBody>
@@ -7748,7 +7830,7 @@
                           <a:ea typeface="Aptos"/>
                           <a:cs typeface="Aptos"/>
                         </a:rPr>
-                        <a:t>New items help only after the measurement is stable</a:t>
+                        <a:t>New questions help after the scoring works correctly</a:t>
                       </a:r>
                     </a:p>
                   </a:txBody>
@@ -7768,7 +7850,7 @@
           <p:cNvPr id="6" name="">
             <a:extLst xmlns:a="http://schemas.openxmlformats.org/drawingml/2006/main">
               <a:ext uri="{FF2B5EF4-FFF2-40B4-BE49-F238E27FC236}">
-                <a16:creationId xmlns:a16="http://schemas.microsoft.com/office/drawing/2014/main" id="{8372ECB5-38D4-4C29-A51E-E64E9512AD87}"/>
+                <a16:creationId xmlns:a16="http://schemas.microsoft.com/office/drawing/2014/main" id="{C69FD85C-47A1-495B-AF16-E87043A5A2D1}"/>
               </a:ext>
             </a:extLst>
           </p:cNvPr>
@@ -7825,7 +7907,7 @@
           <p:cNvPr id="7" name="">
             <a:extLst xmlns:a="http://schemas.openxmlformats.org/drawingml/2006/main">
               <a:ext uri="{FF2B5EF4-FFF2-40B4-BE49-F238E27FC236}">
-                <a16:creationId xmlns:a16="http://schemas.microsoft.com/office/drawing/2014/main" id="{DA65BED2-B613-4D32-A152-0E919B43AF3D}"/>
+                <a16:creationId xmlns:a16="http://schemas.microsoft.com/office/drawing/2014/main" id="{5621AECF-39CA-4FA2-997F-945A73348A77}"/>
               </a:ext>
             </a:extLst>
           </p:cNvPr>
@@ -7872,7 +7954,7 @@
                 <a:ea typeface="Aptos"/>
                 <a:cs typeface="Aptos"/>
               </a:rPr>
-              <a:t>Compare models on the same items, then complete human validation.</a:t>
+              <a:t>Compare models on the same questions. Then have people review the test.</a:t>
             </a:r>
           </a:p>
         </p:txBody>
@@ -7880,7 +7962,7 @@
     </p:spTree>
     <p:extLst>
       <p:ext uri="{BB962C8B-B14F-4D97-AF65-F5344CB8AC3E}">
-        <p14:creationId xmlns:p14="http://schemas.microsoft.com/office/powerpoint/2010/main" val="572413030"/>
+        <p14:creationId xmlns:p14="http://schemas.microsoft.com/office/powerpoint/2010/main" val="1865674994"/>
       </p:ext>
     </p:extLst>
   </p:cSld>

</xml_diff>

<commit_message>
Simplify research-lead result handoff
</commit_message>
<xml_diff>
--- a/slides/cei-moral-psychology-results-deck.pptx
+++ b/slides/cei-moral-psychology-results-deck.pptx
@@ -2,20 +2,20 @@
 <file path=ppt/presentation.xml><?xml version="1.0" encoding="utf-8"?>
 <p:presentation xmlns:p="http://schemas.openxmlformats.org/presentationml/2006/main">
   <p:sldMasterIdLst>
-    <p:sldMasterId xmlns:r="http://schemas.openxmlformats.org/officeDocument/2006/relationships" id="2147483648" r:id="Rd743908979ba41cd"/>
+    <p:sldMasterId xmlns:r="http://schemas.openxmlformats.org/officeDocument/2006/relationships" id="2147483648" r:id="R87d682eb43bc4c71"/>
   </p:sldMasterIdLst>
   <p:notesMasterIdLst>
-    <p:notesMasterId xmlns:r="http://schemas.openxmlformats.org/officeDocument/2006/relationships" r:id="Rfef57cda9edc477b"/>
+    <p:notesMasterId xmlns:r="http://schemas.openxmlformats.org/officeDocument/2006/relationships" r:id="R1e75c533c741418a"/>
   </p:notesMasterIdLst>
   <p:sldIdLst>
-    <p:sldId xmlns:r="http://schemas.openxmlformats.org/officeDocument/2006/relationships" id="256" r:id="R0b47971cee7540d9"/>
-    <p:sldId xmlns:r="http://schemas.openxmlformats.org/officeDocument/2006/relationships" id="257" r:id="Rd9725a86a6534f7a"/>
-    <p:sldId xmlns:r="http://schemas.openxmlformats.org/officeDocument/2006/relationships" id="258" r:id="Re1690afcb4824cd3"/>
-    <p:sldId xmlns:r="http://schemas.openxmlformats.org/officeDocument/2006/relationships" id="259" r:id="Re2b157b5c1ee4e74"/>
-    <p:sldId xmlns:r="http://schemas.openxmlformats.org/officeDocument/2006/relationships" id="260" r:id="Rdf1cc101613443bd"/>
-    <p:sldId xmlns:r="http://schemas.openxmlformats.org/officeDocument/2006/relationships" id="261" r:id="R25c7a59078124659"/>
-    <p:sldId xmlns:r="http://schemas.openxmlformats.org/officeDocument/2006/relationships" id="262" r:id="R7c13019639f04394"/>
-    <p:sldId xmlns:r="http://schemas.openxmlformats.org/officeDocument/2006/relationships" id="263" r:id="Rffbfea72a9a74e0b"/>
+    <p:sldId xmlns:r="http://schemas.openxmlformats.org/officeDocument/2006/relationships" id="256" r:id="Rb80bd4b49520466f"/>
+    <p:sldId xmlns:r="http://schemas.openxmlformats.org/officeDocument/2006/relationships" id="257" r:id="Rdfb44b29abab4078"/>
+    <p:sldId xmlns:r="http://schemas.openxmlformats.org/officeDocument/2006/relationships" id="258" r:id="R7eb52cbbe6c1494e"/>
+    <p:sldId xmlns:r="http://schemas.openxmlformats.org/officeDocument/2006/relationships" id="259" r:id="Rfaae51fd549c41f0"/>
+    <p:sldId xmlns:r="http://schemas.openxmlformats.org/officeDocument/2006/relationships" id="260" r:id="R5550b65903d840fc"/>
+    <p:sldId xmlns:r="http://schemas.openxmlformats.org/officeDocument/2006/relationships" id="261" r:id="R62f7ecdf472b478a"/>
+    <p:sldId xmlns:r="http://schemas.openxmlformats.org/officeDocument/2006/relationships" id="262" r:id="R0dfe3f135809421e"/>
+    <p:sldId xmlns:r="http://schemas.openxmlformats.org/officeDocument/2006/relationships" id="263" r:id="Rf92c9d2b89264f8c"/>
   </p:sldIdLst>
   <p:sldSz cx="12192000" cy="6858000"/>
   <p:notesSz cx="6858000" cy="9144000"/>
@@ -1142,7 +1142,7 @@
   </p:cSld>
   <p:clrMap bg1="lt1" tx1="dk1" bg2="lt2" tx2="dk2" accent1="accent1" accent2="accent2" accent3="accent3" accent4="accent4" accent5="accent5" accent6="accent6" hlink="hlink" folHlink="folHlink"/>
   <p:sldLayoutIdLst>
-    <p:sldLayoutId xmlns:r="http://schemas.openxmlformats.org/officeDocument/2006/relationships" id="2147483649" r:id="R18b66c07dfed4c1b"/>
+    <p:sldLayoutId xmlns:r="http://schemas.openxmlformats.org/officeDocument/2006/relationships" id="2147483649" r:id="R8b6518ddc8e14be5"/>
   </p:sldLayoutIdLst>
   <p:txStyles>
     <p:titleStyle>
@@ -3118,7 +3118,7 @@
           <p:cNvPr id="7" name="cover-title">
             <a:extLst xmlns:a="http://schemas.openxmlformats.org/drawingml/2006/main">
               <a:ext uri="{FF2B5EF4-FFF2-40B4-BE49-F238E27FC236}">
-                <a16:creationId xmlns:a16="http://schemas.microsoft.com/office/drawing/2014/main" id="{904004A8-C44E-4DDD-BEE1-B68CCD211089}"/>
+                <a16:creationId xmlns:a16="http://schemas.microsoft.com/office/drawing/2014/main" id="{71BDFBBA-1BBB-4A27-97AE-EAB169345CAE}"/>
               </a:ext>
             </a:extLst>
           </p:cNvPr>
@@ -3198,7 +3198,7 @@
           <p:cNvPr id="2" name="">
             <a:extLst xmlns:a="http://schemas.openxmlformats.org/drawingml/2006/main">
               <a:ext uri="{FF2B5EF4-FFF2-40B4-BE49-F238E27FC236}">
-                <a16:creationId xmlns:a16="http://schemas.microsoft.com/office/drawing/2014/main" id="{524C7F9C-68A8-42FA-A695-EDC576DEA518}"/>
+                <a16:creationId xmlns:a16="http://schemas.microsoft.com/office/drawing/2014/main" id="{0785032F-790C-4DC0-AC1A-30C538E2897A}"/>
               </a:ext>
             </a:extLst>
           </p:cNvPr>
@@ -3255,7 +3255,7 @@
           <p:cNvPr id="3" name="">
             <a:extLst xmlns:a="http://schemas.openxmlformats.org/drawingml/2006/main">
               <a:ext uri="{FF2B5EF4-FFF2-40B4-BE49-F238E27FC236}">
-                <a16:creationId xmlns:a16="http://schemas.microsoft.com/office/drawing/2014/main" id="{D00D8470-E92E-496F-AC36-5A043370D52E}"/>
+                <a16:creationId xmlns:a16="http://schemas.microsoft.com/office/drawing/2014/main" id="{FE79FA21-70B9-47BB-8A67-F6B6C1DD59FE}"/>
               </a:ext>
             </a:extLst>
           </p:cNvPr>
@@ -3312,7 +3312,7 @@
           <p:cNvPr id="4" name="">
             <a:extLst xmlns:a="http://schemas.openxmlformats.org/drawingml/2006/main">
               <a:ext uri="{FF2B5EF4-FFF2-40B4-BE49-F238E27FC236}">
-                <a16:creationId xmlns:a16="http://schemas.microsoft.com/office/drawing/2014/main" id="{2FFABF7F-5854-4F75-8118-47FDD9D07BE3}"/>
+                <a16:creationId xmlns:a16="http://schemas.microsoft.com/office/drawing/2014/main" id="{F17EF62D-E18D-4C74-A53F-2E27F097D1C2}"/>
               </a:ext>
             </a:extLst>
           </p:cNvPr>
@@ -3343,7 +3343,7 @@
           <p:cNvPr id="5" name="">
             <a:extLst xmlns:a="http://schemas.openxmlformats.org/drawingml/2006/main">
               <a:ext uri="{FF2B5EF4-FFF2-40B4-BE49-F238E27FC236}">
-                <a16:creationId xmlns:a16="http://schemas.microsoft.com/office/drawing/2014/main" id="{0F94BC22-20E4-400A-BBBA-4E8EAA412184}"/>
+                <a16:creationId xmlns:a16="http://schemas.microsoft.com/office/drawing/2014/main" id="{18604258-485C-4293-8A23-FBC0771FC6EB}"/>
               </a:ext>
             </a:extLst>
           </p:cNvPr>
@@ -3400,7 +3400,7 @@
           <p:cNvPr id="6" name="">
             <a:extLst xmlns:a="http://schemas.openxmlformats.org/drawingml/2006/main">
               <a:ext uri="{FF2B5EF4-FFF2-40B4-BE49-F238E27FC236}">
-                <a16:creationId xmlns:a16="http://schemas.microsoft.com/office/drawing/2014/main" id="{0BB557F3-C0DF-43FD-86EE-1BC2C117F43D}"/>
+                <a16:creationId xmlns:a16="http://schemas.microsoft.com/office/drawing/2014/main" id="{CB08836F-58C5-4CCA-A5EE-6EC0DA6B37D0}"/>
               </a:ext>
             </a:extLst>
           </p:cNvPr>
@@ -3455,7 +3455,7 @@
     </p:spTree>
     <p:extLst>
       <p:ext uri="{BB962C8B-B14F-4D97-AF65-F5344CB8AC3E}">
-        <p14:creationId xmlns:p14="http://schemas.microsoft.com/office/powerpoint/2010/main" val="183038892"/>
+        <p14:creationId xmlns:p14="http://schemas.microsoft.com/office/powerpoint/2010/main" val="1571040779"/>
       </p:ext>
     </p:extLst>
   </p:cSld>
@@ -3486,7 +3486,7 @@
           <p:cNvPr id="8" name="slide-title">
             <a:extLst xmlns:a="http://schemas.openxmlformats.org/drawingml/2006/main">
               <a:ext uri="{FF2B5EF4-FFF2-40B4-BE49-F238E27FC236}">
-                <a16:creationId xmlns:a16="http://schemas.microsoft.com/office/drawing/2014/main" id="{6CAD0337-2C3A-455E-92BE-29D9D71D133F}"/>
+                <a16:creationId xmlns:a16="http://schemas.microsoft.com/office/drawing/2014/main" id="{9ADE1A5A-DC84-49BE-8543-E196E2FAF9B1}"/>
               </a:ext>
             </a:extLst>
           </p:cNvPr>
@@ -3543,7 +3543,7 @@
           <p:cNvPr id="2" name="slide-subtitle">
             <a:extLst xmlns:a="http://schemas.openxmlformats.org/drawingml/2006/main">
               <a:ext uri="{FF2B5EF4-FFF2-40B4-BE49-F238E27FC236}">
-                <a16:creationId xmlns:a16="http://schemas.microsoft.com/office/drawing/2014/main" id="{4B6113F3-8D1C-4EC9-A2B5-F67D79BCF3A2}"/>
+                <a16:creationId xmlns:a16="http://schemas.microsoft.com/office/drawing/2014/main" id="{280A0940-1ECB-420D-B9F2-E85A3B766F4D}"/>
               </a:ext>
             </a:extLst>
           </p:cNvPr>
@@ -3600,7 +3600,7 @@
           <p:cNvPr id="3" name="">
             <a:extLst xmlns:a="http://schemas.openxmlformats.org/drawingml/2006/main">
               <a:ext uri="{FF2B5EF4-FFF2-40B4-BE49-F238E27FC236}">
-                <a16:creationId xmlns:a16="http://schemas.microsoft.com/office/drawing/2014/main" id="{9E2B6D97-4D7B-4235-B089-5456CC9694B4}"/>
+                <a16:creationId xmlns:a16="http://schemas.microsoft.com/office/drawing/2014/main" id="{31B45130-8CE3-42DB-9A08-1CA71C7D12FD}"/>
               </a:ext>
             </a:extLst>
           </p:cNvPr>
@@ -3661,7 +3661,7 @@
           <p:cNvPr id="4" name="">
             <a:extLst xmlns:a="http://schemas.openxmlformats.org/drawingml/2006/main">
               <a:ext uri="{FF2B5EF4-FFF2-40B4-BE49-F238E27FC236}">
-                <a16:creationId xmlns:a16="http://schemas.microsoft.com/office/drawing/2014/main" id="{9ACE22B2-5EC9-4BC5-90B4-EE3C3F385175}"/>
+                <a16:creationId xmlns:a16="http://schemas.microsoft.com/office/drawing/2014/main" id="{86EC3C02-6882-41ED-810B-080731AB9F04}"/>
               </a:ext>
             </a:extLst>
           </p:cNvPr>
@@ -4598,7 +4598,7 @@
           <p:cNvPr id="6" name="">
             <a:extLst xmlns:a="http://schemas.openxmlformats.org/drawingml/2006/main">
               <a:ext uri="{FF2B5EF4-FFF2-40B4-BE49-F238E27FC236}">
-                <a16:creationId xmlns:a16="http://schemas.microsoft.com/office/drawing/2014/main" id="{7E7B8E36-631C-448B-856F-72FE697D5B10}"/>
+                <a16:creationId xmlns:a16="http://schemas.microsoft.com/office/drawing/2014/main" id="{D8584922-6DE9-4B53-B383-9E2C07F1D122}"/>
               </a:ext>
             </a:extLst>
           </p:cNvPr>
@@ -4655,7 +4655,7 @@
           <p:cNvPr id="7" name="">
             <a:extLst xmlns:a="http://schemas.openxmlformats.org/drawingml/2006/main">
               <a:ext uri="{FF2B5EF4-FFF2-40B4-BE49-F238E27FC236}">
-                <a16:creationId xmlns:a16="http://schemas.microsoft.com/office/drawing/2014/main" id="{8F5BDA72-ABE0-4EF8-A272-EB933AB20DED}"/>
+                <a16:creationId xmlns:a16="http://schemas.microsoft.com/office/drawing/2014/main" id="{A4B8307F-09CE-4BCB-ABD0-B610BEFBA9E6}"/>
               </a:ext>
             </a:extLst>
           </p:cNvPr>
@@ -4710,7 +4710,7 @@
     </p:spTree>
     <p:extLst>
       <p:ext uri="{BB962C8B-B14F-4D97-AF65-F5344CB8AC3E}">
-        <p14:creationId xmlns:p14="http://schemas.microsoft.com/office/powerpoint/2010/main" val="614573302"/>
+        <p14:creationId xmlns:p14="http://schemas.microsoft.com/office/powerpoint/2010/main" val="1621060186"/>
       </p:ext>
     </p:extLst>
   </p:cSld>
@@ -4741,7 +4741,7 @@
           <p:cNvPr id="8" name="slide-title">
             <a:extLst xmlns:a="http://schemas.openxmlformats.org/drawingml/2006/main">
               <a:ext uri="{FF2B5EF4-FFF2-40B4-BE49-F238E27FC236}">
-                <a16:creationId xmlns:a16="http://schemas.microsoft.com/office/drawing/2014/main" id="{0F268666-EB7B-4EB2-8C6A-F498FECF5C39}"/>
+                <a16:creationId xmlns:a16="http://schemas.microsoft.com/office/drawing/2014/main" id="{69F1139C-2A96-4B0B-8450-5A5CC97BC017}"/>
               </a:ext>
             </a:extLst>
           </p:cNvPr>
@@ -4798,7 +4798,7 @@
           <p:cNvPr id="2" name="slide-subtitle">
             <a:extLst xmlns:a="http://schemas.openxmlformats.org/drawingml/2006/main">
               <a:ext uri="{FF2B5EF4-FFF2-40B4-BE49-F238E27FC236}">
-                <a16:creationId xmlns:a16="http://schemas.microsoft.com/office/drawing/2014/main" id="{D8FCDE4A-998E-42DC-BD2B-52BDE2DE10EE}"/>
+                <a16:creationId xmlns:a16="http://schemas.microsoft.com/office/drawing/2014/main" id="{5B984043-4D83-4B6C-8640-F883A3C12629}"/>
               </a:ext>
             </a:extLst>
           </p:cNvPr>
@@ -4855,7 +4855,7 @@
           <p:cNvPr id="3" name="">
             <a:extLst xmlns:a="http://schemas.openxmlformats.org/drawingml/2006/main">
               <a:ext uri="{FF2B5EF4-FFF2-40B4-BE49-F238E27FC236}">
-                <a16:creationId xmlns:a16="http://schemas.microsoft.com/office/drawing/2014/main" id="{C88C5B53-9685-424C-931D-A00E03652B07}"/>
+                <a16:creationId xmlns:a16="http://schemas.microsoft.com/office/drawing/2014/main" id="{DA75280A-EE1D-4259-BBDF-FBE8E5388DF2}"/>
               </a:ext>
             </a:extLst>
           </p:cNvPr>
@@ -4916,7 +4916,7 @@
           <p:cNvPr id="4" name="">
             <a:extLst xmlns:a="http://schemas.openxmlformats.org/drawingml/2006/main">
               <a:ext uri="{FF2B5EF4-FFF2-40B4-BE49-F238E27FC236}">
-                <a16:creationId xmlns:a16="http://schemas.microsoft.com/office/drawing/2014/main" id="{D5BC1DBE-93FC-4738-9DA9-B7C6F5F7EE02}"/>
+                <a16:creationId xmlns:a16="http://schemas.microsoft.com/office/drawing/2014/main" id="{04089F06-2202-4DC5-AE58-D305D8EE952B}"/>
               </a:ext>
             </a:extLst>
           </p:cNvPr>
@@ -4954,7 +4954,7 @@
         </p:xfrm>
         <a:graphic xmlns:a="http://schemas.openxmlformats.org/drawingml/2006/main">
           <a:graphicData uri="http://schemas.openxmlformats.org/drawingml/2006/chart">
-            <c:chart xmlns:r="http://schemas.openxmlformats.org/officeDocument/2006/relationships" xmlns:c="http://schemas.openxmlformats.org/drawingml/2006/chart" r:id="R50d862d518b3432f"/>
+            <c:chart xmlns:r="http://schemas.openxmlformats.org/officeDocument/2006/relationships" xmlns:c="http://schemas.openxmlformats.org/drawingml/2006/chart" r:id="Ra654c57b30ed4ea6"/>
           </a:graphicData>
         </a:graphic>
       </p:graphicFrame>
@@ -4963,7 +4963,7 @@
           <p:cNvPr id="6" name="">
             <a:extLst xmlns:a="http://schemas.openxmlformats.org/drawingml/2006/main">
               <a:ext uri="{FF2B5EF4-FFF2-40B4-BE49-F238E27FC236}">
-                <a16:creationId xmlns:a16="http://schemas.microsoft.com/office/drawing/2014/main" id="{C66FC219-BD91-437C-8977-2E1A0A3F0FB1}"/>
+                <a16:creationId xmlns:a16="http://schemas.microsoft.com/office/drawing/2014/main" id="{AA836533-2708-49D8-A904-9ADF2FA64EA0}"/>
               </a:ext>
             </a:extLst>
           </p:cNvPr>
@@ -4975,7 +4975,7 @@
         <p:spPr>
           <a:xfrm xmlns:a="http://schemas.openxmlformats.org/drawingml/2006/main">
             <a:off x="1143000" y="5676900"/>
-            <a:ext cx="7429500" cy="323850"/>
+            <a:ext cx="9334500" cy="323850"/>
           </a:xfrm>
           <a:prstGeom xmlns:a="http://schemas.openxmlformats.org/drawingml/2006/main" prst="rect">
             <a:avLst/>
@@ -5010,7 +5010,7 @@
                 <a:ea typeface="Aptos"/>
                 <a:cs typeface="Aptos"/>
               </a:rPr>
-              <a:t>Action: compare every model on the same questions.</a:t>
+              <a:t>Action: recover each question's result, then compare models question by question.</a:t>
             </a:r>
           </a:p>
         </p:txBody>
@@ -5020,7 +5020,7 @@
           <p:cNvPr id="7" name="">
             <a:extLst xmlns:a="http://schemas.openxmlformats.org/drawingml/2006/main">
               <a:ext uri="{FF2B5EF4-FFF2-40B4-BE49-F238E27FC236}">
-                <a16:creationId xmlns:a16="http://schemas.microsoft.com/office/drawing/2014/main" id="{23508C21-58DB-45AF-8B89-ADE4B9F10F1A}"/>
+                <a16:creationId xmlns:a16="http://schemas.microsoft.com/office/drawing/2014/main" id="{AD84C9BB-90DF-48BD-8BD6-21871F564AB7}"/>
               </a:ext>
             </a:extLst>
           </p:cNvPr>
@@ -5075,7 +5075,7 @@
     </p:spTree>
     <p:extLst>
       <p:ext uri="{BB962C8B-B14F-4D97-AF65-F5344CB8AC3E}">
-        <p14:creationId xmlns:p14="http://schemas.microsoft.com/office/powerpoint/2010/main" val="489266278"/>
+        <p14:creationId xmlns:p14="http://schemas.microsoft.com/office/powerpoint/2010/main" val="1091227383"/>
       </p:ext>
     </p:extLst>
   </p:cSld>
@@ -5106,7 +5106,7 @@
           <p:cNvPr id="8" name="slide-title">
             <a:extLst xmlns:a="http://schemas.openxmlformats.org/drawingml/2006/main">
               <a:ext uri="{FF2B5EF4-FFF2-40B4-BE49-F238E27FC236}">
-                <a16:creationId xmlns:a16="http://schemas.microsoft.com/office/drawing/2014/main" id="{2CEEA952-47BC-4548-9C9B-7EFA481FE886}"/>
+                <a16:creationId xmlns:a16="http://schemas.microsoft.com/office/drawing/2014/main" id="{E7CA2F41-4F39-4D63-A013-E1282DB1EED8}"/>
               </a:ext>
             </a:extLst>
           </p:cNvPr>
@@ -5163,7 +5163,7 @@
           <p:cNvPr id="2" name="slide-subtitle">
             <a:extLst xmlns:a="http://schemas.openxmlformats.org/drawingml/2006/main">
               <a:ext uri="{FF2B5EF4-FFF2-40B4-BE49-F238E27FC236}">
-                <a16:creationId xmlns:a16="http://schemas.microsoft.com/office/drawing/2014/main" id="{9C565053-3386-4110-B086-A19EC6502B7E}"/>
+                <a16:creationId xmlns:a16="http://schemas.microsoft.com/office/drawing/2014/main" id="{165581A4-53D8-4AE0-9F46-A7FC224DEACA}"/>
               </a:ext>
             </a:extLst>
           </p:cNvPr>
@@ -5220,7 +5220,7 @@
           <p:cNvPr id="3" name="">
             <a:extLst xmlns:a="http://schemas.openxmlformats.org/drawingml/2006/main">
               <a:ext uri="{FF2B5EF4-FFF2-40B4-BE49-F238E27FC236}">
-                <a16:creationId xmlns:a16="http://schemas.microsoft.com/office/drawing/2014/main" id="{CBEB616C-C59E-496E-BA0C-2A79031EE6A2}"/>
+                <a16:creationId xmlns:a16="http://schemas.microsoft.com/office/drawing/2014/main" id="{4ACE4871-B004-4AEC-8D97-CB8C87B2EF84}"/>
               </a:ext>
             </a:extLst>
           </p:cNvPr>
@@ -5281,7 +5281,7 @@
           <p:cNvPr id="4" name="">
             <a:extLst xmlns:a="http://schemas.openxmlformats.org/drawingml/2006/main">
               <a:ext uri="{FF2B5EF4-FFF2-40B4-BE49-F238E27FC236}">
-                <a16:creationId xmlns:a16="http://schemas.microsoft.com/office/drawing/2014/main" id="{287CE98F-6808-4B0A-8B00-11D5C13AFA8E}"/>
+                <a16:creationId xmlns:a16="http://schemas.microsoft.com/office/drawing/2014/main" id="{28FCD4AB-B8BF-4D9A-8249-D59DAE34818D}"/>
               </a:ext>
             </a:extLst>
           </p:cNvPr>
@@ -5319,7 +5319,7 @@
         </p:xfrm>
         <a:graphic xmlns:a="http://schemas.openxmlformats.org/drawingml/2006/main">
           <a:graphicData uri="http://schemas.openxmlformats.org/drawingml/2006/chart">
-            <c:chart xmlns:r="http://schemas.openxmlformats.org/officeDocument/2006/relationships" xmlns:c="http://schemas.openxmlformats.org/drawingml/2006/chart" r:id="R7b0283ef3b88497c"/>
+            <c:chart xmlns:r="http://schemas.openxmlformats.org/officeDocument/2006/relationships" xmlns:c="http://schemas.openxmlformats.org/drawingml/2006/chart" r:id="R83eb1c4e4ae94c76"/>
           </a:graphicData>
         </a:graphic>
       </p:graphicFrame>
@@ -5328,7 +5328,7 @@
           <p:cNvPr id="6" name="">
             <a:extLst xmlns:a="http://schemas.openxmlformats.org/drawingml/2006/main">
               <a:ext uri="{FF2B5EF4-FFF2-40B4-BE49-F238E27FC236}">
-                <a16:creationId xmlns:a16="http://schemas.microsoft.com/office/drawing/2014/main" id="{51856DED-2486-4678-93AF-12FA4E9BEBF9}"/>
+                <a16:creationId xmlns:a16="http://schemas.microsoft.com/office/drawing/2014/main" id="{59D949A8-B780-40DE-B7FC-B1DB354CB06E}"/>
               </a:ext>
             </a:extLst>
           </p:cNvPr>
@@ -5385,7 +5385,7 @@
           <p:cNvPr id="7" name="">
             <a:extLst xmlns:a="http://schemas.openxmlformats.org/drawingml/2006/main">
               <a:ext uri="{FF2B5EF4-FFF2-40B4-BE49-F238E27FC236}">
-                <a16:creationId xmlns:a16="http://schemas.microsoft.com/office/drawing/2014/main" id="{0A256135-D645-49D5-B848-CCF8FAD64E9C}"/>
+                <a16:creationId xmlns:a16="http://schemas.microsoft.com/office/drawing/2014/main" id="{74DFD8D2-974F-4B4A-AF78-7DE898D2B90D}"/>
               </a:ext>
             </a:extLst>
           </p:cNvPr>
@@ -5440,7 +5440,7 @@
     </p:spTree>
     <p:extLst>
       <p:ext uri="{BB962C8B-B14F-4D97-AF65-F5344CB8AC3E}">
-        <p14:creationId xmlns:p14="http://schemas.microsoft.com/office/powerpoint/2010/main" val="1055896846"/>
+        <p14:creationId xmlns:p14="http://schemas.microsoft.com/office/powerpoint/2010/main" val="890155560"/>
       </p:ext>
     </p:extLst>
   </p:cSld>
@@ -5471,7 +5471,7 @@
           <p:cNvPr id="7" name="slide-title">
             <a:extLst xmlns:a="http://schemas.openxmlformats.org/drawingml/2006/main">
               <a:ext uri="{FF2B5EF4-FFF2-40B4-BE49-F238E27FC236}">
-                <a16:creationId xmlns:a16="http://schemas.microsoft.com/office/drawing/2014/main" id="{38F729F3-5CA7-407E-A101-7D38EE0207B5}"/>
+                <a16:creationId xmlns:a16="http://schemas.microsoft.com/office/drawing/2014/main" id="{5A833F22-6F32-4CB5-9958-71CB3A5ECEE7}"/>
               </a:ext>
             </a:extLst>
           </p:cNvPr>
@@ -5528,7 +5528,7 @@
           <p:cNvPr id="2" name="">
             <a:extLst xmlns:a="http://schemas.openxmlformats.org/drawingml/2006/main">
               <a:ext uri="{FF2B5EF4-FFF2-40B4-BE49-F238E27FC236}">
-                <a16:creationId xmlns:a16="http://schemas.microsoft.com/office/drawing/2014/main" id="{8D753426-D82C-4FD6-BC59-13792041F5C5}"/>
+                <a16:creationId xmlns:a16="http://schemas.microsoft.com/office/drawing/2014/main" id="{3F04D9B9-6E15-40C4-9E64-5594C05FB5C6}"/>
               </a:ext>
             </a:extLst>
           </p:cNvPr>
@@ -5589,7 +5589,7 @@
           <p:cNvPr id="3" name="">
             <a:extLst xmlns:a="http://schemas.openxmlformats.org/drawingml/2006/main">
               <a:ext uri="{FF2B5EF4-FFF2-40B4-BE49-F238E27FC236}">
-                <a16:creationId xmlns:a16="http://schemas.microsoft.com/office/drawing/2014/main" id="{C2ECF6D9-021C-484B-A25D-B9B955E4521F}"/>
+                <a16:creationId xmlns:a16="http://schemas.microsoft.com/office/drawing/2014/main" id="{2895F9A3-D56F-476B-BDE2-4C56FB20FE12}"/>
               </a:ext>
             </a:extLst>
           </p:cNvPr>
@@ -5627,7 +5627,7 @@
         </p:xfrm>
         <a:graphic xmlns:a="http://schemas.openxmlformats.org/drawingml/2006/main">
           <a:graphicData uri="http://schemas.openxmlformats.org/drawingml/2006/chart">
-            <c:chart xmlns:r="http://schemas.openxmlformats.org/officeDocument/2006/relationships" xmlns:c="http://schemas.openxmlformats.org/drawingml/2006/chart" r:id="R8a5e35d920fb4111"/>
+            <c:chart xmlns:r="http://schemas.openxmlformats.org/officeDocument/2006/relationships" xmlns:c="http://schemas.openxmlformats.org/drawingml/2006/chart" r:id="R0f11e802663e408e"/>
           </a:graphicData>
         </a:graphic>
       </p:graphicFrame>
@@ -5636,7 +5636,7 @@
           <p:cNvPr id="5" name="">
             <a:extLst xmlns:a="http://schemas.openxmlformats.org/drawingml/2006/main">
               <a:ext uri="{FF2B5EF4-FFF2-40B4-BE49-F238E27FC236}">
-                <a16:creationId xmlns:a16="http://schemas.microsoft.com/office/drawing/2014/main" id="{F994DA10-7887-49B7-8804-C2CCD0D24831}"/>
+                <a16:creationId xmlns:a16="http://schemas.microsoft.com/office/drawing/2014/main" id="{6369B282-AD98-4D0C-9BD0-3796CDC4BFEF}"/>
               </a:ext>
             </a:extLst>
           </p:cNvPr>
@@ -5693,7 +5693,7 @@
           <p:cNvPr id="6" name="">
             <a:extLst xmlns:a="http://schemas.openxmlformats.org/drawingml/2006/main">
               <a:ext uri="{FF2B5EF4-FFF2-40B4-BE49-F238E27FC236}">
-                <a16:creationId xmlns:a16="http://schemas.microsoft.com/office/drawing/2014/main" id="{3475E8AF-46BE-4925-BE89-62E66EC585D8}"/>
+                <a16:creationId xmlns:a16="http://schemas.microsoft.com/office/drawing/2014/main" id="{4DAA7C8C-FD80-42CD-8E41-C31B4DA68A3B}"/>
               </a:ext>
             </a:extLst>
           </p:cNvPr>
@@ -5748,7 +5748,7 @@
     </p:spTree>
     <p:extLst>
       <p:ext uri="{BB962C8B-B14F-4D97-AF65-F5344CB8AC3E}">
-        <p14:creationId xmlns:p14="http://schemas.microsoft.com/office/powerpoint/2010/main" val="41747011"/>
+        <p14:creationId xmlns:p14="http://schemas.microsoft.com/office/powerpoint/2010/main" val="1111364971"/>
       </p:ext>
     </p:extLst>
   </p:cSld>
@@ -5779,7 +5779,7 @@
           <p:cNvPr id="12" name="slide-title">
             <a:extLst xmlns:a="http://schemas.openxmlformats.org/drawingml/2006/main">
               <a:ext uri="{FF2B5EF4-FFF2-40B4-BE49-F238E27FC236}">
-                <a16:creationId xmlns:a16="http://schemas.microsoft.com/office/drawing/2014/main" id="{4DB080F5-0424-4F1A-8545-62110F0032B8}"/>
+                <a16:creationId xmlns:a16="http://schemas.microsoft.com/office/drawing/2014/main" id="{09D75CE9-43A8-4449-BADC-A596A0A8FA03}"/>
               </a:ext>
             </a:extLst>
           </p:cNvPr>
@@ -5836,7 +5836,7 @@
           <p:cNvPr id="2" name="slide-subtitle">
             <a:extLst xmlns:a="http://schemas.openxmlformats.org/drawingml/2006/main">
               <a:ext uri="{FF2B5EF4-FFF2-40B4-BE49-F238E27FC236}">
-                <a16:creationId xmlns:a16="http://schemas.microsoft.com/office/drawing/2014/main" id="{BD64FF93-66BB-42AA-B01B-549C046699DD}"/>
+                <a16:creationId xmlns:a16="http://schemas.microsoft.com/office/drawing/2014/main" id="{67FB2776-5221-454C-8100-685241171454}"/>
               </a:ext>
             </a:extLst>
           </p:cNvPr>
@@ -5893,7 +5893,7 @@
           <p:cNvPr id="3" name="">
             <a:extLst xmlns:a="http://schemas.openxmlformats.org/drawingml/2006/main">
               <a:ext uri="{FF2B5EF4-FFF2-40B4-BE49-F238E27FC236}">
-                <a16:creationId xmlns:a16="http://schemas.microsoft.com/office/drawing/2014/main" id="{CBBC1C07-3206-4987-8364-789A7AC950BA}"/>
+                <a16:creationId xmlns:a16="http://schemas.microsoft.com/office/drawing/2014/main" id="{E0339D52-8F37-4678-8DA7-08C60035F5FB}"/>
               </a:ext>
             </a:extLst>
           </p:cNvPr>
@@ -5954,7 +5954,7 @@
           <p:cNvPr id="4" name="">
             <a:extLst xmlns:a="http://schemas.openxmlformats.org/drawingml/2006/main">
               <a:ext uri="{FF2B5EF4-FFF2-40B4-BE49-F238E27FC236}">
-                <a16:creationId xmlns:a16="http://schemas.microsoft.com/office/drawing/2014/main" id="{1D1EBD7E-F245-456A-A053-3F5912009925}"/>
+                <a16:creationId xmlns:a16="http://schemas.microsoft.com/office/drawing/2014/main" id="{3781C23A-6954-41FF-84E8-56E329686995}"/>
               </a:ext>
             </a:extLst>
           </p:cNvPr>
@@ -5985,7 +5985,7 @@
           <p:cNvPr id="5" name="">
             <a:extLst xmlns:a="http://schemas.openxmlformats.org/drawingml/2006/main">
               <a:ext uri="{FF2B5EF4-FFF2-40B4-BE49-F238E27FC236}">
-                <a16:creationId xmlns:a16="http://schemas.microsoft.com/office/drawing/2014/main" id="{6D721362-C4E9-42A6-956E-D1BA7098271D}"/>
+                <a16:creationId xmlns:a16="http://schemas.microsoft.com/office/drawing/2014/main" id="{14825699-2261-4747-9EA6-62B2AA56C73D}"/>
               </a:ext>
             </a:extLst>
           </p:cNvPr>
@@ -6042,7 +6042,7 @@
           <p:cNvPr id="6" name="">
             <a:extLst xmlns:a="http://schemas.openxmlformats.org/drawingml/2006/main">
               <a:ext uri="{FF2B5EF4-FFF2-40B4-BE49-F238E27FC236}">
-                <a16:creationId xmlns:a16="http://schemas.microsoft.com/office/drawing/2014/main" id="{36B65528-FEE0-492B-89C8-CFFEA1AADF41}"/>
+                <a16:creationId xmlns:a16="http://schemas.microsoft.com/office/drawing/2014/main" id="{3A9BD3A3-06DB-493B-9FB7-D5E7279ABFCE}"/>
               </a:ext>
             </a:extLst>
           </p:cNvPr>
@@ -6099,7 +6099,7 @@
           <p:cNvPr id="7" name="">
             <a:extLst xmlns:a="http://schemas.openxmlformats.org/drawingml/2006/main">
               <a:ext uri="{FF2B5EF4-FFF2-40B4-BE49-F238E27FC236}">
-                <a16:creationId xmlns:a16="http://schemas.microsoft.com/office/drawing/2014/main" id="{4478803F-53D5-4D48-8DD1-B0071690DC73}"/>
+                <a16:creationId xmlns:a16="http://schemas.microsoft.com/office/drawing/2014/main" id="{A7BE067B-0147-4074-BC28-AECC330762A1}"/>
               </a:ext>
             </a:extLst>
           </p:cNvPr>
@@ -6163,7 +6163,7 @@
         </p:xfrm>
         <a:graphic xmlns:a="http://schemas.openxmlformats.org/drawingml/2006/main">
           <a:graphicData uri="http://schemas.openxmlformats.org/drawingml/2006/chart">
-            <c:chart xmlns:r="http://schemas.openxmlformats.org/officeDocument/2006/relationships" xmlns:c="http://schemas.openxmlformats.org/drawingml/2006/chart" r:id="R78ea8a728413484b"/>
+            <c:chart xmlns:r="http://schemas.openxmlformats.org/officeDocument/2006/relationships" xmlns:c="http://schemas.openxmlformats.org/drawingml/2006/chart" r:id="Rcd3b945c396142e3"/>
           </a:graphicData>
         </a:graphic>
       </p:graphicFrame>
@@ -6172,7 +6172,7 @@
           <p:cNvPr id="9" name="">
             <a:extLst xmlns:a="http://schemas.openxmlformats.org/drawingml/2006/main">
               <a:ext uri="{FF2B5EF4-FFF2-40B4-BE49-F238E27FC236}">
-                <a16:creationId xmlns:a16="http://schemas.microsoft.com/office/drawing/2014/main" id="{50D7603C-332F-4924-BBE5-97F985C96CE9}"/>
+                <a16:creationId xmlns:a16="http://schemas.microsoft.com/office/drawing/2014/main" id="{714127F7-795E-4EFD-AE93-26147B529792}"/>
               </a:ext>
             </a:extLst>
           </p:cNvPr>
@@ -6229,7 +6229,7 @@
           <p:cNvPr id="10" name="">
             <a:extLst xmlns:a="http://schemas.openxmlformats.org/drawingml/2006/main">
               <a:ext uri="{FF2B5EF4-FFF2-40B4-BE49-F238E27FC236}">
-                <a16:creationId xmlns:a16="http://schemas.microsoft.com/office/drawing/2014/main" id="{81CF6524-5541-4930-82C0-8D3B5CFFE815}"/>
+                <a16:creationId xmlns:a16="http://schemas.microsoft.com/office/drawing/2014/main" id="{B963C71C-8250-4974-B0BA-01C4E5326344}"/>
               </a:ext>
             </a:extLst>
           </p:cNvPr>
@@ -6286,7 +6286,7 @@
           <p:cNvPr id="11" name="">
             <a:extLst xmlns:a="http://schemas.openxmlformats.org/drawingml/2006/main">
               <a:ext uri="{FF2B5EF4-FFF2-40B4-BE49-F238E27FC236}">
-                <a16:creationId xmlns:a16="http://schemas.microsoft.com/office/drawing/2014/main" id="{C018F334-19BA-48DD-B683-BF4B262BB9ED}"/>
+                <a16:creationId xmlns:a16="http://schemas.microsoft.com/office/drawing/2014/main" id="{64E6959A-4666-47A2-B009-A0B2B31ADF72}"/>
               </a:ext>
             </a:extLst>
           </p:cNvPr>
@@ -6341,7 +6341,7 @@
     </p:spTree>
     <p:extLst>
       <p:ext uri="{BB962C8B-B14F-4D97-AF65-F5344CB8AC3E}">
-        <p14:creationId xmlns:p14="http://schemas.microsoft.com/office/powerpoint/2010/main" val="1494926282"/>
+        <p14:creationId xmlns:p14="http://schemas.microsoft.com/office/powerpoint/2010/main" val="106739938"/>
       </p:ext>
     </p:extLst>
   </p:cSld>
@@ -6372,7 +6372,7 @@
           <p:cNvPr id="10" name="slide-title">
             <a:extLst xmlns:a="http://schemas.openxmlformats.org/drawingml/2006/main">
               <a:ext uri="{FF2B5EF4-FFF2-40B4-BE49-F238E27FC236}">
-                <a16:creationId xmlns:a16="http://schemas.microsoft.com/office/drawing/2014/main" id="{42D3DB77-0C20-43C7-A2F7-5F26058AD232}"/>
+                <a16:creationId xmlns:a16="http://schemas.microsoft.com/office/drawing/2014/main" id="{3915259D-2635-49C4-B0BD-C7DB17FF9EA3}"/>
               </a:ext>
             </a:extLst>
           </p:cNvPr>
@@ -6429,7 +6429,7 @@
           <p:cNvPr id="2" name="slide-subtitle">
             <a:extLst xmlns:a="http://schemas.openxmlformats.org/drawingml/2006/main">
               <a:ext uri="{FF2B5EF4-FFF2-40B4-BE49-F238E27FC236}">
-                <a16:creationId xmlns:a16="http://schemas.microsoft.com/office/drawing/2014/main" id="{AC96DD11-B3F1-447B-8D4D-64AF9A9EA256}"/>
+                <a16:creationId xmlns:a16="http://schemas.microsoft.com/office/drawing/2014/main" id="{1452ED47-050B-4598-BCEE-58FB419EB70D}"/>
               </a:ext>
             </a:extLst>
           </p:cNvPr>
@@ -6486,7 +6486,7 @@
           <p:cNvPr id="3" name="">
             <a:extLst xmlns:a="http://schemas.openxmlformats.org/drawingml/2006/main">
               <a:ext uri="{FF2B5EF4-FFF2-40B4-BE49-F238E27FC236}">
-                <a16:creationId xmlns:a16="http://schemas.microsoft.com/office/drawing/2014/main" id="{E8E261BF-AFB4-4243-9B2B-CDAB5E7F8E7B}"/>
+                <a16:creationId xmlns:a16="http://schemas.microsoft.com/office/drawing/2014/main" id="{1D83A00C-1CBA-4EE1-997A-A17E37A1525C}"/>
               </a:ext>
             </a:extLst>
           </p:cNvPr>
@@ -6547,7 +6547,7 @@
           <p:cNvPr id="4" name="">
             <a:extLst xmlns:a="http://schemas.openxmlformats.org/drawingml/2006/main">
               <a:ext uri="{FF2B5EF4-FFF2-40B4-BE49-F238E27FC236}">
-                <a16:creationId xmlns:a16="http://schemas.microsoft.com/office/drawing/2014/main" id="{DF65F538-F8B5-4918-B3F0-5472962DB3E5}"/>
+                <a16:creationId xmlns:a16="http://schemas.microsoft.com/office/drawing/2014/main" id="{7A8EC600-085C-4B7F-8EC7-7A8746DD9F17}"/>
               </a:ext>
             </a:extLst>
           </p:cNvPr>
@@ -6578,7 +6578,7 @@
           <p:cNvPr id="5" name="">
             <a:extLst xmlns:a="http://schemas.openxmlformats.org/drawingml/2006/main">
               <a:ext uri="{FF2B5EF4-FFF2-40B4-BE49-F238E27FC236}">
-                <a16:creationId xmlns:a16="http://schemas.microsoft.com/office/drawing/2014/main" id="{5FF9EEE4-1D18-4605-983E-D37BAFDE1B6A}"/>
+                <a16:creationId xmlns:a16="http://schemas.microsoft.com/office/drawing/2014/main" id="{5E2E7962-CDE1-40AE-9597-ACE6690FEED2}"/>
               </a:ext>
             </a:extLst>
           </p:cNvPr>
@@ -6635,7 +6635,7 @@
           <p:cNvPr id="6" name="">
             <a:extLst xmlns:a="http://schemas.openxmlformats.org/drawingml/2006/main">
               <a:ext uri="{FF2B5EF4-FFF2-40B4-BE49-F238E27FC236}">
-                <a16:creationId xmlns:a16="http://schemas.microsoft.com/office/drawing/2014/main" id="{55F5E9C3-E624-495D-ACE5-557D569D2B0D}"/>
+                <a16:creationId xmlns:a16="http://schemas.microsoft.com/office/drawing/2014/main" id="{812D49EA-43D2-44BE-B9C4-A8AFE9FAB392}"/>
               </a:ext>
             </a:extLst>
           </p:cNvPr>
@@ -7108,7 +7108,7 @@
           <p:cNvPr id="8" name="">
             <a:extLst xmlns:a="http://schemas.openxmlformats.org/drawingml/2006/main">
               <a:ext uri="{FF2B5EF4-FFF2-40B4-BE49-F238E27FC236}">
-                <a16:creationId xmlns:a16="http://schemas.microsoft.com/office/drawing/2014/main" id="{0D8787BC-2B41-4905-8A23-8B91C8C60B74}"/>
+                <a16:creationId xmlns:a16="http://schemas.microsoft.com/office/drawing/2014/main" id="{B2F3BE03-BBCE-4483-83A5-F343A8DAFAC0}"/>
               </a:ext>
             </a:extLst>
           </p:cNvPr>
@@ -7165,7 +7165,7 @@
           <p:cNvPr id="9" name="">
             <a:extLst xmlns:a="http://schemas.openxmlformats.org/drawingml/2006/main">
               <a:ext uri="{FF2B5EF4-FFF2-40B4-BE49-F238E27FC236}">
-                <a16:creationId xmlns:a16="http://schemas.microsoft.com/office/drawing/2014/main" id="{DF7FD1F6-17BD-4C7A-A9C9-C3914239C9A8}"/>
+                <a16:creationId xmlns:a16="http://schemas.microsoft.com/office/drawing/2014/main" id="{36591EC3-FD87-4C33-A545-FF54D9F9435B}"/>
               </a:ext>
             </a:extLst>
           </p:cNvPr>
@@ -7220,7 +7220,7 @@
     </p:spTree>
     <p:extLst>
       <p:ext uri="{BB962C8B-B14F-4D97-AF65-F5344CB8AC3E}">
-        <p14:creationId xmlns:p14="http://schemas.microsoft.com/office/powerpoint/2010/main" val="1336127272"/>
+        <p14:creationId xmlns:p14="http://schemas.microsoft.com/office/powerpoint/2010/main" val="343924896"/>
       </p:ext>
     </p:extLst>
   </p:cSld>
@@ -7251,7 +7251,7 @@
           <p:cNvPr id="8" name="slide-title">
             <a:extLst xmlns:a="http://schemas.openxmlformats.org/drawingml/2006/main">
               <a:ext uri="{FF2B5EF4-FFF2-40B4-BE49-F238E27FC236}">
-                <a16:creationId xmlns:a16="http://schemas.microsoft.com/office/drawing/2014/main" id="{1B9F74D4-4408-4233-92A9-D28D0E9ABC71}"/>
+                <a16:creationId xmlns:a16="http://schemas.microsoft.com/office/drawing/2014/main" id="{0D38488C-41FD-4DEC-BCDD-8EC39D8810FB}"/>
               </a:ext>
             </a:extLst>
           </p:cNvPr>
@@ -7308,7 +7308,7 @@
           <p:cNvPr id="2" name="slide-subtitle">
             <a:extLst xmlns:a="http://schemas.openxmlformats.org/drawingml/2006/main">
               <a:ext uri="{FF2B5EF4-FFF2-40B4-BE49-F238E27FC236}">
-                <a16:creationId xmlns:a16="http://schemas.microsoft.com/office/drawing/2014/main" id="{C9A9BC2D-D396-4255-B212-E8132F401054}"/>
+                <a16:creationId xmlns:a16="http://schemas.microsoft.com/office/drawing/2014/main" id="{A105C744-6F12-4FAD-A3A5-EC7577DD0B11}"/>
               </a:ext>
             </a:extLst>
           </p:cNvPr>
@@ -7365,7 +7365,7 @@
           <p:cNvPr id="3" name="">
             <a:extLst xmlns:a="http://schemas.openxmlformats.org/drawingml/2006/main">
               <a:ext uri="{FF2B5EF4-FFF2-40B4-BE49-F238E27FC236}">
-                <a16:creationId xmlns:a16="http://schemas.microsoft.com/office/drawing/2014/main" id="{FE142CBF-075F-4AC6-8745-7815CEB498F3}"/>
+                <a16:creationId xmlns:a16="http://schemas.microsoft.com/office/drawing/2014/main" id="{21A2718A-07A9-4BBC-A8E9-7857577ED806}"/>
               </a:ext>
             </a:extLst>
           </p:cNvPr>
@@ -7426,7 +7426,7 @@
           <p:cNvPr id="4" name="">
             <a:extLst xmlns:a="http://schemas.openxmlformats.org/drawingml/2006/main">
               <a:ext uri="{FF2B5EF4-FFF2-40B4-BE49-F238E27FC236}">
-                <a16:creationId xmlns:a16="http://schemas.microsoft.com/office/drawing/2014/main" id="{D67FF727-0E62-404F-9EC2-5408E27F7FAF}"/>
+                <a16:creationId xmlns:a16="http://schemas.microsoft.com/office/drawing/2014/main" id="{B7F5703D-E180-41C3-833F-08F586A0DADD}"/>
               </a:ext>
             </a:extLst>
           </p:cNvPr>
@@ -7658,7 +7658,7 @@
                           <a:ea typeface="Aptos"/>
                           <a:cs typeface="Aptos"/>
                         </a:rPr>
-                        <a:t>Compare the same questions; check that answers were read and labeled correctly</a:t>
+                        <a:t>Recover each question's result; check reading and labels</a:t>
                       </a:r>
                     </a:p>
                   </a:txBody>
@@ -7682,7 +7682,7 @@
                           <a:ea typeface="Aptos"/>
                           <a:cs typeface="Aptos"/>
                         </a:rPr>
-                        <a:t>This tackles the biggest gaps</a:t>
+                        <a:t>This lets us compare models directly</a:t>
                       </a:r>
                     </a:p>
                   </a:txBody>
@@ -7850,7 +7850,7 @@
           <p:cNvPr id="6" name="">
             <a:extLst xmlns:a="http://schemas.openxmlformats.org/drawingml/2006/main">
               <a:ext uri="{FF2B5EF4-FFF2-40B4-BE49-F238E27FC236}">
-                <a16:creationId xmlns:a16="http://schemas.microsoft.com/office/drawing/2014/main" id="{C69FD85C-47A1-495B-AF16-E87043A5A2D1}"/>
+                <a16:creationId xmlns:a16="http://schemas.microsoft.com/office/drawing/2014/main" id="{07845D37-9D28-403C-BFDD-5B672E3C432E}"/>
               </a:ext>
             </a:extLst>
           </p:cNvPr>
@@ -7907,7 +7907,7 @@
           <p:cNvPr id="7" name="">
             <a:extLst xmlns:a="http://schemas.openxmlformats.org/drawingml/2006/main">
               <a:ext uri="{FF2B5EF4-FFF2-40B4-BE49-F238E27FC236}">
-                <a16:creationId xmlns:a16="http://schemas.microsoft.com/office/drawing/2014/main" id="{5621AECF-39CA-4FA2-997F-945A73348A77}"/>
+                <a16:creationId xmlns:a16="http://schemas.microsoft.com/office/drawing/2014/main" id="{E3D259D9-32AF-4373-B628-BB337F62E935}"/>
               </a:ext>
             </a:extLst>
           </p:cNvPr>
@@ -7919,7 +7919,7 @@
         <p:spPr>
           <a:xfrm xmlns:a="http://schemas.openxmlformats.org/drawingml/2006/main">
             <a:off x="876300" y="5848350"/>
-            <a:ext cx="10001250" cy="438150"/>
+            <a:ext cx="10439400" cy="438150"/>
           </a:xfrm>
           <a:prstGeom xmlns:a="http://schemas.openxmlformats.org/drawingml/2006/main" prst="rect">
             <a:avLst/>
@@ -7936,7 +7936,7 @@
           <a:lstStyle xmlns:a="http://schemas.openxmlformats.org/drawingml/2006/main"/>
           <a:p xmlns:a="http://schemas.openxmlformats.org/drawingml/2006/main">
             <a:pPr algn="l">
-              <a:defRPr sz="2100" b="1">
+              <a:defRPr sz="1950" b="1">
                 <a:solidFill>
                   <a:srgbClr val="17212B"/>
                 </a:solidFill>
@@ -7946,7 +7946,7 @@
               </a:defRPr>
             </a:pPr>
             <a:r>
-              <a:rPr sz="2100" b="1">
+              <a:rPr sz="1950" b="1">
                 <a:solidFill>
                   <a:srgbClr val="17212B"/>
                 </a:solidFill>
@@ -7954,7 +7954,7 @@
                 <a:ea typeface="Aptos"/>
                 <a:cs typeface="Aptos"/>
               </a:rPr>
-              <a:t>Compare models on the same questions. Then have people review the test.</a:t>
+              <a:t>Recover each question's result. Compare models. Then have people review the test.</a:t>
             </a:r>
           </a:p>
         </p:txBody>
@@ -7962,7 +7962,7 @@
     </p:spTree>
     <p:extLst>
       <p:ext uri="{BB962C8B-B14F-4D97-AF65-F5344CB8AC3E}">
-        <p14:creationId xmlns:p14="http://schemas.microsoft.com/office/powerpoint/2010/main" val="1865674994"/>
+        <p14:creationId xmlns:p14="http://schemas.microsoft.com/office/powerpoint/2010/main" val="1631343589"/>
       </p:ext>
     </p:extLst>
   </p:cSld>

</xml_diff>

<commit_message>
Clarify result populations and comparison uncertainty
</commit_message>
<xml_diff>
--- a/slides/cei-moral-psychology-results-deck.pptx
+++ b/slides/cei-moral-psychology-results-deck.pptx
@@ -2,20 +2,20 @@
 <file path=ppt/presentation.xml><?xml version="1.0" encoding="utf-8"?>
 <p:presentation xmlns:p="http://schemas.openxmlformats.org/presentationml/2006/main">
   <p:sldMasterIdLst>
-    <p:sldMasterId xmlns:r="http://schemas.openxmlformats.org/officeDocument/2006/relationships" id="2147483648" r:id="R87d682eb43bc4c71"/>
+    <p:sldMasterId xmlns:r="http://schemas.openxmlformats.org/officeDocument/2006/relationships" id="2147483648" r:id="R61cd8b7a0e634a0e"/>
   </p:sldMasterIdLst>
   <p:notesMasterIdLst>
-    <p:notesMasterId xmlns:r="http://schemas.openxmlformats.org/officeDocument/2006/relationships" r:id="R1e75c533c741418a"/>
+    <p:notesMasterId xmlns:r="http://schemas.openxmlformats.org/officeDocument/2006/relationships" r:id="R990e15a58efa4467"/>
   </p:notesMasterIdLst>
   <p:sldIdLst>
-    <p:sldId xmlns:r="http://schemas.openxmlformats.org/officeDocument/2006/relationships" id="256" r:id="Rb80bd4b49520466f"/>
-    <p:sldId xmlns:r="http://schemas.openxmlformats.org/officeDocument/2006/relationships" id="257" r:id="Rdfb44b29abab4078"/>
-    <p:sldId xmlns:r="http://schemas.openxmlformats.org/officeDocument/2006/relationships" id="258" r:id="R7eb52cbbe6c1494e"/>
-    <p:sldId xmlns:r="http://schemas.openxmlformats.org/officeDocument/2006/relationships" id="259" r:id="Rfaae51fd549c41f0"/>
-    <p:sldId xmlns:r="http://schemas.openxmlformats.org/officeDocument/2006/relationships" id="260" r:id="R5550b65903d840fc"/>
-    <p:sldId xmlns:r="http://schemas.openxmlformats.org/officeDocument/2006/relationships" id="261" r:id="R62f7ecdf472b478a"/>
-    <p:sldId xmlns:r="http://schemas.openxmlformats.org/officeDocument/2006/relationships" id="262" r:id="R0dfe3f135809421e"/>
-    <p:sldId xmlns:r="http://schemas.openxmlformats.org/officeDocument/2006/relationships" id="263" r:id="Rf92c9d2b89264f8c"/>
+    <p:sldId xmlns:r="http://schemas.openxmlformats.org/officeDocument/2006/relationships" id="256" r:id="R8e86394e54734515"/>
+    <p:sldId xmlns:r="http://schemas.openxmlformats.org/officeDocument/2006/relationships" id="257" r:id="R4af1f1d8d7f24a27"/>
+    <p:sldId xmlns:r="http://schemas.openxmlformats.org/officeDocument/2006/relationships" id="258" r:id="Rcc5aca3358c54a8d"/>
+    <p:sldId xmlns:r="http://schemas.openxmlformats.org/officeDocument/2006/relationships" id="259" r:id="R80f339c386b24948"/>
+    <p:sldId xmlns:r="http://schemas.openxmlformats.org/officeDocument/2006/relationships" id="260" r:id="R43eafd66d5ec4c1d"/>
+    <p:sldId xmlns:r="http://schemas.openxmlformats.org/officeDocument/2006/relationships" id="261" r:id="R59eb355073104c30"/>
+    <p:sldId xmlns:r="http://schemas.openxmlformats.org/officeDocument/2006/relationships" id="262" r:id="R40e0262293a94300"/>
+    <p:sldId xmlns:r="http://schemas.openxmlformats.org/officeDocument/2006/relationships" id="263" r:id="Rc806270a275f4200"/>
   </p:sldIdLst>
   <p:sldSz cx="12192000" cy="6858000"/>
   <p:notesSz cx="6858000" cy="9144000"/>
@@ -629,6 +629,11 @@
           </a:p>
           <a:p xmlns:a="http://schemas.openxmlformats.org/drawingml/2006/main">
             <a:r>
+              <a:t>Denominator: all available primary models—8 on MFQ compare and 10 on vignette compare—not the five-model common roster.</a:t>
+            </a:r>
+          </a:p>
+          <a:p xmlns:a="http://schemas.openxmlformats.org/drawingml/2006/main">
+            <a:r>
               <a:t>Within each comparison task, every model pair has overlapping marginal intervals: 28 of 28 MFQ pairs and 45 of 45 vignette pairs.</a:t>
             </a:r>
           </a:p>
@@ -1142,7 +1147,7 @@
   </p:cSld>
   <p:clrMap bg1="lt1" tx1="dk1" bg2="lt2" tx2="dk2" accent1="accent1" accent2="accent2" accent3="accent3" accent4="accent4" accent5="accent5" accent6="accent6" hlink="hlink" folHlink="folHlink"/>
   <p:sldLayoutIdLst>
-    <p:sldLayoutId xmlns:r="http://schemas.openxmlformats.org/officeDocument/2006/relationships" id="2147483649" r:id="R8b6518ddc8e14be5"/>
+    <p:sldLayoutId xmlns:r="http://schemas.openxmlformats.org/officeDocument/2006/relationships" id="2147483649" r:id="R4019ee32aa014baa"/>
   </p:sldLayoutIdLst>
   <p:txStyles>
     <p:titleStyle>
@@ -1685,7 +1690,7 @@
                 <a:ea typeface="Aptos"/>
                 <a:cs typeface="Aptos"/>
               </a:rPr>
-              <a:t>How wide is the uncertainty range? Wider means less sure.</a:t>
+              <a:t>Median width of saved 95% ranges — wider means less sure</a:t>
             </a:r>
           </a:p>
         </c:rich>
@@ -1941,7 +1946,7 @@
                     <a:ea typeface="Aptos"/>
                     <a:cs typeface="Aptos"/>
                   </a:rPr>
-                  <a:t>Width of the uncertainty range</a:t>
+                  <a:t>Median full width of saved 95% interval</a:t>
                 </a:r>
               </a:p>
             </c:rich>
@@ -3118,7 +3123,7 @@
           <p:cNvPr id="7" name="cover-title">
             <a:extLst xmlns:a="http://schemas.openxmlformats.org/drawingml/2006/main">
               <a:ext uri="{FF2B5EF4-FFF2-40B4-BE49-F238E27FC236}">
-                <a16:creationId xmlns:a16="http://schemas.microsoft.com/office/drawing/2014/main" id="{71BDFBBA-1BBB-4A27-97AE-EAB169345CAE}"/>
+                <a16:creationId xmlns:a16="http://schemas.microsoft.com/office/drawing/2014/main" id="{DBAF1B79-1470-4F91-B929-8CCB3A3F06CF}"/>
               </a:ext>
             </a:extLst>
           </p:cNvPr>
@@ -3198,7 +3203,7 @@
           <p:cNvPr id="2" name="">
             <a:extLst xmlns:a="http://schemas.openxmlformats.org/drawingml/2006/main">
               <a:ext uri="{FF2B5EF4-FFF2-40B4-BE49-F238E27FC236}">
-                <a16:creationId xmlns:a16="http://schemas.microsoft.com/office/drawing/2014/main" id="{0785032F-790C-4DC0-AC1A-30C538E2897A}"/>
+                <a16:creationId xmlns:a16="http://schemas.microsoft.com/office/drawing/2014/main" id="{495EF5D1-3CA1-44E6-8A14-25F9ECAFCCBD}"/>
               </a:ext>
             </a:extLst>
           </p:cNvPr>
@@ -3255,7 +3260,7 @@
           <p:cNvPr id="3" name="">
             <a:extLst xmlns:a="http://schemas.openxmlformats.org/drawingml/2006/main">
               <a:ext uri="{FF2B5EF4-FFF2-40B4-BE49-F238E27FC236}">
-                <a16:creationId xmlns:a16="http://schemas.microsoft.com/office/drawing/2014/main" id="{FE79FA21-70B9-47BB-8A67-F6B6C1DD59FE}"/>
+                <a16:creationId xmlns:a16="http://schemas.microsoft.com/office/drawing/2014/main" id="{771361B1-B8EF-4CC0-B5DC-2BCEB14A78AB}"/>
               </a:ext>
             </a:extLst>
           </p:cNvPr>
@@ -3312,7 +3317,7 @@
           <p:cNvPr id="4" name="">
             <a:extLst xmlns:a="http://schemas.openxmlformats.org/drawingml/2006/main">
               <a:ext uri="{FF2B5EF4-FFF2-40B4-BE49-F238E27FC236}">
-                <a16:creationId xmlns:a16="http://schemas.microsoft.com/office/drawing/2014/main" id="{F17EF62D-E18D-4C74-A53F-2E27F097D1C2}"/>
+                <a16:creationId xmlns:a16="http://schemas.microsoft.com/office/drawing/2014/main" id="{4563625F-59A7-47A1-8199-6478178CF948}"/>
               </a:ext>
             </a:extLst>
           </p:cNvPr>
@@ -3343,7 +3348,7 @@
           <p:cNvPr id="5" name="">
             <a:extLst xmlns:a="http://schemas.openxmlformats.org/drawingml/2006/main">
               <a:ext uri="{FF2B5EF4-FFF2-40B4-BE49-F238E27FC236}">
-                <a16:creationId xmlns:a16="http://schemas.microsoft.com/office/drawing/2014/main" id="{18604258-485C-4293-8A23-FBC0771FC6EB}"/>
+                <a16:creationId xmlns:a16="http://schemas.microsoft.com/office/drawing/2014/main" id="{1D84E92B-4135-492F-B2EB-77D725358130}"/>
               </a:ext>
             </a:extLst>
           </p:cNvPr>
@@ -3390,7 +3395,7 @@
                 <a:ea typeface="Aptos"/>
                 <a:cs typeface="Aptos"/>
               </a:rPr>
-              <a:t>Why: the top model changes by task, and two comparison tests still cannot give a reliable order.</a:t>
+              <a:t>Why: the highest saved score changes by task, and saved ranges overlap on both comparison tests.</a:t>
             </a:r>
           </a:p>
         </p:txBody>
@@ -3400,7 +3405,7 @@
           <p:cNvPr id="6" name="">
             <a:extLst xmlns:a="http://schemas.openxmlformats.org/drawingml/2006/main">
               <a:ext uri="{FF2B5EF4-FFF2-40B4-BE49-F238E27FC236}">
-                <a16:creationId xmlns:a16="http://schemas.microsoft.com/office/drawing/2014/main" id="{CB08836F-58C5-4CCA-A5EE-6EC0DA6B37D0}"/>
+                <a16:creationId xmlns:a16="http://schemas.microsoft.com/office/drawing/2014/main" id="{DD0132A2-4D6F-469C-903A-123363C7A073}"/>
               </a:ext>
             </a:extLst>
           </p:cNvPr>
@@ -3455,7 +3460,7 @@
     </p:spTree>
     <p:extLst>
       <p:ext uri="{BB962C8B-B14F-4D97-AF65-F5344CB8AC3E}">
-        <p14:creationId xmlns:p14="http://schemas.microsoft.com/office/powerpoint/2010/main" val="1571040779"/>
+        <p14:creationId xmlns:p14="http://schemas.microsoft.com/office/powerpoint/2010/main" val="1342251856"/>
       </p:ext>
     </p:extLst>
   </p:cSld>
@@ -3486,7 +3491,7 @@
           <p:cNvPr id="8" name="slide-title">
             <a:extLst xmlns:a="http://schemas.openxmlformats.org/drawingml/2006/main">
               <a:ext uri="{FF2B5EF4-FFF2-40B4-BE49-F238E27FC236}">
-                <a16:creationId xmlns:a16="http://schemas.microsoft.com/office/drawing/2014/main" id="{9ADE1A5A-DC84-49BE-8543-E196E2FAF9B1}"/>
+                <a16:creationId xmlns:a16="http://schemas.microsoft.com/office/drawing/2014/main" id="{501876E5-BBD3-4124-B251-E1D8062242F6}"/>
               </a:ext>
             </a:extLst>
           </p:cNvPr>
@@ -3510,7 +3515,7 @@
         </p:spPr>
         <p:txBody>
           <a:bodyPr xmlns:a="http://schemas.openxmlformats.org/drawingml/2006/main">
-            <a:normAutofit fontScale="100000"/>
+            <a:normAutofit fontScale="93121"/>
           </a:bodyPr>
           <a:lstStyle xmlns:a="http://schemas.openxmlformats.org/drawingml/2006/main"/>
           <a:p xmlns:a="http://schemas.openxmlformats.org/drawingml/2006/main">
@@ -3533,7 +3538,7 @@
                 <a:ea typeface="Aptos"/>
                 <a:cs typeface="Aptos"/>
               </a:rPr>
-              <a:t>No model leads all eight tasks</a:t>
+              <a:t>No model has the highest saved score on all eight tasks</a:t>
             </a:r>
           </a:p>
         </p:txBody>
@@ -3543,7 +3548,7 @@
           <p:cNvPr id="2" name="slide-subtitle">
             <a:extLst xmlns:a="http://schemas.openxmlformats.org/drawingml/2006/main">
               <a:ext uri="{FF2B5EF4-FFF2-40B4-BE49-F238E27FC236}">
-                <a16:creationId xmlns:a16="http://schemas.microsoft.com/office/drawing/2014/main" id="{280A0940-1ECB-420D-B9F2-E85A3B766F4D}"/>
+                <a16:creationId xmlns:a16="http://schemas.microsoft.com/office/drawing/2014/main" id="{E325D4E8-3CD9-4FE2-8D2A-C9C8A8EC67BD}"/>
               </a:ext>
             </a:extLst>
           </p:cNvPr>
@@ -3590,7 +3595,7 @@
                 <a:ea typeface="Aptos"/>
                 <a:cs typeface="Aptos"/>
               </a:rPr>
-              <a:t>Highest stored result for each task, using the same five models</a:t>
+              <a:t>Highest saved score for each task, using the same five models</a:t>
             </a:r>
           </a:p>
         </p:txBody>
@@ -3600,7 +3605,7 @@
           <p:cNvPr id="3" name="">
             <a:extLst xmlns:a="http://schemas.openxmlformats.org/drawingml/2006/main">
               <a:ext uri="{FF2B5EF4-FFF2-40B4-BE49-F238E27FC236}">
-                <a16:creationId xmlns:a16="http://schemas.microsoft.com/office/drawing/2014/main" id="{31B45130-8CE3-42DB-9A08-1CA71C7D12FD}"/>
+                <a16:creationId xmlns:a16="http://schemas.microsoft.com/office/drawing/2014/main" id="{F0B44462-9E39-494F-BD10-C9F2F2864435}"/>
               </a:ext>
             </a:extLst>
           </p:cNvPr>
@@ -3661,7 +3666,7 @@
           <p:cNvPr id="4" name="">
             <a:extLst xmlns:a="http://schemas.openxmlformats.org/drawingml/2006/main">
               <a:ext uri="{FF2B5EF4-FFF2-40B4-BE49-F238E27FC236}">
-                <a16:creationId xmlns:a16="http://schemas.microsoft.com/office/drawing/2014/main" id="{86EC3C02-6882-41ED-810B-080731AB9F04}"/>
+                <a16:creationId xmlns:a16="http://schemas.microsoft.com/office/drawing/2014/main" id="{C3318DFD-806E-4F3F-A9A5-D6DFB89585AE}"/>
               </a:ext>
             </a:extLst>
           </p:cNvPr>
@@ -3746,7 +3751,7 @@
                           <a:ea typeface="Aptos"/>
                           <a:cs typeface="Aptos"/>
                         </a:rPr>
-                        <a:t>Highest stored result</a:t>
+                        <a:t>Highest saved score</a:t>
                       </a:r>
                     </a:p>
                   </a:txBody>
@@ -4598,7 +4603,7 @@
           <p:cNvPr id="6" name="">
             <a:extLst xmlns:a="http://schemas.openxmlformats.org/drawingml/2006/main">
               <a:ext uri="{FF2B5EF4-FFF2-40B4-BE49-F238E27FC236}">
-                <a16:creationId xmlns:a16="http://schemas.microsoft.com/office/drawing/2014/main" id="{D8584922-6DE9-4B53-B383-9E2C07F1D122}"/>
+                <a16:creationId xmlns:a16="http://schemas.microsoft.com/office/drawing/2014/main" id="{2A4ED951-5B5C-43B9-BF2A-6A75C62BA76F}"/>
               </a:ext>
             </a:extLst>
           </p:cNvPr>
@@ -4655,7 +4660,7 @@
           <p:cNvPr id="7" name="">
             <a:extLst xmlns:a="http://schemas.openxmlformats.org/drawingml/2006/main">
               <a:ext uri="{FF2B5EF4-FFF2-40B4-BE49-F238E27FC236}">
-                <a16:creationId xmlns:a16="http://schemas.microsoft.com/office/drawing/2014/main" id="{A4B8307F-09CE-4BCB-ABD0-B610BEFBA9E6}"/>
+                <a16:creationId xmlns:a16="http://schemas.microsoft.com/office/drawing/2014/main" id="{9A3BABAF-0004-433A-8A57-0CFD4D68BA75}"/>
               </a:ext>
             </a:extLst>
           </p:cNvPr>
@@ -4710,7 +4715,7 @@
     </p:spTree>
     <p:extLst>
       <p:ext uri="{BB962C8B-B14F-4D97-AF65-F5344CB8AC3E}">
-        <p14:creationId xmlns:p14="http://schemas.microsoft.com/office/powerpoint/2010/main" val="1621060186"/>
+        <p14:creationId xmlns:p14="http://schemas.microsoft.com/office/powerpoint/2010/main" val="1326189787"/>
       </p:ext>
     </p:extLst>
   </p:cSld>
@@ -4738,10 +4743,10 @@
       </p:grpSpPr>
       <p:sp>
         <p:nvSpPr>
-          <p:cNvPr id="8" name="slide-title">
+          <p:cNvPr id="10" name="slide-title">
             <a:extLst xmlns:a="http://schemas.openxmlformats.org/drawingml/2006/main">
               <a:ext uri="{FF2B5EF4-FFF2-40B4-BE49-F238E27FC236}">
-                <a16:creationId xmlns:a16="http://schemas.microsoft.com/office/drawing/2014/main" id="{69F1139C-2A96-4B0B-8450-5A5CC97BC017}"/>
+                <a16:creationId xmlns:a16="http://schemas.microsoft.com/office/drawing/2014/main" id="{B549F0AC-DC8C-49C5-A5D6-9C46D881EEB2}"/>
               </a:ext>
             </a:extLst>
           </p:cNvPr>
@@ -4765,7 +4770,7 @@
         </p:spPr>
         <p:txBody>
           <a:bodyPr xmlns:a="http://schemas.openxmlformats.org/drawingml/2006/main">
-            <a:normAutofit fontScale="100000"/>
+            <a:normAutofit fontScale="94074"/>
           </a:bodyPr>
           <a:lstStyle xmlns:a="http://schemas.openxmlformats.org/drawingml/2006/main"/>
           <a:p xmlns:a="http://schemas.openxmlformats.org/drawingml/2006/main">
@@ -4788,7 +4793,7 @@
                 <a:ea typeface="Aptos"/>
                 <a:cs typeface="Aptos"/>
               </a:rPr>
-              <a:t>Two comparison tests cannot rank models yet</a:t>
+              <a:t>Saved ranges overlap for every model pair in both tests</a:t>
             </a:r>
           </a:p>
         </p:txBody>
@@ -4798,7 +4803,7 @@
           <p:cNvPr id="2" name="slide-subtitle">
             <a:extLst xmlns:a="http://schemas.openxmlformats.org/drawingml/2006/main">
               <a:ext uri="{FF2B5EF4-FFF2-40B4-BE49-F238E27FC236}">
-                <a16:creationId xmlns:a16="http://schemas.microsoft.com/office/drawing/2014/main" id="{5B984043-4D83-4B6C-8640-F883A3C12629}"/>
+                <a16:creationId xmlns:a16="http://schemas.microsoft.com/office/drawing/2014/main" id="{B79854F2-E8E6-4694-9D37-E9335C658ED3}"/>
               </a:ext>
             </a:extLst>
           </p:cNvPr>
@@ -4845,7 +4850,7 @@
                 <a:ea typeface="Aptos"/>
                 <a:cs typeface="Aptos"/>
               </a:rPr>
-              <a:t>Wider bar = less sure. MFQ has 20 questions per model; Vignette has 24.</a:t>
+              <a:t>Full primary panels: MFQ = 8 models × 20 questions; Vignette = 10 × 24.</a:t>
             </a:r>
           </a:p>
         </p:txBody>
@@ -4855,7 +4860,7 @@
           <p:cNvPr id="3" name="">
             <a:extLst xmlns:a="http://schemas.openxmlformats.org/drawingml/2006/main">
               <a:ext uri="{FF2B5EF4-FFF2-40B4-BE49-F238E27FC236}">
-                <a16:creationId xmlns:a16="http://schemas.microsoft.com/office/drawing/2014/main" id="{DA75280A-EE1D-4259-BBDF-FBE8E5388DF2}"/>
+                <a16:creationId xmlns:a16="http://schemas.microsoft.com/office/drawing/2014/main" id="{70A9DCE7-2804-4583-9210-6CE662708315}"/>
               </a:ext>
             </a:extLst>
           </p:cNvPr>
@@ -4916,7 +4921,7 @@
           <p:cNvPr id="4" name="">
             <a:extLst xmlns:a="http://schemas.openxmlformats.org/drawingml/2006/main">
               <a:ext uri="{FF2B5EF4-FFF2-40B4-BE49-F238E27FC236}">
-                <a16:creationId xmlns:a16="http://schemas.microsoft.com/office/drawing/2014/main" id="{04089F06-2202-4DC5-AE58-D305D8EE952B}"/>
+                <a16:creationId xmlns:a16="http://schemas.microsoft.com/office/drawing/2014/main" id="{43D6CC02-EB4C-4F2E-8AE1-30EFDDA9DA7C}"/>
               </a:ext>
             </a:extLst>
           </p:cNvPr>
@@ -4942,28 +4947,12 @@
           </a:ln>
         </p:spPr>
       </p:sp>
-      <p:graphicFrame>
-        <p:nvGraphicFramePr>
-          <p:cNvPr id="12" name="Chart"/>
-          <p:cNvGraphicFramePr/>
-          <p:nvPr/>
-        </p:nvGraphicFramePr>
-        <p:xfrm>
-          <a:off xmlns:a="http://schemas.openxmlformats.org/drawingml/2006/main" x="1143000" y="1619250"/>
-          <a:ext xmlns:a="http://schemas.openxmlformats.org/drawingml/2006/main" cx="9810750" cy="3857625"/>
-        </p:xfrm>
-        <a:graphic xmlns:a="http://schemas.openxmlformats.org/drawingml/2006/main">
-          <a:graphicData uri="http://schemas.openxmlformats.org/drawingml/2006/chart">
-            <c:chart xmlns:r="http://schemas.openxmlformats.org/officeDocument/2006/relationships" xmlns:c="http://schemas.openxmlformats.org/drawingml/2006/chart" r:id="Ra654c57b30ed4ea6"/>
-          </a:graphicData>
-        </a:graphic>
-      </p:graphicFrame>
-      <p:sp>
-        <p:nvSpPr>
-          <p:cNvPr id="6" name="">
+      <p:sp>
+        <p:nvSpPr>
+          <p:cNvPr id="5" name="">
             <a:extLst xmlns:a="http://schemas.openxmlformats.org/drawingml/2006/main">
               <a:ext uri="{FF2B5EF4-FFF2-40B4-BE49-F238E27FC236}">
-                <a16:creationId xmlns:a16="http://schemas.microsoft.com/office/drawing/2014/main" id="{AA836533-2708-49D8-A904-9ADF2FA64EA0}"/>
+                <a16:creationId xmlns:a16="http://schemas.microsoft.com/office/drawing/2014/main" id="{44EEC586-67DC-4847-8686-596423D5130B}"/>
               </a:ext>
             </a:extLst>
           </p:cNvPr>
@@ -4974,8 +4963,8 @@
         </p:nvSpPr>
         <p:spPr>
           <a:xfrm xmlns:a="http://schemas.openxmlformats.org/drawingml/2006/main">
-            <a:off x="1143000" y="5676900"/>
-            <a:ext cx="9334500" cy="323850"/>
+            <a:off x="1143000" y="1419225"/>
+            <a:ext cx="9810750" cy="209550"/>
           </a:xfrm>
           <a:prstGeom xmlns:a="http://schemas.openxmlformats.org/drawingml/2006/main" prst="rect">
             <a:avLst/>
@@ -4987,14 +4976,14 @@
         </p:spPr>
         <p:txBody>
           <a:bodyPr xmlns:a="http://schemas.openxmlformats.org/drawingml/2006/main">
-            <a:normAutofit fontScale="92424"/>
+            <a:normAutofit fontScale="68889"/>
           </a:bodyPr>
           <a:lstStyle xmlns:a="http://schemas.openxmlformats.org/drawingml/2006/main"/>
           <a:p xmlns:a="http://schemas.openxmlformats.org/drawingml/2006/main">
             <a:pPr algn="l">
-              <a:defRPr sz="1650" b="1">
-                <a:solidFill>
-                  <a:srgbClr val="CF5D4A"/>
+              <a:defRPr sz="1125" b="0">
+                <a:solidFill>
+                  <a:srgbClr val="66727E"/>
                 </a:solidFill>
                 <a:latin typeface="Aptos"/>
                 <a:ea typeface="Aptos"/>
@@ -5002,25 +4991,41 @@
               </a:defRPr>
             </a:pPr>
             <a:r>
-              <a:rPr sz="1650" b="1">
-                <a:solidFill>
-                  <a:srgbClr val="CF5D4A"/>
+              <a:rPr sz="1125" b="0">
+                <a:solidFill>
+                  <a:srgbClr val="66727E"/>
                 </a:solidFill>
                 <a:latin typeface="Aptos"/>
                 <a:ea typeface="Aptos"/>
                 <a:cs typeface="Aptos"/>
               </a:rPr>
-              <a:t>Action: recover each question's result, then compare models question by question.</a:t>
+              <a:t>Each bar = the median full width of saved 95% intervals across available models.</a:t>
             </a:r>
           </a:p>
         </p:txBody>
       </p:sp>
+      <p:graphicFrame>
+        <p:nvGraphicFramePr>
+          <p:cNvPr id="15" name="Chart"/>
+          <p:cNvGraphicFramePr/>
+          <p:nvPr/>
+        </p:nvGraphicFramePr>
+        <p:xfrm>
+          <a:off xmlns:a="http://schemas.openxmlformats.org/drawingml/2006/main" x="1143000" y="1685925"/>
+          <a:ext xmlns:a="http://schemas.openxmlformats.org/drawingml/2006/main" cx="9810750" cy="3209925"/>
+        </p:xfrm>
+        <a:graphic xmlns:a="http://schemas.openxmlformats.org/drawingml/2006/main">
+          <a:graphicData uri="http://schemas.openxmlformats.org/drawingml/2006/chart">
+            <c:chart xmlns:r="http://schemas.openxmlformats.org/officeDocument/2006/relationships" xmlns:c="http://schemas.openxmlformats.org/drawingml/2006/chart" r:id="R29b1b8b7029e4326"/>
+          </a:graphicData>
+        </a:graphic>
+      </p:graphicFrame>
       <p:sp>
         <p:nvSpPr>
           <p:cNvPr id="7" name="">
             <a:extLst xmlns:a="http://schemas.openxmlformats.org/drawingml/2006/main">
               <a:ext uri="{FF2B5EF4-FFF2-40B4-BE49-F238E27FC236}">
-                <a16:creationId xmlns:a16="http://schemas.microsoft.com/office/drawing/2014/main" id="{AD84C9BB-90DF-48BD-8BD6-21871F564AB7}"/>
+                <a16:creationId xmlns:a16="http://schemas.microsoft.com/office/drawing/2014/main" id="{E57CCB19-3063-4B77-9530-ED6A0518222F}"/>
               </a:ext>
             </a:extLst>
           </p:cNvPr>
@@ -5031,8 +5036,122 @@
         </p:nvSpPr>
         <p:spPr>
           <a:xfrm xmlns:a="http://schemas.openxmlformats.org/drawingml/2006/main">
-            <a:off x="1143000" y="6019800"/>
-            <a:ext cx="8191500" cy="266700"/>
+            <a:off x="1143000" y="5010150"/>
+            <a:ext cx="9810750" cy="285750"/>
+          </a:xfrm>
+          <a:prstGeom xmlns:a="http://schemas.openxmlformats.org/drawingml/2006/main" prst="rect">
+            <a:avLst/>
+          </a:prstGeom>
+          <a:noFill xmlns:a="http://schemas.openxmlformats.org/drawingml/2006/main"/>
+          <a:ln xmlns:a="http://schemas.openxmlformats.org/drawingml/2006/main" w="0">
+            <a:noFill/>
+          </a:ln>
+        </p:spPr>
+        <p:txBody>
+          <a:bodyPr xmlns:a="http://schemas.openxmlformats.org/drawingml/2006/main">
+            <a:normAutofit fontScale="94444"/>
+          </a:bodyPr>
+          <a:lstStyle xmlns:a="http://schemas.openxmlformats.org/drawingml/2006/main"/>
+          <a:p xmlns:a="http://schemas.openxmlformats.org/drawingml/2006/main">
+            <a:pPr algn="l">
+              <a:defRPr sz="1350" b="1">
+                <a:solidFill>
+                  <a:srgbClr val="CF5D4A"/>
+                </a:solidFill>
+                <a:latin typeface="Aptos"/>
+                <a:ea typeface="Aptos"/>
+                <a:cs typeface="Aptos"/>
+              </a:defRPr>
+            </a:pPr>
+            <a:r>
+              <a:rPr sz="1350" b="1">
+                <a:solidFill>
+                  <a:srgbClr val="CF5D4A"/>
+                </a:solidFill>
+                <a:latin typeface="Aptos"/>
+                <a:ea typeface="Aptos"/>
+                <a:cs typeface="Aptos"/>
+              </a:rPr>
+              <a:t>Direct evidence: saved ranges overlap for all 28 MFQ and all 45 Vignette model pairs.</a:t>
+            </a:r>
+          </a:p>
+        </p:txBody>
+      </p:sp>
+      <p:sp>
+        <p:nvSpPr>
+          <p:cNvPr id="8" name="">
+            <a:extLst xmlns:a="http://schemas.openxmlformats.org/drawingml/2006/main">
+              <a:ext uri="{FF2B5EF4-FFF2-40B4-BE49-F238E27FC236}">
+                <a16:creationId xmlns:a16="http://schemas.microsoft.com/office/drawing/2014/main" id="{7BC87FE3-427F-47BD-8C3D-829E42C9F065}"/>
+              </a:ext>
+            </a:extLst>
+          </p:cNvPr>
+          <p:cNvSpPr>
+            <a:spLocks xmlns:a="http://schemas.openxmlformats.org/drawingml/2006/main" noGrp="1"/>
+          </p:cNvSpPr>
+          <p:nvPr/>
+        </p:nvSpPr>
+        <p:spPr>
+          <a:xfrm xmlns:a="http://schemas.openxmlformats.org/drawingml/2006/main">
+            <a:off x="1143000" y="5524500"/>
+            <a:ext cx="9334500" cy="304800"/>
+          </a:xfrm>
+          <a:prstGeom xmlns:a="http://schemas.openxmlformats.org/drawingml/2006/main" prst="rect">
+            <a:avLst/>
+          </a:prstGeom>
+          <a:noFill xmlns:a="http://schemas.openxmlformats.org/drawingml/2006/main"/>
+          <a:ln xmlns:a="http://schemas.openxmlformats.org/drawingml/2006/main" w="0">
+            <a:noFill/>
+          </a:ln>
+        </p:spPr>
+        <p:txBody>
+          <a:bodyPr xmlns:a="http://schemas.openxmlformats.org/drawingml/2006/main">
+            <a:normAutofit fontScale="88889"/>
+          </a:bodyPr>
+          <a:lstStyle xmlns:a="http://schemas.openxmlformats.org/drawingml/2006/main"/>
+          <a:p xmlns:a="http://schemas.openxmlformats.org/drawingml/2006/main">
+            <a:pPr algn="l">
+              <a:defRPr sz="1575" b="1">
+                <a:solidFill>
+                  <a:srgbClr val="17212B"/>
+                </a:solidFill>
+                <a:latin typeface="Aptos"/>
+                <a:ea typeface="Aptos"/>
+                <a:cs typeface="Aptos"/>
+              </a:defRPr>
+            </a:pPr>
+            <a:r>
+              <a:rPr sz="1575" b="1">
+                <a:solidFill>
+                  <a:srgbClr val="17212B"/>
+                </a:solidFill>
+                <a:latin typeface="Aptos"/>
+                <a:ea typeface="Aptos"/>
+                <a:cs typeface="Aptos"/>
+              </a:rPr>
+              <a:t>Action: recover per-question outcomes and check scoring.</a:t>
+            </a:r>
+          </a:p>
+        </p:txBody>
+      </p:sp>
+      <p:sp>
+        <p:nvSpPr>
+          <p:cNvPr id="9" name="">
+            <a:extLst xmlns:a="http://schemas.openxmlformats.org/drawingml/2006/main">
+              <a:ext uri="{FF2B5EF4-FFF2-40B4-BE49-F238E27FC236}">
+                <a16:creationId xmlns:a16="http://schemas.microsoft.com/office/drawing/2014/main" id="{C44D7A6C-45CB-402D-9C98-112F05E034D2}"/>
+              </a:ext>
+            </a:extLst>
+          </p:cNvPr>
+          <p:cNvSpPr>
+            <a:spLocks xmlns:a="http://schemas.openxmlformats.org/drawingml/2006/main" noGrp="1"/>
+          </p:cNvSpPr>
+          <p:nvPr/>
+        </p:nvSpPr>
+        <p:spPr>
+          <a:xfrm xmlns:a="http://schemas.openxmlformats.org/drawingml/2006/main">
+            <a:off x="1143000" y="5867400"/>
+            <a:ext cx="9525000" cy="266700"/>
           </a:xfrm>
           <a:prstGeom xmlns:a="http://schemas.openxmlformats.org/drawingml/2006/main" prst="rect">
             <a:avLst/>
@@ -5067,7 +5186,7 @@
                 <a:ea typeface="Aptos"/>
                 <a:cs typeface="Aptos"/>
               </a:rPr>
-              <a:t>If the order is still unclear, add more comparison questions.</a:t>
+              <a:t>Then compare models, run human review, and add questions only if still unclear.</a:t>
             </a:r>
           </a:p>
         </p:txBody>
@@ -5075,7 +5194,7 @@
     </p:spTree>
     <p:extLst>
       <p:ext uri="{BB962C8B-B14F-4D97-AF65-F5344CB8AC3E}">
-        <p14:creationId xmlns:p14="http://schemas.microsoft.com/office/powerpoint/2010/main" val="1091227383"/>
+        <p14:creationId xmlns:p14="http://schemas.microsoft.com/office/powerpoint/2010/main" val="2050498249"/>
       </p:ext>
     </p:extLst>
   </p:cSld>
@@ -5106,7 +5225,7 @@
           <p:cNvPr id="8" name="slide-title">
             <a:extLst xmlns:a="http://schemas.openxmlformats.org/drawingml/2006/main">
               <a:ext uri="{FF2B5EF4-FFF2-40B4-BE49-F238E27FC236}">
-                <a16:creationId xmlns:a16="http://schemas.microsoft.com/office/drawing/2014/main" id="{E7CA2F41-4F39-4D63-A013-E1282DB1EED8}"/>
+                <a16:creationId xmlns:a16="http://schemas.microsoft.com/office/drawing/2014/main" id="{B7A09889-AB58-49D7-A4A4-7277EF525ED4}"/>
               </a:ext>
             </a:extLst>
           </p:cNvPr>
@@ -5163,7 +5282,7 @@
           <p:cNvPr id="2" name="slide-subtitle">
             <a:extLst xmlns:a="http://schemas.openxmlformats.org/drawingml/2006/main">
               <a:ext uri="{FF2B5EF4-FFF2-40B4-BE49-F238E27FC236}">
-                <a16:creationId xmlns:a16="http://schemas.microsoft.com/office/drawing/2014/main" id="{165581A4-53D8-4AE0-9F46-A7FC224DEACA}"/>
+                <a16:creationId xmlns:a16="http://schemas.microsoft.com/office/drawing/2014/main" id="{46F8F79D-452B-4414-9712-6953473FD288}"/>
               </a:ext>
             </a:extLst>
           </p:cNvPr>
@@ -5220,7 +5339,7 @@
           <p:cNvPr id="3" name="">
             <a:extLst xmlns:a="http://schemas.openxmlformats.org/drawingml/2006/main">
               <a:ext uri="{FF2B5EF4-FFF2-40B4-BE49-F238E27FC236}">
-                <a16:creationId xmlns:a16="http://schemas.microsoft.com/office/drawing/2014/main" id="{4ACE4871-B004-4AEC-8D97-CB8C87B2EF84}"/>
+                <a16:creationId xmlns:a16="http://schemas.microsoft.com/office/drawing/2014/main" id="{3E020EC4-B431-4077-9E82-68A2561F56A2}"/>
               </a:ext>
             </a:extLst>
           </p:cNvPr>
@@ -5281,7 +5400,7 @@
           <p:cNvPr id="4" name="">
             <a:extLst xmlns:a="http://schemas.openxmlformats.org/drawingml/2006/main">
               <a:ext uri="{FF2B5EF4-FFF2-40B4-BE49-F238E27FC236}">
-                <a16:creationId xmlns:a16="http://schemas.microsoft.com/office/drawing/2014/main" id="{28FCD4AB-B8BF-4D9A-8249-D59DAE34818D}"/>
+                <a16:creationId xmlns:a16="http://schemas.microsoft.com/office/drawing/2014/main" id="{7564A438-EECC-4B40-BEFA-7D5B8B73112A}"/>
               </a:ext>
             </a:extLst>
           </p:cNvPr>
@@ -5319,7 +5438,7 @@
         </p:xfrm>
         <a:graphic xmlns:a="http://schemas.openxmlformats.org/drawingml/2006/main">
           <a:graphicData uri="http://schemas.openxmlformats.org/drawingml/2006/chart">
-            <c:chart xmlns:r="http://schemas.openxmlformats.org/officeDocument/2006/relationships" xmlns:c="http://schemas.openxmlformats.org/drawingml/2006/chart" r:id="R83eb1c4e4ae94c76"/>
+            <c:chart xmlns:r="http://schemas.openxmlformats.org/officeDocument/2006/relationships" xmlns:c="http://schemas.openxmlformats.org/drawingml/2006/chart" r:id="R64c5fe6af22643c1"/>
           </a:graphicData>
         </a:graphic>
       </p:graphicFrame>
@@ -5328,7 +5447,7 @@
           <p:cNvPr id="6" name="">
             <a:extLst xmlns:a="http://schemas.openxmlformats.org/drawingml/2006/main">
               <a:ext uri="{FF2B5EF4-FFF2-40B4-BE49-F238E27FC236}">
-                <a16:creationId xmlns:a16="http://schemas.microsoft.com/office/drawing/2014/main" id="{59D949A8-B780-40DE-B7FC-B1DB354CB06E}"/>
+                <a16:creationId xmlns:a16="http://schemas.microsoft.com/office/drawing/2014/main" id="{34968153-D1DC-44B8-A21A-1547BB671017}"/>
               </a:ext>
             </a:extLst>
           </p:cNvPr>
@@ -5385,7 +5504,7 @@
           <p:cNvPr id="7" name="">
             <a:extLst xmlns:a="http://schemas.openxmlformats.org/drawingml/2006/main">
               <a:ext uri="{FF2B5EF4-FFF2-40B4-BE49-F238E27FC236}">
-                <a16:creationId xmlns:a16="http://schemas.microsoft.com/office/drawing/2014/main" id="{74DFD8D2-974F-4B4A-AF78-7DE898D2B90D}"/>
+                <a16:creationId xmlns:a16="http://schemas.microsoft.com/office/drawing/2014/main" id="{F1323C5A-E2A8-46DD-AE0A-A3C650E35F39}"/>
               </a:ext>
             </a:extLst>
           </p:cNvPr>
@@ -5440,7 +5559,7 @@
     </p:spTree>
     <p:extLst>
       <p:ext uri="{BB962C8B-B14F-4D97-AF65-F5344CB8AC3E}">
-        <p14:creationId xmlns:p14="http://schemas.microsoft.com/office/powerpoint/2010/main" val="890155560"/>
+        <p14:creationId xmlns:p14="http://schemas.microsoft.com/office/powerpoint/2010/main" val="1466435012"/>
       </p:ext>
     </p:extLst>
   </p:cSld>
@@ -5471,7 +5590,7 @@
           <p:cNvPr id="7" name="slide-title">
             <a:extLst xmlns:a="http://schemas.openxmlformats.org/drawingml/2006/main">
               <a:ext uri="{FF2B5EF4-FFF2-40B4-BE49-F238E27FC236}">
-                <a16:creationId xmlns:a16="http://schemas.microsoft.com/office/drawing/2014/main" id="{5A833F22-6F32-4CB5-9958-71CB3A5ECEE7}"/>
+                <a16:creationId xmlns:a16="http://schemas.microsoft.com/office/drawing/2014/main" id="{8282358E-82B0-4FDE-B166-C225DE3C3F5A}"/>
               </a:ext>
             </a:extLst>
           </p:cNvPr>
@@ -5528,7 +5647,7 @@
           <p:cNvPr id="2" name="">
             <a:extLst xmlns:a="http://schemas.openxmlformats.org/drawingml/2006/main">
               <a:ext uri="{FF2B5EF4-FFF2-40B4-BE49-F238E27FC236}">
-                <a16:creationId xmlns:a16="http://schemas.microsoft.com/office/drawing/2014/main" id="{3F04D9B9-6E15-40C4-9E64-5594C05FB5C6}"/>
+                <a16:creationId xmlns:a16="http://schemas.microsoft.com/office/drawing/2014/main" id="{A4DC62B3-BE67-4A79-B6E5-4FFDDE7A2786}"/>
               </a:ext>
             </a:extLst>
           </p:cNvPr>
@@ -5589,7 +5708,7 @@
           <p:cNvPr id="3" name="">
             <a:extLst xmlns:a="http://schemas.openxmlformats.org/drawingml/2006/main">
               <a:ext uri="{FF2B5EF4-FFF2-40B4-BE49-F238E27FC236}">
-                <a16:creationId xmlns:a16="http://schemas.microsoft.com/office/drawing/2014/main" id="{2895F9A3-D56F-476B-BDE2-4C56FB20FE12}"/>
+                <a16:creationId xmlns:a16="http://schemas.microsoft.com/office/drawing/2014/main" id="{C868AA23-1C10-45F2-93FB-846F7773BD23}"/>
               </a:ext>
             </a:extLst>
           </p:cNvPr>
@@ -5627,7 +5746,7 @@
         </p:xfrm>
         <a:graphic xmlns:a="http://schemas.openxmlformats.org/drawingml/2006/main">
           <a:graphicData uri="http://schemas.openxmlformats.org/drawingml/2006/chart">
-            <c:chart xmlns:r="http://schemas.openxmlformats.org/officeDocument/2006/relationships" xmlns:c="http://schemas.openxmlformats.org/drawingml/2006/chart" r:id="R0f11e802663e408e"/>
+            <c:chart xmlns:r="http://schemas.openxmlformats.org/officeDocument/2006/relationships" xmlns:c="http://schemas.openxmlformats.org/drawingml/2006/chart" r:id="R0bd7d51386a0447d"/>
           </a:graphicData>
         </a:graphic>
       </p:graphicFrame>
@@ -5636,7 +5755,7 @@
           <p:cNvPr id="5" name="">
             <a:extLst xmlns:a="http://schemas.openxmlformats.org/drawingml/2006/main">
               <a:ext uri="{FF2B5EF4-FFF2-40B4-BE49-F238E27FC236}">
-                <a16:creationId xmlns:a16="http://schemas.microsoft.com/office/drawing/2014/main" id="{6369B282-AD98-4D0C-9BD0-3796CDC4BFEF}"/>
+                <a16:creationId xmlns:a16="http://schemas.microsoft.com/office/drawing/2014/main" id="{A05A7DA4-C6CD-4A44-BDC3-293004670002}"/>
               </a:ext>
             </a:extLst>
           </p:cNvPr>
@@ -5693,7 +5812,7 @@
           <p:cNvPr id="6" name="">
             <a:extLst xmlns:a="http://schemas.openxmlformats.org/drawingml/2006/main">
               <a:ext uri="{FF2B5EF4-FFF2-40B4-BE49-F238E27FC236}">
-                <a16:creationId xmlns:a16="http://schemas.microsoft.com/office/drawing/2014/main" id="{4DAA7C8C-FD80-42CD-8E41-C31B4DA68A3B}"/>
+                <a16:creationId xmlns:a16="http://schemas.microsoft.com/office/drawing/2014/main" id="{B9574A1F-C931-469C-B47C-1F28AD8932E0}"/>
               </a:ext>
             </a:extLst>
           </p:cNvPr>
@@ -5748,7 +5867,7 @@
     </p:spTree>
     <p:extLst>
       <p:ext uri="{BB962C8B-B14F-4D97-AF65-F5344CB8AC3E}">
-        <p14:creationId xmlns:p14="http://schemas.microsoft.com/office/powerpoint/2010/main" val="1111364971"/>
+        <p14:creationId xmlns:p14="http://schemas.microsoft.com/office/powerpoint/2010/main" val="194638413"/>
       </p:ext>
     </p:extLst>
   </p:cSld>
@@ -5779,7 +5898,7 @@
           <p:cNvPr id="12" name="slide-title">
             <a:extLst xmlns:a="http://schemas.openxmlformats.org/drawingml/2006/main">
               <a:ext uri="{FF2B5EF4-FFF2-40B4-BE49-F238E27FC236}">
-                <a16:creationId xmlns:a16="http://schemas.microsoft.com/office/drawing/2014/main" id="{09D75CE9-43A8-4449-BADC-A596A0A8FA03}"/>
+                <a16:creationId xmlns:a16="http://schemas.microsoft.com/office/drawing/2014/main" id="{D4107A65-1821-45C3-8844-6E93EE811BE8}"/>
               </a:ext>
             </a:extLst>
           </p:cNvPr>
@@ -5836,7 +5955,7 @@
           <p:cNvPr id="2" name="slide-subtitle">
             <a:extLst xmlns:a="http://schemas.openxmlformats.org/drawingml/2006/main">
               <a:ext uri="{FF2B5EF4-FFF2-40B4-BE49-F238E27FC236}">
-                <a16:creationId xmlns:a16="http://schemas.microsoft.com/office/drawing/2014/main" id="{67FB2776-5221-454C-8100-685241171454}"/>
+                <a16:creationId xmlns:a16="http://schemas.microsoft.com/office/drawing/2014/main" id="{A9C9FDB1-9025-4685-B12B-921FD01F23AB}"/>
               </a:ext>
             </a:extLst>
           </p:cNvPr>
@@ -5893,7 +6012,7 @@
           <p:cNvPr id="3" name="">
             <a:extLst xmlns:a="http://schemas.openxmlformats.org/drawingml/2006/main">
               <a:ext uri="{FF2B5EF4-FFF2-40B4-BE49-F238E27FC236}">
-                <a16:creationId xmlns:a16="http://schemas.microsoft.com/office/drawing/2014/main" id="{E0339D52-8F37-4678-8DA7-08C60035F5FB}"/>
+                <a16:creationId xmlns:a16="http://schemas.microsoft.com/office/drawing/2014/main" id="{6A26A84D-AA21-4163-A9EF-87BBBF6B1556}"/>
               </a:ext>
             </a:extLst>
           </p:cNvPr>
@@ -5954,7 +6073,7 @@
           <p:cNvPr id="4" name="">
             <a:extLst xmlns:a="http://schemas.openxmlformats.org/drawingml/2006/main">
               <a:ext uri="{FF2B5EF4-FFF2-40B4-BE49-F238E27FC236}">
-                <a16:creationId xmlns:a16="http://schemas.microsoft.com/office/drawing/2014/main" id="{3781C23A-6954-41FF-84E8-56E329686995}"/>
+                <a16:creationId xmlns:a16="http://schemas.microsoft.com/office/drawing/2014/main" id="{37AC38DD-A16B-4815-B5A8-CF59D02CE279}"/>
               </a:ext>
             </a:extLst>
           </p:cNvPr>
@@ -5985,7 +6104,7 @@
           <p:cNvPr id="5" name="">
             <a:extLst xmlns:a="http://schemas.openxmlformats.org/drawingml/2006/main">
               <a:ext uri="{FF2B5EF4-FFF2-40B4-BE49-F238E27FC236}">
-                <a16:creationId xmlns:a16="http://schemas.microsoft.com/office/drawing/2014/main" id="{14825699-2261-4747-9EA6-62B2AA56C73D}"/>
+                <a16:creationId xmlns:a16="http://schemas.microsoft.com/office/drawing/2014/main" id="{DCC30248-A3AD-4475-967D-250F2F23A146}"/>
               </a:ext>
             </a:extLst>
           </p:cNvPr>
@@ -6042,7 +6161,7 @@
           <p:cNvPr id="6" name="">
             <a:extLst xmlns:a="http://schemas.openxmlformats.org/drawingml/2006/main">
               <a:ext uri="{FF2B5EF4-FFF2-40B4-BE49-F238E27FC236}">
-                <a16:creationId xmlns:a16="http://schemas.microsoft.com/office/drawing/2014/main" id="{3A9BD3A3-06DB-493B-9FB7-D5E7279ABFCE}"/>
+                <a16:creationId xmlns:a16="http://schemas.microsoft.com/office/drawing/2014/main" id="{EF3F8581-16BF-404C-AD29-E2722ADA934D}"/>
               </a:ext>
             </a:extLst>
           </p:cNvPr>
@@ -6099,7 +6218,7 @@
           <p:cNvPr id="7" name="">
             <a:extLst xmlns:a="http://schemas.openxmlformats.org/drawingml/2006/main">
               <a:ext uri="{FF2B5EF4-FFF2-40B4-BE49-F238E27FC236}">
-                <a16:creationId xmlns:a16="http://schemas.microsoft.com/office/drawing/2014/main" id="{A7BE067B-0147-4074-BC28-AECC330762A1}"/>
+                <a16:creationId xmlns:a16="http://schemas.microsoft.com/office/drawing/2014/main" id="{637570C7-6AF3-4842-A314-248C4ED709DD}"/>
               </a:ext>
             </a:extLst>
           </p:cNvPr>
@@ -6163,7 +6282,7 @@
         </p:xfrm>
         <a:graphic xmlns:a="http://schemas.openxmlformats.org/drawingml/2006/main">
           <a:graphicData uri="http://schemas.openxmlformats.org/drawingml/2006/chart">
-            <c:chart xmlns:r="http://schemas.openxmlformats.org/officeDocument/2006/relationships" xmlns:c="http://schemas.openxmlformats.org/drawingml/2006/chart" r:id="Rcd3b945c396142e3"/>
+            <c:chart xmlns:r="http://schemas.openxmlformats.org/officeDocument/2006/relationships" xmlns:c="http://schemas.openxmlformats.org/drawingml/2006/chart" r:id="R619d1d8fa5f04ecb"/>
           </a:graphicData>
         </a:graphic>
       </p:graphicFrame>
@@ -6172,7 +6291,7 @@
           <p:cNvPr id="9" name="">
             <a:extLst xmlns:a="http://schemas.openxmlformats.org/drawingml/2006/main">
               <a:ext uri="{FF2B5EF4-FFF2-40B4-BE49-F238E27FC236}">
-                <a16:creationId xmlns:a16="http://schemas.microsoft.com/office/drawing/2014/main" id="{714127F7-795E-4EFD-AE93-26147B529792}"/>
+                <a16:creationId xmlns:a16="http://schemas.microsoft.com/office/drawing/2014/main" id="{620CABA5-E1B8-4770-B4AD-4764FB15DA92}"/>
               </a:ext>
             </a:extLst>
           </p:cNvPr>
@@ -6229,7 +6348,7 @@
           <p:cNvPr id="10" name="">
             <a:extLst xmlns:a="http://schemas.openxmlformats.org/drawingml/2006/main">
               <a:ext uri="{FF2B5EF4-FFF2-40B4-BE49-F238E27FC236}">
-                <a16:creationId xmlns:a16="http://schemas.microsoft.com/office/drawing/2014/main" id="{B963C71C-8250-4974-B0BA-01C4E5326344}"/>
+                <a16:creationId xmlns:a16="http://schemas.microsoft.com/office/drawing/2014/main" id="{3FD742F2-5868-4B4E-9E44-D9FE3B3EAF3F}"/>
               </a:ext>
             </a:extLst>
           </p:cNvPr>
@@ -6286,7 +6405,7 @@
           <p:cNvPr id="11" name="">
             <a:extLst xmlns:a="http://schemas.openxmlformats.org/drawingml/2006/main">
               <a:ext uri="{FF2B5EF4-FFF2-40B4-BE49-F238E27FC236}">
-                <a16:creationId xmlns:a16="http://schemas.microsoft.com/office/drawing/2014/main" id="{64E6959A-4666-47A2-B009-A0B2B31ADF72}"/>
+                <a16:creationId xmlns:a16="http://schemas.microsoft.com/office/drawing/2014/main" id="{8E88AA8F-F8BE-48F9-AD81-51B59FD45047}"/>
               </a:ext>
             </a:extLst>
           </p:cNvPr>
@@ -6341,7 +6460,7 @@
     </p:spTree>
     <p:extLst>
       <p:ext uri="{BB962C8B-B14F-4D97-AF65-F5344CB8AC3E}">
-        <p14:creationId xmlns:p14="http://schemas.microsoft.com/office/powerpoint/2010/main" val="106739938"/>
+        <p14:creationId xmlns:p14="http://schemas.microsoft.com/office/powerpoint/2010/main" val="839166429"/>
       </p:ext>
     </p:extLst>
   </p:cSld>
@@ -6372,7 +6491,7 @@
           <p:cNvPr id="10" name="slide-title">
             <a:extLst xmlns:a="http://schemas.openxmlformats.org/drawingml/2006/main">
               <a:ext uri="{FF2B5EF4-FFF2-40B4-BE49-F238E27FC236}">
-                <a16:creationId xmlns:a16="http://schemas.microsoft.com/office/drawing/2014/main" id="{3915259D-2635-49C4-B0BD-C7DB17FF9EA3}"/>
+                <a16:creationId xmlns:a16="http://schemas.microsoft.com/office/drawing/2014/main" id="{D048B509-BE4C-4A05-8C07-BA09133A3EE7}"/>
               </a:ext>
             </a:extLst>
           </p:cNvPr>
@@ -6429,7 +6548,7 @@
           <p:cNvPr id="2" name="slide-subtitle">
             <a:extLst xmlns:a="http://schemas.openxmlformats.org/drawingml/2006/main">
               <a:ext uri="{FF2B5EF4-FFF2-40B4-BE49-F238E27FC236}">
-                <a16:creationId xmlns:a16="http://schemas.microsoft.com/office/drawing/2014/main" id="{1452ED47-050B-4598-BCEE-58FB419EB70D}"/>
+                <a16:creationId xmlns:a16="http://schemas.microsoft.com/office/drawing/2014/main" id="{D11CBDF5-EBCD-4F49-A265-D449F5A878AA}"/>
               </a:ext>
             </a:extLst>
           </p:cNvPr>
@@ -6486,7 +6605,7 @@
           <p:cNvPr id="3" name="">
             <a:extLst xmlns:a="http://schemas.openxmlformats.org/drawingml/2006/main">
               <a:ext uri="{FF2B5EF4-FFF2-40B4-BE49-F238E27FC236}">
-                <a16:creationId xmlns:a16="http://schemas.microsoft.com/office/drawing/2014/main" id="{1D83A00C-1CBA-4EE1-997A-A17E37A1525C}"/>
+                <a16:creationId xmlns:a16="http://schemas.microsoft.com/office/drawing/2014/main" id="{E2301FF3-DB19-4F10-8599-631149912AE6}"/>
               </a:ext>
             </a:extLst>
           </p:cNvPr>
@@ -6547,7 +6666,7 @@
           <p:cNvPr id="4" name="">
             <a:extLst xmlns:a="http://schemas.openxmlformats.org/drawingml/2006/main">
               <a:ext uri="{FF2B5EF4-FFF2-40B4-BE49-F238E27FC236}">
-                <a16:creationId xmlns:a16="http://schemas.microsoft.com/office/drawing/2014/main" id="{7A8EC600-085C-4B7F-8EC7-7A8746DD9F17}"/>
+                <a16:creationId xmlns:a16="http://schemas.microsoft.com/office/drawing/2014/main" id="{FB28D9A8-8103-4EAC-9553-69F1BD153DDD}"/>
               </a:ext>
             </a:extLst>
           </p:cNvPr>
@@ -6578,7 +6697,7 @@
           <p:cNvPr id="5" name="">
             <a:extLst xmlns:a="http://schemas.openxmlformats.org/drawingml/2006/main">
               <a:ext uri="{FF2B5EF4-FFF2-40B4-BE49-F238E27FC236}">
-                <a16:creationId xmlns:a16="http://schemas.microsoft.com/office/drawing/2014/main" id="{5E2E7962-CDE1-40AE-9597-ACE6690FEED2}"/>
+                <a16:creationId xmlns:a16="http://schemas.microsoft.com/office/drawing/2014/main" id="{05B1455E-2E96-42E3-A651-EE8F303575BE}"/>
               </a:ext>
             </a:extLst>
           </p:cNvPr>
@@ -6635,7 +6754,7 @@
           <p:cNvPr id="6" name="">
             <a:extLst xmlns:a="http://schemas.openxmlformats.org/drawingml/2006/main">
               <a:ext uri="{FF2B5EF4-FFF2-40B4-BE49-F238E27FC236}">
-                <a16:creationId xmlns:a16="http://schemas.microsoft.com/office/drawing/2014/main" id="{812D49EA-43D2-44BE-B9C4-A8AFE9FAB392}"/>
+                <a16:creationId xmlns:a16="http://schemas.microsoft.com/office/drawing/2014/main" id="{D06115BF-5EB1-4EC9-8F10-882E991C6867}"/>
               </a:ext>
             </a:extLst>
           </p:cNvPr>
@@ -7108,7 +7227,7 @@
           <p:cNvPr id="8" name="">
             <a:extLst xmlns:a="http://schemas.openxmlformats.org/drawingml/2006/main">
               <a:ext uri="{FF2B5EF4-FFF2-40B4-BE49-F238E27FC236}">
-                <a16:creationId xmlns:a16="http://schemas.microsoft.com/office/drawing/2014/main" id="{B2F3BE03-BBCE-4483-83A5-F343A8DAFAC0}"/>
+                <a16:creationId xmlns:a16="http://schemas.microsoft.com/office/drawing/2014/main" id="{DEAA8DCC-B77C-479E-BD19-58D59F82E122}"/>
               </a:ext>
             </a:extLst>
           </p:cNvPr>
@@ -7165,7 +7284,7 @@
           <p:cNvPr id="9" name="">
             <a:extLst xmlns:a="http://schemas.openxmlformats.org/drawingml/2006/main">
               <a:ext uri="{FF2B5EF4-FFF2-40B4-BE49-F238E27FC236}">
-                <a16:creationId xmlns:a16="http://schemas.microsoft.com/office/drawing/2014/main" id="{36591EC3-FD87-4C33-A545-FF54D9F9435B}"/>
+                <a16:creationId xmlns:a16="http://schemas.microsoft.com/office/drawing/2014/main" id="{CCD3233E-8995-4346-9296-7322065B8749}"/>
               </a:ext>
             </a:extLst>
           </p:cNvPr>
@@ -7220,7 +7339,7 @@
     </p:spTree>
     <p:extLst>
       <p:ext uri="{BB962C8B-B14F-4D97-AF65-F5344CB8AC3E}">
-        <p14:creationId xmlns:p14="http://schemas.microsoft.com/office/powerpoint/2010/main" val="343924896"/>
+        <p14:creationId xmlns:p14="http://schemas.microsoft.com/office/powerpoint/2010/main" val="775342382"/>
       </p:ext>
     </p:extLst>
   </p:cSld>
@@ -7251,7 +7370,7 @@
           <p:cNvPr id="8" name="slide-title">
             <a:extLst xmlns:a="http://schemas.openxmlformats.org/drawingml/2006/main">
               <a:ext uri="{FF2B5EF4-FFF2-40B4-BE49-F238E27FC236}">
-                <a16:creationId xmlns:a16="http://schemas.microsoft.com/office/drawing/2014/main" id="{0D38488C-41FD-4DEC-BCDD-8EC39D8810FB}"/>
+                <a16:creationId xmlns:a16="http://schemas.microsoft.com/office/drawing/2014/main" id="{C50DC2E6-9F8C-466E-B8A1-299865E7AF1D}"/>
               </a:ext>
             </a:extLst>
           </p:cNvPr>
@@ -7308,7 +7427,7 @@
           <p:cNvPr id="2" name="slide-subtitle">
             <a:extLst xmlns:a="http://schemas.openxmlformats.org/drawingml/2006/main">
               <a:ext uri="{FF2B5EF4-FFF2-40B4-BE49-F238E27FC236}">
-                <a16:creationId xmlns:a16="http://schemas.microsoft.com/office/drawing/2014/main" id="{A105C744-6F12-4FAD-A3A5-EC7577DD0B11}"/>
+                <a16:creationId xmlns:a16="http://schemas.microsoft.com/office/drawing/2014/main" id="{B41FDDD7-1BEF-41DB-8A9F-EB03DA680586}"/>
               </a:ext>
             </a:extLst>
           </p:cNvPr>
@@ -7365,7 +7484,7 @@
           <p:cNvPr id="3" name="">
             <a:extLst xmlns:a="http://schemas.openxmlformats.org/drawingml/2006/main">
               <a:ext uri="{FF2B5EF4-FFF2-40B4-BE49-F238E27FC236}">
-                <a16:creationId xmlns:a16="http://schemas.microsoft.com/office/drawing/2014/main" id="{21A2718A-07A9-4BBC-A8E9-7857577ED806}"/>
+                <a16:creationId xmlns:a16="http://schemas.microsoft.com/office/drawing/2014/main" id="{A3C993B2-D1D7-41F1-A7D3-C46F0AF274A1}"/>
               </a:ext>
             </a:extLst>
           </p:cNvPr>
@@ -7426,7 +7545,7 @@
           <p:cNvPr id="4" name="">
             <a:extLst xmlns:a="http://schemas.openxmlformats.org/drawingml/2006/main">
               <a:ext uri="{FF2B5EF4-FFF2-40B4-BE49-F238E27FC236}">
-                <a16:creationId xmlns:a16="http://schemas.microsoft.com/office/drawing/2014/main" id="{B7F5703D-E180-41C3-833F-08F586A0DADD}"/>
+                <a16:creationId xmlns:a16="http://schemas.microsoft.com/office/drawing/2014/main" id="{FC536CC8-7BB4-45F7-841A-2C89B61989F8}"/>
               </a:ext>
             </a:extLst>
           </p:cNvPr>
@@ -7850,7 +7969,7 @@
           <p:cNvPr id="6" name="">
             <a:extLst xmlns:a="http://schemas.openxmlformats.org/drawingml/2006/main">
               <a:ext uri="{FF2B5EF4-FFF2-40B4-BE49-F238E27FC236}">
-                <a16:creationId xmlns:a16="http://schemas.microsoft.com/office/drawing/2014/main" id="{07845D37-9D28-403C-BFDD-5B672E3C432E}"/>
+                <a16:creationId xmlns:a16="http://schemas.microsoft.com/office/drawing/2014/main" id="{E3894B3B-ED41-4C1B-AE96-2C78BB19DF9B}"/>
               </a:ext>
             </a:extLst>
           </p:cNvPr>
@@ -7907,7 +8026,7 @@
           <p:cNvPr id="7" name="">
             <a:extLst xmlns:a="http://schemas.openxmlformats.org/drawingml/2006/main">
               <a:ext uri="{FF2B5EF4-FFF2-40B4-BE49-F238E27FC236}">
-                <a16:creationId xmlns:a16="http://schemas.microsoft.com/office/drawing/2014/main" id="{E3D259D9-32AF-4373-B628-BB337F62E935}"/>
+                <a16:creationId xmlns:a16="http://schemas.microsoft.com/office/drawing/2014/main" id="{639A2F20-3DDA-4897-BB12-E2A330B5B89D}"/>
               </a:ext>
             </a:extLst>
           </p:cNvPr>
@@ -7962,7 +8081,7 @@
     </p:spTree>
     <p:extLst>
       <p:ext uri="{BB962C8B-B14F-4D97-AF65-F5344CB8AC3E}">
-        <p14:creationId xmlns:p14="http://schemas.microsoft.com/office/powerpoint/2010/main" val="1631343589"/>
+        <p14:creationId xmlns:p14="http://schemas.microsoft.com/office/powerpoint/2010/main" val="1472254359"/>
       </p:ext>
     </p:extLst>
   </p:cSld>

</xml_diff>

<commit_message>
Clarify slide evidence and release metadata
</commit_message>
<xml_diff>
--- a/slides/cei-moral-psychology-results-deck.pptx
+++ b/slides/cei-moral-psychology-results-deck.pptx
@@ -2,20 +2,20 @@
 <file path=ppt/presentation.xml><?xml version="1.0" encoding="utf-8"?>
 <p:presentation xmlns:p="http://schemas.openxmlformats.org/presentationml/2006/main">
   <p:sldMasterIdLst>
-    <p:sldMasterId xmlns:r="http://schemas.openxmlformats.org/officeDocument/2006/relationships" id="2147483648" r:id="R61cd8b7a0e634a0e"/>
+    <p:sldMasterId xmlns:r="http://schemas.openxmlformats.org/officeDocument/2006/relationships" id="2147483648" r:id="Rdcf63d9084a84398"/>
   </p:sldMasterIdLst>
   <p:notesMasterIdLst>
-    <p:notesMasterId xmlns:r="http://schemas.openxmlformats.org/officeDocument/2006/relationships" r:id="R990e15a58efa4467"/>
+    <p:notesMasterId xmlns:r="http://schemas.openxmlformats.org/officeDocument/2006/relationships" r:id="R52684c4be9d74455"/>
   </p:notesMasterIdLst>
   <p:sldIdLst>
-    <p:sldId xmlns:r="http://schemas.openxmlformats.org/officeDocument/2006/relationships" id="256" r:id="R8e86394e54734515"/>
-    <p:sldId xmlns:r="http://schemas.openxmlformats.org/officeDocument/2006/relationships" id="257" r:id="R4af1f1d8d7f24a27"/>
-    <p:sldId xmlns:r="http://schemas.openxmlformats.org/officeDocument/2006/relationships" id="258" r:id="Rcc5aca3358c54a8d"/>
-    <p:sldId xmlns:r="http://schemas.openxmlformats.org/officeDocument/2006/relationships" id="259" r:id="R80f339c386b24948"/>
-    <p:sldId xmlns:r="http://schemas.openxmlformats.org/officeDocument/2006/relationships" id="260" r:id="R43eafd66d5ec4c1d"/>
-    <p:sldId xmlns:r="http://schemas.openxmlformats.org/officeDocument/2006/relationships" id="261" r:id="R59eb355073104c30"/>
-    <p:sldId xmlns:r="http://schemas.openxmlformats.org/officeDocument/2006/relationships" id="262" r:id="R40e0262293a94300"/>
-    <p:sldId xmlns:r="http://schemas.openxmlformats.org/officeDocument/2006/relationships" id="263" r:id="Rc806270a275f4200"/>
+    <p:sldId xmlns:r="http://schemas.openxmlformats.org/officeDocument/2006/relationships" id="256" r:id="R28316098380046eb"/>
+    <p:sldId xmlns:r="http://schemas.openxmlformats.org/officeDocument/2006/relationships" id="257" r:id="R60ef4dffb91541d6"/>
+    <p:sldId xmlns:r="http://schemas.openxmlformats.org/officeDocument/2006/relationships" id="258" r:id="Ra42e66c4d5324c60"/>
+    <p:sldId xmlns:r="http://schemas.openxmlformats.org/officeDocument/2006/relationships" id="259" r:id="R59bc5b76c2d749b6"/>
+    <p:sldId xmlns:r="http://schemas.openxmlformats.org/officeDocument/2006/relationships" id="260" r:id="Re52612187c24413f"/>
+    <p:sldId xmlns:r="http://schemas.openxmlformats.org/officeDocument/2006/relationships" id="261" r:id="Rfd495d76baec4ac4"/>
+    <p:sldId xmlns:r="http://schemas.openxmlformats.org/officeDocument/2006/relationships" id="262" r:id="Re74b7d5afe3d4f02"/>
+    <p:sldId xmlns:r="http://schemas.openxmlformats.org/officeDocument/2006/relationships" id="263" r:id="R3c764319d77b453a"/>
   </p:sldIdLst>
   <p:sldSz cx="12192000" cy="6858000"/>
   <p:notesSz cx="6858000" cy="9144000"/>
@@ -889,7 +889,7 @@
           <a:lstStyle xmlns:a="http://schemas.openxmlformats.org/drawingml/2006/main"/>
           <a:p xmlns:a="http://schemas.openxmlformats.org/drawingml/2006/main">
             <a:r>
-              <a:t>Sources: data/results/release_path_summary.csv; data/results/release_period_task_points.csv; evidence/model-parameter-sources.csv.</a:t>
+              <a:t>Sources: data/results/release_path_summary.csv; data/results/release_period_task_points.csv; data/model_release_periods.csv; evidence/model-parameter-sources.csv.</a:t>
             </a:r>
           </a:p>
           <a:p xmlns:a="http://schemas.openxmlformats.org/drawingml/2006/main">
@@ -1147,7 +1147,7 @@
   </p:cSld>
   <p:clrMap bg1="lt1" tx1="dk1" bg2="lt2" tx2="dk2" accent1="accent1" accent2="accent2" accent3="accent3" accent4="accent4" accent5="accent5" accent6="accent6" hlink="hlink" folHlink="folHlink"/>
   <p:sldLayoutIdLst>
-    <p:sldLayoutId xmlns:r="http://schemas.openxmlformats.org/officeDocument/2006/relationships" id="2147483649" r:id="R4019ee32aa014baa"/>
+    <p:sldLayoutId xmlns:r="http://schemas.openxmlformats.org/officeDocument/2006/relationships" id="2147483649" r:id="Ra24c1e3d7a9149ea"/>
   </p:sldLayoutIdLst>
   <p:txStyles>
     <p:titleStyle>
@@ -2563,7 +2563,7 @@
                     <a:ea typeface="Aptos"/>
                     <a:cs typeface="Aptos"/>
                   </a:rPr>
-                  <a:t>Published total parameter count within the Gemma 3 family</a:t>
+                  <a:t>Gemma variants ordered by published total parameters</a:t>
                 </a:r>
               </a:p>
             </c:rich>
@@ -3123,7 +3123,7 @@
           <p:cNvPr id="7" name="cover-title">
             <a:extLst xmlns:a="http://schemas.openxmlformats.org/drawingml/2006/main">
               <a:ext uri="{FF2B5EF4-FFF2-40B4-BE49-F238E27FC236}">
-                <a16:creationId xmlns:a16="http://schemas.microsoft.com/office/drawing/2014/main" id="{DBAF1B79-1470-4F91-B929-8CCB3A3F06CF}"/>
+                <a16:creationId xmlns:a16="http://schemas.microsoft.com/office/drawing/2014/main" id="{23FA2206-BDD9-42CF-880C-93988009AF0E}"/>
               </a:ext>
             </a:extLst>
           </p:cNvPr>
@@ -3203,7 +3203,7 @@
           <p:cNvPr id="2" name="">
             <a:extLst xmlns:a="http://schemas.openxmlformats.org/drawingml/2006/main">
               <a:ext uri="{FF2B5EF4-FFF2-40B4-BE49-F238E27FC236}">
-                <a16:creationId xmlns:a16="http://schemas.microsoft.com/office/drawing/2014/main" id="{495EF5D1-3CA1-44E6-8A14-25F9ECAFCCBD}"/>
+                <a16:creationId xmlns:a16="http://schemas.microsoft.com/office/drawing/2014/main" id="{3C4B8375-F024-4CDC-AA25-CCD3EA85D61C}"/>
               </a:ext>
             </a:extLst>
           </p:cNvPr>
@@ -3260,7 +3260,7 @@
           <p:cNvPr id="3" name="">
             <a:extLst xmlns:a="http://schemas.openxmlformats.org/drawingml/2006/main">
               <a:ext uri="{FF2B5EF4-FFF2-40B4-BE49-F238E27FC236}">
-                <a16:creationId xmlns:a16="http://schemas.microsoft.com/office/drawing/2014/main" id="{771361B1-B8EF-4CC0-B5DC-2BCEB14A78AB}"/>
+                <a16:creationId xmlns:a16="http://schemas.microsoft.com/office/drawing/2014/main" id="{1F0B8570-5D06-4A0E-B587-9C1D657568B3}"/>
               </a:ext>
             </a:extLst>
           </p:cNvPr>
@@ -3317,7 +3317,7 @@
           <p:cNvPr id="4" name="">
             <a:extLst xmlns:a="http://schemas.openxmlformats.org/drawingml/2006/main">
               <a:ext uri="{FF2B5EF4-FFF2-40B4-BE49-F238E27FC236}">
-                <a16:creationId xmlns:a16="http://schemas.microsoft.com/office/drawing/2014/main" id="{4563625F-59A7-47A1-8199-6478178CF948}"/>
+                <a16:creationId xmlns:a16="http://schemas.microsoft.com/office/drawing/2014/main" id="{109F0233-8290-4EC9-9EA2-A9A82FD17EC6}"/>
               </a:ext>
             </a:extLst>
           </p:cNvPr>
@@ -3348,7 +3348,7 @@
           <p:cNvPr id="5" name="">
             <a:extLst xmlns:a="http://schemas.openxmlformats.org/drawingml/2006/main">
               <a:ext uri="{FF2B5EF4-FFF2-40B4-BE49-F238E27FC236}">
-                <a16:creationId xmlns:a16="http://schemas.microsoft.com/office/drawing/2014/main" id="{1D84E92B-4135-492F-B2EB-77D725358130}"/>
+                <a16:creationId xmlns:a16="http://schemas.microsoft.com/office/drawing/2014/main" id="{7733683A-0666-41F4-86B4-CE04EB3C84C2}"/>
               </a:ext>
             </a:extLst>
           </p:cNvPr>
@@ -3405,7 +3405,7 @@
           <p:cNvPr id="6" name="">
             <a:extLst xmlns:a="http://schemas.openxmlformats.org/drawingml/2006/main">
               <a:ext uri="{FF2B5EF4-FFF2-40B4-BE49-F238E27FC236}">
-                <a16:creationId xmlns:a16="http://schemas.microsoft.com/office/drawing/2014/main" id="{DD0132A2-4D6F-469C-903A-123363C7A073}"/>
+                <a16:creationId xmlns:a16="http://schemas.microsoft.com/office/drawing/2014/main" id="{41A47809-8D02-4742-8AC9-856FCE31997B}"/>
               </a:ext>
             </a:extLst>
           </p:cNvPr>
@@ -3460,7 +3460,7 @@
     </p:spTree>
     <p:extLst>
       <p:ext uri="{BB962C8B-B14F-4D97-AF65-F5344CB8AC3E}">
-        <p14:creationId xmlns:p14="http://schemas.microsoft.com/office/powerpoint/2010/main" val="1342251856"/>
+        <p14:creationId xmlns:p14="http://schemas.microsoft.com/office/powerpoint/2010/main" val="1540705597"/>
       </p:ext>
     </p:extLst>
   </p:cSld>
@@ -3491,7 +3491,7 @@
           <p:cNvPr id="8" name="slide-title">
             <a:extLst xmlns:a="http://schemas.openxmlformats.org/drawingml/2006/main">
               <a:ext uri="{FF2B5EF4-FFF2-40B4-BE49-F238E27FC236}">
-                <a16:creationId xmlns:a16="http://schemas.microsoft.com/office/drawing/2014/main" id="{501876E5-BBD3-4124-B251-E1D8062242F6}"/>
+                <a16:creationId xmlns:a16="http://schemas.microsoft.com/office/drawing/2014/main" id="{F8A64EDA-16ED-43D5-BA29-FA8A6EA4A880}"/>
               </a:ext>
             </a:extLst>
           </p:cNvPr>
@@ -3548,7 +3548,7 @@
           <p:cNvPr id="2" name="slide-subtitle">
             <a:extLst xmlns:a="http://schemas.openxmlformats.org/drawingml/2006/main">
               <a:ext uri="{FF2B5EF4-FFF2-40B4-BE49-F238E27FC236}">
-                <a16:creationId xmlns:a16="http://schemas.microsoft.com/office/drawing/2014/main" id="{E325D4E8-3CD9-4FE2-8D2A-C9C8A8EC67BD}"/>
+                <a16:creationId xmlns:a16="http://schemas.microsoft.com/office/drawing/2014/main" id="{09848AF5-A81F-4381-8040-344908193E09}"/>
               </a:ext>
             </a:extLst>
           </p:cNvPr>
@@ -3605,7 +3605,7 @@
           <p:cNvPr id="3" name="">
             <a:extLst xmlns:a="http://schemas.openxmlformats.org/drawingml/2006/main">
               <a:ext uri="{FF2B5EF4-FFF2-40B4-BE49-F238E27FC236}">
-                <a16:creationId xmlns:a16="http://schemas.microsoft.com/office/drawing/2014/main" id="{F0B44462-9E39-494F-BD10-C9F2F2864435}"/>
+                <a16:creationId xmlns:a16="http://schemas.microsoft.com/office/drawing/2014/main" id="{6F4D3E0A-2AF7-4DAE-9CC8-174047319E46}"/>
               </a:ext>
             </a:extLst>
           </p:cNvPr>
@@ -3666,7 +3666,7 @@
           <p:cNvPr id="4" name="">
             <a:extLst xmlns:a="http://schemas.openxmlformats.org/drawingml/2006/main">
               <a:ext uri="{FF2B5EF4-FFF2-40B4-BE49-F238E27FC236}">
-                <a16:creationId xmlns:a16="http://schemas.microsoft.com/office/drawing/2014/main" id="{C3318DFD-806E-4F3F-A9A5-D6DFB89585AE}"/>
+                <a16:creationId xmlns:a16="http://schemas.microsoft.com/office/drawing/2014/main" id="{E7896B7A-3480-413F-B64F-B193308A1BCE}"/>
               </a:ext>
             </a:extLst>
           </p:cNvPr>
@@ -4603,7 +4603,7 @@
           <p:cNvPr id="6" name="">
             <a:extLst xmlns:a="http://schemas.openxmlformats.org/drawingml/2006/main">
               <a:ext uri="{FF2B5EF4-FFF2-40B4-BE49-F238E27FC236}">
-                <a16:creationId xmlns:a16="http://schemas.microsoft.com/office/drawing/2014/main" id="{2A4ED951-5B5C-43B9-BF2A-6A75C62BA76F}"/>
+                <a16:creationId xmlns:a16="http://schemas.microsoft.com/office/drawing/2014/main" id="{B071CAC1-9941-4C3B-9603-0A8CA5FF8741}"/>
               </a:ext>
             </a:extLst>
           </p:cNvPr>
@@ -4660,7 +4660,7 @@
           <p:cNvPr id="7" name="">
             <a:extLst xmlns:a="http://schemas.openxmlformats.org/drawingml/2006/main">
               <a:ext uri="{FF2B5EF4-FFF2-40B4-BE49-F238E27FC236}">
-                <a16:creationId xmlns:a16="http://schemas.microsoft.com/office/drawing/2014/main" id="{9A3BABAF-0004-433A-8A57-0CFD4D68BA75}"/>
+                <a16:creationId xmlns:a16="http://schemas.microsoft.com/office/drawing/2014/main" id="{ED06E150-3124-4E40-A541-E3AC3158D785}"/>
               </a:ext>
             </a:extLst>
           </p:cNvPr>
@@ -4715,7 +4715,7 @@
     </p:spTree>
     <p:extLst>
       <p:ext uri="{BB962C8B-B14F-4D97-AF65-F5344CB8AC3E}">
-        <p14:creationId xmlns:p14="http://schemas.microsoft.com/office/powerpoint/2010/main" val="1326189787"/>
+        <p14:creationId xmlns:p14="http://schemas.microsoft.com/office/powerpoint/2010/main" val="1891365037"/>
       </p:ext>
     </p:extLst>
   </p:cSld>
@@ -4746,7 +4746,7 @@
           <p:cNvPr id="10" name="slide-title">
             <a:extLst xmlns:a="http://schemas.openxmlformats.org/drawingml/2006/main">
               <a:ext uri="{FF2B5EF4-FFF2-40B4-BE49-F238E27FC236}">
-                <a16:creationId xmlns:a16="http://schemas.microsoft.com/office/drawing/2014/main" id="{B549F0AC-DC8C-49C5-A5D6-9C46D881EEB2}"/>
+                <a16:creationId xmlns:a16="http://schemas.microsoft.com/office/drawing/2014/main" id="{F7686218-E9AD-4780-90D7-ADA42E09E675}"/>
               </a:ext>
             </a:extLst>
           </p:cNvPr>
@@ -4803,7 +4803,7 @@
           <p:cNvPr id="2" name="slide-subtitle">
             <a:extLst xmlns:a="http://schemas.openxmlformats.org/drawingml/2006/main">
               <a:ext uri="{FF2B5EF4-FFF2-40B4-BE49-F238E27FC236}">
-                <a16:creationId xmlns:a16="http://schemas.microsoft.com/office/drawing/2014/main" id="{B79854F2-E8E6-4694-9D37-E9335C658ED3}"/>
+                <a16:creationId xmlns:a16="http://schemas.microsoft.com/office/drawing/2014/main" id="{557B42DF-5C3F-4524-9476-E905C829169A}"/>
               </a:ext>
             </a:extLst>
           </p:cNvPr>
@@ -4860,7 +4860,7 @@
           <p:cNvPr id="3" name="">
             <a:extLst xmlns:a="http://schemas.openxmlformats.org/drawingml/2006/main">
               <a:ext uri="{FF2B5EF4-FFF2-40B4-BE49-F238E27FC236}">
-                <a16:creationId xmlns:a16="http://schemas.microsoft.com/office/drawing/2014/main" id="{70A9DCE7-2804-4583-9210-6CE662708315}"/>
+                <a16:creationId xmlns:a16="http://schemas.microsoft.com/office/drawing/2014/main" id="{AEB78AC8-4CF4-4188-B3CB-14D04D56A47A}"/>
               </a:ext>
             </a:extLst>
           </p:cNvPr>
@@ -4921,7 +4921,7 @@
           <p:cNvPr id="4" name="">
             <a:extLst xmlns:a="http://schemas.openxmlformats.org/drawingml/2006/main">
               <a:ext uri="{FF2B5EF4-FFF2-40B4-BE49-F238E27FC236}">
-                <a16:creationId xmlns:a16="http://schemas.microsoft.com/office/drawing/2014/main" id="{43D6CC02-EB4C-4F2E-8AE1-30EFDDA9DA7C}"/>
+                <a16:creationId xmlns:a16="http://schemas.microsoft.com/office/drawing/2014/main" id="{12C82605-8EE3-46A5-ADAA-8C9DEEA2C32A}"/>
               </a:ext>
             </a:extLst>
           </p:cNvPr>
@@ -4952,7 +4952,7 @@
           <p:cNvPr id="5" name="">
             <a:extLst xmlns:a="http://schemas.openxmlformats.org/drawingml/2006/main">
               <a:ext uri="{FF2B5EF4-FFF2-40B4-BE49-F238E27FC236}">
-                <a16:creationId xmlns:a16="http://schemas.microsoft.com/office/drawing/2014/main" id="{44EEC586-67DC-4847-8686-596423D5130B}"/>
+                <a16:creationId xmlns:a16="http://schemas.microsoft.com/office/drawing/2014/main" id="{5336EE74-E189-4C19-8B09-DC12093B2294}"/>
               </a:ext>
             </a:extLst>
           </p:cNvPr>
@@ -5016,7 +5016,7 @@
         </p:xfrm>
         <a:graphic xmlns:a="http://schemas.openxmlformats.org/drawingml/2006/main">
           <a:graphicData uri="http://schemas.openxmlformats.org/drawingml/2006/chart">
-            <c:chart xmlns:r="http://schemas.openxmlformats.org/officeDocument/2006/relationships" xmlns:c="http://schemas.openxmlformats.org/drawingml/2006/chart" r:id="R29b1b8b7029e4326"/>
+            <c:chart xmlns:r="http://schemas.openxmlformats.org/officeDocument/2006/relationships" xmlns:c="http://schemas.openxmlformats.org/drawingml/2006/chart" r:id="Rbea0eff9e2794173"/>
           </a:graphicData>
         </a:graphic>
       </p:graphicFrame>
@@ -5025,7 +5025,7 @@
           <p:cNvPr id="7" name="">
             <a:extLst xmlns:a="http://schemas.openxmlformats.org/drawingml/2006/main">
               <a:ext uri="{FF2B5EF4-FFF2-40B4-BE49-F238E27FC236}">
-                <a16:creationId xmlns:a16="http://schemas.microsoft.com/office/drawing/2014/main" id="{E57CCB19-3063-4B77-9530-ED6A0518222F}"/>
+                <a16:creationId xmlns:a16="http://schemas.microsoft.com/office/drawing/2014/main" id="{A0178A51-0432-4086-8370-BB3C05BEB176}"/>
               </a:ext>
             </a:extLst>
           </p:cNvPr>
@@ -5082,7 +5082,7 @@
           <p:cNvPr id="8" name="">
             <a:extLst xmlns:a="http://schemas.openxmlformats.org/drawingml/2006/main">
               <a:ext uri="{FF2B5EF4-FFF2-40B4-BE49-F238E27FC236}">
-                <a16:creationId xmlns:a16="http://schemas.microsoft.com/office/drawing/2014/main" id="{7BC87FE3-427F-47BD-8C3D-829E42C9F065}"/>
+                <a16:creationId xmlns:a16="http://schemas.microsoft.com/office/drawing/2014/main" id="{9F50F310-50CC-43F6-BF90-7974FC7715FE}"/>
               </a:ext>
             </a:extLst>
           </p:cNvPr>
@@ -5139,7 +5139,7 @@
           <p:cNvPr id="9" name="">
             <a:extLst xmlns:a="http://schemas.openxmlformats.org/drawingml/2006/main">
               <a:ext uri="{FF2B5EF4-FFF2-40B4-BE49-F238E27FC236}">
-                <a16:creationId xmlns:a16="http://schemas.microsoft.com/office/drawing/2014/main" id="{C44D7A6C-45CB-402D-9C98-112F05E034D2}"/>
+                <a16:creationId xmlns:a16="http://schemas.microsoft.com/office/drawing/2014/main" id="{E7760CC9-7627-4636-993D-1373DA583C4B}"/>
               </a:ext>
             </a:extLst>
           </p:cNvPr>
@@ -5194,7 +5194,7 @@
     </p:spTree>
     <p:extLst>
       <p:ext uri="{BB962C8B-B14F-4D97-AF65-F5344CB8AC3E}">
-        <p14:creationId xmlns:p14="http://schemas.microsoft.com/office/powerpoint/2010/main" val="2050498249"/>
+        <p14:creationId xmlns:p14="http://schemas.microsoft.com/office/powerpoint/2010/main" val="1887841718"/>
       </p:ext>
     </p:extLst>
   </p:cSld>
@@ -5222,10 +5222,10 @@
       </p:grpSpPr>
       <p:sp>
         <p:nvSpPr>
-          <p:cNvPr id="8" name="slide-title">
+          <p:cNvPr id="9" name="slide-title">
             <a:extLst xmlns:a="http://schemas.openxmlformats.org/drawingml/2006/main">
               <a:ext uri="{FF2B5EF4-FFF2-40B4-BE49-F238E27FC236}">
-                <a16:creationId xmlns:a16="http://schemas.microsoft.com/office/drawing/2014/main" id="{B7A09889-AB58-49D7-A4A4-7277EF525ED4}"/>
+                <a16:creationId xmlns:a16="http://schemas.microsoft.com/office/drawing/2014/main" id="{13AF2979-C8C3-4AA9-979C-89BF7A524A17}"/>
               </a:ext>
             </a:extLst>
           </p:cNvPr>
@@ -5282,7 +5282,7 @@
           <p:cNvPr id="2" name="slide-subtitle">
             <a:extLst xmlns:a="http://schemas.openxmlformats.org/drawingml/2006/main">
               <a:ext uri="{FF2B5EF4-FFF2-40B4-BE49-F238E27FC236}">
-                <a16:creationId xmlns:a16="http://schemas.microsoft.com/office/drawing/2014/main" id="{46F8F79D-452B-4414-9712-6953473FD288}"/>
+                <a16:creationId xmlns:a16="http://schemas.microsoft.com/office/drawing/2014/main" id="{7A209F66-D6EA-4BFF-852B-1BBB05AAE265}"/>
               </a:ext>
             </a:extLst>
           </p:cNvPr>
@@ -5339,7 +5339,7 @@
           <p:cNvPr id="3" name="">
             <a:extLst xmlns:a="http://schemas.openxmlformats.org/drawingml/2006/main">
               <a:ext uri="{FF2B5EF4-FFF2-40B4-BE49-F238E27FC236}">
-                <a16:creationId xmlns:a16="http://schemas.microsoft.com/office/drawing/2014/main" id="{3E020EC4-B431-4077-9E82-68A2561F56A2}"/>
+                <a16:creationId xmlns:a16="http://schemas.microsoft.com/office/drawing/2014/main" id="{98F370EF-334B-4DA7-8939-99EEA4662828}"/>
               </a:ext>
             </a:extLst>
           </p:cNvPr>
@@ -5400,7 +5400,7 @@
           <p:cNvPr id="4" name="">
             <a:extLst xmlns:a="http://schemas.openxmlformats.org/drawingml/2006/main">
               <a:ext uri="{FF2B5EF4-FFF2-40B4-BE49-F238E27FC236}">
-                <a16:creationId xmlns:a16="http://schemas.microsoft.com/office/drawing/2014/main" id="{7564A438-EECC-4B40-BEFA-7D5B8B73112A}"/>
+                <a16:creationId xmlns:a16="http://schemas.microsoft.com/office/drawing/2014/main" id="{28335A8E-CDD0-419C-A240-C3C31EE9D37A}"/>
               </a:ext>
             </a:extLst>
           </p:cNvPr>
@@ -5428,7 +5428,7 @@
       </p:sp>
       <p:graphicFrame>
         <p:nvGraphicFramePr>
-          <p:cNvPr id="12" name="Chart"/>
+          <p:cNvPr id="13" name="Chart"/>
           <p:cNvGraphicFramePr/>
           <p:nvPr/>
         </p:nvGraphicFramePr>
@@ -5438,7 +5438,7 @@
         </p:xfrm>
         <a:graphic xmlns:a="http://schemas.openxmlformats.org/drawingml/2006/main">
           <a:graphicData uri="http://schemas.openxmlformats.org/drawingml/2006/chart">
-            <c:chart xmlns:r="http://schemas.openxmlformats.org/officeDocument/2006/relationships" xmlns:c="http://schemas.openxmlformats.org/drawingml/2006/chart" r:id="R64c5fe6af22643c1"/>
+            <c:chart xmlns:r="http://schemas.openxmlformats.org/officeDocument/2006/relationships" xmlns:c="http://schemas.openxmlformats.org/drawingml/2006/chart" r:id="R8874bd99273b48b3"/>
           </a:graphicData>
         </a:graphic>
       </p:graphicFrame>
@@ -5447,7 +5447,64 @@
           <p:cNvPr id="6" name="">
             <a:extLst xmlns:a="http://schemas.openxmlformats.org/drawingml/2006/main">
               <a:ext uri="{FF2B5EF4-FFF2-40B4-BE49-F238E27FC236}">
-                <a16:creationId xmlns:a16="http://schemas.microsoft.com/office/drawing/2014/main" id="{34968153-D1DC-44B8-A21A-1547BB671017}"/>
+                <a16:creationId xmlns:a16="http://schemas.microsoft.com/office/drawing/2014/main" id="{ED20F61A-833E-438E-9FDD-9B31F5AA2F1B}"/>
+              </a:ext>
+            </a:extLst>
+          </p:cNvPr>
+          <p:cNvSpPr>
+            <a:spLocks xmlns:a="http://schemas.openxmlformats.org/drawingml/2006/main" noGrp="1"/>
+          </p:cNvSpPr>
+          <p:nvPr/>
+        </p:nvSpPr>
+        <p:spPr>
+          <a:xfrm xmlns:a="http://schemas.openxmlformats.org/drawingml/2006/main">
+            <a:off x="1428750" y="5010150"/>
+            <a:ext cx="8572500" cy="228600"/>
+          </a:xfrm>
+          <a:prstGeom xmlns:a="http://schemas.openxmlformats.org/drawingml/2006/main" prst="rect">
+            <a:avLst/>
+          </a:prstGeom>
+          <a:noFill xmlns:a="http://schemas.openxmlformats.org/drawingml/2006/main"/>
+          <a:ln xmlns:a="http://schemas.openxmlformats.org/drawingml/2006/main" w="0">
+            <a:noFill/>
+          </a:ln>
+        </p:spPr>
+        <p:txBody>
+          <a:bodyPr xmlns:a="http://schemas.openxmlformats.org/drawingml/2006/main">
+            <a:normAutofit fontScale="85714"/>
+          </a:bodyPr>
+          <a:lstStyle xmlns:a="http://schemas.openxmlformats.org/drawingml/2006/main"/>
+          <a:p xmlns:a="http://schemas.openxmlformats.org/drawingml/2006/main">
+            <a:pPr algn="l">
+              <a:defRPr sz="1050" b="0">
+                <a:solidFill>
+                  <a:srgbClr val="66727E"/>
+                </a:solidFill>
+                <a:latin typeface="Aptos"/>
+                <a:ea typeface="Aptos"/>
+                <a:cs typeface="Aptos"/>
+              </a:defRPr>
+            </a:pPr>
+            <a:r>
+              <a:rPr sz="1050" b="0">
+                <a:solidFill>
+                  <a:srgbClr val="66727E"/>
+                </a:solidFill>
+                <a:latin typeface="Aptos"/>
+                <a:ea typeface="Aptos"/>
+                <a:cs typeface="Aptos"/>
+              </a:rPr>
+              <a:t>Each bar counts model-family × task cases (12 total).</a:t>
+            </a:r>
+          </a:p>
+        </p:txBody>
+      </p:sp>
+      <p:sp>
+        <p:nvSpPr>
+          <p:cNvPr id="7" name="">
+            <a:extLst xmlns:a="http://schemas.openxmlformats.org/drawingml/2006/main">
+              <a:ext uri="{FF2B5EF4-FFF2-40B4-BE49-F238E27FC236}">
+                <a16:creationId xmlns:a16="http://schemas.microsoft.com/office/drawing/2014/main" id="{ED964583-A207-410F-BA25-FB4979EE9BD2}"/>
               </a:ext>
             </a:extLst>
           </p:cNvPr>
@@ -5501,10 +5558,10 @@
       </p:sp>
       <p:sp>
         <p:nvSpPr>
-          <p:cNvPr id="7" name="">
+          <p:cNvPr id="8" name="">
             <a:extLst xmlns:a="http://schemas.openxmlformats.org/drawingml/2006/main">
               <a:ext uri="{FF2B5EF4-FFF2-40B4-BE49-F238E27FC236}">
-                <a16:creationId xmlns:a16="http://schemas.microsoft.com/office/drawing/2014/main" id="{F1323C5A-E2A8-46DD-AE0A-A3C650E35F39}"/>
+                <a16:creationId xmlns:a16="http://schemas.microsoft.com/office/drawing/2014/main" id="{3E56E9C8-8EC3-472C-8F9D-3E28FDCA77C5}"/>
               </a:ext>
             </a:extLst>
           </p:cNvPr>
@@ -5559,7 +5616,7 @@
     </p:spTree>
     <p:extLst>
       <p:ext uri="{BB962C8B-B14F-4D97-AF65-F5344CB8AC3E}">
-        <p14:creationId xmlns:p14="http://schemas.microsoft.com/office/powerpoint/2010/main" val="1466435012"/>
+        <p14:creationId xmlns:p14="http://schemas.microsoft.com/office/powerpoint/2010/main" val="1399440294"/>
       </p:ext>
     </p:extLst>
   </p:cSld>
@@ -5590,7 +5647,7 @@
           <p:cNvPr id="7" name="slide-title">
             <a:extLst xmlns:a="http://schemas.openxmlformats.org/drawingml/2006/main">
               <a:ext uri="{FF2B5EF4-FFF2-40B4-BE49-F238E27FC236}">
-                <a16:creationId xmlns:a16="http://schemas.microsoft.com/office/drawing/2014/main" id="{8282358E-82B0-4FDE-B166-C225DE3C3F5A}"/>
+                <a16:creationId xmlns:a16="http://schemas.microsoft.com/office/drawing/2014/main" id="{F9101F7A-5963-4B3F-BA40-99977E4855A9}"/>
               </a:ext>
             </a:extLst>
           </p:cNvPr>
@@ -5614,7 +5671,7 @@
         </p:spPr>
         <p:txBody>
           <a:bodyPr xmlns:a="http://schemas.openxmlformats.org/drawingml/2006/main">
-            <a:normAutofit fontScale="95560"/>
+            <a:normAutofit fontScale="100000"/>
           </a:bodyPr>
           <a:lstStyle xmlns:a="http://schemas.openxmlformats.org/drawingml/2006/main"/>
           <a:p xmlns:a="http://schemas.openxmlformats.org/drawingml/2006/main">
@@ -5637,7 +5694,7 @@
                 <a:ea typeface="Aptos"/>
                 <a:cs typeface="Aptos"/>
               </a:rPr>
-              <a:t>The same Gemma models move in opposite directions</a:t>
+              <a:t>Gemma scores rise on one task and fall on another</a:t>
             </a:r>
           </a:p>
         </p:txBody>
@@ -5647,7 +5704,7 @@
           <p:cNvPr id="2" name="">
             <a:extLst xmlns:a="http://schemas.openxmlformats.org/drawingml/2006/main">
               <a:ext uri="{FF2B5EF4-FFF2-40B4-BE49-F238E27FC236}">
-                <a16:creationId xmlns:a16="http://schemas.microsoft.com/office/drawing/2014/main" id="{A4DC62B3-BE67-4A79-B6E5-4FFDDE7A2786}"/>
+                <a16:creationId xmlns:a16="http://schemas.microsoft.com/office/drawing/2014/main" id="{F19763A0-8B89-4924-BBFE-D6B4D6C3FB1B}"/>
               </a:ext>
             </a:extLst>
           </p:cNvPr>
@@ -5708,7 +5765,7 @@
           <p:cNvPr id="3" name="">
             <a:extLst xmlns:a="http://schemas.openxmlformats.org/drawingml/2006/main">
               <a:ext uri="{FF2B5EF4-FFF2-40B4-BE49-F238E27FC236}">
-                <a16:creationId xmlns:a16="http://schemas.microsoft.com/office/drawing/2014/main" id="{C868AA23-1C10-45F2-93FB-846F7773BD23}"/>
+                <a16:creationId xmlns:a16="http://schemas.microsoft.com/office/drawing/2014/main" id="{B43312F9-05F6-40AA-9F51-34F575E8212F}"/>
               </a:ext>
             </a:extLst>
           </p:cNvPr>
@@ -5746,7 +5803,7 @@
         </p:xfrm>
         <a:graphic xmlns:a="http://schemas.openxmlformats.org/drawingml/2006/main">
           <a:graphicData uri="http://schemas.openxmlformats.org/drawingml/2006/chart">
-            <c:chart xmlns:r="http://schemas.openxmlformats.org/officeDocument/2006/relationships" xmlns:c="http://schemas.openxmlformats.org/drawingml/2006/chart" r:id="R0bd7d51386a0447d"/>
+            <c:chart xmlns:r="http://schemas.openxmlformats.org/officeDocument/2006/relationships" xmlns:c="http://schemas.openxmlformats.org/drawingml/2006/chart" r:id="R1168b3b2784648e4"/>
           </a:graphicData>
         </a:graphic>
       </p:graphicFrame>
@@ -5755,7 +5812,7 @@
           <p:cNvPr id="5" name="">
             <a:extLst xmlns:a="http://schemas.openxmlformats.org/drawingml/2006/main">
               <a:ext uri="{FF2B5EF4-FFF2-40B4-BE49-F238E27FC236}">
-                <a16:creationId xmlns:a16="http://schemas.microsoft.com/office/drawing/2014/main" id="{A05A7DA4-C6CD-4A44-BDC3-293004670002}"/>
+                <a16:creationId xmlns:a16="http://schemas.microsoft.com/office/drawing/2014/main" id="{51B3D2D6-7E37-4438-81D0-31DA9F849536}"/>
               </a:ext>
             </a:extLst>
           </p:cNvPr>
@@ -5812,7 +5869,7 @@
           <p:cNvPr id="6" name="">
             <a:extLst xmlns:a="http://schemas.openxmlformats.org/drawingml/2006/main">
               <a:ext uri="{FF2B5EF4-FFF2-40B4-BE49-F238E27FC236}">
-                <a16:creationId xmlns:a16="http://schemas.microsoft.com/office/drawing/2014/main" id="{B9574A1F-C931-469C-B47C-1F28AD8932E0}"/>
+                <a16:creationId xmlns:a16="http://schemas.microsoft.com/office/drawing/2014/main" id="{98A8E0E7-3286-4D83-ADB5-481BB206272D}"/>
               </a:ext>
             </a:extLst>
           </p:cNvPr>
@@ -5859,7 +5916,7 @@
                 <a:ea typeface="Aptos"/>
                 <a:cs typeface="Aptos"/>
               </a:rPr>
-              <a:t>Each point is one stored task score. Its uncertainty range and original run are unavailable.</a:t>
+              <a:t>Each point is one stored task score. Its uncertainty range and raw run archive are unavailable.</a:t>
             </a:r>
           </a:p>
         </p:txBody>
@@ -5867,7 +5924,7 @@
     </p:spTree>
     <p:extLst>
       <p:ext uri="{BB962C8B-B14F-4D97-AF65-F5344CB8AC3E}">
-        <p14:creationId xmlns:p14="http://schemas.microsoft.com/office/powerpoint/2010/main" val="194638413"/>
+        <p14:creationId xmlns:p14="http://schemas.microsoft.com/office/powerpoint/2010/main" val="871776287"/>
       </p:ext>
     </p:extLst>
   </p:cSld>
@@ -5898,7 +5955,7 @@
           <p:cNvPr id="12" name="slide-title">
             <a:extLst xmlns:a="http://schemas.openxmlformats.org/drawingml/2006/main">
               <a:ext uri="{FF2B5EF4-FFF2-40B4-BE49-F238E27FC236}">
-                <a16:creationId xmlns:a16="http://schemas.microsoft.com/office/drawing/2014/main" id="{D4107A65-1821-45C3-8844-6E93EE811BE8}"/>
+                <a16:creationId xmlns:a16="http://schemas.microsoft.com/office/drawing/2014/main" id="{C15073F5-53ED-4580-8D27-539D6AB089BA}"/>
               </a:ext>
             </a:extLst>
           </p:cNvPr>
@@ -5955,7 +6012,7 @@
           <p:cNvPr id="2" name="slide-subtitle">
             <a:extLst xmlns:a="http://schemas.openxmlformats.org/drawingml/2006/main">
               <a:ext uri="{FF2B5EF4-FFF2-40B4-BE49-F238E27FC236}">
-                <a16:creationId xmlns:a16="http://schemas.microsoft.com/office/drawing/2014/main" id="{A9C9FDB1-9025-4685-B12B-921FD01F23AB}"/>
+                <a16:creationId xmlns:a16="http://schemas.microsoft.com/office/drawing/2014/main" id="{9DD12F77-CD89-45DD-A2E8-DCAEDA1BDE38}"/>
               </a:ext>
             </a:extLst>
           </p:cNvPr>
@@ -6012,7 +6069,7 @@
           <p:cNvPr id="3" name="">
             <a:extLst xmlns:a="http://schemas.openxmlformats.org/drawingml/2006/main">
               <a:ext uri="{FF2B5EF4-FFF2-40B4-BE49-F238E27FC236}">
-                <a16:creationId xmlns:a16="http://schemas.microsoft.com/office/drawing/2014/main" id="{6A26A84D-AA21-4163-A9EF-87BBBF6B1556}"/>
+                <a16:creationId xmlns:a16="http://schemas.microsoft.com/office/drawing/2014/main" id="{4F39ACB6-0210-47A7-8BA3-CBE5A2199CB2}"/>
               </a:ext>
             </a:extLst>
           </p:cNvPr>
@@ -6073,7 +6130,7 @@
           <p:cNvPr id="4" name="">
             <a:extLst xmlns:a="http://schemas.openxmlformats.org/drawingml/2006/main">
               <a:ext uri="{FF2B5EF4-FFF2-40B4-BE49-F238E27FC236}">
-                <a16:creationId xmlns:a16="http://schemas.microsoft.com/office/drawing/2014/main" id="{37AC38DD-A16B-4815-B5A8-CF59D02CE279}"/>
+                <a16:creationId xmlns:a16="http://schemas.microsoft.com/office/drawing/2014/main" id="{6BC1EBC1-01FA-44E8-BBF5-EEE73AC6B705}"/>
               </a:ext>
             </a:extLst>
           </p:cNvPr>
@@ -6104,7 +6161,7 @@
           <p:cNvPr id="5" name="">
             <a:extLst xmlns:a="http://schemas.openxmlformats.org/drawingml/2006/main">
               <a:ext uri="{FF2B5EF4-FFF2-40B4-BE49-F238E27FC236}">
-                <a16:creationId xmlns:a16="http://schemas.microsoft.com/office/drawing/2014/main" id="{DCC30248-A3AD-4475-967D-250F2F23A146}"/>
+                <a16:creationId xmlns:a16="http://schemas.microsoft.com/office/drawing/2014/main" id="{47DB4DB4-07E4-451C-8784-9ABDF636645C}"/>
               </a:ext>
             </a:extLst>
           </p:cNvPr>
@@ -6128,12 +6185,12 @@
         </p:spPr>
         <p:txBody>
           <a:bodyPr xmlns:a="http://schemas.openxmlformats.org/drawingml/2006/main">
-            <a:normAutofit fontScale="91111"/>
+            <a:normAutofit fontScale="97619"/>
           </a:bodyPr>
           <a:lstStyle xmlns:a="http://schemas.openxmlformats.org/drawingml/2006/main"/>
           <a:p xmlns:a="http://schemas.openxmlformats.org/drawingml/2006/main">
             <a:pPr algn="l">
-              <a:defRPr sz="1125" b="1">
+              <a:defRPr sz="1050" b="1">
                 <a:solidFill>
                   <a:srgbClr val="14856D"/>
                 </a:solidFill>
@@ -6143,7 +6200,7 @@
               </a:defRPr>
             </a:pPr>
             <a:r>
-              <a:rPr sz="1125" b="1">
+              <a:rPr sz="1050" b="1">
                 <a:solidFill>
                   <a:srgbClr val="14856D"/>
                 </a:solidFill>
@@ -6151,7 +6208,7 @@
                 <a:ea typeface="Aptos"/>
                 <a:cs typeface="Aptos"/>
               </a:rPr>
-              <a:t>Qwen: Qwen2.5 7B Instruct (7.61B) to Qwen3.5 9B (9B)</a:t>
+              <a:t>Qwen: 2024-Q3 · Qwen2.5 7B Instruct (7.61B) → 2026-Q1 · Qwen3.5 9B (9B)</a:t>
             </a:r>
           </a:p>
         </p:txBody>
@@ -6161,7 +6218,7 @@
           <p:cNvPr id="6" name="">
             <a:extLst xmlns:a="http://schemas.openxmlformats.org/drawingml/2006/main">
               <a:ext uri="{FF2B5EF4-FFF2-40B4-BE49-F238E27FC236}">
-                <a16:creationId xmlns:a16="http://schemas.microsoft.com/office/drawing/2014/main" id="{EF3F8581-16BF-404C-AD29-E2722ADA934D}"/>
+                <a16:creationId xmlns:a16="http://schemas.microsoft.com/office/drawing/2014/main" id="{49887189-79DC-4CB2-BACF-EAC552ACA0C1}"/>
               </a:ext>
             </a:extLst>
           </p:cNvPr>
@@ -6185,12 +6242,12 @@
         </p:spPr>
         <p:txBody>
           <a:bodyPr xmlns:a="http://schemas.openxmlformats.org/drawingml/2006/main">
-            <a:normAutofit fontScale="91111"/>
+            <a:normAutofit fontScale="97619"/>
           </a:bodyPr>
           <a:lstStyle xmlns:a="http://schemas.openxmlformats.org/drawingml/2006/main"/>
           <a:p xmlns:a="http://schemas.openxmlformats.org/drawingml/2006/main">
             <a:pPr algn="l">
-              <a:defRPr sz="1125" b="1">
+              <a:defRPr sz="1050" b="1">
                 <a:solidFill>
                   <a:srgbClr val="6E5AA8"/>
                 </a:solidFill>
@@ -6200,7 +6257,7 @@
               </a:defRPr>
             </a:pPr>
             <a:r>
-              <a:rPr sz="1125" b="1">
+              <a:rPr sz="1050" b="1">
                 <a:solidFill>
                   <a:srgbClr val="6E5AA8"/>
                 </a:solidFill>
@@ -6208,7 +6265,7 @@
                 <a:ea typeface="Aptos"/>
                 <a:cs typeface="Aptos"/>
               </a:rPr>
-              <a:t>DeepSeek: V3-0324 (671B main, 37B active) to V4 Flash (284B main, 13B active)</a:t>
+              <a:t>DeepSeek: 2025-Q1 · V3-0324 (671B main, 37B active) → 2026-Q2 · V4 Flash (284B main, 13B active)</a:t>
             </a:r>
           </a:p>
         </p:txBody>
@@ -6218,7 +6275,7 @@
           <p:cNvPr id="7" name="">
             <a:extLst xmlns:a="http://schemas.openxmlformats.org/drawingml/2006/main">
               <a:ext uri="{FF2B5EF4-FFF2-40B4-BE49-F238E27FC236}">
-                <a16:creationId xmlns:a16="http://schemas.microsoft.com/office/drawing/2014/main" id="{637570C7-6AF3-4842-A314-248C4ED709DD}"/>
+                <a16:creationId xmlns:a16="http://schemas.microsoft.com/office/drawing/2014/main" id="{1F0BBC3E-95FF-427A-979B-1B7BE4ED4409}"/>
               </a:ext>
             </a:extLst>
           </p:cNvPr>
@@ -6230,7 +6287,7 @@
         <p:spPr>
           <a:xfrm xmlns:a="http://schemas.openxmlformats.org/drawingml/2006/main">
             <a:off x="1047750" y="2019300"/>
-            <a:ext cx="7810500" cy="190500"/>
+            <a:ext cx="9334500" cy="190500"/>
           </a:xfrm>
           <a:prstGeom xmlns:a="http://schemas.openxmlformats.org/drawingml/2006/main" prst="rect">
             <a:avLst/>
@@ -6265,7 +6322,7 @@
                 <a:ea typeface="Aptos"/>
                 <a:cs typeface="Aptos"/>
               </a:rPr>
-              <a:t>main = all parameters; active = parameters used for each token</a:t>
+              <a:t>main = published main-model parameters (auxiliary/MTP excluded); active = parameters used per token</a:t>
             </a:r>
           </a:p>
         </p:txBody>
@@ -6282,7 +6339,7 @@
         </p:xfrm>
         <a:graphic xmlns:a="http://schemas.openxmlformats.org/drawingml/2006/main">
           <a:graphicData uri="http://schemas.openxmlformats.org/drawingml/2006/chart">
-            <c:chart xmlns:r="http://schemas.openxmlformats.org/officeDocument/2006/relationships" xmlns:c="http://schemas.openxmlformats.org/drawingml/2006/chart" r:id="R619d1d8fa5f04ecb"/>
+            <c:chart xmlns:r="http://schemas.openxmlformats.org/officeDocument/2006/relationships" xmlns:c="http://schemas.openxmlformats.org/drawingml/2006/chart" r:id="Re50ebbed3b004919"/>
           </a:graphicData>
         </a:graphic>
       </p:graphicFrame>
@@ -6291,7 +6348,7 @@
           <p:cNvPr id="9" name="">
             <a:extLst xmlns:a="http://schemas.openxmlformats.org/drawingml/2006/main">
               <a:ext uri="{FF2B5EF4-FFF2-40B4-BE49-F238E27FC236}">
-                <a16:creationId xmlns:a16="http://schemas.microsoft.com/office/drawing/2014/main" id="{620CABA5-E1B8-4770-B4AD-4764FB15DA92}"/>
+                <a16:creationId xmlns:a16="http://schemas.microsoft.com/office/drawing/2014/main" id="{A20B28AC-89E0-4680-AE1A-41718E391948}"/>
               </a:ext>
             </a:extLst>
           </p:cNvPr>
@@ -6348,7 +6405,7 @@
           <p:cNvPr id="10" name="">
             <a:extLst xmlns:a="http://schemas.openxmlformats.org/drawingml/2006/main">
               <a:ext uri="{FF2B5EF4-FFF2-40B4-BE49-F238E27FC236}">
-                <a16:creationId xmlns:a16="http://schemas.microsoft.com/office/drawing/2014/main" id="{3FD742F2-5868-4B4E-9E44-D9FE3B3EAF3F}"/>
+                <a16:creationId xmlns:a16="http://schemas.microsoft.com/office/drawing/2014/main" id="{E7ACA89B-87F6-468A-A3D9-9EBAC986E9B2}"/>
               </a:ext>
             </a:extLst>
           </p:cNvPr>
@@ -6372,12 +6429,12 @@
         </p:spPr>
         <p:txBody>
           <a:bodyPr xmlns:a="http://schemas.openxmlformats.org/drawingml/2006/main">
-            <a:normAutofit fontScale="90196"/>
+            <a:normAutofit fontScale="100000"/>
           </a:bodyPr>
           <a:lstStyle xmlns:a="http://schemas.openxmlformats.org/drawingml/2006/main"/>
           <a:p xmlns:a="http://schemas.openxmlformats.org/drawingml/2006/main">
             <a:pPr algn="l">
-              <a:defRPr sz="1275" b="0">
+              <a:defRPr sz="1125" b="0">
                 <a:solidFill>
                   <a:srgbClr val="66727E"/>
                 </a:solidFill>
@@ -6387,7 +6444,7 @@
               </a:defRPr>
             </a:pPr>
             <a:r>
-              <a:rPr sz="1275" b="0">
+              <a:rPr sz="1125" b="0">
                 <a:solidFill>
                   <a:srgbClr val="66727E"/>
                 </a:solidFill>
@@ -6395,7 +6452,7 @@
                 <a:ea typeface="Aptos"/>
                 <a:cs typeface="Aptos"/>
               </a:rPr>
-              <a:t>Release period describes the model. It is not a progress timeline.</a:t>
+              <a:t>Release period is model metadata, not a progress timeline; 28–29 May is the evaluation time.</a:t>
             </a:r>
           </a:p>
         </p:txBody>
@@ -6405,7 +6462,7 @@
           <p:cNvPr id="11" name="">
             <a:extLst xmlns:a="http://schemas.openxmlformats.org/drawingml/2006/main">
               <a:ext uri="{FF2B5EF4-FFF2-40B4-BE49-F238E27FC236}">
-                <a16:creationId xmlns:a16="http://schemas.microsoft.com/office/drawing/2014/main" id="{8E88AA8F-F8BE-48F9-AD81-51B59FD45047}"/>
+                <a16:creationId xmlns:a16="http://schemas.microsoft.com/office/drawing/2014/main" id="{5B69485E-C820-4601-A512-D5283430A1F0}"/>
               </a:ext>
             </a:extLst>
           </p:cNvPr>
@@ -6429,12 +6486,12 @@
         </p:spPr>
         <p:txBody>
           <a:bodyPr xmlns:a="http://schemas.openxmlformats.org/drawingml/2006/main">
-            <a:normAutofit fontScale="85714"/>
+            <a:normAutofit fontScale="92308"/>
           </a:bodyPr>
           <a:lstStyle xmlns:a="http://schemas.openxmlformats.org/drawingml/2006/main"/>
           <a:p xmlns:a="http://schemas.openxmlformats.org/drawingml/2006/main">
             <a:pPr algn="l">
-              <a:defRPr sz="1050" b="0">
+              <a:defRPr sz="975" b="0">
                 <a:solidFill>
                   <a:srgbClr val="66727E"/>
                 </a:solidFill>
@@ -6444,7 +6501,7 @@
               </a:defRPr>
             </a:pPr>
             <a:r>
-              <a:rPr sz="1050" b="0">
+              <a:rPr sz="975" b="0">
                 <a:solidFill>
                   <a:srgbClr val="66727E"/>
                 </a:solidFill>
@@ -6452,7 +6509,7 @@
                 <a:ea typeface="Aptos"/>
                 <a:cs typeface="Aptos"/>
               </a:rPr>
-              <a:t>The consequence task uses a different score, so it is not shown here.</a:t>
+              <a:t>Exploratory: saved uncertainty is unavailable. Consequence uses a different score and is not shown.</a:t>
             </a:r>
           </a:p>
         </p:txBody>
@@ -6460,7 +6517,7 @@
     </p:spTree>
     <p:extLst>
       <p:ext uri="{BB962C8B-B14F-4D97-AF65-F5344CB8AC3E}">
-        <p14:creationId xmlns:p14="http://schemas.microsoft.com/office/powerpoint/2010/main" val="839166429"/>
+        <p14:creationId xmlns:p14="http://schemas.microsoft.com/office/powerpoint/2010/main" val="8334273"/>
       </p:ext>
     </p:extLst>
   </p:cSld>
@@ -6491,7 +6548,7 @@
           <p:cNvPr id="10" name="slide-title">
             <a:extLst xmlns:a="http://schemas.openxmlformats.org/drawingml/2006/main">
               <a:ext uri="{FF2B5EF4-FFF2-40B4-BE49-F238E27FC236}">
-                <a16:creationId xmlns:a16="http://schemas.microsoft.com/office/drawing/2014/main" id="{D048B509-BE4C-4A05-8C07-BA09133A3EE7}"/>
+                <a16:creationId xmlns:a16="http://schemas.microsoft.com/office/drawing/2014/main" id="{987FD353-18CF-4D7F-8243-9819F110A290}"/>
               </a:ext>
             </a:extLst>
           </p:cNvPr>
@@ -6548,7 +6605,7 @@
           <p:cNvPr id="2" name="slide-subtitle">
             <a:extLst xmlns:a="http://schemas.openxmlformats.org/drawingml/2006/main">
               <a:ext uri="{FF2B5EF4-FFF2-40B4-BE49-F238E27FC236}">
-                <a16:creationId xmlns:a16="http://schemas.microsoft.com/office/drawing/2014/main" id="{D11CBDF5-EBCD-4F49-A265-D449F5A878AA}"/>
+                <a16:creationId xmlns:a16="http://schemas.microsoft.com/office/drawing/2014/main" id="{54A6CE7D-501A-43FD-9067-089E5F933EED}"/>
               </a:ext>
             </a:extLst>
           </p:cNvPr>
@@ -6605,7 +6662,7 @@
           <p:cNvPr id="3" name="">
             <a:extLst xmlns:a="http://schemas.openxmlformats.org/drawingml/2006/main">
               <a:ext uri="{FF2B5EF4-FFF2-40B4-BE49-F238E27FC236}">
-                <a16:creationId xmlns:a16="http://schemas.microsoft.com/office/drawing/2014/main" id="{E2301FF3-DB19-4F10-8599-631149912AE6}"/>
+                <a16:creationId xmlns:a16="http://schemas.microsoft.com/office/drawing/2014/main" id="{8260E1A8-9AAA-4665-9B72-08468204259C}"/>
               </a:ext>
             </a:extLst>
           </p:cNvPr>
@@ -6666,7 +6723,7 @@
           <p:cNvPr id="4" name="">
             <a:extLst xmlns:a="http://schemas.openxmlformats.org/drawingml/2006/main">
               <a:ext uri="{FF2B5EF4-FFF2-40B4-BE49-F238E27FC236}">
-                <a16:creationId xmlns:a16="http://schemas.microsoft.com/office/drawing/2014/main" id="{FB28D9A8-8103-4EAC-9553-69F1BD153DDD}"/>
+                <a16:creationId xmlns:a16="http://schemas.microsoft.com/office/drawing/2014/main" id="{78F501A7-FE85-48B9-BAB0-23E875CC0BB9}"/>
               </a:ext>
             </a:extLst>
           </p:cNvPr>
@@ -6697,7 +6754,7 @@
           <p:cNvPr id="5" name="">
             <a:extLst xmlns:a="http://schemas.openxmlformats.org/drawingml/2006/main">
               <a:ext uri="{FF2B5EF4-FFF2-40B4-BE49-F238E27FC236}">
-                <a16:creationId xmlns:a16="http://schemas.microsoft.com/office/drawing/2014/main" id="{05B1455E-2E96-42E3-A651-EE8F303575BE}"/>
+                <a16:creationId xmlns:a16="http://schemas.microsoft.com/office/drawing/2014/main" id="{4A6676A2-4141-483F-9635-9743B11EF0C6}"/>
               </a:ext>
             </a:extLst>
           </p:cNvPr>
@@ -6708,8 +6765,8 @@
         </p:nvSpPr>
         <p:spPr>
           <a:xfrm xmlns:a="http://schemas.openxmlformats.org/drawingml/2006/main">
-            <a:off x="838200" y="2047875"/>
-            <a:ext cx="2190750" cy="1238250"/>
+            <a:off x="838200" y="2190750"/>
+            <a:ext cx="2190750" cy="1000125"/>
           </a:xfrm>
           <a:prstGeom xmlns:a="http://schemas.openxmlformats.org/drawingml/2006/main" prst="rect">
             <a:avLst/>
@@ -6726,7 +6783,7 @@
           <a:lstStyle xmlns:a="http://schemas.openxmlformats.org/drawingml/2006/main"/>
           <a:p xmlns:a="http://schemas.openxmlformats.org/drawingml/2006/main">
             <a:pPr algn="ctr">
-              <a:defRPr sz="7200" b="1">
+              <a:defRPr sz="4500" b="1">
                 <a:solidFill>
                   <a:srgbClr val="CF5D4A"/>
                 </a:solidFill>
@@ -6736,7 +6793,7 @@
               </a:defRPr>
             </a:pPr>
             <a:r>
-              <a:rPr sz="7200" b="1">
+              <a:rPr sz="4500" b="1">
                 <a:solidFill>
                   <a:srgbClr val="CF5D4A"/>
                 </a:solidFill>
@@ -6744,7 +6801,7 @@
                 <a:ea typeface="Aptos"/>
                 <a:cs typeface="Aptos"/>
               </a:rPr>
-              <a:t>0</a:t>
+              <a:t>0 of 4</a:t>
             </a:r>
           </a:p>
         </p:txBody>
@@ -6754,7 +6811,7 @@
           <p:cNvPr id="6" name="">
             <a:extLst xmlns:a="http://schemas.openxmlformats.org/drawingml/2006/main">
               <a:ext uri="{FF2B5EF4-FFF2-40B4-BE49-F238E27FC236}">
-                <a16:creationId xmlns:a16="http://schemas.microsoft.com/office/drawing/2014/main" id="{D06115BF-5EB1-4EC9-8F10-882E991C6867}"/>
+                <a16:creationId xmlns:a16="http://schemas.microsoft.com/office/drawing/2014/main" id="{FA1CBCE0-21BD-4D6E-9892-CC9458CC7BE0}"/>
               </a:ext>
             </a:extLst>
           </p:cNvPr>
@@ -7227,7 +7284,7 @@
           <p:cNvPr id="8" name="">
             <a:extLst xmlns:a="http://schemas.openxmlformats.org/drawingml/2006/main">
               <a:ext uri="{FF2B5EF4-FFF2-40B4-BE49-F238E27FC236}">
-                <a16:creationId xmlns:a16="http://schemas.microsoft.com/office/drawing/2014/main" id="{DEAA8DCC-B77C-479E-BD19-58D59F82E122}"/>
+                <a16:creationId xmlns:a16="http://schemas.microsoft.com/office/drawing/2014/main" id="{2A7759CA-9DCA-4FB4-BB05-218C0FB9A598}"/>
               </a:ext>
             </a:extLst>
           </p:cNvPr>
@@ -7284,7 +7341,7 @@
           <p:cNvPr id="9" name="">
             <a:extLst xmlns:a="http://schemas.openxmlformats.org/drawingml/2006/main">
               <a:ext uri="{FF2B5EF4-FFF2-40B4-BE49-F238E27FC236}">
-                <a16:creationId xmlns:a16="http://schemas.microsoft.com/office/drawing/2014/main" id="{CCD3233E-8995-4346-9296-7322065B8749}"/>
+                <a16:creationId xmlns:a16="http://schemas.microsoft.com/office/drawing/2014/main" id="{B7CA18F2-AB33-4680-9CDD-478B895D559C}"/>
               </a:ext>
             </a:extLst>
           </p:cNvPr>
@@ -7339,7 +7396,7 @@
     </p:spTree>
     <p:extLst>
       <p:ext uri="{BB962C8B-B14F-4D97-AF65-F5344CB8AC3E}">
-        <p14:creationId xmlns:p14="http://schemas.microsoft.com/office/powerpoint/2010/main" val="775342382"/>
+        <p14:creationId xmlns:p14="http://schemas.microsoft.com/office/powerpoint/2010/main" val="1554332125"/>
       </p:ext>
     </p:extLst>
   </p:cSld>
@@ -7370,7 +7427,7 @@
           <p:cNvPr id="8" name="slide-title">
             <a:extLst xmlns:a="http://schemas.openxmlformats.org/drawingml/2006/main">
               <a:ext uri="{FF2B5EF4-FFF2-40B4-BE49-F238E27FC236}">
-                <a16:creationId xmlns:a16="http://schemas.microsoft.com/office/drawing/2014/main" id="{C50DC2E6-9F8C-466E-B8A1-299865E7AF1D}"/>
+                <a16:creationId xmlns:a16="http://schemas.microsoft.com/office/drawing/2014/main" id="{18D6B917-B00A-423D-B14F-DE6DD2DD4FC4}"/>
               </a:ext>
             </a:extLst>
           </p:cNvPr>
@@ -7417,7 +7474,7 @@
                 <a:ea typeface="Aptos"/>
                 <a:cs typeface="Aptos"/>
               </a:rPr>
-              <a:t>Make the test stronger before adding more models</a:t>
+              <a:t>Share task results now. Strengthen the test next.</a:t>
             </a:r>
           </a:p>
         </p:txBody>
@@ -7427,7 +7484,7 @@
           <p:cNvPr id="2" name="slide-subtitle">
             <a:extLst xmlns:a="http://schemas.openxmlformats.org/drawingml/2006/main">
               <a:ext uri="{FF2B5EF4-FFF2-40B4-BE49-F238E27FC236}">
-                <a16:creationId xmlns:a16="http://schemas.microsoft.com/office/drawing/2014/main" id="{B41FDDD7-1BEF-41DB-8A9F-EB03DA680586}"/>
+                <a16:creationId xmlns:a16="http://schemas.microsoft.com/office/drawing/2014/main" id="{05CB7DCF-D882-413C-A0B3-3CC4406F7875}"/>
               </a:ext>
             </a:extLst>
           </p:cNvPr>
@@ -7484,7 +7541,7 @@
           <p:cNvPr id="3" name="">
             <a:extLst xmlns:a="http://schemas.openxmlformats.org/drawingml/2006/main">
               <a:ext uri="{FF2B5EF4-FFF2-40B4-BE49-F238E27FC236}">
-                <a16:creationId xmlns:a16="http://schemas.microsoft.com/office/drawing/2014/main" id="{A3C993B2-D1D7-41F1-A7D3-C46F0AF274A1}"/>
+                <a16:creationId xmlns:a16="http://schemas.microsoft.com/office/drawing/2014/main" id="{55B94623-7938-459F-BA5B-C902AD2D6DC3}"/>
               </a:ext>
             </a:extLst>
           </p:cNvPr>
@@ -7545,7 +7602,7 @@
           <p:cNvPr id="4" name="">
             <a:extLst xmlns:a="http://schemas.openxmlformats.org/drawingml/2006/main">
               <a:ext uri="{FF2B5EF4-FFF2-40B4-BE49-F238E27FC236}">
-                <a16:creationId xmlns:a16="http://schemas.microsoft.com/office/drawing/2014/main" id="{FC536CC8-7BB4-45F7-841A-2C89B61989F8}"/>
+                <a16:creationId xmlns:a16="http://schemas.microsoft.com/office/drawing/2014/main" id="{89DED89E-90FC-4DF7-86BD-3EE8000AAAC6}"/>
               </a:ext>
             </a:extLst>
           </p:cNvPr>
@@ -7777,7 +7834,7 @@
                           <a:ea typeface="Aptos"/>
                           <a:cs typeface="Aptos"/>
                         </a:rPr>
-                        <a:t>Recover each question's result; check reading and labels</a:t>
+                        <a:t>Recover per-question outcomes; check scoring and labels</a:t>
                       </a:r>
                     </a:p>
                   </a:txBody>
@@ -7969,7 +8026,7 @@
           <p:cNvPr id="6" name="">
             <a:extLst xmlns:a="http://schemas.openxmlformats.org/drawingml/2006/main">
               <a:ext uri="{FF2B5EF4-FFF2-40B4-BE49-F238E27FC236}">
-                <a16:creationId xmlns:a16="http://schemas.microsoft.com/office/drawing/2014/main" id="{E3894B3B-ED41-4C1B-AE96-2C78BB19DF9B}"/>
+                <a16:creationId xmlns:a16="http://schemas.microsoft.com/office/drawing/2014/main" id="{7E2A7D9F-9A2F-43EA-9742-F65AE56940F0}"/>
               </a:ext>
             </a:extLst>
           </p:cNvPr>
@@ -7981,7 +8038,7 @@
         <p:spPr>
           <a:xfrm xmlns:a="http://schemas.openxmlformats.org/drawingml/2006/main">
             <a:off x="876300" y="5543550"/>
-            <a:ext cx="2095500" cy="285750"/>
+            <a:ext cx="2857500" cy="285750"/>
           </a:xfrm>
           <a:prstGeom xmlns:a="http://schemas.openxmlformats.org/drawingml/2006/main" prst="rect">
             <a:avLst/>
@@ -8016,7 +8073,7 @@
                 <a:ea typeface="Aptos"/>
                 <a:cs typeface="Aptos"/>
               </a:rPr>
-              <a:t>Best next move</a:t>
+              <a:t>Best research next move</a:t>
             </a:r>
           </a:p>
         </p:txBody>
@@ -8026,7 +8083,7 @@
           <p:cNvPr id="7" name="">
             <a:extLst xmlns:a="http://schemas.openxmlformats.org/drawingml/2006/main">
               <a:ext uri="{FF2B5EF4-FFF2-40B4-BE49-F238E27FC236}">
-                <a16:creationId xmlns:a16="http://schemas.microsoft.com/office/drawing/2014/main" id="{639A2F20-3DDA-4897-BB12-E2A330B5B89D}"/>
+                <a16:creationId xmlns:a16="http://schemas.microsoft.com/office/drawing/2014/main" id="{08F6A29E-6AA7-4BE1-8DC3-5E6C2E462EFF}"/>
               </a:ext>
             </a:extLst>
           </p:cNvPr>
@@ -8073,7 +8130,7 @@
                 <a:ea typeface="Aptos"/>
                 <a:cs typeface="Aptos"/>
               </a:rPr>
-              <a:t>Recover each question's result. Compare models. Then have people review the test.</a:t>
+              <a:t>Recover per-question outcomes. Compare models. Then have people review the test.</a:t>
             </a:r>
           </a:p>
         </p:txBody>
@@ -8081,7 +8138,7 @@
     </p:spTree>
     <p:extLst>
       <p:ext uri="{BB962C8B-B14F-4D97-AF65-F5344CB8AC3E}">
-        <p14:creationId xmlns:p14="http://schemas.microsoft.com/office/powerpoint/2010/main" val="1472254359"/>
+        <p14:creationId xmlns:p14="http://schemas.microsoft.com/office/powerpoint/2010/main" val="965390794"/>
       </p:ext>
     </p:extLst>
   </p:cSld>

</xml_diff>

<commit_message>
Simplify research-lead readout and actions
</commit_message>
<xml_diff>
--- a/slides/cei-moral-psychology-results-deck.pptx
+++ b/slides/cei-moral-psychology-results-deck.pptx
@@ -2,20 +2,20 @@
 <file path=ppt/presentation.xml><?xml version="1.0" encoding="utf-8"?>
 <p:presentation xmlns:p="http://schemas.openxmlformats.org/presentationml/2006/main">
   <p:sldMasterIdLst>
-    <p:sldMasterId xmlns:r="http://schemas.openxmlformats.org/officeDocument/2006/relationships" id="2147483648" r:id="Rdcf63d9084a84398"/>
+    <p:sldMasterId xmlns:r="http://schemas.openxmlformats.org/officeDocument/2006/relationships" id="2147483648" r:id="R08bf78f4860e4570"/>
   </p:sldMasterIdLst>
   <p:notesMasterIdLst>
-    <p:notesMasterId xmlns:r="http://schemas.openxmlformats.org/officeDocument/2006/relationships" r:id="R52684c4be9d74455"/>
+    <p:notesMasterId xmlns:r="http://schemas.openxmlformats.org/officeDocument/2006/relationships" r:id="R359fcbef56f2473f"/>
   </p:notesMasterIdLst>
   <p:sldIdLst>
-    <p:sldId xmlns:r="http://schemas.openxmlformats.org/officeDocument/2006/relationships" id="256" r:id="R28316098380046eb"/>
-    <p:sldId xmlns:r="http://schemas.openxmlformats.org/officeDocument/2006/relationships" id="257" r:id="R60ef4dffb91541d6"/>
-    <p:sldId xmlns:r="http://schemas.openxmlformats.org/officeDocument/2006/relationships" id="258" r:id="Ra42e66c4d5324c60"/>
-    <p:sldId xmlns:r="http://schemas.openxmlformats.org/officeDocument/2006/relationships" id="259" r:id="R59bc5b76c2d749b6"/>
-    <p:sldId xmlns:r="http://schemas.openxmlformats.org/officeDocument/2006/relationships" id="260" r:id="Re52612187c24413f"/>
-    <p:sldId xmlns:r="http://schemas.openxmlformats.org/officeDocument/2006/relationships" id="261" r:id="Rfd495d76baec4ac4"/>
-    <p:sldId xmlns:r="http://schemas.openxmlformats.org/officeDocument/2006/relationships" id="262" r:id="Re74b7d5afe3d4f02"/>
-    <p:sldId xmlns:r="http://schemas.openxmlformats.org/officeDocument/2006/relationships" id="263" r:id="R3c764319d77b453a"/>
+    <p:sldId xmlns:r="http://schemas.openxmlformats.org/officeDocument/2006/relationships" id="256" r:id="Rb0ad8be8fafa47b7"/>
+    <p:sldId xmlns:r="http://schemas.openxmlformats.org/officeDocument/2006/relationships" id="257" r:id="R8e291d4e955745f8"/>
+    <p:sldId xmlns:r="http://schemas.openxmlformats.org/officeDocument/2006/relationships" id="258" r:id="R02d7515f1d484e96"/>
+    <p:sldId xmlns:r="http://schemas.openxmlformats.org/officeDocument/2006/relationships" id="259" r:id="R548e48cc0f1a46d4"/>
+    <p:sldId xmlns:r="http://schemas.openxmlformats.org/officeDocument/2006/relationships" id="260" r:id="R5ef55b18ace443ff"/>
+    <p:sldId xmlns:r="http://schemas.openxmlformats.org/officeDocument/2006/relationships" id="261" r:id="R82ef7f98e8094022"/>
+    <p:sldId xmlns:r="http://schemas.openxmlformats.org/officeDocument/2006/relationships" id="262" r:id="R55df7994b796414e"/>
+    <p:sldId xmlns:r="http://schemas.openxmlformats.org/officeDocument/2006/relationships" id="263" r:id="R8bb1a88be7684af3"/>
   </p:sldIdLst>
   <p:sldSz cx="12192000" cy="6858000"/>
   <p:notesSz cx="6858000" cy="9144000"/>
@@ -1147,7 +1147,7 @@
   </p:cSld>
   <p:clrMap bg1="lt1" tx1="dk1" bg2="lt2" tx2="dk2" accent1="accent1" accent2="accent2" accent3="accent3" accent4="accent4" accent5="accent5" accent6="accent6" hlink="hlink" folHlink="folHlink"/>
   <p:sldLayoutIdLst>
-    <p:sldLayoutId xmlns:r="http://schemas.openxmlformats.org/officeDocument/2006/relationships" id="2147483649" r:id="Ra24c1e3d7a9149ea"/>
+    <p:sldLayoutId xmlns:r="http://schemas.openxmlformats.org/officeDocument/2006/relationships" id="2147483649" r:id="R47c4c3dd19b24db5"/>
   </p:sldLayoutIdLst>
   <p:txStyles>
     <p:titleStyle>
@@ -3123,7 +3123,7 @@
           <p:cNvPr id="7" name="cover-title">
             <a:extLst xmlns:a="http://schemas.openxmlformats.org/drawingml/2006/main">
               <a:ext uri="{FF2B5EF4-FFF2-40B4-BE49-F238E27FC236}">
-                <a16:creationId xmlns:a16="http://schemas.microsoft.com/office/drawing/2014/main" id="{23FA2206-BDD9-42CF-880C-93988009AF0E}"/>
+                <a16:creationId xmlns:a16="http://schemas.microsoft.com/office/drawing/2014/main" id="{9867D34F-0CCE-493A-8257-9A6115FB2188}"/>
               </a:ext>
             </a:extLst>
           </p:cNvPr>
@@ -3203,7 +3203,7 @@
           <p:cNvPr id="2" name="">
             <a:extLst xmlns:a="http://schemas.openxmlformats.org/drawingml/2006/main">
               <a:ext uri="{FF2B5EF4-FFF2-40B4-BE49-F238E27FC236}">
-                <a16:creationId xmlns:a16="http://schemas.microsoft.com/office/drawing/2014/main" id="{3C4B8375-F024-4CDC-AA25-CCD3EA85D61C}"/>
+                <a16:creationId xmlns:a16="http://schemas.microsoft.com/office/drawing/2014/main" id="{FED5646C-9E9B-4A25-B3C9-6754D3449042}"/>
               </a:ext>
             </a:extLst>
           </p:cNvPr>
@@ -3260,7 +3260,7 @@
           <p:cNvPr id="3" name="">
             <a:extLst xmlns:a="http://schemas.openxmlformats.org/drawingml/2006/main">
               <a:ext uri="{FF2B5EF4-FFF2-40B4-BE49-F238E27FC236}">
-                <a16:creationId xmlns:a16="http://schemas.microsoft.com/office/drawing/2014/main" id="{1F0B8570-5D06-4A0E-B587-9C1D657568B3}"/>
+                <a16:creationId xmlns:a16="http://schemas.microsoft.com/office/drawing/2014/main" id="{2CA19375-27D9-4477-97D0-BFDC431663E5}"/>
               </a:ext>
             </a:extLst>
           </p:cNvPr>
@@ -3317,7 +3317,7 @@
           <p:cNvPr id="4" name="">
             <a:extLst xmlns:a="http://schemas.openxmlformats.org/drawingml/2006/main">
               <a:ext uri="{FF2B5EF4-FFF2-40B4-BE49-F238E27FC236}">
-                <a16:creationId xmlns:a16="http://schemas.microsoft.com/office/drawing/2014/main" id="{109F0233-8290-4EC9-9EA2-A9A82FD17EC6}"/>
+                <a16:creationId xmlns:a16="http://schemas.microsoft.com/office/drawing/2014/main" id="{BBE6B9D3-98BD-47AC-8DE8-4F567101BB61}"/>
               </a:ext>
             </a:extLst>
           </p:cNvPr>
@@ -3348,7 +3348,7 @@
           <p:cNvPr id="5" name="">
             <a:extLst xmlns:a="http://schemas.openxmlformats.org/drawingml/2006/main">
               <a:ext uri="{FF2B5EF4-FFF2-40B4-BE49-F238E27FC236}">
-                <a16:creationId xmlns:a16="http://schemas.microsoft.com/office/drawing/2014/main" id="{7733683A-0666-41F4-86B4-CE04EB3C84C2}"/>
+                <a16:creationId xmlns:a16="http://schemas.microsoft.com/office/drawing/2014/main" id="{5FED375B-AC9C-4AF8-9006-8DC9DF83F46E}"/>
               </a:ext>
             </a:extLst>
           </p:cNvPr>
@@ -3405,7 +3405,7 @@
           <p:cNvPr id="6" name="">
             <a:extLst xmlns:a="http://schemas.openxmlformats.org/drawingml/2006/main">
               <a:ext uri="{FF2B5EF4-FFF2-40B4-BE49-F238E27FC236}">
-                <a16:creationId xmlns:a16="http://schemas.microsoft.com/office/drawing/2014/main" id="{41A47809-8D02-4742-8AC9-856FCE31997B}"/>
+                <a16:creationId xmlns:a16="http://schemas.microsoft.com/office/drawing/2014/main" id="{A7B5A675-844B-41E5-AB80-6EBCFCD807CD}"/>
               </a:ext>
             </a:extLst>
           </p:cNvPr>
@@ -3460,7 +3460,7 @@
     </p:spTree>
     <p:extLst>
       <p:ext uri="{BB962C8B-B14F-4D97-AF65-F5344CB8AC3E}">
-        <p14:creationId xmlns:p14="http://schemas.microsoft.com/office/powerpoint/2010/main" val="1540705597"/>
+        <p14:creationId xmlns:p14="http://schemas.microsoft.com/office/powerpoint/2010/main" val="1651103330"/>
       </p:ext>
     </p:extLst>
   </p:cSld>
@@ -3491,7 +3491,7 @@
           <p:cNvPr id="8" name="slide-title">
             <a:extLst xmlns:a="http://schemas.openxmlformats.org/drawingml/2006/main">
               <a:ext uri="{FF2B5EF4-FFF2-40B4-BE49-F238E27FC236}">
-                <a16:creationId xmlns:a16="http://schemas.microsoft.com/office/drawing/2014/main" id="{F8A64EDA-16ED-43D5-BA29-FA8A6EA4A880}"/>
+                <a16:creationId xmlns:a16="http://schemas.microsoft.com/office/drawing/2014/main" id="{D1B141AE-0A87-4452-9A8E-E4B0E623839A}"/>
               </a:ext>
             </a:extLst>
           </p:cNvPr>
@@ -3548,7 +3548,7 @@
           <p:cNvPr id="2" name="slide-subtitle">
             <a:extLst xmlns:a="http://schemas.openxmlformats.org/drawingml/2006/main">
               <a:ext uri="{FF2B5EF4-FFF2-40B4-BE49-F238E27FC236}">
-                <a16:creationId xmlns:a16="http://schemas.microsoft.com/office/drawing/2014/main" id="{09848AF5-A81F-4381-8040-344908193E09}"/>
+                <a16:creationId xmlns:a16="http://schemas.microsoft.com/office/drawing/2014/main" id="{437759E4-A2F9-4AD3-BBB3-C7FE200CAD28}"/>
               </a:ext>
             </a:extLst>
           </p:cNvPr>
@@ -3605,7 +3605,7 @@
           <p:cNvPr id="3" name="">
             <a:extLst xmlns:a="http://schemas.openxmlformats.org/drawingml/2006/main">
               <a:ext uri="{FF2B5EF4-FFF2-40B4-BE49-F238E27FC236}">
-                <a16:creationId xmlns:a16="http://schemas.microsoft.com/office/drawing/2014/main" id="{6F4D3E0A-2AF7-4DAE-9CC8-174047319E46}"/>
+                <a16:creationId xmlns:a16="http://schemas.microsoft.com/office/drawing/2014/main" id="{02DDC73D-79D2-4BCA-A1AD-F62E423A3DB5}"/>
               </a:ext>
             </a:extLst>
           </p:cNvPr>
@@ -3666,7 +3666,7 @@
           <p:cNvPr id="4" name="">
             <a:extLst xmlns:a="http://schemas.openxmlformats.org/drawingml/2006/main">
               <a:ext uri="{FF2B5EF4-FFF2-40B4-BE49-F238E27FC236}">
-                <a16:creationId xmlns:a16="http://schemas.microsoft.com/office/drawing/2014/main" id="{E7896B7A-3480-413F-B64F-B193308A1BCE}"/>
+                <a16:creationId xmlns:a16="http://schemas.microsoft.com/office/drawing/2014/main" id="{67927C9F-0598-41AE-8B26-EEBF79BB4588}"/>
               </a:ext>
             </a:extLst>
           </p:cNvPr>
@@ -4603,7 +4603,7 @@
           <p:cNvPr id="6" name="">
             <a:extLst xmlns:a="http://schemas.openxmlformats.org/drawingml/2006/main">
               <a:ext uri="{FF2B5EF4-FFF2-40B4-BE49-F238E27FC236}">
-                <a16:creationId xmlns:a16="http://schemas.microsoft.com/office/drawing/2014/main" id="{B071CAC1-9941-4C3B-9603-0A8CA5FF8741}"/>
+                <a16:creationId xmlns:a16="http://schemas.microsoft.com/office/drawing/2014/main" id="{6982ED4B-1CDF-49DA-8A18-73E33F002799}"/>
               </a:ext>
             </a:extLst>
           </p:cNvPr>
@@ -4650,7 +4650,7 @@
                 <a:ea typeface="Aptos"/>
                 <a:cs typeface="Aptos"/>
               </a:rPr>
-              <a:t>† The uncertainty ranges overlap on the two comparison tasks. We cannot tell who leads.</a:t>
+              <a:t>† Marginal ranges overlap on both comparison tasks; paired question results are unavailable, so no leader is resolved.</a:t>
             </a:r>
           </a:p>
         </p:txBody>
@@ -4660,7 +4660,7 @@
           <p:cNvPr id="7" name="">
             <a:extLst xmlns:a="http://schemas.openxmlformats.org/drawingml/2006/main">
               <a:ext uri="{FF2B5EF4-FFF2-40B4-BE49-F238E27FC236}">
-                <a16:creationId xmlns:a16="http://schemas.microsoft.com/office/drawing/2014/main" id="{ED06E150-3124-4E40-A541-E3AC3158D785}"/>
+                <a16:creationId xmlns:a16="http://schemas.microsoft.com/office/drawing/2014/main" id="{2CA34357-74CC-46AE-A3A5-D49E51BDDDEA}"/>
               </a:ext>
             </a:extLst>
           </p:cNvPr>
@@ -4715,7 +4715,7 @@
     </p:spTree>
     <p:extLst>
       <p:ext uri="{BB962C8B-B14F-4D97-AF65-F5344CB8AC3E}">
-        <p14:creationId xmlns:p14="http://schemas.microsoft.com/office/powerpoint/2010/main" val="1891365037"/>
+        <p14:creationId xmlns:p14="http://schemas.microsoft.com/office/powerpoint/2010/main" val="1085649377"/>
       </p:ext>
     </p:extLst>
   </p:cSld>
@@ -4743,10 +4743,10 @@
       </p:grpSpPr>
       <p:sp>
         <p:nvSpPr>
-          <p:cNvPr id="10" name="slide-title">
+          <p:cNvPr id="11" name="slide-title">
             <a:extLst xmlns:a="http://schemas.openxmlformats.org/drawingml/2006/main">
               <a:ext uri="{FF2B5EF4-FFF2-40B4-BE49-F238E27FC236}">
-                <a16:creationId xmlns:a16="http://schemas.microsoft.com/office/drawing/2014/main" id="{F7686218-E9AD-4780-90D7-ADA42E09E675}"/>
+                <a16:creationId xmlns:a16="http://schemas.microsoft.com/office/drawing/2014/main" id="{31596B0F-238C-4C99-9684-F5A797CD80A7}"/>
               </a:ext>
             </a:extLst>
           </p:cNvPr>
@@ -4770,7 +4770,7 @@
         </p:spPr>
         <p:txBody>
           <a:bodyPr xmlns:a="http://schemas.openxmlformats.org/drawingml/2006/main">
-            <a:normAutofit fontScale="94074"/>
+            <a:normAutofit fontScale="85462"/>
           </a:bodyPr>
           <a:lstStyle xmlns:a="http://schemas.openxmlformats.org/drawingml/2006/main"/>
           <a:p xmlns:a="http://schemas.openxmlformats.org/drawingml/2006/main">
@@ -4793,7 +4793,7 @@
                 <a:ea typeface="Aptos"/>
                 <a:cs typeface="Aptos"/>
               </a:rPr>
-              <a:t>Saved ranges overlap for every model pair in both tests</a:t>
+              <a:t>Every model pair has overlapping score ranges on both tests</a:t>
             </a:r>
           </a:p>
         </p:txBody>
@@ -4803,7 +4803,7 @@
           <p:cNvPr id="2" name="slide-subtitle">
             <a:extLst xmlns:a="http://schemas.openxmlformats.org/drawingml/2006/main">
               <a:ext uri="{FF2B5EF4-FFF2-40B4-BE49-F238E27FC236}">
-                <a16:creationId xmlns:a16="http://schemas.microsoft.com/office/drawing/2014/main" id="{557B42DF-5C3F-4524-9476-E905C829169A}"/>
+                <a16:creationId xmlns:a16="http://schemas.microsoft.com/office/drawing/2014/main" id="{849C5352-1CB5-4C30-8A5B-5684DCF3DF7A}"/>
               </a:ext>
             </a:extLst>
           </p:cNvPr>
@@ -4860,7 +4860,7 @@
           <p:cNvPr id="3" name="">
             <a:extLst xmlns:a="http://schemas.openxmlformats.org/drawingml/2006/main">
               <a:ext uri="{FF2B5EF4-FFF2-40B4-BE49-F238E27FC236}">
-                <a16:creationId xmlns:a16="http://schemas.microsoft.com/office/drawing/2014/main" id="{AEB78AC8-4CF4-4188-B3CB-14D04D56A47A}"/>
+                <a16:creationId xmlns:a16="http://schemas.microsoft.com/office/drawing/2014/main" id="{588B5E80-366C-4695-926B-6EA6D522B461}"/>
               </a:ext>
             </a:extLst>
           </p:cNvPr>
@@ -4921,7 +4921,7 @@
           <p:cNvPr id="4" name="">
             <a:extLst xmlns:a="http://schemas.openxmlformats.org/drawingml/2006/main">
               <a:ext uri="{FF2B5EF4-FFF2-40B4-BE49-F238E27FC236}">
-                <a16:creationId xmlns:a16="http://schemas.microsoft.com/office/drawing/2014/main" id="{12C82605-8EE3-46A5-ADAA-8C9DEEA2C32A}"/>
+                <a16:creationId xmlns:a16="http://schemas.microsoft.com/office/drawing/2014/main" id="{5B5E3913-97A7-49F3-A70F-7B2B0DAC875A}"/>
               </a:ext>
             </a:extLst>
           </p:cNvPr>
@@ -4952,7 +4952,7 @@
           <p:cNvPr id="5" name="">
             <a:extLst xmlns:a="http://schemas.openxmlformats.org/drawingml/2006/main">
               <a:ext uri="{FF2B5EF4-FFF2-40B4-BE49-F238E27FC236}">
-                <a16:creationId xmlns:a16="http://schemas.microsoft.com/office/drawing/2014/main" id="{5336EE74-E189-4C19-8B09-DC12093B2294}"/>
+                <a16:creationId xmlns:a16="http://schemas.microsoft.com/office/drawing/2014/main" id="{F1D1840F-E9E7-4E43-BC6D-B6DA42C49B9B}"/>
               </a:ext>
             </a:extLst>
           </p:cNvPr>
@@ -5006,7 +5006,7 @@
       </p:sp>
       <p:graphicFrame>
         <p:nvGraphicFramePr>
-          <p:cNvPr id="15" name="Chart"/>
+          <p:cNvPr id="16" name="Chart"/>
           <p:cNvGraphicFramePr/>
           <p:nvPr/>
         </p:nvGraphicFramePr>
@@ -5016,7 +5016,7 @@
         </p:xfrm>
         <a:graphic xmlns:a="http://schemas.openxmlformats.org/drawingml/2006/main">
           <a:graphicData uri="http://schemas.openxmlformats.org/drawingml/2006/chart">
-            <c:chart xmlns:r="http://schemas.openxmlformats.org/officeDocument/2006/relationships" xmlns:c="http://schemas.openxmlformats.org/drawingml/2006/chart" r:id="Rbea0eff9e2794173"/>
+            <c:chart xmlns:r="http://schemas.openxmlformats.org/officeDocument/2006/relationships" xmlns:c="http://schemas.openxmlformats.org/drawingml/2006/chart" r:id="R3390438968ec45da"/>
           </a:graphicData>
         </a:graphic>
       </p:graphicFrame>
@@ -5025,7 +5025,7 @@
           <p:cNvPr id="7" name="">
             <a:extLst xmlns:a="http://schemas.openxmlformats.org/drawingml/2006/main">
               <a:ext uri="{FF2B5EF4-FFF2-40B4-BE49-F238E27FC236}">
-                <a16:creationId xmlns:a16="http://schemas.microsoft.com/office/drawing/2014/main" id="{A0178A51-0432-4086-8370-BB3C05BEB176}"/>
+                <a16:creationId xmlns:a16="http://schemas.microsoft.com/office/drawing/2014/main" id="{7B72E2FF-0D09-4065-9A17-2E9117DD6E89}"/>
               </a:ext>
             </a:extLst>
           </p:cNvPr>
@@ -5072,7 +5072,7 @@
                 <a:ea typeface="Aptos"/>
                 <a:cs typeface="Aptos"/>
               </a:rPr>
-              <a:t>Direct evidence: saved ranges overlap for all 28 MFQ and all 45 Vignette model pairs.</a:t>
+              <a:t>Marginal ranges overlap for all 28 MFQ and all 45 Vignette model pairs.</a:t>
             </a:r>
           </a:p>
         </p:txBody>
@@ -5082,7 +5082,7 @@
           <p:cNvPr id="8" name="">
             <a:extLst xmlns:a="http://schemas.openxmlformats.org/drawingml/2006/main">
               <a:ext uri="{FF2B5EF4-FFF2-40B4-BE49-F238E27FC236}">
-                <a16:creationId xmlns:a16="http://schemas.microsoft.com/office/drawing/2014/main" id="{9F50F310-50CC-43F6-BF90-7974FC7715FE}"/>
+                <a16:creationId xmlns:a16="http://schemas.microsoft.com/office/drawing/2014/main" id="{3CA7612D-60FF-4543-8470-05BA3C847066}"/>
               </a:ext>
             </a:extLst>
           </p:cNvPr>
@@ -5093,8 +5093,8 @@
         </p:nvSpPr>
         <p:spPr>
           <a:xfrm xmlns:a="http://schemas.openxmlformats.org/drawingml/2006/main">
-            <a:off x="1143000" y="5524500"/>
-            <a:ext cx="9334500" cy="304800"/>
+            <a:off x="1143000" y="5324475"/>
+            <a:ext cx="9810750" cy="228600"/>
           </a:xfrm>
           <a:prstGeom xmlns:a="http://schemas.openxmlformats.org/drawingml/2006/main" prst="rect">
             <a:avLst/>
@@ -5106,14 +5106,14 @@
         </p:spPr>
         <p:txBody>
           <a:bodyPr xmlns:a="http://schemas.openxmlformats.org/drawingml/2006/main">
-            <a:normAutofit fontScale="88889"/>
+            <a:normAutofit fontScale="80000"/>
           </a:bodyPr>
           <a:lstStyle xmlns:a="http://schemas.openxmlformats.org/drawingml/2006/main"/>
           <a:p xmlns:a="http://schemas.openxmlformats.org/drawingml/2006/main">
             <a:pPr algn="l">
-              <a:defRPr sz="1575" b="1">
-                <a:solidFill>
-                  <a:srgbClr val="17212B"/>
+              <a:defRPr sz="1125" b="0">
+                <a:solidFill>
+                  <a:srgbClr val="66727E"/>
                 </a:solidFill>
                 <a:latin typeface="Aptos"/>
                 <a:ea typeface="Aptos"/>
@@ -5121,15 +5121,15 @@
               </a:defRPr>
             </a:pPr>
             <a:r>
-              <a:rPr sz="1575" b="1">
-                <a:solidFill>
-                  <a:srgbClr val="17212B"/>
+              <a:rPr sz="1125" b="0">
+                <a:solidFill>
+                  <a:srgbClr val="66727E"/>
                 </a:solidFill>
                 <a:latin typeface="Aptos"/>
                 <a:ea typeface="Aptos"/>
                 <a:cs typeface="Aptos"/>
               </a:rPr>
-              <a:t>Action: recover per-question outcomes and check scoring.</a:t>
+              <a:t>These ranges look at one model at a time; paired question results are unavailable.</a:t>
             </a:r>
           </a:p>
         </p:txBody>
@@ -5139,7 +5139,7 @@
           <p:cNvPr id="9" name="">
             <a:extLst xmlns:a="http://schemas.openxmlformats.org/drawingml/2006/main">
               <a:ext uri="{FF2B5EF4-FFF2-40B4-BE49-F238E27FC236}">
-                <a16:creationId xmlns:a16="http://schemas.microsoft.com/office/drawing/2014/main" id="{E7760CC9-7627-4636-993D-1373DA583C4B}"/>
+                <a16:creationId xmlns:a16="http://schemas.microsoft.com/office/drawing/2014/main" id="{5C8E407D-E6A6-4490-8A57-7E280E973E05}"/>
               </a:ext>
             </a:extLst>
           </p:cNvPr>
@@ -5150,8 +5150,8 @@
         </p:nvSpPr>
         <p:spPr>
           <a:xfrm xmlns:a="http://schemas.openxmlformats.org/drawingml/2006/main">
-            <a:off x="1143000" y="5867400"/>
-            <a:ext cx="9525000" cy="266700"/>
+            <a:off x="1143000" y="5638800"/>
+            <a:ext cx="9810750" cy="304800"/>
           </a:xfrm>
           <a:prstGeom xmlns:a="http://schemas.openxmlformats.org/drawingml/2006/main" prst="rect">
             <a:avLst/>
@@ -5163,14 +5163,14 @@
         </p:spPr>
         <p:txBody>
           <a:bodyPr xmlns:a="http://schemas.openxmlformats.org/drawingml/2006/main">
-            <a:normAutofit fontScale="90196"/>
+            <a:normAutofit fontScale="93333"/>
           </a:bodyPr>
           <a:lstStyle xmlns:a="http://schemas.openxmlformats.org/drawingml/2006/main"/>
           <a:p xmlns:a="http://schemas.openxmlformats.org/drawingml/2006/main">
             <a:pPr algn="l">
-              <a:defRPr sz="1275" b="0">
-                <a:solidFill>
-                  <a:srgbClr val="66727E"/>
+              <a:defRPr sz="1500" b="1">
+                <a:solidFill>
+                  <a:srgbClr val="17212B"/>
                 </a:solidFill>
                 <a:latin typeface="Aptos"/>
                 <a:ea typeface="Aptos"/>
@@ -5178,15 +5178,72 @@
               </a:defRPr>
             </a:pPr>
             <a:r>
-              <a:rPr sz="1275" b="0">
+              <a:rPr sz="1500" b="1">
+                <a:solidFill>
+                  <a:srgbClr val="17212B"/>
+                </a:solidFill>
+                <a:latin typeface="Aptos"/>
+                <a:ea typeface="Aptos"/>
+                <a:cs typeface="Aptos"/>
+              </a:rPr>
+              <a:t>Next: restore every model's answer and score for each question.</a:t>
+            </a:r>
+          </a:p>
+        </p:txBody>
+      </p:sp>
+      <p:sp>
+        <p:nvSpPr>
+          <p:cNvPr id="10" name="">
+            <a:extLst xmlns:a="http://schemas.openxmlformats.org/drawingml/2006/main">
+              <a:ext uri="{FF2B5EF4-FFF2-40B4-BE49-F238E27FC236}">
+                <a16:creationId xmlns:a16="http://schemas.microsoft.com/office/drawing/2014/main" id="{1817A31B-C74D-4743-8D1D-2B4461F4822B}"/>
+              </a:ext>
+            </a:extLst>
+          </p:cNvPr>
+          <p:cNvSpPr>
+            <a:spLocks xmlns:a="http://schemas.openxmlformats.org/drawingml/2006/main" noGrp="1"/>
+          </p:cNvSpPr>
+          <p:nvPr/>
+        </p:nvSpPr>
+        <p:spPr>
+          <a:xfrm xmlns:a="http://schemas.openxmlformats.org/drawingml/2006/main">
+            <a:off x="1143000" y="5981700"/>
+            <a:ext cx="9810750" cy="266700"/>
+          </a:xfrm>
+          <a:prstGeom xmlns:a="http://schemas.openxmlformats.org/drawingml/2006/main" prst="rect">
+            <a:avLst/>
+          </a:prstGeom>
+          <a:noFill xmlns:a="http://schemas.openxmlformats.org/drawingml/2006/main"/>
+          <a:ln xmlns:a="http://schemas.openxmlformats.org/drawingml/2006/main" w="0">
+            <a:noFill/>
+          </a:ln>
+        </p:spPr>
+        <p:txBody>
+          <a:bodyPr xmlns:a="http://schemas.openxmlformats.org/drawingml/2006/main">
+            <a:normAutofit fontScale="95833"/>
+          </a:bodyPr>
+          <a:lstStyle xmlns:a="http://schemas.openxmlformats.org/drawingml/2006/main"/>
+          <a:p xmlns:a="http://schemas.openxmlformats.org/drawingml/2006/main">
+            <a:pPr algn="l">
+              <a:defRPr sz="1200" b="0">
                 <a:solidFill>
                   <a:srgbClr val="66727E"/>
                 </a:solidFill>
                 <a:latin typeface="Aptos"/>
                 <a:ea typeface="Aptos"/>
                 <a:cs typeface="Aptos"/>
+              </a:defRPr>
+            </a:pPr>
+            <a:r>
+              <a:rPr sz="1200" b="0">
+                <a:solidFill>
+                  <a:srgbClr val="66727E"/>
+                </a:solidFill>
+                <a:latin typeface="Aptos"/>
+                <a:ea typeface="Aptos"/>
+                <a:cs typeface="Aptos"/>
               </a:rPr>
-              <a:t>Then compare models, run human review, and add questions only if still unclear.</a:t>
+              <a:t>Check scoring and labels. Then compare models and have people review the test.</a:t>
             </a:r>
           </a:p>
         </p:txBody>
@@ -5194,7 +5251,7 @@
     </p:spTree>
     <p:extLst>
       <p:ext uri="{BB962C8B-B14F-4D97-AF65-F5344CB8AC3E}">
-        <p14:creationId xmlns:p14="http://schemas.microsoft.com/office/powerpoint/2010/main" val="1887841718"/>
+        <p14:creationId xmlns:p14="http://schemas.microsoft.com/office/powerpoint/2010/main" val="1962121643"/>
       </p:ext>
     </p:extLst>
   </p:cSld>
@@ -5225,7 +5282,7 @@
           <p:cNvPr id="9" name="slide-title">
             <a:extLst xmlns:a="http://schemas.openxmlformats.org/drawingml/2006/main">
               <a:ext uri="{FF2B5EF4-FFF2-40B4-BE49-F238E27FC236}">
-                <a16:creationId xmlns:a16="http://schemas.microsoft.com/office/drawing/2014/main" id="{13AF2979-C8C3-4AA9-979C-89BF7A524A17}"/>
+                <a16:creationId xmlns:a16="http://schemas.microsoft.com/office/drawing/2014/main" id="{CE09F1C1-4F8F-4A3B-8CDD-AA21577B0766}"/>
               </a:ext>
             </a:extLst>
           </p:cNvPr>
@@ -5282,7 +5339,7 @@
           <p:cNvPr id="2" name="slide-subtitle">
             <a:extLst xmlns:a="http://schemas.openxmlformats.org/drawingml/2006/main">
               <a:ext uri="{FF2B5EF4-FFF2-40B4-BE49-F238E27FC236}">
-                <a16:creationId xmlns:a16="http://schemas.microsoft.com/office/drawing/2014/main" id="{7A209F66-D6EA-4BFF-852B-1BBB05AAE265}"/>
+                <a16:creationId xmlns:a16="http://schemas.microsoft.com/office/drawing/2014/main" id="{CE143E08-F909-4358-A840-6082978225FC}"/>
               </a:ext>
             </a:extLst>
           </p:cNvPr>
@@ -5339,7 +5396,7 @@
           <p:cNvPr id="3" name="">
             <a:extLst xmlns:a="http://schemas.openxmlformats.org/drawingml/2006/main">
               <a:ext uri="{FF2B5EF4-FFF2-40B4-BE49-F238E27FC236}">
-                <a16:creationId xmlns:a16="http://schemas.microsoft.com/office/drawing/2014/main" id="{98F370EF-334B-4DA7-8939-99EEA4662828}"/>
+                <a16:creationId xmlns:a16="http://schemas.microsoft.com/office/drawing/2014/main" id="{7DC0684F-F33C-4E99-B0E0-6A5B7970A940}"/>
               </a:ext>
             </a:extLst>
           </p:cNvPr>
@@ -5400,7 +5457,7 @@
           <p:cNvPr id="4" name="">
             <a:extLst xmlns:a="http://schemas.openxmlformats.org/drawingml/2006/main">
               <a:ext uri="{FF2B5EF4-FFF2-40B4-BE49-F238E27FC236}">
-                <a16:creationId xmlns:a16="http://schemas.microsoft.com/office/drawing/2014/main" id="{28335A8E-CDD0-419C-A240-C3C31EE9D37A}"/>
+                <a16:creationId xmlns:a16="http://schemas.microsoft.com/office/drawing/2014/main" id="{A37BBBDC-2C02-466B-8F5F-46F9930C9DD5}"/>
               </a:ext>
             </a:extLst>
           </p:cNvPr>
@@ -5438,7 +5495,7 @@
         </p:xfrm>
         <a:graphic xmlns:a="http://schemas.openxmlformats.org/drawingml/2006/main">
           <a:graphicData uri="http://schemas.openxmlformats.org/drawingml/2006/chart">
-            <c:chart xmlns:r="http://schemas.openxmlformats.org/officeDocument/2006/relationships" xmlns:c="http://schemas.openxmlformats.org/drawingml/2006/chart" r:id="R8874bd99273b48b3"/>
+            <c:chart xmlns:r="http://schemas.openxmlformats.org/officeDocument/2006/relationships" xmlns:c="http://schemas.openxmlformats.org/drawingml/2006/chart" r:id="Rdb49c5426f5b4c7c"/>
           </a:graphicData>
         </a:graphic>
       </p:graphicFrame>
@@ -5447,7 +5504,7 @@
           <p:cNvPr id="6" name="">
             <a:extLst xmlns:a="http://schemas.openxmlformats.org/drawingml/2006/main">
               <a:ext uri="{FF2B5EF4-FFF2-40B4-BE49-F238E27FC236}">
-                <a16:creationId xmlns:a16="http://schemas.microsoft.com/office/drawing/2014/main" id="{ED20F61A-833E-438E-9FDD-9B31F5AA2F1B}"/>
+                <a16:creationId xmlns:a16="http://schemas.microsoft.com/office/drawing/2014/main" id="{0A49A6A6-053E-4AB9-8299-2238B7173BD8}"/>
               </a:ext>
             </a:extLst>
           </p:cNvPr>
@@ -5504,7 +5561,7 @@
           <p:cNvPr id="7" name="">
             <a:extLst xmlns:a="http://schemas.openxmlformats.org/drawingml/2006/main">
               <a:ext uri="{FF2B5EF4-FFF2-40B4-BE49-F238E27FC236}">
-                <a16:creationId xmlns:a16="http://schemas.microsoft.com/office/drawing/2014/main" id="{ED964583-A207-410F-BA25-FB4979EE9BD2}"/>
+                <a16:creationId xmlns:a16="http://schemas.microsoft.com/office/drawing/2014/main" id="{F1DDAEE7-1E6E-4FE9-9338-46939C238518}"/>
               </a:ext>
             </a:extLst>
           </p:cNvPr>
@@ -5561,7 +5618,7 @@
           <p:cNvPr id="8" name="">
             <a:extLst xmlns:a="http://schemas.openxmlformats.org/drawingml/2006/main">
               <a:ext uri="{FF2B5EF4-FFF2-40B4-BE49-F238E27FC236}">
-                <a16:creationId xmlns:a16="http://schemas.microsoft.com/office/drawing/2014/main" id="{3E56E9C8-8EC3-472C-8F9D-3E28FDCA77C5}"/>
+                <a16:creationId xmlns:a16="http://schemas.microsoft.com/office/drawing/2014/main" id="{00ACAE09-87A7-45CD-9749-59DAA6C54007}"/>
               </a:ext>
             </a:extLst>
           </p:cNvPr>
@@ -5616,7 +5673,7 @@
     </p:spTree>
     <p:extLst>
       <p:ext uri="{BB962C8B-B14F-4D97-AF65-F5344CB8AC3E}">
-        <p14:creationId xmlns:p14="http://schemas.microsoft.com/office/powerpoint/2010/main" val="1399440294"/>
+        <p14:creationId xmlns:p14="http://schemas.microsoft.com/office/powerpoint/2010/main" val="1719988644"/>
       </p:ext>
     </p:extLst>
   </p:cSld>
@@ -5647,7 +5704,7 @@
           <p:cNvPr id="7" name="slide-title">
             <a:extLst xmlns:a="http://schemas.openxmlformats.org/drawingml/2006/main">
               <a:ext uri="{FF2B5EF4-FFF2-40B4-BE49-F238E27FC236}">
-                <a16:creationId xmlns:a16="http://schemas.microsoft.com/office/drawing/2014/main" id="{F9101F7A-5963-4B3F-BA40-99977E4855A9}"/>
+                <a16:creationId xmlns:a16="http://schemas.microsoft.com/office/drawing/2014/main" id="{51FAFFA0-A64E-415C-B5F6-949AAA80217D}"/>
               </a:ext>
             </a:extLst>
           </p:cNvPr>
@@ -5704,7 +5761,7 @@
           <p:cNvPr id="2" name="">
             <a:extLst xmlns:a="http://schemas.openxmlformats.org/drawingml/2006/main">
               <a:ext uri="{FF2B5EF4-FFF2-40B4-BE49-F238E27FC236}">
-                <a16:creationId xmlns:a16="http://schemas.microsoft.com/office/drawing/2014/main" id="{F19763A0-8B89-4924-BBFE-D6B4D6C3FB1B}"/>
+                <a16:creationId xmlns:a16="http://schemas.microsoft.com/office/drawing/2014/main" id="{0D589AC9-6FC6-4144-A1C0-3589B789B02B}"/>
               </a:ext>
             </a:extLst>
           </p:cNvPr>
@@ -5765,7 +5822,7 @@
           <p:cNvPr id="3" name="">
             <a:extLst xmlns:a="http://schemas.openxmlformats.org/drawingml/2006/main">
               <a:ext uri="{FF2B5EF4-FFF2-40B4-BE49-F238E27FC236}">
-                <a16:creationId xmlns:a16="http://schemas.microsoft.com/office/drawing/2014/main" id="{B43312F9-05F6-40AA-9F51-34F575E8212F}"/>
+                <a16:creationId xmlns:a16="http://schemas.microsoft.com/office/drawing/2014/main" id="{F1A8A548-6E13-4478-985E-F080CD483B85}"/>
               </a:ext>
             </a:extLst>
           </p:cNvPr>
@@ -5803,7 +5860,7 @@
         </p:xfrm>
         <a:graphic xmlns:a="http://schemas.openxmlformats.org/drawingml/2006/main">
           <a:graphicData uri="http://schemas.openxmlformats.org/drawingml/2006/chart">
-            <c:chart xmlns:r="http://schemas.openxmlformats.org/officeDocument/2006/relationships" xmlns:c="http://schemas.openxmlformats.org/drawingml/2006/chart" r:id="R1168b3b2784648e4"/>
+            <c:chart xmlns:r="http://schemas.openxmlformats.org/officeDocument/2006/relationships" xmlns:c="http://schemas.openxmlformats.org/drawingml/2006/chart" r:id="R0f5c0d8562b74e4f"/>
           </a:graphicData>
         </a:graphic>
       </p:graphicFrame>
@@ -5812,7 +5869,7 @@
           <p:cNvPr id="5" name="">
             <a:extLst xmlns:a="http://schemas.openxmlformats.org/drawingml/2006/main">
               <a:ext uri="{FF2B5EF4-FFF2-40B4-BE49-F238E27FC236}">
-                <a16:creationId xmlns:a16="http://schemas.microsoft.com/office/drawing/2014/main" id="{51B3D2D6-7E37-4438-81D0-31DA9F849536}"/>
+                <a16:creationId xmlns:a16="http://schemas.microsoft.com/office/drawing/2014/main" id="{A5C1BD23-0419-4E28-AA23-F56B3261C65C}"/>
               </a:ext>
             </a:extLst>
           </p:cNvPr>
@@ -5869,7 +5926,7 @@
           <p:cNvPr id="6" name="">
             <a:extLst xmlns:a="http://schemas.openxmlformats.org/drawingml/2006/main">
               <a:ext uri="{FF2B5EF4-FFF2-40B4-BE49-F238E27FC236}">
-                <a16:creationId xmlns:a16="http://schemas.microsoft.com/office/drawing/2014/main" id="{98A8E0E7-3286-4D83-ADB5-481BB206272D}"/>
+                <a16:creationId xmlns:a16="http://schemas.microsoft.com/office/drawing/2014/main" id="{F02E7FE8-E6FE-41A9-9BCC-1E82B00C974B}"/>
               </a:ext>
             </a:extLst>
           </p:cNvPr>
@@ -5924,7 +5981,7 @@
     </p:spTree>
     <p:extLst>
       <p:ext uri="{BB962C8B-B14F-4D97-AF65-F5344CB8AC3E}">
-        <p14:creationId xmlns:p14="http://schemas.microsoft.com/office/powerpoint/2010/main" val="871776287"/>
+        <p14:creationId xmlns:p14="http://schemas.microsoft.com/office/powerpoint/2010/main" val="665246059"/>
       </p:ext>
     </p:extLst>
   </p:cSld>
@@ -5955,7 +6012,7 @@
           <p:cNvPr id="12" name="slide-title">
             <a:extLst xmlns:a="http://schemas.openxmlformats.org/drawingml/2006/main">
               <a:ext uri="{FF2B5EF4-FFF2-40B4-BE49-F238E27FC236}">
-                <a16:creationId xmlns:a16="http://schemas.microsoft.com/office/drawing/2014/main" id="{C15073F5-53ED-4580-8D27-539D6AB089BA}"/>
+                <a16:creationId xmlns:a16="http://schemas.microsoft.com/office/drawing/2014/main" id="{3869A397-58B0-4412-BC32-FE33A4EF0272}"/>
               </a:ext>
             </a:extLst>
           </p:cNvPr>
@@ -6012,7 +6069,7 @@
           <p:cNvPr id="2" name="slide-subtitle">
             <a:extLst xmlns:a="http://schemas.openxmlformats.org/drawingml/2006/main">
               <a:ext uri="{FF2B5EF4-FFF2-40B4-BE49-F238E27FC236}">
-                <a16:creationId xmlns:a16="http://schemas.microsoft.com/office/drawing/2014/main" id="{9DD12F77-CD89-45DD-A2E8-DCAEDA1BDE38}"/>
+                <a16:creationId xmlns:a16="http://schemas.microsoft.com/office/drawing/2014/main" id="{2C89ABE0-4D46-4A8F-BC45-BEF296E267AE}"/>
               </a:ext>
             </a:extLst>
           </p:cNvPr>
@@ -6069,7 +6126,7 @@
           <p:cNvPr id="3" name="">
             <a:extLst xmlns:a="http://schemas.openxmlformats.org/drawingml/2006/main">
               <a:ext uri="{FF2B5EF4-FFF2-40B4-BE49-F238E27FC236}">
-                <a16:creationId xmlns:a16="http://schemas.microsoft.com/office/drawing/2014/main" id="{4F39ACB6-0210-47A7-8BA3-CBE5A2199CB2}"/>
+                <a16:creationId xmlns:a16="http://schemas.microsoft.com/office/drawing/2014/main" id="{8A990744-32C9-43BB-93B5-6CD07D79EAA8}"/>
               </a:ext>
             </a:extLst>
           </p:cNvPr>
@@ -6130,7 +6187,7 @@
           <p:cNvPr id="4" name="">
             <a:extLst xmlns:a="http://schemas.openxmlformats.org/drawingml/2006/main">
               <a:ext uri="{FF2B5EF4-FFF2-40B4-BE49-F238E27FC236}">
-                <a16:creationId xmlns:a16="http://schemas.microsoft.com/office/drawing/2014/main" id="{6BC1EBC1-01FA-44E8-BBF5-EEE73AC6B705}"/>
+                <a16:creationId xmlns:a16="http://schemas.microsoft.com/office/drawing/2014/main" id="{3EA23C9B-C157-40AE-B281-D3F40771D99F}"/>
               </a:ext>
             </a:extLst>
           </p:cNvPr>
@@ -6161,7 +6218,7 @@
           <p:cNvPr id="5" name="">
             <a:extLst xmlns:a="http://schemas.openxmlformats.org/drawingml/2006/main">
               <a:ext uri="{FF2B5EF4-FFF2-40B4-BE49-F238E27FC236}">
-                <a16:creationId xmlns:a16="http://schemas.microsoft.com/office/drawing/2014/main" id="{47DB4DB4-07E4-451C-8784-9ABDF636645C}"/>
+                <a16:creationId xmlns:a16="http://schemas.microsoft.com/office/drawing/2014/main" id="{928DDD29-1DFB-448F-A854-D9EDBE3FE834}"/>
               </a:ext>
             </a:extLst>
           </p:cNvPr>
@@ -6218,7 +6275,7 @@
           <p:cNvPr id="6" name="">
             <a:extLst xmlns:a="http://schemas.openxmlformats.org/drawingml/2006/main">
               <a:ext uri="{FF2B5EF4-FFF2-40B4-BE49-F238E27FC236}">
-                <a16:creationId xmlns:a16="http://schemas.microsoft.com/office/drawing/2014/main" id="{49887189-79DC-4CB2-BACF-EAC552ACA0C1}"/>
+                <a16:creationId xmlns:a16="http://schemas.microsoft.com/office/drawing/2014/main" id="{69FAA15B-8BCC-414D-805B-3B5A52199678}"/>
               </a:ext>
             </a:extLst>
           </p:cNvPr>
@@ -6275,7 +6332,7 @@
           <p:cNvPr id="7" name="">
             <a:extLst xmlns:a="http://schemas.openxmlformats.org/drawingml/2006/main">
               <a:ext uri="{FF2B5EF4-FFF2-40B4-BE49-F238E27FC236}">
-                <a16:creationId xmlns:a16="http://schemas.microsoft.com/office/drawing/2014/main" id="{1F0BBC3E-95FF-427A-979B-1B7BE4ED4409}"/>
+                <a16:creationId xmlns:a16="http://schemas.microsoft.com/office/drawing/2014/main" id="{31078EBD-6E9B-499E-BA57-780F0655FE47}"/>
               </a:ext>
             </a:extLst>
           </p:cNvPr>
@@ -6339,7 +6396,7 @@
         </p:xfrm>
         <a:graphic xmlns:a="http://schemas.openxmlformats.org/drawingml/2006/main">
           <a:graphicData uri="http://schemas.openxmlformats.org/drawingml/2006/chart">
-            <c:chart xmlns:r="http://schemas.openxmlformats.org/officeDocument/2006/relationships" xmlns:c="http://schemas.openxmlformats.org/drawingml/2006/chart" r:id="Re50ebbed3b004919"/>
+            <c:chart xmlns:r="http://schemas.openxmlformats.org/officeDocument/2006/relationships" xmlns:c="http://schemas.openxmlformats.org/drawingml/2006/chart" r:id="R4586caa7cb99409e"/>
           </a:graphicData>
         </a:graphic>
       </p:graphicFrame>
@@ -6348,7 +6405,7 @@
           <p:cNvPr id="9" name="">
             <a:extLst xmlns:a="http://schemas.openxmlformats.org/drawingml/2006/main">
               <a:ext uri="{FF2B5EF4-FFF2-40B4-BE49-F238E27FC236}">
-                <a16:creationId xmlns:a16="http://schemas.microsoft.com/office/drawing/2014/main" id="{A20B28AC-89E0-4680-AE1A-41718E391948}"/>
+                <a16:creationId xmlns:a16="http://schemas.microsoft.com/office/drawing/2014/main" id="{F0D41F9A-01B7-4DEE-A1EE-8E2B1803C6EF}"/>
               </a:ext>
             </a:extLst>
           </p:cNvPr>
@@ -6405,7 +6462,7 @@
           <p:cNvPr id="10" name="">
             <a:extLst xmlns:a="http://schemas.openxmlformats.org/drawingml/2006/main">
               <a:ext uri="{FF2B5EF4-FFF2-40B4-BE49-F238E27FC236}">
-                <a16:creationId xmlns:a16="http://schemas.microsoft.com/office/drawing/2014/main" id="{E7ACA89B-87F6-468A-A3D9-9EBAC986E9B2}"/>
+                <a16:creationId xmlns:a16="http://schemas.microsoft.com/office/drawing/2014/main" id="{CDC2277B-6899-4D3D-B019-A4C73AE18D80}"/>
               </a:ext>
             </a:extLst>
           </p:cNvPr>
@@ -6462,7 +6519,7 @@
           <p:cNvPr id="11" name="">
             <a:extLst xmlns:a="http://schemas.openxmlformats.org/drawingml/2006/main">
               <a:ext uri="{FF2B5EF4-FFF2-40B4-BE49-F238E27FC236}">
-                <a16:creationId xmlns:a16="http://schemas.microsoft.com/office/drawing/2014/main" id="{5B69485E-C820-4601-A512-D5283430A1F0}"/>
+                <a16:creationId xmlns:a16="http://schemas.microsoft.com/office/drawing/2014/main" id="{DF69BA7A-F92C-44BF-A0D8-2FFBA634BBD7}"/>
               </a:ext>
             </a:extLst>
           </p:cNvPr>
@@ -6517,7 +6574,7 @@
     </p:spTree>
     <p:extLst>
       <p:ext uri="{BB962C8B-B14F-4D97-AF65-F5344CB8AC3E}">
-        <p14:creationId xmlns:p14="http://schemas.microsoft.com/office/powerpoint/2010/main" val="8334273"/>
+        <p14:creationId xmlns:p14="http://schemas.microsoft.com/office/powerpoint/2010/main" val="1869118811"/>
       </p:ext>
     </p:extLst>
   </p:cSld>
@@ -6548,7 +6605,7 @@
           <p:cNvPr id="10" name="slide-title">
             <a:extLst xmlns:a="http://schemas.openxmlformats.org/drawingml/2006/main">
               <a:ext uri="{FF2B5EF4-FFF2-40B4-BE49-F238E27FC236}">
-                <a16:creationId xmlns:a16="http://schemas.microsoft.com/office/drawing/2014/main" id="{987FD353-18CF-4D7F-8243-9819F110A290}"/>
+                <a16:creationId xmlns:a16="http://schemas.microsoft.com/office/drawing/2014/main" id="{168EF986-60A5-491B-8E75-4A64CC8EF68B}"/>
               </a:ext>
             </a:extLst>
           </p:cNvPr>
@@ -6605,7 +6662,7 @@
           <p:cNvPr id="2" name="slide-subtitle">
             <a:extLst xmlns:a="http://schemas.openxmlformats.org/drawingml/2006/main">
               <a:ext uri="{FF2B5EF4-FFF2-40B4-BE49-F238E27FC236}">
-                <a16:creationId xmlns:a16="http://schemas.microsoft.com/office/drawing/2014/main" id="{54A6CE7D-501A-43FD-9067-089E5F933EED}"/>
+                <a16:creationId xmlns:a16="http://schemas.microsoft.com/office/drawing/2014/main" id="{9B2E87B2-4F96-4B49-BD5C-2F621D4F4387}"/>
               </a:ext>
             </a:extLst>
           </p:cNvPr>
@@ -6662,7 +6719,7 @@
           <p:cNvPr id="3" name="">
             <a:extLst xmlns:a="http://schemas.openxmlformats.org/drawingml/2006/main">
               <a:ext uri="{FF2B5EF4-FFF2-40B4-BE49-F238E27FC236}">
-                <a16:creationId xmlns:a16="http://schemas.microsoft.com/office/drawing/2014/main" id="{8260E1A8-9AAA-4665-9B72-08468204259C}"/>
+                <a16:creationId xmlns:a16="http://schemas.microsoft.com/office/drawing/2014/main" id="{C86FEC1D-1378-4471-842A-4AE381589CFB}"/>
               </a:ext>
             </a:extLst>
           </p:cNvPr>
@@ -6723,7 +6780,7 @@
           <p:cNvPr id="4" name="">
             <a:extLst xmlns:a="http://schemas.openxmlformats.org/drawingml/2006/main">
               <a:ext uri="{FF2B5EF4-FFF2-40B4-BE49-F238E27FC236}">
-                <a16:creationId xmlns:a16="http://schemas.microsoft.com/office/drawing/2014/main" id="{78F501A7-FE85-48B9-BAB0-23E875CC0BB9}"/>
+                <a16:creationId xmlns:a16="http://schemas.microsoft.com/office/drawing/2014/main" id="{7B7132BE-8B52-4E37-84E9-D9C3FFE0CB64}"/>
               </a:ext>
             </a:extLst>
           </p:cNvPr>
@@ -6754,7 +6811,7 @@
           <p:cNvPr id="5" name="">
             <a:extLst xmlns:a="http://schemas.openxmlformats.org/drawingml/2006/main">
               <a:ext uri="{FF2B5EF4-FFF2-40B4-BE49-F238E27FC236}">
-                <a16:creationId xmlns:a16="http://schemas.microsoft.com/office/drawing/2014/main" id="{4A6676A2-4141-483F-9635-9743B11EF0C6}"/>
+                <a16:creationId xmlns:a16="http://schemas.microsoft.com/office/drawing/2014/main" id="{507CC4AD-9CE1-4894-9977-112FAFA31CEE}"/>
               </a:ext>
             </a:extLst>
           </p:cNvPr>
@@ -6811,7 +6868,7 @@
           <p:cNvPr id="6" name="">
             <a:extLst xmlns:a="http://schemas.openxmlformats.org/drawingml/2006/main">
               <a:ext uri="{FF2B5EF4-FFF2-40B4-BE49-F238E27FC236}">
-                <a16:creationId xmlns:a16="http://schemas.microsoft.com/office/drawing/2014/main" id="{FA1CBCE0-21BD-4D6E-9892-CC9458CC7BE0}"/>
+                <a16:creationId xmlns:a16="http://schemas.microsoft.com/office/drawing/2014/main" id="{0CFAA9FB-B113-430A-8868-E613E7CBCCD1}"/>
               </a:ext>
             </a:extLst>
           </p:cNvPr>
@@ -7190,7 +7247,7 @@
                           <a:ea typeface="Aptos"/>
                           <a:cs typeface="Aptos"/>
                         </a:rPr>
-                        <a:t>Different scoring</a:t>
+                        <a:t>Related question, different test</a:t>
                       </a:r>
                     </a:p>
                   </a:txBody>
@@ -7264,7 +7321,7 @@
                           <a:ea typeface="Aptos"/>
                           <a:cs typeface="Aptos"/>
                         </a:rPr>
-                        <a:t>Different scoring</a:t>
+                        <a:t>Related question, different test</a:t>
                       </a:r>
                     </a:p>
                   </a:txBody>
@@ -7284,7 +7341,7 @@
           <p:cNvPr id="8" name="">
             <a:extLst xmlns:a="http://schemas.openxmlformats.org/drawingml/2006/main">
               <a:ext uri="{FF2B5EF4-FFF2-40B4-BE49-F238E27FC236}">
-                <a16:creationId xmlns:a16="http://schemas.microsoft.com/office/drawing/2014/main" id="{2A7759CA-9DCA-4FB4-BB05-218C0FB9A598}"/>
+                <a16:creationId xmlns:a16="http://schemas.microsoft.com/office/drawing/2014/main" id="{EE266924-6B79-4CEC-8E03-62A824837DC3}"/>
               </a:ext>
             </a:extLst>
           </p:cNvPr>
@@ -7341,7 +7398,7 @@
           <p:cNvPr id="9" name="">
             <a:extLst xmlns:a="http://schemas.openxmlformats.org/drawingml/2006/main">
               <a:ext uri="{FF2B5EF4-FFF2-40B4-BE49-F238E27FC236}">
-                <a16:creationId xmlns:a16="http://schemas.microsoft.com/office/drawing/2014/main" id="{B7CA18F2-AB33-4680-9CDD-478B895D559C}"/>
+                <a16:creationId xmlns:a16="http://schemas.microsoft.com/office/drawing/2014/main" id="{D870DEB4-4674-4DB2-953D-0EF9B1A4A788}"/>
               </a:ext>
             </a:extLst>
           </p:cNvPr>
@@ -7396,7 +7453,7 @@
     </p:spTree>
     <p:extLst>
       <p:ext uri="{BB962C8B-B14F-4D97-AF65-F5344CB8AC3E}">
-        <p14:creationId xmlns:p14="http://schemas.microsoft.com/office/powerpoint/2010/main" val="1554332125"/>
+        <p14:creationId xmlns:p14="http://schemas.microsoft.com/office/powerpoint/2010/main" val="1753124928"/>
       </p:ext>
     </p:extLst>
   </p:cSld>
@@ -7427,7 +7484,7 @@
           <p:cNvPr id="8" name="slide-title">
             <a:extLst xmlns:a="http://schemas.openxmlformats.org/drawingml/2006/main">
               <a:ext uri="{FF2B5EF4-FFF2-40B4-BE49-F238E27FC236}">
-                <a16:creationId xmlns:a16="http://schemas.microsoft.com/office/drawing/2014/main" id="{18D6B917-B00A-423D-B14F-DE6DD2DD4FC4}"/>
+                <a16:creationId xmlns:a16="http://schemas.microsoft.com/office/drawing/2014/main" id="{1111C9C7-9477-4B0A-92BB-D919AC9D3B5D}"/>
               </a:ext>
             </a:extLst>
           </p:cNvPr>
@@ -7484,7 +7541,7 @@
           <p:cNvPr id="2" name="slide-subtitle">
             <a:extLst xmlns:a="http://schemas.openxmlformats.org/drawingml/2006/main">
               <a:ext uri="{FF2B5EF4-FFF2-40B4-BE49-F238E27FC236}">
-                <a16:creationId xmlns:a16="http://schemas.microsoft.com/office/drawing/2014/main" id="{05CB7DCF-D882-413C-A0B3-3CC4406F7875}"/>
+                <a16:creationId xmlns:a16="http://schemas.microsoft.com/office/drawing/2014/main" id="{49B1364C-F982-4537-ACFC-B75EC34DAB00}"/>
               </a:ext>
             </a:extLst>
           </p:cNvPr>
@@ -7541,7 +7598,7 @@
           <p:cNvPr id="3" name="">
             <a:extLst xmlns:a="http://schemas.openxmlformats.org/drawingml/2006/main">
               <a:ext uri="{FF2B5EF4-FFF2-40B4-BE49-F238E27FC236}">
-                <a16:creationId xmlns:a16="http://schemas.microsoft.com/office/drawing/2014/main" id="{55B94623-7938-459F-BA5B-C902AD2D6DC3}"/>
+                <a16:creationId xmlns:a16="http://schemas.microsoft.com/office/drawing/2014/main" id="{9DB898C2-7E73-4A88-B525-35D6EFA85281}"/>
               </a:ext>
             </a:extLst>
           </p:cNvPr>
@@ -7602,7 +7659,7 @@
           <p:cNvPr id="4" name="">
             <a:extLst xmlns:a="http://schemas.openxmlformats.org/drawingml/2006/main">
               <a:ext uri="{FF2B5EF4-FFF2-40B4-BE49-F238E27FC236}">
-                <a16:creationId xmlns:a16="http://schemas.microsoft.com/office/drawing/2014/main" id="{89DED89E-90FC-4DF7-86BD-3EE8000AAAC6}"/>
+                <a16:creationId xmlns:a16="http://schemas.microsoft.com/office/drawing/2014/main" id="{6141F8A4-7823-45B6-9F56-C98A9052520C}"/>
               </a:ext>
             </a:extLst>
           </p:cNvPr>
@@ -7834,7 +7891,7 @@
                           <a:ea typeface="Aptos"/>
                           <a:cs typeface="Aptos"/>
                         </a:rPr>
-                        <a:t>Recover per-question outcomes; check scoring and labels</a:t>
+                        <a:t>Restore each model's answer and score for every question</a:t>
                       </a:r>
                     </a:p>
                   </a:txBody>
@@ -7858,7 +7915,7 @@
                           <a:ea typeface="Aptos"/>
                           <a:cs typeface="Aptos"/>
                         </a:rPr>
-                        <a:t>This lets us compare models directly</a:t>
+                        <a:t>This lets us compare models on the same questions</a:t>
                       </a:r>
                     </a:p>
                   </a:txBody>
@@ -7908,7 +7965,7 @@
                           <a:ea typeface="Aptos"/>
                           <a:cs typeface="Aptos"/>
                         </a:rPr>
-                        <a:t>Have people review the test</a:t>
+                        <a:t>Check scoring and labels; have people review the test</a:t>
                       </a:r>
                     </a:p>
                   </a:txBody>
@@ -7932,7 +7989,7 @@
                           <a:ea typeface="Aptos"/>
                           <a:cs typeface="Aptos"/>
                         </a:rPr>
-                        <a:t>A benchmark score does not prove the test matches human judgment</a:t>
+                        <a:t>A benchmark score alone does not prove the test matches human judgment</a:t>
                       </a:r>
                     </a:p>
                   </a:txBody>
@@ -8026,7 +8083,7 @@
           <p:cNvPr id="6" name="">
             <a:extLst xmlns:a="http://schemas.openxmlformats.org/drawingml/2006/main">
               <a:ext uri="{FF2B5EF4-FFF2-40B4-BE49-F238E27FC236}">
-                <a16:creationId xmlns:a16="http://schemas.microsoft.com/office/drawing/2014/main" id="{7E2A7D9F-9A2F-43EA-9742-F65AE56940F0}"/>
+                <a16:creationId xmlns:a16="http://schemas.microsoft.com/office/drawing/2014/main" id="{12717C60-F55E-4E7E-A92E-442F5E9302B9}"/>
               </a:ext>
             </a:extLst>
           </p:cNvPr>
@@ -8083,7 +8140,7 @@
           <p:cNvPr id="7" name="">
             <a:extLst xmlns:a="http://schemas.openxmlformats.org/drawingml/2006/main">
               <a:ext uri="{FF2B5EF4-FFF2-40B4-BE49-F238E27FC236}">
-                <a16:creationId xmlns:a16="http://schemas.microsoft.com/office/drawing/2014/main" id="{08F6A29E-6AA7-4BE1-8DC3-5E6C2E462EFF}"/>
+                <a16:creationId xmlns:a16="http://schemas.microsoft.com/office/drawing/2014/main" id="{454B4DEE-DC38-40BD-A2E1-7912B0A549E2}"/>
               </a:ext>
             </a:extLst>
           </p:cNvPr>
@@ -8107,12 +8164,12 @@
         </p:spPr>
         <p:txBody>
           <a:bodyPr xmlns:a="http://schemas.openxmlformats.org/drawingml/2006/main">
-            <a:normAutofit fontScale="100000"/>
+            <a:normAutofit fontScale="87244"/>
           </a:bodyPr>
           <a:lstStyle xmlns:a="http://schemas.openxmlformats.org/drawingml/2006/main"/>
           <a:p xmlns:a="http://schemas.openxmlformats.org/drawingml/2006/main">
             <a:pPr algn="l">
-              <a:defRPr sz="1950" b="1">
+              <a:defRPr sz="1800" b="1">
                 <a:solidFill>
                   <a:srgbClr val="17212B"/>
                 </a:solidFill>
@@ -8122,7 +8179,7 @@
               </a:defRPr>
             </a:pPr>
             <a:r>
-              <a:rPr sz="1950" b="1">
+              <a:rPr sz="1800" b="1">
                 <a:solidFill>
                   <a:srgbClr val="17212B"/>
                 </a:solidFill>
@@ -8130,7 +8187,7 @@
                 <a:ea typeface="Aptos"/>
                 <a:cs typeface="Aptos"/>
               </a:rPr>
-              <a:t>Recover per-question outcomes. Compare models. Then have people review the test.</a:t>
+              <a:t>Restore answers and scores. Check scoring and labels. Compare models. Then have people review the test.</a:t>
             </a:r>
           </a:p>
         </p:txBody>
@@ -8138,7 +8195,7 @@
     </p:spTree>
     <p:extLst>
       <p:ext uri="{BB962C8B-B14F-4D97-AF65-F5344CB8AC3E}">
-        <p14:creationId xmlns:p14="http://schemas.microsoft.com/office/powerpoint/2010/main" val="965390794"/>
+        <p14:creationId xmlns:p14="http://schemas.microsoft.com/office/powerpoint/2010/main" val="1451424418"/>
       </p:ext>
     </p:extLst>
   </p:cSld>

</xml_diff>

<commit_message>
Explain benchmark tasks in the results slide
</commit_message>
<xml_diff>
--- a/slides/cei-moral-psychology-results-deck.pptx
+++ b/slides/cei-moral-psychology-results-deck.pptx
@@ -2,20 +2,20 @@
 <file path=ppt/presentation.xml><?xml version="1.0" encoding="utf-8"?>
 <p:presentation xmlns:p="http://schemas.openxmlformats.org/presentationml/2006/main">
   <p:sldMasterIdLst>
-    <p:sldMasterId xmlns:r="http://schemas.openxmlformats.org/officeDocument/2006/relationships" id="2147483648" r:id="R08bf78f4860e4570"/>
+    <p:sldMasterId xmlns:r="http://schemas.openxmlformats.org/officeDocument/2006/relationships" id="2147483648" r:id="R11b9dc11f36e4eb9"/>
   </p:sldMasterIdLst>
   <p:notesMasterIdLst>
-    <p:notesMasterId xmlns:r="http://schemas.openxmlformats.org/officeDocument/2006/relationships" r:id="R359fcbef56f2473f"/>
+    <p:notesMasterId xmlns:r="http://schemas.openxmlformats.org/officeDocument/2006/relationships" r:id="R80c1f0be74924332"/>
   </p:notesMasterIdLst>
   <p:sldIdLst>
-    <p:sldId xmlns:r="http://schemas.openxmlformats.org/officeDocument/2006/relationships" id="256" r:id="Rb0ad8be8fafa47b7"/>
-    <p:sldId xmlns:r="http://schemas.openxmlformats.org/officeDocument/2006/relationships" id="257" r:id="R8e291d4e955745f8"/>
-    <p:sldId xmlns:r="http://schemas.openxmlformats.org/officeDocument/2006/relationships" id="258" r:id="R02d7515f1d484e96"/>
-    <p:sldId xmlns:r="http://schemas.openxmlformats.org/officeDocument/2006/relationships" id="259" r:id="R548e48cc0f1a46d4"/>
-    <p:sldId xmlns:r="http://schemas.openxmlformats.org/officeDocument/2006/relationships" id="260" r:id="R5ef55b18ace443ff"/>
-    <p:sldId xmlns:r="http://schemas.openxmlformats.org/officeDocument/2006/relationships" id="261" r:id="R82ef7f98e8094022"/>
-    <p:sldId xmlns:r="http://schemas.openxmlformats.org/officeDocument/2006/relationships" id="262" r:id="R55df7994b796414e"/>
-    <p:sldId xmlns:r="http://schemas.openxmlformats.org/officeDocument/2006/relationships" id="263" r:id="R8bb1a88be7684af3"/>
+    <p:sldId xmlns:r="http://schemas.openxmlformats.org/officeDocument/2006/relationships" id="256" r:id="R739d4acd8630410d"/>
+    <p:sldId xmlns:r="http://schemas.openxmlformats.org/officeDocument/2006/relationships" id="257" r:id="Rc576b5af96434409"/>
+    <p:sldId xmlns:r="http://schemas.openxmlformats.org/officeDocument/2006/relationships" id="258" r:id="Rcc5b8af201c547c5"/>
+    <p:sldId xmlns:r="http://schemas.openxmlformats.org/officeDocument/2006/relationships" id="259" r:id="Rb14238e4acf24f02"/>
+    <p:sldId xmlns:r="http://schemas.openxmlformats.org/officeDocument/2006/relationships" id="260" r:id="Rb75aa7a08de64a5b"/>
+    <p:sldId xmlns:r="http://schemas.openxmlformats.org/officeDocument/2006/relationships" id="261" r:id="R55604c4408934a0b"/>
+    <p:sldId xmlns:r="http://schemas.openxmlformats.org/officeDocument/2006/relationships" id="262" r:id="R066fac9192344a60"/>
+    <p:sldId xmlns:r="http://schemas.openxmlformats.org/officeDocument/2006/relationships" id="263" r:id="Ra391a77358844501"/>
   </p:sldIdLst>
   <p:sldSz cx="12192000" cy="6858000"/>
   <p:notesSz cx="6858000" cy="9144000"/>
@@ -534,12 +534,22 @@
           </a:p>
           <a:p xmlns:a="http://schemas.openxmlformats.org/drawingml/2006/main">
             <a:r>
-              <a:t>Sources: data/results/common_roster_primary.csv; docs/RESULTS_READOUT.md section 1.</a:t>
+              <a:t>Sources: data/results/common_roster_primary.csv; docs/RESULTS_READOUT.md section 1; docs/PAPER_REVIEW.md protocol comparison; evidence/canonical-audit/CLAIM_BOUNDARIES.md.</a:t>
             </a:r>
           </a:p>
           <a:p xmlns:a="http://schemas.openxmlformats.org/drawingml/2006/main">
             <a:r>
               <a:t>The MFQ compare top value is shared by Claude Haiku 4.5 and Qwen3 8B. The vignette compare top value is shared by Claude Haiku 4.5 and GPT-5.4.</a:t>
+            </a:r>
+          </a:p>
+          <a:p xmlns:a="http://schemas.openxmlformats.org/drawingml/2006/main">
+            <a:r>
+              <a:t>Each task cell keeps the formal task name on the first line and explains what it tests on the second.</a:t>
+            </a:r>
+          </a:p>
+          <a:p xmlns:a="http://schemas.openxmlformats.org/drawingml/2006/main">
+            <a:r>
+              <a:t>The UniMoral action, typology, and factor rows match saved annotator-specific labels under no-persona prompts; the consequence row matches generated text to saved human references. None infers a person's stable moral identity.</a:t>
             </a:r>
           </a:p>
           <a:p xmlns:a="http://schemas.openxmlformats.org/drawingml/2006/main">
@@ -1147,7 +1157,7 @@
   </p:cSld>
   <p:clrMap bg1="lt1" tx1="dk1" bg2="lt2" tx2="dk2" accent1="accent1" accent2="accent2" accent3="accent3" accent4="accent4" accent5="accent5" accent6="accent6" hlink="hlink" folHlink="folHlink"/>
   <p:sldLayoutIdLst>
-    <p:sldLayoutId xmlns:r="http://schemas.openxmlformats.org/officeDocument/2006/relationships" id="2147483649" r:id="R47c4c3dd19b24db5"/>
+    <p:sldLayoutId xmlns:r="http://schemas.openxmlformats.org/officeDocument/2006/relationships" id="2147483649" r:id="Rb9e84d7c67d7469a"/>
   </p:sldLayoutIdLst>
   <p:txStyles>
     <p:titleStyle>
@@ -3123,7 +3133,7 @@
           <p:cNvPr id="7" name="cover-title">
             <a:extLst xmlns:a="http://schemas.openxmlformats.org/drawingml/2006/main">
               <a:ext uri="{FF2B5EF4-FFF2-40B4-BE49-F238E27FC236}">
-                <a16:creationId xmlns:a16="http://schemas.microsoft.com/office/drawing/2014/main" id="{9867D34F-0CCE-493A-8257-9A6115FB2188}"/>
+                <a16:creationId xmlns:a16="http://schemas.microsoft.com/office/drawing/2014/main" id="{0E3229AB-1BD1-4B7B-8ADE-D93BA95BF379}"/>
               </a:ext>
             </a:extLst>
           </p:cNvPr>
@@ -3203,7 +3213,7 @@
           <p:cNvPr id="2" name="">
             <a:extLst xmlns:a="http://schemas.openxmlformats.org/drawingml/2006/main">
               <a:ext uri="{FF2B5EF4-FFF2-40B4-BE49-F238E27FC236}">
-                <a16:creationId xmlns:a16="http://schemas.microsoft.com/office/drawing/2014/main" id="{FED5646C-9E9B-4A25-B3C9-6754D3449042}"/>
+                <a16:creationId xmlns:a16="http://schemas.microsoft.com/office/drawing/2014/main" id="{FD7CCB59-4DE3-4244-A176-51D5E16ED15A}"/>
               </a:ext>
             </a:extLst>
           </p:cNvPr>
@@ -3260,7 +3270,7 @@
           <p:cNvPr id="3" name="">
             <a:extLst xmlns:a="http://schemas.openxmlformats.org/drawingml/2006/main">
               <a:ext uri="{FF2B5EF4-FFF2-40B4-BE49-F238E27FC236}">
-                <a16:creationId xmlns:a16="http://schemas.microsoft.com/office/drawing/2014/main" id="{2CA19375-27D9-4477-97D0-BFDC431663E5}"/>
+                <a16:creationId xmlns:a16="http://schemas.microsoft.com/office/drawing/2014/main" id="{A8290B8F-7479-455F-9BA6-9CD70EFEAEF0}"/>
               </a:ext>
             </a:extLst>
           </p:cNvPr>
@@ -3317,7 +3327,7 @@
           <p:cNvPr id="4" name="">
             <a:extLst xmlns:a="http://schemas.openxmlformats.org/drawingml/2006/main">
               <a:ext uri="{FF2B5EF4-FFF2-40B4-BE49-F238E27FC236}">
-                <a16:creationId xmlns:a16="http://schemas.microsoft.com/office/drawing/2014/main" id="{BBE6B9D3-98BD-47AC-8DE8-4F567101BB61}"/>
+                <a16:creationId xmlns:a16="http://schemas.microsoft.com/office/drawing/2014/main" id="{DF2D7E97-97AF-4B2E-B69F-1984F2F7C97C}"/>
               </a:ext>
             </a:extLst>
           </p:cNvPr>
@@ -3348,7 +3358,7 @@
           <p:cNvPr id="5" name="">
             <a:extLst xmlns:a="http://schemas.openxmlformats.org/drawingml/2006/main">
               <a:ext uri="{FF2B5EF4-FFF2-40B4-BE49-F238E27FC236}">
-                <a16:creationId xmlns:a16="http://schemas.microsoft.com/office/drawing/2014/main" id="{5FED375B-AC9C-4AF8-9006-8DC9DF83F46E}"/>
+                <a16:creationId xmlns:a16="http://schemas.microsoft.com/office/drawing/2014/main" id="{533E62EB-2220-4AC4-AC93-AC7548045A8D}"/>
               </a:ext>
             </a:extLst>
           </p:cNvPr>
@@ -3405,7 +3415,7 @@
           <p:cNvPr id="6" name="">
             <a:extLst xmlns:a="http://schemas.openxmlformats.org/drawingml/2006/main">
               <a:ext uri="{FF2B5EF4-FFF2-40B4-BE49-F238E27FC236}">
-                <a16:creationId xmlns:a16="http://schemas.microsoft.com/office/drawing/2014/main" id="{A7B5A675-844B-41E5-AB80-6EBCFCD807CD}"/>
+                <a16:creationId xmlns:a16="http://schemas.microsoft.com/office/drawing/2014/main" id="{D3639A99-A4DE-4ED1-B712-CAE6E9A5F4A2}"/>
               </a:ext>
             </a:extLst>
           </p:cNvPr>
@@ -3460,7 +3470,7 @@
     </p:spTree>
     <p:extLst>
       <p:ext uri="{BB962C8B-B14F-4D97-AF65-F5344CB8AC3E}">
-        <p14:creationId xmlns:p14="http://schemas.microsoft.com/office/powerpoint/2010/main" val="1651103330"/>
+        <p14:creationId xmlns:p14="http://schemas.microsoft.com/office/powerpoint/2010/main" val="1032029879"/>
       </p:ext>
     </p:extLst>
   </p:cSld>
@@ -3491,7 +3501,7 @@
           <p:cNvPr id="8" name="slide-title">
             <a:extLst xmlns:a="http://schemas.openxmlformats.org/drawingml/2006/main">
               <a:ext uri="{FF2B5EF4-FFF2-40B4-BE49-F238E27FC236}">
-                <a16:creationId xmlns:a16="http://schemas.microsoft.com/office/drawing/2014/main" id="{D1B141AE-0A87-4452-9A8E-E4B0E623839A}"/>
+                <a16:creationId xmlns:a16="http://schemas.microsoft.com/office/drawing/2014/main" id="{1F79086F-5600-4073-912E-E42CB18E4F2B}"/>
               </a:ext>
             </a:extLst>
           </p:cNvPr>
@@ -3548,7 +3558,7 @@
           <p:cNvPr id="2" name="slide-subtitle">
             <a:extLst xmlns:a="http://schemas.openxmlformats.org/drawingml/2006/main">
               <a:ext uri="{FF2B5EF4-FFF2-40B4-BE49-F238E27FC236}">
-                <a16:creationId xmlns:a16="http://schemas.microsoft.com/office/drawing/2014/main" id="{437759E4-A2F9-4AD3-BBB3-C7FE200CAD28}"/>
+                <a16:creationId xmlns:a16="http://schemas.microsoft.com/office/drawing/2014/main" id="{0E650A18-004C-45A0-898C-F0F308FF2386}"/>
               </a:ext>
             </a:extLst>
           </p:cNvPr>
@@ -3605,7 +3615,7 @@
           <p:cNvPr id="3" name="">
             <a:extLst xmlns:a="http://schemas.openxmlformats.org/drawingml/2006/main">
               <a:ext uri="{FF2B5EF4-FFF2-40B4-BE49-F238E27FC236}">
-                <a16:creationId xmlns:a16="http://schemas.microsoft.com/office/drawing/2014/main" id="{02DDC73D-79D2-4BCA-A1AD-F62E423A3DB5}"/>
+                <a16:creationId xmlns:a16="http://schemas.microsoft.com/office/drawing/2014/main" id="{E0F1618D-6E31-4572-8020-DADFE93F8FF8}"/>
               </a:ext>
             </a:extLst>
           </p:cNvPr>
@@ -3666,7 +3676,7 @@
           <p:cNvPr id="4" name="">
             <a:extLst xmlns:a="http://schemas.openxmlformats.org/drawingml/2006/main">
               <a:ext uri="{FF2B5EF4-FFF2-40B4-BE49-F238E27FC236}">
-                <a16:creationId xmlns:a16="http://schemas.microsoft.com/office/drawing/2014/main" id="{67927C9F-0598-41AE-8B26-EEBF79BB4588}"/>
+                <a16:creationId xmlns:a16="http://schemas.microsoft.com/office/drawing/2014/main" id="{AE20C4E7-C792-4A3D-83AE-E188C25F3E17}"/>
               </a:ext>
             </a:extLst>
           </p:cNvPr>
@@ -3707,10 +3717,10 @@
             <a:tbl>
               <a:tblPr/>
               <a:tblGrid>
-                <a:gridCol w="3143250"/>
+                <a:gridCol w="3810000"/>
                 <a:gridCol w="1809750"/>
-                <a:gridCol w="2143125"/>
-                <a:gridCol w="3267075"/>
+                <a:gridCol w="2000250"/>
+                <a:gridCol w="2743200"/>
               </a:tblGrid>
               <a:tr h="455083">
                 <a:tc>
@@ -3817,7 +3827,7 @@
                     <a:lstStyle/>
                     <a:p>
                       <a:r>
-                        <a:rPr sz="1275">
+                        <a:rPr sz="975">
                           <a:solidFill>
                             <a:srgbClr val="17212B"/>
                           </a:solidFill>
@@ -3828,8 +3838,21 @@
                         <a:t>MFQ agreement</a:t>
                       </a:r>
                     </a:p>
+                    <a:p>
+                      <a:r>
+                        <a:rPr sz="975">
+                          <a:solidFill>
+                            <a:srgbClr val="17212B"/>
+                          </a:solidFill>
+                          <a:latin typeface="Aptos"/>
+                          <a:ea typeface="Aptos"/>
+                          <a:cs typeface="Aptos"/>
+                        </a:rPr>
+                        <a:t>Track benchmark human ratings of value statements</a:t>
+                      </a:r>
+                    </a:p>
                   </a:txBody>
-                  <a:tcPr marL="114300" marR="114300" marT="66675" marB="66675">
+                  <a:tcPr marL="114300" marR="114300" marT="38100" marB="38100">
                     <a:solidFill>
                       <a:srgbClr val="FFFFFF"/>
                     </a:solidFill>
@@ -3915,7 +3938,7 @@
                     <a:lstStyle/>
                     <a:p>
                       <a:r>
-                        <a:rPr sz="1275">
+                        <a:rPr sz="975">
                           <a:solidFill>
                             <a:srgbClr val="17212B"/>
                           </a:solidFill>
@@ -3926,8 +3949,21 @@
                         <a:t>Vignette agreement</a:t>
                       </a:r>
                     </a:p>
+                    <a:p>
+                      <a:r>
+                        <a:rPr sz="975">
+                          <a:solidFill>
+                            <a:srgbClr val="17212B"/>
+                          </a:solidFill>
+                          <a:latin typeface="Aptos"/>
+                          <a:ea typeface="Aptos"/>
+                          <a:cs typeface="Aptos"/>
+                        </a:rPr>
+                        <a:t>Track benchmark human ratings of moral stories</a:t>
+                      </a:r>
+                    </a:p>
                   </a:txBody>
-                  <a:tcPr marL="114300" marR="114300" marT="66675" marB="66675">
+                  <a:tcPr marL="114300" marR="114300" marT="38100" marB="38100">
                     <a:solidFill>
                       <a:srgbClr val="FFFFFF"/>
                     </a:solidFill>
@@ -4013,7 +4049,7 @@
                     <a:lstStyle/>
                     <a:p>
                       <a:r>
-                        <a:rPr sz="1275">
+                        <a:rPr sz="975">
                           <a:solidFill>
                             <a:srgbClr val="17212B"/>
                           </a:solidFill>
@@ -4024,8 +4060,21 @@
                         <a:t>MFQ compare</a:t>
                       </a:r>
                     </a:p>
+                    <a:p>
+                      <a:r>
+                        <a:rPr sz="975">
+                          <a:solidFill>
+                            <a:srgbClr val="17212B"/>
+                          </a:solidFill>
+                          <a:latin typeface="Aptos"/>
+                          <a:ea typeface="Aptos"/>
+                          <a:cs typeface="Aptos"/>
+                        </a:rPr>
+                        <a:t>Pick the higher-rated value statement</a:t>
+                      </a:r>
+                    </a:p>
                   </a:txBody>
-                  <a:tcPr marL="114300" marR="114300" marT="66675" marB="66675">
+                  <a:tcPr marL="114300" marR="114300" marT="38100" marB="38100">
                     <a:solidFill>
                       <a:srgbClr val="FFFFFF"/>
                     </a:solidFill>
@@ -4111,7 +4160,7 @@
                     <a:lstStyle/>
                     <a:p>
                       <a:r>
-                        <a:rPr sz="1275">
+                        <a:rPr sz="975">
                           <a:solidFill>
                             <a:srgbClr val="17212B"/>
                           </a:solidFill>
@@ -4122,8 +4171,21 @@
                         <a:t>Vignette compare</a:t>
                       </a:r>
                     </a:p>
+                    <a:p>
+                      <a:r>
+                        <a:rPr sz="975">
+                          <a:solidFill>
+                            <a:srgbClr val="17212B"/>
+                          </a:solidFill>
+                          <a:latin typeface="Aptos"/>
+                          <a:ea typeface="Aptos"/>
+                          <a:cs typeface="Aptos"/>
+                        </a:rPr>
+                        <a:t>Pick the higher-rated moral story</a:t>
+                      </a:r>
+                    </a:p>
                   </a:txBody>
-                  <a:tcPr marL="114300" marR="114300" marT="66675" marB="66675">
+                  <a:tcPr marL="114300" marR="114300" marT="38100" marB="38100">
                     <a:solidFill>
                       <a:srgbClr val="FFFFFF"/>
                     </a:solidFill>
@@ -4209,7 +4271,7 @@
                     <a:lstStyle/>
                     <a:p>
                       <a:r>
-                        <a:rPr sz="1275">
+                        <a:rPr sz="975">
                           <a:solidFill>
                             <a:srgbClr val="17212B"/>
                           </a:solidFill>
@@ -4220,8 +4282,21 @@
                         <a:t>UniMoral action</a:t>
                       </a:r>
                     </a:p>
+                    <a:p>
+                      <a:r>
+                        <a:rPr sz="975">
+                          <a:solidFill>
+                            <a:srgbClr val="17212B"/>
+                          </a:solidFill>
+                          <a:latin typeface="Aptos"/>
+                          <a:ea typeface="Aptos"/>
+                          <a:cs typeface="Aptos"/>
+                        </a:rPr>
+                        <a:t>Match one recorded human choice</a:t>
+                      </a:r>
+                    </a:p>
                   </a:txBody>
-                  <a:tcPr marL="114300" marR="114300" marT="66675" marB="66675">
+                  <a:tcPr marL="114300" marR="114300" marT="38100" marB="38100">
                     <a:solidFill>
                       <a:srgbClr val="FFFFFF"/>
                     </a:solidFill>
@@ -4307,7 +4382,7 @@
                     <a:lstStyle/>
                     <a:p>
                       <a:r>
-                        <a:rPr sz="1275">
+                        <a:rPr sz="975">
                           <a:solidFill>
                             <a:srgbClr val="17212B"/>
                           </a:solidFill>
@@ -4318,8 +4393,21 @@
                         <a:t>UniMoral typology</a:t>
                       </a:r>
                     </a:p>
+                    <a:p>
+                      <a:r>
+                        <a:rPr sz="975">
+                          <a:solidFill>
+                            <a:srgbClr val="17212B"/>
+                          </a:solidFill>
+                          <a:latin typeface="Aptos"/>
+                          <a:ea typeface="Aptos"/>
+                          <a:cs typeface="Aptos"/>
+                        </a:rPr>
+                        <a:t>Classify the recorded choice into one of four types</a:t>
+                      </a:r>
+                    </a:p>
                   </a:txBody>
-                  <a:tcPr marL="114300" marR="114300" marT="66675" marB="66675">
+                  <a:tcPr marL="114300" marR="114300" marT="38100" marB="38100">
                     <a:solidFill>
                       <a:srgbClr val="FFFFFF"/>
                     </a:solidFill>
@@ -4405,7 +4493,7 @@
                     <a:lstStyle/>
                     <a:p>
                       <a:r>
-                        <a:rPr sz="1275">
+                        <a:rPr sz="975">
                           <a:solidFill>
                             <a:srgbClr val="17212B"/>
                           </a:solidFill>
@@ -4416,8 +4504,21 @@
                         <a:t>UniMoral factor</a:t>
                       </a:r>
                     </a:p>
+                    <a:p>
+                      <a:r>
+                        <a:rPr sz="975">
+                          <a:solidFill>
+                            <a:srgbClr val="17212B"/>
+                          </a:solidFill>
+                          <a:latin typeface="Aptos"/>
+                          <a:ea typeface="Aptos"/>
+                          <a:cs typeface="Aptos"/>
+                        </a:rPr>
+                        <a:t>Pick a top-rated factor for the recorded choice</a:t>
+                      </a:r>
+                    </a:p>
                   </a:txBody>
-                  <a:tcPr marL="114300" marR="114300" marT="66675" marB="66675">
+                  <a:tcPr marL="114300" marR="114300" marT="38100" marB="38100">
                     <a:solidFill>
                       <a:srgbClr val="FFFFFF"/>
                     </a:solidFill>
@@ -4503,7 +4604,7 @@
                     <a:lstStyle/>
                     <a:p>
                       <a:r>
-                        <a:rPr sz="1275">
+                        <a:rPr sz="975">
                           <a:solidFill>
                             <a:srgbClr val="17212B"/>
                           </a:solidFill>
@@ -4514,8 +4615,21 @@
                         <a:t>UniMoral consequence</a:t>
                       </a:r>
                     </a:p>
+                    <a:p>
+                      <a:r>
+                        <a:rPr sz="975">
+                          <a:solidFill>
+                            <a:srgbClr val="17212B"/>
+                          </a:solidFill>
+                          <a:latin typeface="Aptos"/>
+                          <a:ea typeface="Aptos"/>
+                          <a:cs typeface="Aptos"/>
+                        </a:rPr>
+                        <a:t>Write what could happen next</a:t>
+                      </a:r>
+                    </a:p>
                   </a:txBody>
-                  <a:tcPr marL="114300" marR="114300" marT="66675" marB="66675">
+                  <a:tcPr marL="114300" marR="114300" marT="38100" marB="38100">
                     <a:solidFill>
                       <a:srgbClr val="FFFFFF"/>
                     </a:solidFill>
@@ -4603,7 +4717,7 @@
           <p:cNvPr id="6" name="">
             <a:extLst xmlns:a="http://schemas.openxmlformats.org/drawingml/2006/main">
               <a:ext uri="{FF2B5EF4-FFF2-40B4-BE49-F238E27FC236}">
-                <a16:creationId xmlns:a16="http://schemas.microsoft.com/office/drawing/2014/main" id="{6982ED4B-1CDF-49DA-8A18-73E33F002799}"/>
+                <a16:creationId xmlns:a16="http://schemas.microsoft.com/office/drawing/2014/main" id="{1F6EE849-AD0B-40B7-9706-7249164C5827}"/>
               </a:ext>
             </a:extLst>
           </p:cNvPr>
@@ -4660,7 +4774,7 @@
           <p:cNvPr id="7" name="">
             <a:extLst xmlns:a="http://schemas.openxmlformats.org/drawingml/2006/main">
               <a:ext uri="{FF2B5EF4-FFF2-40B4-BE49-F238E27FC236}">
-                <a16:creationId xmlns:a16="http://schemas.microsoft.com/office/drawing/2014/main" id="{2CA34357-74CC-46AE-A3A5-D49E51BDDDEA}"/>
+                <a16:creationId xmlns:a16="http://schemas.microsoft.com/office/drawing/2014/main" id="{C0DD8B33-CCB1-4105-8F43-71F8023D1C4F}"/>
               </a:ext>
             </a:extLst>
           </p:cNvPr>
@@ -4715,7 +4829,7 @@
     </p:spTree>
     <p:extLst>
       <p:ext uri="{BB962C8B-B14F-4D97-AF65-F5344CB8AC3E}">
-        <p14:creationId xmlns:p14="http://schemas.microsoft.com/office/powerpoint/2010/main" val="1085649377"/>
+        <p14:creationId xmlns:p14="http://schemas.microsoft.com/office/powerpoint/2010/main" val="1193849475"/>
       </p:ext>
     </p:extLst>
   </p:cSld>
@@ -4746,7 +4860,7 @@
           <p:cNvPr id="11" name="slide-title">
             <a:extLst xmlns:a="http://schemas.openxmlformats.org/drawingml/2006/main">
               <a:ext uri="{FF2B5EF4-FFF2-40B4-BE49-F238E27FC236}">
-                <a16:creationId xmlns:a16="http://schemas.microsoft.com/office/drawing/2014/main" id="{31596B0F-238C-4C99-9684-F5A797CD80A7}"/>
+                <a16:creationId xmlns:a16="http://schemas.microsoft.com/office/drawing/2014/main" id="{F0D5B4DA-65B4-4B4C-84BC-3D77839014F3}"/>
               </a:ext>
             </a:extLst>
           </p:cNvPr>
@@ -4803,7 +4917,7 @@
           <p:cNvPr id="2" name="slide-subtitle">
             <a:extLst xmlns:a="http://schemas.openxmlformats.org/drawingml/2006/main">
               <a:ext uri="{FF2B5EF4-FFF2-40B4-BE49-F238E27FC236}">
-                <a16:creationId xmlns:a16="http://schemas.microsoft.com/office/drawing/2014/main" id="{849C5352-1CB5-4C30-8A5B-5684DCF3DF7A}"/>
+                <a16:creationId xmlns:a16="http://schemas.microsoft.com/office/drawing/2014/main" id="{043A3F8D-2BAA-4C5E-BA9A-7CBB0D51A24C}"/>
               </a:ext>
             </a:extLst>
           </p:cNvPr>
@@ -4860,7 +4974,7 @@
           <p:cNvPr id="3" name="">
             <a:extLst xmlns:a="http://schemas.openxmlformats.org/drawingml/2006/main">
               <a:ext uri="{FF2B5EF4-FFF2-40B4-BE49-F238E27FC236}">
-                <a16:creationId xmlns:a16="http://schemas.microsoft.com/office/drawing/2014/main" id="{588B5E80-366C-4695-926B-6EA6D522B461}"/>
+                <a16:creationId xmlns:a16="http://schemas.microsoft.com/office/drawing/2014/main" id="{E67F9D4A-3C06-4148-974E-088A412F5D67}"/>
               </a:ext>
             </a:extLst>
           </p:cNvPr>
@@ -4921,7 +5035,7 @@
           <p:cNvPr id="4" name="">
             <a:extLst xmlns:a="http://schemas.openxmlformats.org/drawingml/2006/main">
               <a:ext uri="{FF2B5EF4-FFF2-40B4-BE49-F238E27FC236}">
-                <a16:creationId xmlns:a16="http://schemas.microsoft.com/office/drawing/2014/main" id="{5B5E3913-97A7-49F3-A70F-7B2B0DAC875A}"/>
+                <a16:creationId xmlns:a16="http://schemas.microsoft.com/office/drawing/2014/main" id="{5428237C-F603-427D-9392-7D9FC890495B}"/>
               </a:ext>
             </a:extLst>
           </p:cNvPr>
@@ -4952,7 +5066,7 @@
           <p:cNvPr id="5" name="">
             <a:extLst xmlns:a="http://schemas.openxmlformats.org/drawingml/2006/main">
               <a:ext uri="{FF2B5EF4-FFF2-40B4-BE49-F238E27FC236}">
-                <a16:creationId xmlns:a16="http://schemas.microsoft.com/office/drawing/2014/main" id="{F1D1840F-E9E7-4E43-BC6D-B6DA42C49B9B}"/>
+                <a16:creationId xmlns:a16="http://schemas.microsoft.com/office/drawing/2014/main" id="{9D4FEAFB-3F74-4B8F-8923-EB6B357B8EA6}"/>
               </a:ext>
             </a:extLst>
           </p:cNvPr>
@@ -5016,7 +5130,7 @@
         </p:xfrm>
         <a:graphic xmlns:a="http://schemas.openxmlformats.org/drawingml/2006/main">
           <a:graphicData uri="http://schemas.openxmlformats.org/drawingml/2006/chart">
-            <c:chart xmlns:r="http://schemas.openxmlformats.org/officeDocument/2006/relationships" xmlns:c="http://schemas.openxmlformats.org/drawingml/2006/chart" r:id="R3390438968ec45da"/>
+            <c:chart xmlns:r="http://schemas.openxmlformats.org/officeDocument/2006/relationships" xmlns:c="http://schemas.openxmlformats.org/drawingml/2006/chart" r:id="Rf884f9d7cd8744e8"/>
           </a:graphicData>
         </a:graphic>
       </p:graphicFrame>
@@ -5025,7 +5139,7 @@
           <p:cNvPr id="7" name="">
             <a:extLst xmlns:a="http://schemas.openxmlformats.org/drawingml/2006/main">
               <a:ext uri="{FF2B5EF4-FFF2-40B4-BE49-F238E27FC236}">
-                <a16:creationId xmlns:a16="http://schemas.microsoft.com/office/drawing/2014/main" id="{7B72E2FF-0D09-4065-9A17-2E9117DD6E89}"/>
+                <a16:creationId xmlns:a16="http://schemas.microsoft.com/office/drawing/2014/main" id="{72EFB587-8FF3-45B1-912D-12032C1A895E}"/>
               </a:ext>
             </a:extLst>
           </p:cNvPr>
@@ -5082,7 +5196,7 @@
           <p:cNvPr id="8" name="">
             <a:extLst xmlns:a="http://schemas.openxmlformats.org/drawingml/2006/main">
               <a:ext uri="{FF2B5EF4-FFF2-40B4-BE49-F238E27FC236}">
-                <a16:creationId xmlns:a16="http://schemas.microsoft.com/office/drawing/2014/main" id="{3CA7612D-60FF-4543-8470-05BA3C847066}"/>
+                <a16:creationId xmlns:a16="http://schemas.microsoft.com/office/drawing/2014/main" id="{2E41B546-C0E2-4597-9496-BD32945029E1}"/>
               </a:ext>
             </a:extLst>
           </p:cNvPr>
@@ -5139,7 +5253,7 @@
           <p:cNvPr id="9" name="">
             <a:extLst xmlns:a="http://schemas.openxmlformats.org/drawingml/2006/main">
               <a:ext uri="{FF2B5EF4-FFF2-40B4-BE49-F238E27FC236}">
-                <a16:creationId xmlns:a16="http://schemas.microsoft.com/office/drawing/2014/main" id="{5C8E407D-E6A6-4490-8A57-7E280E973E05}"/>
+                <a16:creationId xmlns:a16="http://schemas.microsoft.com/office/drawing/2014/main" id="{A29EC2BC-D2EC-4E18-A068-C6D95053E570}"/>
               </a:ext>
             </a:extLst>
           </p:cNvPr>
@@ -5196,7 +5310,7 @@
           <p:cNvPr id="10" name="">
             <a:extLst xmlns:a="http://schemas.openxmlformats.org/drawingml/2006/main">
               <a:ext uri="{FF2B5EF4-FFF2-40B4-BE49-F238E27FC236}">
-                <a16:creationId xmlns:a16="http://schemas.microsoft.com/office/drawing/2014/main" id="{1817A31B-C74D-4743-8D1D-2B4461F4822B}"/>
+                <a16:creationId xmlns:a16="http://schemas.microsoft.com/office/drawing/2014/main" id="{9715F10B-3FA7-4AB3-9F18-BE0EF75167E0}"/>
               </a:ext>
             </a:extLst>
           </p:cNvPr>
@@ -5251,7 +5365,7 @@
     </p:spTree>
     <p:extLst>
       <p:ext uri="{BB962C8B-B14F-4D97-AF65-F5344CB8AC3E}">
-        <p14:creationId xmlns:p14="http://schemas.microsoft.com/office/powerpoint/2010/main" val="1962121643"/>
+        <p14:creationId xmlns:p14="http://schemas.microsoft.com/office/powerpoint/2010/main" val="1590806344"/>
       </p:ext>
     </p:extLst>
   </p:cSld>
@@ -5282,7 +5396,7 @@
           <p:cNvPr id="9" name="slide-title">
             <a:extLst xmlns:a="http://schemas.openxmlformats.org/drawingml/2006/main">
               <a:ext uri="{FF2B5EF4-FFF2-40B4-BE49-F238E27FC236}">
-                <a16:creationId xmlns:a16="http://schemas.microsoft.com/office/drawing/2014/main" id="{CE09F1C1-4F8F-4A3B-8CDD-AA21577B0766}"/>
+                <a16:creationId xmlns:a16="http://schemas.microsoft.com/office/drawing/2014/main" id="{96C7BED6-114F-4A47-AE17-F4726D07CCC1}"/>
               </a:ext>
             </a:extLst>
           </p:cNvPr>
@@ -5339,7 +5453,7 @@
           <p:cNvPr id="2" name="slide-subtitle">
             <a:extLst xmlns:a="http://schemas.openxmlformats.org/drawingml/2006/main">
               <a:ext uri="{FF2B5EF4-FFF2-40B4-BE49-F238E27FC236}">
-                <a16:creationId xmlns:a16="http://schemas.microsoft.com/office/drawing/2014/main" id="{CE143E08-F909-4358-A840-6082978225FC}"/>
+                <a16:creationId xmlns:a16="http://schemas.microsoft.com/office/drawing/2014/main" id="{17BC0FEE-5D0E-4401-9A57-3494FE402E4C}"/>
               </a:ext>
             </a:extLst>
           </p:cNvPr>
@@ -5396,7 +5510,7 @@
           <p:cNvPr id="3" name="">
             <a:extLst xmlns:a="http://schemas.openxmlformats.org/drawingml/2006/main">
               <a:ext uri="{FF2B5EF4-FFF2-40B4-BE49-F238E27FC236}">
-                <a16:creationId xmlns:a16="http://schemas.microsoft.com/office/drawing/2014/main" id="{7DC0684F-F33C-4E99-B0E0-6A5B7970A940}"/>
+                <a16:creationId xmlns:a16="http://schemas.microsoft.com/office/drawing/2014/main" id="{1ACDDE21-DBEE-49CA-85A6-0D74E5DFCB8B}"/>
               </a:ext>
             </a:extLst>
           </p:cNvPr>
@@ -5457,7 +5571,7 @@
           <p:cNvPr id="4" name="">
             <a:extLst xmlns:a="http://schemas.openxmlformats.org/drawingml/2006/main">
               <a:ext uri="{FF2B5EF4-FFF2-40B4-BE49-F238E27FC236}">
-                <a16:creationId xmlns:a16="http://schemas.microsoft.com/office/drawing/2014/main" id="{A37BBBDC-2C02-466B-8F5F-46F9930C9DD5}"/>
+                <a16:creationId xmlns:a16="http://schemas.microsoft.com/office/drawing/2014/main" id="{1EE75887-21A1-4DD9-94CF-259E075EC5D1}"/>
               </a:ext>
             </a:extLst>
           </p:cNvPr>
@@ -5495,7 +5609,7 @@
         </p:xfrm>
         <a:graphic xmlns:a="http://schemas.openxmlformats.org/drawingml/2006/main">
           <a:graphicData uri="http://schemas.openxmlformats.org/drawingml/2006/chart">
-            <c:chart xmlns:r="http://schemas.openxmlformats.org/officeDocument/2006/relationships" xmlns:c="http://schemas.openxmlformats.org/drawingml/2006/chart" r:id="Rdb49c5426f5b4c7c"/>
+            <c:chart xmlns:r="http://schemas.openxmlformats.org/officeDocument/2006/relationships" xmlns:c="http://schemas.openxmlformats.org/drawingml/2006/chart" r:id="R2aa6bce0eedc4a78"/>
           </a:graphicData>
         </a:graphic>
       </p:graphicFrame>
@@ -5504,7 +5618,7 @@
           <p:cNvPr id="6" name="">
             <a:extLst xmlns:a="http://schemas.openxmlformats.org/drawingml/2006/main">
               <a:ext uri="{FF2B5EF4-FFF2-40B4-BE49-F238E27FC236}">
-                <a16:creationId xmlns:a16="http://schemas.microsoft.com/office/drawing/2014/main" id="{0A49A6A6-053E-4AB9-8299-2238B7173BD8}"/>
+                <a16:creationId xmlns:a16="http://schemas.microsoft.com/office/drawing/2014/main" id="{F81D1606-7715-4D5D-A3FB-2FC9572C3C58}"/>
               </a:ext>
             </a:extLst>
           </p:cNvPr>
@@ -5561,7 +5675,7 @@
           <p:cNvPr id="7" name="">
             <a:extLst xmlns:a="http://schemas.openxmlformats.org/drawingml/2006/main">
               <a:ext uri="{FF2B5EF4-FFF2-40B4-BE49-F238E27FC236}">
-                <a16:creationId xmlns:a16="http://schemas.microsoft.com/office/drawing/2014/main" id="{F1DDAEE7-1E6E-4FE9-9338-46939C238518}"/>
+                <a16:creationId xmlns:a16="http://schemas.microsoft.com/office/drawing/2014/main" id="{9955E619-17CA-482B-A4F5-CA49029D1522}"/>
               </a:ext>
             </a:extLst>
           </p:cNvPr>
@@ -5618,7 +5732,7 @@
           <p:cNvPr id="8" name="">
             <a:extLst xmlns:a="http://schemas.openxmlformats.org/drawingml/2006/main">
               <a:ext uri="{FF2B5EF4-FFF2-40B4-BE49-F238E27FC236}">
-                <a16:creationId xmlns:a16="http://schemas.microsoft.com/office/drawing/2014/main" id="{00ACAE09-87A7-45CD-9749-59DAA6C54007}"/>
+                <a16:creationId xmlns:a16="http://schemas.microsoft.com/office/drawing/2014/main" id="{3D18F694-5776-4C50-A747-195C6766D177}"/>
               </a:ext>
             </a:extLst>
           </p:cNvPr>
@@ -5673,7 +5787,7 @@
     </p:spTree>
     <p:extLst>
       <p:ext uri="{BB962C8B-B14F-4D97-AF65-F5344CB8AC3E}">
-        <p14:creationId xmlns:p14="http://schemas.microsoft.com/office/powerpoint/2010/main" val="1719988644"/>
+        <p14:creationId xmlns:p14="http://schemas.microsoft.com/office/powerpoint/2010/main" val="1377702039"/>
       </p:ext>
     </p:extLst>
   </p:cSld>
@@ -5704,7 +5818,7 @@
           <p:cNvPr id="7" name="slide-title">
             <a:extLst xmlns:a="http://schemas.openxmlformats.org/drawingml/2006/main">
               <a:ext uri="{FF2B5EF4-FFF2-40B4-BE49-F238E27FC236}">
-                <a16:creationId xmlns:a16="http://schemas.microsoft.com/office/drawing/2014/main" id="{51FAFFA0-A64E-415C-B5F6-949AAA80217D}"/>
+                <a16:creationId xmlns:a16="http://schemas.microsoft.com/office/drawing/2014/main" id="{2376CE92-F826-4400-B1D6-53495439C51E}"/>
               </a:ext>
             </a:extLst>
           </p:cNvPr>
@@ -5761,7 +5875,7 @@
           <p:cNvPr id="2" name="">
             <a:extLst xmlns:a="http://schemas.openxmlformats.org/drawingml/2006/main">
               <a:ext uri="{FF2B5EF4-FFF2-40B4-BE49-F238E27FC236}">
-                <a16:creationId xmlns:a16="http://schemas.microsoft.com/office/drawing/2014/main" id="{0D589AC9-6FC6-4144-A1C0-3589B789B02B}"/>
+                <a16:creationId xmlns:a16="http://schemas.microsoft.com/office/drawing/2014/main" id="{6490B9FC-E5CB-4DEB-A5E0-C7EF4DE5326F}"/>
               </a:ext>
             </a:extLst>
           </p:cNvPr>
@@ -5822,7 +5936,7 @@
           <p:cNvPr id="3" name="">
             <a:extLst xmlns:a="http://schemas.openxmlformats.org/drawingml/2006/main">
               <a:ext uri="{FF2B5EF4-FFF2-40B4-BE49-F238E27FC236}">
-                <a16:creationId xmlns:a16="http://schemas.microsoft.com/office/drawing/2014/main" id="{F1A8A548-6E13-4478-985E-F080CD483B85}"/>
+                <a16:creationId xmlns:a16="http://schemas.microsoft.com/office/drawing/2014/main" id="{A748517A-99BB-4C11-82A2-794325A13A14}"/>
               </a:ext>
             </a:extLst>
           </p:cNvPr>
@@ -5860,7 +5974,7 @@
         </p:xfrm>
         <a:graphic xmlns:a="http://schemas.openxmlformats.org/drawingml/2006/main">
           <a:graphicData uri="http://schemas.openxmlformats.org/drawingml/2006/chart">
-            <c:chart xmlns:r="http://schemas.openxmlformats.org/officeDocument/2006/relationships" xmlns:c="http://schemas.openxmlformats.org/drawingml/2006/chart" r:id="R0f5c0d8562b74e4f"/>
+            <c:chart xmlns:r="http://schemas.openxmlformats.org/officeDocument/2006/relationships" xmlns:c="http://schemas.openxmlformats.org/drawingml/2006/chart" r:id="R3b1adfa1d3db432e"/>
           </a:graphicData>
         </a:graphic>
       </p:graphicFrame>
@@ -5869,7 +5983,7 @@
           <p:cNvPr id="5" name="">
             <a:extLst xmlns:a="http://schemas.openxmlformats.org/drawingml/2006/main">
               <a:ext uri="{FF2B5EF4-FFF2-40B4-BE49-F238E27FC236}">
-                <a16:creationId xmlns:a16="http://schemas.microsoft.com/office/drawing/2014/main" id="{A5C1BD23-0419-4E28-AA23-F56B3261C65C}"/>
+                <a16:creationId xmlns:a16="http://schemas.microsoft.com/office/drawing/2014/main" id="{5DDE1148-18E8-4C1E-A2AA-1D9FDF5B38E7}"/>
               </a:ext>
             </a:extLst>
           </p:cNvPr>
@@ -5926,7 +6040,7 @@
           <p:cNvPr id="6" name="">
             <a:extLst xmlns:a="http://schemas.openxmlformats.org/drawingml/2006/main">
               <a:ext uri="{FF2B5EF4-FFF2-40B4-BE49-F238E27FC236}">
-                <a16:creationId xmlns:a16="http://schemas.microsoft.com/office/drawing/2014/main" id="{F02E7FE8-E6FE-41A9-9BCC-1E82B00C974B}"/>
+                <a16:creationId xmlns:a16="http://schemas.microsoft.com/office/drawing/2014/main" id="{EBD46545-BB0A-42C8-9119-2140893BF729}"/>
               </a:ext>
             </a:extLst>
           </p:cNvPr>
@@ -5981,7 +6095,7 @@
     </p:spTree>
     <p:extLst>
       <p:ext uri="{BB962C8B-B14F-4D97-AF65-F5344CB8AC3E}">
-        <p14:creationId xmlns:p14="http://schemas.microsoft.com/office/powerpoint/2010/main" val="665246059"/>
+        <p14:creationId xmlns:p14="http://schemas.microsoft.com/office/powerpoint/2010/main" val="425058091"/>
       </p:ext>
     </p:extLst>
   </p:cSld>
@@ -6012,7 +6126,7 @@
           <p:cNvPr id="12" name="slide-title">
             <a:extLst xmlns:a="http://schemas.openxmlformats.org/drawingml/2006/main">
               <a:ext uri="{FF2B5EF4-FFF2-40B4-BE49-F238E27FC236}">
-                <a16:creationId xmlns:a16="http://schemas.microsoft.com/office/drawing/2014/main" id="{3869A397-58B0-4412-BC32-FE33A4EF0272}"/>
+                <a16:creationId xmlns:a16="http://schemas.microsoft.com/office/drawing/2014/main" id="{257B4F31-A97E-4ED3-AA96-5D42FEEE66EF}"/>
               </a:ext>
             </a:extLst>
           </p:cNvPr>
@@ -6069,7 +6183,7 @@
           <p:cNvPr id="2" name="slide-subtitle">
             <a:extLst xmlns:a="http://schemas.openxmlformats.org/drawingml/2006/main">
               <a:ext uri="{FF2B5EF4-FFF2-40B4-BE49-F238E27FC236}">
-                <a16:creationId xmlns:a16="http://schemas.microsoft.com/office/drawing/2014/main" id="{2C89ABE0-4D46-4A8F-BC45-BEF296E267AE}"/>
+                <a16:creationId xmlns:a16="http://schemas.microsoft.com/office/drawing/2014/main" id="{8B4B576A-4DB3-4CCB-87DC-F791DBCDC844}"/>
               </a:ext>
             </a:extLst>
           </p:cNvPr>
@@ -6126,7 +6240,7 @@
           <p:cNvPr id="3" name="">
             <a:extLst xmlns:a="http://schemas.openxmlformats.org/drawingml/2006/main">
               <a:ext uri="{FF2B5EF4-FFF2-40B4-BE49-F238E27FC236}">
-                <a16:creationId xmlns:a16="http://schemas.microsoft.com/office/drawing/2014/main" id="{8A990744-32C9-43BB-93B5-6CD07D79EAA8}"/>
+                <a16:creationId xmlns:a16="http://schemas.microsoft.com/office/drawing/2014/main" id="{0B25F986-ABFF-46E7-A001-9DD7C9A83C97}"/>
               </a:ext>
             </a:extLst>
           </p:cNvPr>
@@ -6187,7 +6301,7 @@
           <p:cNvPr id="4" name="">
             <a:extLst xmlns:a="http://schemas.openxmlformats.org/drawingml/2006/main">
               <a:ext uri="{FF2B5EF4-FFF2-40B4-BE49-F238E27FC236}">
-                <a16:creationId xmlns:a16="http://schemas.microsoft.com/office/drawing/2014/main" id="{3EA23C9B-C157-40AE-B281-D3F40771D99F}"/>
+                <a16:creationId xmlns:a16="http://schemas.microsoft.com/office/drawing/2014/main" id="{6B15676E-2D83-4704-80AA-07ADBA2401AE}"/>
               </a:ext>
             </a:extLst>
           </p:cNvPr>
@@ -6218,7 +6332,7 @@
           <p:cNvPr id="5" name="">
             <a:extLst xmlns:a="http://schemas.openxmlformats.org/drawingml/2006/main">
               <a:ext uri="{FF2B5EF4-FFF2-40B4-BE49-F238E27FC236}">
-                <a16:creationId xmlns:a16="http://schemas.microsoft.com/office/drawing/2014/main" id="{928DDD29-1DFB-448F-A854-D9EDBE3FE834}"/>
+                <a16:creationId xmlns:a16="http://schemas.microsoft.com/office/drawing/2014/main" id="{D47C89F0-8600-4575-8D85-76B473C5C95D}"/>
               </a:ext>
             </a:extLst>
           </p:cNvPr>
@@ -6275,7 +6389,7 @@
           <p:cNvPr id="6" name="">
             <a:extLst xmlns:a="http://schemas.openxmlformats.org/drawingml/2006/main">
               <a:ext uri="{FF2B5EF4-FFF2-40B4-BE49-F238E27FC236}">
-                <a16:creationId xmlns:a16="http://schemas.microsoft.com/office/drawing/2014/main" id="{69FAA15B-8BCC-414D-805B-3B5A52199678}"/>
+                <a16:creationId xmlns:a16="http://schemas.microsoft.com/office/drawing/2014/main" id="{42FAD62B-7519-4B38-9A06-6220FA79C9A4}"/>
               </a:ext>
             </a:extLst>
           </p:cNvPr>
@@ -6332,7 +6446,7 @@
           <p:cNvPr id="7" name="">
             <a:extLst xmlns:a="http://schemas.openxmlformats.org/drawingml/2006/main">
               <a:ext uri="{FF2B5EF4-FFF2-40B4-BE49-F238E27FC236}">
-                <a16:creationId xmlns:a16="http://schemas.microsoft.com/office/drawing/2014/main" id="{31078EBD-6E9B-499E-BA57-780F0655FE47}"/>
+                <a16:creationId xmlns:a16="http://schemas.microsoft.com/office/drawing/2014/main" id="{6E42AD07-999F-418E-A65A-4DC457CED35E}"/>
               </a:ext>
             </a:extLst>
           </p:cNvPr>
@@ -6396,7 +6510,7 @@
         </p:xfrm>
         <a:graphic xmlns:a="http://schemas.openxmlformats.org/drawingml/2006/main">
           <a:graphicData uri="http://schemas.openxmlformats.org/drawingml/2006/chart">
-            <c:chart xmlns:r="http://schemas.openxmlformats.org/officeDocument/2006/relationships" xmlns:c="http://schemas.openxmlformats.org/drawingml/2006/chart" r:id="R4586caa7cb99409e"/>
+            <c:chart xmlns:r="http://schemas.openxmlformats.org/officeDocument/2006/relationships" xmlns:c="http://schemas.openxmlformats.org/drawingml/2006/chart" r:id="Redf4769112e54f92"/>
           </a:graphicData>
         </a:graphic>
       </p:graphicFrame>
@@ -6405,7 +6519,7 @@
           <p:cNvPr id="9" name="">
             <a:extLst xmlns:a="http://schemas.openxmlformats.org/drawingml/2006/main">
               <a:ext uri="{FF2B5EF4-FFF2-40B4-BE49-F238E27FC236}">
-                <a16:creationId xmlns:a16="http://schemas.microsoft.com/office/drawing/2014/main" id="{F0D41F9A-01B7-4DEE-A1EE-8E2B1803C6EF}"/>
+                <a16:creationId xmlns:a16="http://schemas.microsoft.com/office/drawing/2014/main" id="{A704D29B-B62F-4B16-BBA4-E527945F58F1}"/>
               </a:ext>
             </a:extLst>
           </p:cNvPr>
@@ -6462,7 +6576,7 @@
           <p:cNvPr id="10" name="">
             <a:extLst xmlns:a="http://schemas.openxmlformats.org/drawingml/2006/main">
               <a:ext uri="{FF2B5EF4-FFF2-40B4-BE49-F238E27FC236}">
-                <a16:creationId xmlns:a16="http://schemas.microsoft.com/office/drawing/2014/main" id="{CDC2277B-6899-4D3D-B019-A4C73AE18D80}"/>
+                <a16:creationId xmlns:a16="http://schemas.microsoft.com/office/drawing/2014/main" id="{618DD82F-4F89-4511-8D2C-827E907A7EFC}"/>
               </a:ext>
             </a:extLst>
           </p:cNvPr>
@@ -6519,7 +6633,7 @@
           <p:cNvPr id="11" name="">
             <a:extLst xmlns:a="http://schemas.openxmlformats.org/drawingml/2006/main">
               <a:ext uri="{FF2B5EF4-FFF2-40B4-BE49-F238E27FC236}">
-                <a16:creationId xmlns:a16="http://schemas.microsoft.com/office/drawing/2014/main" id="{DF69BA7A-F92C-44BF-A0D8-2FFBA634BBD7}"/>
+                <a16:creationId xmlns:a16="http://schemas.microsoft.com/office/drawing/2014/main" id="{4BE76B02-918C-40C2-A694-DA988C87AA47}"/>
               </a:ext>
             </a:extLst>
           </p:cNvPr>
@@ -6574,7 +6688,7 @@
     </p:spTree>
     <p:extLst>
       <p:ext uri="{BB962C8B-B14F-4D97-AF65-F5344CB8AC3E}">
-        <p14:creationId xmlns:p14="http://schemas.microsoft.com/office/powerpoint/2010/main" val="1869118811"/>
+        <p14:creationId xmlns:p14="http://schemas.microsoft.com/office/powerpoint/2010/main" val="1184862491"/>
       </p:ext>
     </p:extLst>
   </p:cSld>
@@ -6605,7 +6719,7 @@
           <p:cNvPr id="10" name="slide-title">
             <a:extLst xmlns:a="http://schemas.openxmlformats.org/drawingml/2006/main">
               <a:ext uri="{FF2B5EF4-FFF2-40B4-BE49-F238E27FC236}">
-                <a16:creationId xmlns:a16="http://schemas.microsoft.com/office/drawing/2014/main" id="{168EF986-60A5-491B-8E75-4A64CC8EF68B}"/>
+                <a16:creationId xmlns:a16="http://schemas.microsoft.com/office/drawing/2014/main" id="{529A7410-2AC4-4837-BEC6-410552849462}"/>
               </a:ext>
             </a:extLst>
           </p:cNvPr>
@@ -6662,7 +6776,7 @@
           <p:cNvPr id="2" name="slide-subtitle">
             <a:extLst xmlns:a="http://schemas.openxmlformats.org/drawingml/2006/main">
               <a:ext uri="{FF2B5EF4-FFF2-40B4-BE49-F238E27FC236}">
-                <a16:creationId xmlns:a16="http://schemas.microsoft.com/office/drawing/2014/main" id="{9B2E87B2-4F96-4B49-BD5C-2F621D4F4387}"/>
+                <a16:creationId xmlns:a16="http://schemas.microsoft.com/office/drawing/2014/main" id="{9DE74ECF-9DE4-4026-BC98-216AD66A331E}"/>
               </a:ext>
             </a:extLst>
           </p:cNvPr>
@@ -6719,7 +6833,7 @@
           <p:cNvPr id="3" name="">
             <a:extLst xmlns:a="http://schemas.openxmlformats.org/drawingml/2006/main">
               <a:ext uri="{FF2B5EF4-FFF2-40B4-BE49-F238E27FC236}">
-                <a16:creationId xmlns:a16="http://schemas.microsoft.com/office/drawing/2014/main" id="{C86FEC1D-1378-4471-842A-4AE381589CFB}"/>
+                <a16:creationId xmlns:a16="http://schemas.microsoft.com/office/drawing/2014/main" id="{632B875B-A5C7-4741-811C-90192BBDC8CB}"/>
               </a:ext>
             </a:extLst>
           </p:cNvPr>
@@ -6780,7 +6894,7 @@
           <p:cNvPr id="4" name="">
             <a:extLst xmlns:a="http://schemas.openxmlformats.org/drawingml/2006/main">
               <a:ext uri="{FF2B5EF4-FFF2-40B4-BE49-F238E27FC236}">
-                <a16:creationId xmlns:a16="http://schemas.microsoft.com/office/drawing/2014/main" id="{7B7132BE-8B52-4E37-84E9-D9C3FFE0CB64}"/>
+                <a16:creationId xmlns:a16="http://schemas.microsoft.com/office/drawing/2014/main" id="{0877D003-2483-4987-B519-D5DB4EF5DFD1}"/>
               </a:ext>
             </a:extLst>
           </p:cNvPr>
@@ -6811,7 +6925,7 @@
           <p:cNvPr id="5" name="">
             <a:extLst xmlns:a="http://schemas.openxmlformats.org/drawingml/2006/main">
               <a:ext uri="{FF2B5EF4-FFF2-40B4-BE49-F238E27FC236}">
-                <a16:creationId xmlns:a16="http://schemas.microsoft.com/office/drawing/2014/main" id="{507CC4AD-9CE1-4894-9977-112FAFA31CEE}"/>
+                <a16:creationId xmlns:a16="http://schemas.microsoft.com/office/drawing/2014/main" id="{4E1A1B4C-B378-4553-91A9-365CD9FD715A}"/>
               </a:ext>
             </a:extLst>
           </p:cNvPr>
@@ -6868,7 +6982,7 @@
           <p:cNvPr id="6" name="">
             <a:extLst xmlns:a="http://schemas.openxmlformats.org/drawingml/2006/main">
               <a:ext uri="{FF2B5EF4-FFF2-40B4-BE49-F238E27FC236}">
-                <a16:creationId xmlns:a16="http://schemas.microsoft.com/office/drawing/2014/main" id="{0CFAA9FB-B113-430A-8868-E613E7CBCCD1}"/>
+                <a16:creationId xmlns:a16="http://schemas.microsoft.com/office/drawing/2014/main" id="{A3C9B203-C4A7-44E8-81D8-758594F0290D}"/>
               </a:ext>
             </a:extLst>
           </p:cNvPr>
@@ -7341,7 +7455,7 @@
           <p:cNvPr id="8" name="">
             <a:extLst xmlns:a="http://schemas.openxmlformats.org/drawingml/2006/main">
               <a:ext uri="{FF2B5EF4-FFF2-40B4-BE49-F238E27FC236}">
-                <a16:creationId xmlns:a16="http://schemas.microsoft.com/office/drawing/2014/main" id="{EE266924-6B79-4CEC-8E03-62A824837DC3}"/>
+                <a16:creationId xmlns:a16="http://schemas.microsoft.com/office/drawing/2014/main" id="{07591309-4742-4C5F-B439-574ECADCDFE4}"/>
               </a:ext>
             </a:extLst>
           </p:cNvPr>
@@ -7398,7 +7512,7 @@
           <p:cNvPr id="9" name="">
             <a:extLst xmlns:a="http://schemas.openxmlformats.org/drawingml/2006/main">
               <a:ext uri="{FF2B5EF4-FFF2-40B4-BE49-F238E27FC236}">
-                <a16:creationId xmlns:a16="http://schemas.microsoft.com/office/drawing/2014/main" id="{D870DEB4-4674-4DB2-953D-0EF9B1A4A788}"/>
+                <a16:creationId xmlns:a16="http://schemas.microsoft.com/office/drawing/2014/main" id="{DC36197E-179D-422D-9400-7B940F558661}"/>
               </a:ext>
             </a:extLst>
           </p:cNvPr>
@@ -7453,7 +7567,7 @@
     </p:spTree>
     <p:extLst>
       <p:ext uri="{BB962C8B-B14F-4D97-AF65-F5344CB8AC3E}">
-        <p14:creationId xmlns:p14="http://schemas.microsoft.com/office/powerpoint/2010/main" val="1753124928"/>
+        <p14:creationId xmlns:p14="http://schemas.microsoft.com/office/powerpoint/2010/main" val="1824626533"/>
       </p:ext>
     </p:extLst>
   </p:cSld>
@@ -7484,7 +7598,7 @@
           <p:cNvPr id="8" name="slide-title">
             <a:extLst xmlns:a="http://schemas.openxmlformats.org/drawingml/2006/main">
               <a:ext uri="{FF2B5EF4-FFF2-40B4-BE49-F238E27FC236}">
-                <a16:creationId xmlns:a16="http://schemas.microsoft.com/office/drawing/2014/main" id="{1111C9C7-9477-4B0A-92BB-D919AC9D3B5D}"/>
+                <a16:creationId xmlns:a16="http://schemas.microsoft.com/office/drawing/2014/main" id="{1D0B1235-B404-48EC-8169-A71F8E09165C}"/>
               </a:ext>
             </a:extLst>
           </p:cNvPr>
@@ -7541,7 +7655,7 @@
           <p:cNvPr id="2" name="slide-subtitle">
             <a:extLst xmlns:a="http://schemas.openxmlformats.org/drawingml/2006/main">
               <a:ext uri="{FF2B5EF4-FFF2-40B4-BE49-F238E27FC236}">
-                <a16:creationId xmlns:a16="http://schemas.microsoft.com/office/drawing/2014/main" id="{49B1364C-F982-4537-ACFC-B75EC34DAB00}"/>
+                <a16:creationId xmlns:a16="http://schemas.microsoft.com/office/drawing/2014/main" id="{C2F3482D-930B-4CE2-81EB-07C98C4B17A1}"/>
               </a:ext>
             </a:extLst>
           </p:cNvPr>
@@ -7598,7 +7712,7 @@
           <p:cNvPr id="3" name="">
             <a:extLst xmlns:a="http://schemas.openxmlformats.org/drawingml/2006/main">
               <a:ext uri="{FF2B5EF4-FFF2-40B4-BE49-F238E27FC236}">
-                <a16:creationId xmlns:a16="http://schemas.microsoft.com/office/drawing/2014/main" id="{9DB898C2-7E73-4A88-B525-35D6EFA85281}"/>
+                <a16:creationId xmlns:a16="http://schemas.microsoft.com/office/drawing/2014/main" id="{9D28AE69-85DE-4D9E-81D6-23914B53A153}"/>
               </a:ext>
             </a:extLst>
           </p:cNvPr>
@@ -7659,7 +7773,7 @@
           <p:cNvPr id="4" name="">
             <a:extLst xmlns:a="http://schemas.openxmlformats.org/drawingml/2006/main">
               <a:ext uri="{FF2B5EF4-FFF2-40B4-BE49-F238E27FC236}">
-                <a16:creationId xmlns:a16="http://schemas.microsoft.com/office/drawing/2014/main" id="{6141F8A4-7823-45B6-9F56-C98A9052520C}"/>
+                <a16:creationId xmlns:a16="http://schemas.microsoft.com/office/drawing/2014/main" id="{B442718B-1D0D-407B-B7EE-DE5EC4C3739F}"/>
               </a:ext>
             </a:extLst>
           </p:cNvPr>
@@ -8083,7 +8197,7 @@
           <p:cNvPr id="6" name="">
             <a:extLst xmlns:a="http://schemas.openxmlformats.org/drawingml/2006/main">
               <a:ext uri="{FF2B5EF4-FFF2-40B4-BE49-F238E27FC236}">
-                <a16:creationId xmlns:a16="http://schemas.microsoft.com/office/drawing/2014/main" id="{12717C60-F55E-4E7E-A92E-442F5E9302B9}"/>
+                <a16:creationId xmlns:a16="http://schemas.microsoft.com/office/drawing/2014/main" id="{78FB07AC-6F17-44B9-AE95-EB73302A8A63}"/>
               </a:ext>
             </a:extLst>
           </p:cNvPr>
@@ -8140,7 +8254,7 @@
           <p:cNvPr id="7" name="">
             <a:extLst xmlns:a="http://schemas.openxmlformats.org/drawingml/2006/main">
               <a:ext uri="{FF2B5EF4-FFF2-40B4-BE49-F238E27FC236}">
-                <a16:creationId xmlns:a16="http://schemas.microsoft.com/office/drawing/2014/main" id="{454B4DEE-DC38-40BD-A2E1-7912B0A549E2}"/>
+                <a16:creationId xmlns:a16="http://schemas.microsoft.com/office/drawing/2014/main" id="{0B7F2157-49E7-4E3C-AC9E-41FFD2397E05}"/>
               </a:ext>
             </a:extLst>
           </p:cNvPr>
@@ -8195,7 +8309,7 @@
     </p:spTree>
     <p:extLst>
       <p:ext uri="{BB962C8B-B14F-4D97-AF65-F5344CB8AC3E}">
-        <p14:creationId xmlns:p14="http://schemas.microsoft.com/office/powerpoint/2010/main" val="1451424418"/>
+        <p14:creationId xmlns:p14="http://schemas.microsoft.com/office/powerpoint/2010/main" val="458260065"/>
       </p:ext>
     </p:extLst>
   </p:cSld>

</xml_diff>

<commit_message>
Harden slide release and clarify comparison evidence
</commit_message>
<xml_diff>
--- a/slides/cei-moral-psychology-results-deck.pptx
+++ b/slides/cei-moral-psychology-results-deck.pptx
@@ -2,20 +2,20 @@
 <file path=ppt/presentation.xml><?xml version="1.0" encoding="utf-8"?>
 <p:presentation xmlns:p="http://schemas.openxmlformats.org/presentationml/2006/main">
   <p:sldMasterIdLst>
-    <p:sldMasterId xmlns:r="http://schemas.openxmlformats.org/officeDocument/2006/relationships" id="2147483648" r:id="R11b9dc11f36e4eb9"/>
+    <p:sldMasterId xmlns:r="http://schemas.openxmlformats.org/officeDocument/2006/relationships" id="2147483648" r:id="Rf9cf5c432cbd451b"/>
   </p:sldMasterIdLst>
   <p:notesMasterIdLst>
-    <p:notesMasterId xmlns:r="http://schemas.openxmlformats.org/officeDocument/2006/relationships" r:id="R80c1f0be74924332"/>
+    <p:notesMasterId xmlns:r="http://schemas.openxmlformats.org/officeDocument/2006/relationships" r:id="R8e5db12ff58f480a"/>
   </p:notesMasterIdLst>
   <p:sldIdLst>
-    <p:sldId xmlns:r="http://schemas.openxmlformats.org/officeDocument/2006/relationships" id="256" r:id="R739d4acd8630410d"/>
-    <p:sldId xmlns:r="http://schemas.openxmlformats.org/officeDocument/2006/relationships" id="257" r:id="Rc576b5af96434409"/>
-    <p:sldId xmlns:r="http://schemas.openxmlformats.org/officeDocument/2006/relationships" id="258" r:id="Rcc5b8af201c547c5"/>
-    <p:sldId xmlns:r="http://schemas.openxmlformats.org/officeDocument/2006/relationships" id="259" r:id="Rb14238e4acf24f02"/>
-    <p:sldId xmlns:r="http://schemas.openxmlformats.org/officeDocument/2006/relationships" id="260" r:id="Rb75aa7a08de64a5b"/>
-    <p:sldId xmlns:r="http://schemas.openxmlformats.org/officeDocument/2006/relationships" id="261" r:id="R55604c4408934a0b"/>
-    <p:sldId xmlns:r="http://schemas.openxmlformats.org/officeDocument/2006/relationships" id="262" r:id="R066fac9192344a60"/>
-    <p:sldId xmlns:r="http://schemas.openxmlformats.org/officeDocument/2006/relationships" id="263" r:id="Ra391a77358844501"/>
+    <p:sldId xmlns:r="http://schemas.openxmlformats.org/officeDocument/2006/relationships" id="256" r:id="R57ecc9c9b3064384"/>
+    <p:sldId xmlns:r="http://schemas.openxmlformats.org/officeDocument/2006/relationships" id="257" r:id="R2b0cc4a35e67476a"/>
+    <p:sldId xmlns:r="http://schemas.openxmlformats.org/officeDocument/2006/relationships" id="258" r:id="Rf2c17c465fd84a51"/>
+    <p:sldId xmlns:r="http://schemas.openxmlformats.org/officeDocument/2006/relationships" id="259" r:id="R3ea47c879adc4f35"/>
+    <p:sldId xmlns:r="http://schemas.openxmlformats.org/officeDocument/2006/relationships" id="260" r:id="Rf4667a02415d42d1"/>
+    <p:sldId xmlns:r="http://schemas.openxmlformats.org/officeDocument/2006/relationships" id="261" r:id="R35bf000902a84c5b"/>
+    <p:sldId xmlns:r="http://schemas.openxmlformats.org/officeDocument/2006/relationships" id="262" r:id="Redfc71dcae534551"/>
+    <p:sldId xmlns:r="http://schemas.openxmlformats.org/officeDocument/2006/relationships" id="263" r:id="R6919750d01ea4456"/>
   </p:sldIdLst>
   <p:sldSz cx="12192000" cy="6858000"/>
   <p:notesSz cx="6858000" cy="9144000"/>
@@ -629,7 +629,7 @@
           <a:lstStyle xmlns:a="http://schemas.openxmlformats.org/drawingml/2006/main"/>
           <a:p xmlns:a="http://schemas.openxmlformats.org/drawingml/2006/main">
             <a:r>
-              <a:t>Source: data/results/task_precision.csv.</a:t>
+              <a:t>Source: evidence/canonical-audit/figures/data/primary_confidence_intervals.csv.</a:t>
             </a:r>
           </a:p>
           <a:p xmlns:a="http://schemas.openxmlformats.org/drawingml/2006/main">
@@ -649,7 +649,12 @@
           </a:p>
           <a:p xmlns:a="http://schemas.openxmlformats.org/drawingml/2006/main">
             <a:r>
-              <a:t>This is not a paired model-difference test. The narrow UniMoral intervals are nominal row-level estimates and do not establish cluster-aware uncertainty or human validity.</a:t>
+              <a:t>This is not a paired model-difference test. The visible cards compare only the two accuracy tasks; they do not rank interval widths across different metrics.</a:t>
+            </a:r>
+          </a:p>
+          <a:p xmlns:a="http://schemas.openxmlformats.org/drawingml/2006/main">
+            <a:r>
+              <a:t>The saved intervals are nominal row-level estimates and do not establish cluster-aware uncertainty or human validity.</a:t>
             </a:r>
           </a:p>
         </p:txBody>
@@ -1157,7 +1162,7 @@
   </p:cSld>
   <p:clrMap bg1="lt1" tx1="dk1" bg2="lt2" tx2="dk2" accent1="accent1" accent2="accent2" accent3="accent3" accent4="accent4" accent5="accent5" accent6="accent6" hlink="hlink" folHlink="folHlink"/>
   <p:sldLayoutIdLst>
-    <p:sldLayoutId xmlns:r="http://schemas.openxmlformats.org/officeDocument/2006/relationships" id="2147483649" r:id="Rb9e84d7c67d7469a"/>
+    <p:sldLayoutId xmlns:r="http://schemas.openxmlformats.org/officeDocument/2006/relationships" id="2147483649" r:id="Rd7b06535ddf248c2"/>
   </p:sldLayoutIdLst>
   <p:txStyles>
     <p:titleStyle>
@@ -1700,386 +1705,6 @@
                 <a:ea typeface="Aptos"/>
                 <a:cs typeface="Aptos"/>
               </a:rPr>
-              <a:t>Median width of saved 95% ranges — wider means less sure</a:t>
-            </a:r>
-          </a:p>
-        </c:rich>
-      </c:tx>
-      <c:txPr>
-        <a:bodyPr xmlns:a="http://schemas.openxmlformats.org/drawingml/2006/main" anchorCtr="1"/>
-        <a:lstStyle xmlns:a="http://schemas.openxmlformats.org/drawingml/2006/main"/>
-        <a:p xmlns:a="http://schemas.openxmlformats.org/drawingml/2006/main">
-          <a:pPr>
-            <a:defRPr>
-              <a:latin typeface="Aptos"/>
-              <a:ea typeface="Aptos"/>
-              <a:cs typeface="Aptos"/>
-            </a:defRPr>
-          </a:pPr>
-        </a:p>
-      </c:txPr>
-    </c:title>
-    <c:plotArea>
-      <c:barChart>
-        <c:barDir val="bar"/>
-        <c:grouping val="clustered"/>
-        <c:varyColors val="0"/>
-        <c:ser>
-          <c:idx val="0"/>
-          <c:order val="0"/>
-          <c:tx>
-            <c:v>Interval width</c:v>
-          </c:tx>
-          <c:spPr>
-            <a:solidFill xmlns:a="http://schemas.openxmlformats.org/drawingml/2006/main">
-              <a:srgbClr val="14856D"/>
-            </a:solidFill>
-          </c:spPr>
-          <c:dPt>
-            <c:idx val="0"/>
-            <c:invertIfNegative val="0"/>
-            <c:spPr>
-              <a:solidFill xmlns:a="http://schemas.openxmlformats.org/drawingml/2006/main">
-                <a:srgbClr val="CF5D4A"/>
-              </a:solidFill>
-              <a:ln xmlns:a="http://schemas.openxmlformats.org/drawingml/2006/main" w="0">
-                <a:noFill/>
-              </a:ln>
-            </c:spPr>
-          </c:dPt>
-          <c:dPt>
-            <c:idx val="1"/>
-            <c:invertIfNegative val="0"/>
-            <c:spPr>
-              <a:solidFill xmlns:a="http://schemas.openxmlformats.org/drawingml/2006/main">
-                <a:srgbClr val="CF5D4A"/>
-              </a:solidFill>
-              <a:ln xmlns:a="http://schemas.openxmlformats.org/drawingml/2006/main" w="0">
-                <a:noFill/>
-              </a:ln>
-            </c:spPr>
-          </c:dPt>
-          <c:dPt>
-            <c:idx val="2"/>
-            <c:invertIfNegative val="0"/>
-            <c:spPr>
-              <a:solidFill xmlns:a="http://schemas.openxmlformats.org/drawingml/2006/main">
-                <a:srgbClr val="D3971E"/>
-              </a:solidFill>
-              <a:ln xmlns:a="http://schemas.openxmlformats.org/drawingml/2006/main" w="0">
-                <a:noFill/>
-              </a:ln>
-            </c:spPr>
-          </c:dPt>
-          <c:dPt>
-            <c:idx val="3"/>
-            <c:invertIfNegative val="0"/>
-            <c:spPr>
-              <a:solidFill xmlns:a="http://schemas.openxmlformats.org/drawingml/2006/main">
-                <a:srgbClr val="D3971E"/>
-              </a:solidFill>
-              <a:ln xmlns:a="http://schemas.openxmlformats.org/drawingml/2006/main" w="0">
-                <a:noFill/>
-              </a:ln>
-            </c:spPr>
-          </c:dPt>
-          <c:dPt>
-            <c:idx val="4"/>
-            <c:invertIfNegative val="0"/>
-            <c:spPr>
-              <a:solidFill xmlns:a="http://schemas.openxmlformats.org/drawingml/2006/main">
-                <a:srgbClr val="14856D"/>
-              </a:solidFill>
-              <a:ln xmlns:a="http://schemas.openxmlformats.org/drawingml/2006/main" w="0">
-                <a:noFill/>
-              </a:ln>
-            </c:spPr>
-          </c:dPt>
-          <c:dPt>
-            <c:idx val="5"/>
-            <c:invertIfNegative val="0"/>
-            <c:spPr>
-              <a:solidFill xmlns:a="http://schemas.openxmlformats.org/drawingml/2006/main">
-                <a:srgbClr val="14856D"/>
-              </a:solidFill>
-              <a:ln xmlns:a="http://schemas.openxmlformats.org/drawingml/2006/main" w="0">
-                <a:noFill/>
-              </a:ln>
-            </c:spPr>
-          </c:dPt>
-          <c:dPt>
-            <c:idx val="6"/>
-            <c:invertIfNegative val="0"/>
-            <c:spPr>
-              <a:solidFill xmlns:a="http://schemas.openxmlformats.org/drawingml/2006/main">
-                <a:srgbClr val="14856D"/>
-              </a:solidFill>
-              <a:ln xmlns:a="http://schemas.openxmlformats.org/drawingml/2006/main" w="0">
-                <a:noFill/>
-              </a:ln>
-            </c:spPr>
-          </c:dPt>
-          <c:dPt>
-            <c:idx val="7"/>
-            <c:invertIfNegative val="0"/>
-            <c:spPr>
-              <a:solidFill xmlns:a="http://schemas.openxmlformats.org/drawingml/2006/main">
-                <a:srgbClr val="14856D"/>
-              </a:solidFill>
-              <a:ln xmlns:a="http://schemas.openxmlformats.org/drawingml/2006/main" w="0">
-                <a:noFill/>
-              </a:ln>
-            </c:spPr>
-          </c:dPt>
-          <c:cat>
-            <c:strRef>
-              <c:f>'Chart Data'!$A$2:$A$9</c:f>
-              <c:strCache>
-                <c:ptCount val="8"/>
-                <c:pt idx="0">
-                  <c:v>MFQ compare</c:v>
-                </c:pt>
-                <c:pt idx="1">
-                  <c:v>Vignette compare</c:v>
-                </c:pt>
-                <c:pt idx="2">
-                  <c:v>MFQ agreement</c:v>
-                </c:pt>
-                <c:pt idx="3">
-                  <c:v>Vignette agreement</c:v>
-                </c:pt>
-                <c:pt idx="4">
-                  <c:v>UniMoral factor</c:v>
-                </c:pt>
-                <c:pt idx="5">
-                  <c:v>UniMoral typology</c:v>
-                </c:pt>
-                <c:pt idx="6">
-                  <c:v>UniMoral action</c:v>
-                </c:pt>
-                <c:pt idx="7">
-                  <c:v>UniMoral consequence</c:v>
-                </c:pt>
-              </c:strCache>
-            </c:strRef>
-          </c:cat>
-          <c:val>
-            <c:numRef>
-              <c:f>'Chart Data'!$B$2:$B$9</c:f>
-              <c:numCache>
-                <c:formatCode>0.000</c:formatCode>
-                <c:ptCount val="8"/>
-                <c:pt idx="0">
-                  <c:v>0.395</c:v>
-                </c:pt>
-                <c:pt idx="1">
-                  <c:v>0.37</c:v>
-                </c:pt>
-                <c:pt idx="2">
-                  <c:v>0.22</c:v>
-                </c:pt>
-                <c:pt idx="3">
-                  <c:v>0.124</c:v>
-                </c:pt>
-                <c:pt idx="4">
-                  <c:v>0.033</c:v>
-                </c:pt>
-                <c:pt idx="5">
-                  <c:v>0.032</c:v>
-                </c:pt>
-                <c:pt idx="6">
-                  <c:v>0.02</c:v>
-                </c:pt>
-                <c:pt idx="7">
-                  <c:v>0.012</c:v>
-                </c:pt>
-              </c:numCache>
-            </c:numRef>
-          </c:val>
-        </c:ser>
-        <c:dLbls>
-          <c:txPr>
-            <a:bodyPr xmlns:a="http://schemas.openxmlformats.org/drawingml/2006/main" anchorCtr="1"/>
-            <a:lstStyle xmlns:a="http://schemas.openxmlformats.org/drawingml/2006/main"/>
-            <a:p xmlns:a="http://schemas.openxmlformats.org/drawingml/2006/main">
-              <a:pPr>
-                <a:defRPr sz="1050" b="1">
-                  <a:solidFill>
-                    <a:srgbClr val="17212B"/>
-                  </a:solidFill>
-                  <a:latin typeface="Aptos"/>
-                  <a:ea typeface="Aptos"/>
-                  <a:cs typeface="Aptos"/>
-                </a:defRPr>
-              </a:pPr>
-            </a:p>
-          </c:txPr>
-          <c:dLblPos val="outEnd"/>
-          <c:showLegendKey val="0"/>
-          <c:showVal val="1"/>
-          <c:showCatName val="0"/>
-          <c:showSerName val="0"/>
-          <c:showPercent val="0"/>
-          <c:showBubbleSize val="0"/>
-          <c:showLeaderLines val="0"/>
-        </c:dLbls>
-        <c:gapWidth val="36"/>
-        <c:axId val="48650112"/>
-        <c:axId val="48672768"/>
-      </c:barChart>
-      <c:catAx>
-        <c:axId val="48650112"/>
-        <c:scaling>
-          <c:orientation val="minMax"/>
-        </c:scaling>
-        <c:delete val="0"/>
-        <c:axPos val="l"/>
-        <c:majorGridlines>
-          <c:spPr>
-            <a:ln xmlns:a="http://schemas.openxmlformats.org/drawingml/2006/main" w="9525">
-              <a:solidFill>
-                <a:srgbClr val="D8D9D5"/>
-              </a:solidFill>
-              <a:prstDash val="solid"/>
-            </a:ln>
-          </c:spPr>
-        </c:majorGridlines>
-        <c:title>
-          <c:tx>
-            <c:rich>
-              <a:bodyPr xmlns:a="http://schemas.openxmlformats.org/drawingml/2006/main"/>
-              <a:lstStyle xmlns:a="http://schemas.openxmlformats.org/drawingml/2006/main"/>
-              <a:p xmlns:a="http://schemas.openxmlformats.org/drawingml/2006/main">
-                <a:r>
-                  <a:rPr>
-                    <a:latin typeface="Aptos"/>
-                    <a:ea typeface="Aptos"/>
-                    <a:cs typeface="Aptos"/>
-                  </a:rPr>
-                  <a:t>Median full width of saved 95% interval</a:t>
-                </a:r>
-              </a:p>
-            </c:rich>
-          </c:tx>
-          <c:overlay val="0"/>
-          <c:txPr>
-            <a:bodyPr xmlns:a="http://schemas.openxmlformats.org/drawingml/2006/main" anchorCtr="1"/>
-            <a:lstStyle xmlns:a="http://schemas.openxmlformats.org/drawingml/2006/main"/>
-            <a:p xmlns:a="http://schemas.openxmlformats.org/drawingml/2006/main">
-              <a:pPr>
-                <a:defRPr>
-                  <a:latin typeface="Aptos"/>
-                  <a:ea typeface="Aptos"/>
-                  <a:cs typeface="Aptos"/>
-                </a:defRPr>
-              </a:pPr>
-            </a:p>
-          </c:txPr>
-        </c:title>
-        <c:numFmt formatCode="0.00"/>
-        <c:majorTickMark val="none"/>
-        <c:minorTickMark val="none"/>
-        <c:spPr>
-          <a:ln xmlns:a="http://schemas.openxmlformats.org/drawingml/2006/main" w="9525">
-            <a:solidFill>
-              <a:srgbClr val="D4D4D4"/>
-            </a:solidFill>
-            <a:prstDash val="solid"/>
-          </a:ln>
-        </c:spPr>
-        <c:txPr>
-          <a:bodyPr xmlns:a="http://schemas.openxmlformats.org/drawingml/2006/main" anchorCtr="1"/>
-          <a:lstStyle xmlns:a="http://schemas.openxmlformats.org/drawingml/2006/main"/>
-          <a:p xmlns:a="http://schemas.openxmlformats.org/drawingml/2006/main">
-            <a:pPr>
-              <a:defRPr sz="975">
-                <a:solidFill>
-                  <a:srgbClr val="66727E"/>
-                </a:solidFill>
-                <a:latin typeface="Aptos"/>
-                <a:ea typeface="Aptos"/>
-                <a:cs typeface="Aptos"/>
-              </a:defRPr>
-            </a:pPr>
-          </a:p>
-        </c:txPr>
-        <c:crossAx val="48672768"/>
-      </c:catAx>
-      <c:valAx>
-        <c:axId val="48672768"/>
-        <c:scaling>
-          <c:orientation val="minMax"/>
-        </c:scaling>
-        <c:delete val="0"/>
-        <c:axPos val="b"/>
-        <c:numFmt formatCode="General"/>
-        <c:majorTickMark val="none"/>
-        <c:minorTickMark val="none"/>
-        <c:spPr>
-          <a:ln xmlns:a="http://schemas.openxmlformats.org/drawingml/2006/main" w="0">
-            <a:noFill/>
-          </a:ln>
-        </c:spPr>
-        <c:txPr>
-          <a:bodyPr xmlns:a="http://schemas.openxmlformats.org/drawingml/2006/main" anchorCtr="1"/>
-          <a:lstStyle xmlns:a="http://schemas.openxmlformats.org/drawingml/2006/main"/>
-          <a:p xmlns:a="http://schemas.openxmlformats.org/drawingml/2006/main">
-            <a:pPr>
-              <a:defRPr sz="1125">
-                <a:solidFill>
-                  <a:srgbClr val="17212B"/>
-                </a:solidFill>
-                <a:latin typeface="Aptos"/>
-                <a:ea typeface="Aptos"/>
-                <a:cs typeface="Aptos"/>
-              </a:defRPr>
-            </a:pPr>
-          </a:p>
-        </c:txPr>
-        <c:crossAx val="48650112"/>
-        <c:crossBetween val="between"/>
-      </c:valAx>
-      <c:spPr>
-        <a:solidFill xmlns:a="http://schemas.openxmlformats.org/drawingml/2006/main">
-          <a:srgbClr val="F7F5EF"/>
-        </a:solidFill>
-        <a:ln xmlns:a="http://schemas.openxmlformats.org/drawingml/2006/main" w="0">
-          <a:noFill/>
-        </a:ln>
-      </c:spPr>
-    </c:plotArea>
-    <c:plotVisOnly val="1"/>
-  </c:chart>
-  <c:spPr>
-    <a:solidFill xmlns:a="http://schemas.openxmlformats.org/drawingml/2006/main">
-      <a:srgbClr val="F7F5EF"/>
-    </a:solidFill>
-    <a:ln xmlns:a="http://schemas.openxmlformats.org/drawingml/2006/main" w="0">
-      <a:noFill/>
-    </a:ln>
-  </c:spPr>
-  <c:externalData r:id="rIdChartSnapshot1">
-    <c:autoUpdate val="0"/>
-  </c:externalData>
-</c:chartSpace>
-</file>
-
-<file path=ppt/slides/charts/chart2.xml><?xml version="1.0" encoding="utf-8"?>
-<c:chartSpace xmlns:c="http://schemas.openxmlformats.org/drawingml/2006/chart" xmlns:r="http://schemas.openxmlformats.org/officeDocument/2006/relationships">
-  <c:lang val="en-US"/>
-  <c:chart>
-    <c:title>
-      <c:tx>
-        <c:rich>
-          <a:bodyPr xmlns:a="http://schemas.openxmlformats.org/drawingml/2006/main"/>
-          <a:lstStyle xmlns:a="http://schemas.openxmlformats.org/drawingml/2006/main"/>
-          <a:p xmlns:a="http://schemas.openxmlformats.org/drawingml/2006/main">
-            <a:r>
-              <a:rPr>
-                <a:latin typeface="Aptos"/>
-                <a:ea typeface="Aptos"/>
-                <a:cs typeface="Aptos"/>
-              </a:rPr>
               <a:t>What happens across three model versions?</a:t>
             </a:r>
           </a:p>
@@ -2354,7 +1979,7 @@
 </c:chartSpace>
 </file>
 
-<file path=ppt/slides/charts/chart3.xml><?xml version="1.0" encoding="utf-8"?>
+<file path=ppt/slides/charts/chart2.xml><?xml version="1.0" encoding="utf-8"?>
 <c:chartSpace xmlns:c="http://schemas.openxmlformats.org/drawingml/2006/chart" xmlns:r="http://schemas.openxmlformats.org/officeDocument/2006/relationships">
   <c:lang val="en-US"/>
   <c:chart>
@@ -2749,7 +2374,7 @@
 </c:chartSpace>
 </file>
 
-<file path=ppt/slides/charts/chart4.xml><?xml version="1.0" encoding="utf-8"?>
+<file path=ppt/slides/charts/chart3.xml><?xml version="1.0" encoding="utf-8"?>
 <c:chartSpace xmlns:c="http://schemas.openxmlformats.org/drawingml/2006/chart" xmlns:r="http://schemas.openxmlformats.org/officeDocument/2006/relationships">
   <c:lang val="en-US"/>
   <c:chart>
@@ -2765,7 +2390,7 @@
                 <a:ea typeface="Aptos"/>
                 <a:cs typeface="Aptos"/>
               </a:rPr>
-              <a:t>Score change from earlier to later version</a:t>
+              <a:t>Accuracy change from earlier to later version</a:t>
             </a:r>
           </a:p>
         </c:rich>
@@ -3133,7 +2758,7 @@
           <p:cNvPr id="7" name="cover-title">
             <a:extLst xmlns:a="http://schemas.openxmlformats.org/drawingml/2006/main">
               <a:ext uri="{FF2B5EF4-FFF2-40B4-BE49-F238E27FC236}">
-                <a16:creationId xmlns:a16="http://schemas.microsoft.com/office/drawing/2014/main" id="{0E3229AB-1BD1-4B7B-8ADE-D93BA95BF379}"/>
+                <a16:creationId xmlns:a16="http://schemas.microsoft.com/office/drawing/2014/main" id="{51A6F185-9CC8-492C-B20F-EE5A49D9853B}"/>
               </a:ext>
             </a:extLst>
           </p:cNvPr>
@@ -3213,7 +2838,7 @@
           <p:cNvPr id="2" name="">
             <a:extLst xmlns:a="http://schemas.openxmlformats.org/drawingml/2006/main">
               <a:ext uri="{FF2B5EF4-FFF2-40B4-BE49-F238E27FC236}">
-                <a16:creationId xmlns:a16="http://schemas.microsoft.com/office/drawing/2014/main" id="{FD7CCB59-4DE3-4244-A176-51D5E16ED15A}"/>
+                <a16:creationId xmlns:a16="http://schemas.microsoft.com/office/drawing/2014/main" id="{FF2A1102-37FA-48B5-BE01-3FC194FC3095}"/>
               </a:ext>
             </a:extLst>
           </p:cNvPr>
@@ -3270,7 +2895,7 @@
           <p:cNvPr id="3" name="">
             <a:extLst xmlns:a="http://schemas.openxmlformats.org/drawingml/2006/main">
               <a:ext uri="{FF2B5EF4-FFF2-40B4-BE49-F238E27FC236}">
-                <a16:creationId xmlns:a16="http://schemas.microsoft.com/office/drawing/2014/main" id="{A8290B8F-7479-455F-9BA6-9CD70EFEAEF0}"/>
+                <a16:creationId xmlns:a16="http://schemas.microsoft.com/office/drawing/2014/main" id="{B774F739-3AD5-434E-8109-566E8472B66A}"/>
               </a:ext>
             </a:extLst>
           </p:cNvPr>
@@ -3327,7 +2952,7 @@
           <p:cNvPr id="4" name="">
             <a:extLst xmlns:a="http://schemas.openxmlformats.org/drawingml/2006/main">
               <a:ext uri="{FF2B5EF4-FFF2-40B4-BE49-F238E27FC236}">
-                <a16:creationId xmlns:a16="http://schemas.microsoft.com/office/drawing/2014/main" id="{DF2D7E97-97AF-4B2E-B69F-1984F2F7C97C}"/>
+                <a16:creationId xmlns:a16="http://schemas.microsoft.com/office/drawing/2014/main" id="{B5B6588A-05E0-4E9A-92F1-300E71A9DCEF}"/>
               </a:ext>
             </a:extLst>
           </p:cNvPr>
@@ -3358,7 +2983,7 @@
           <p:cNvPr id="5" name="">
             <a:extLst xmlns:a="http://schemas.openxmlformats.org/drawingml/2006/main">
               <a:ext uri="{FF2B5EF4-FFF2-40B4-BE49-F238E27FC236}">
-                <a16:creationId xmlns:a16="http://schemas.microsoft.com/office/drawing/2014/main" id="{533E62EB-2220-4AC4-AC93-AC7548045A8D}"/>
+                <a16:creationId xmlns:a16="http://schemas.microsoft.com/office/drawing/2014/main" id="{48F8E464-E400-4EE3-BE39-2F1AB1675E24}"/>
               </a:ext>
             </a:extLst>
           </p:cNvPr>
@@ -3415,7 +3040,7 @@
           <p:cNvPr id="6" name="">
             <a:extLst xmlns:a="http://schemas.openxmlformats.org/drawingml/2006/main">
               <a:ext uri="{FF2B5EF4-FFF2-40B4-BE49-F238E27FC236}">
-                <a16:creationId xmlns:a16="http://schemas.microsoft.com/office/drawing/2014/main" id="{D3639A99-A4DE-4ED1-B712-CAE6E9A5F4A2}"/>
+                <a16:creationId xmlns:a16="http://schemas.microsoft.com/office/drawing/2014/main" id="{92E1A050-B217-4957-9B48-58BF4E6D6FDD}"/>
               </a:ext>
             </a:extLst>
           </p:cNvPr>
@@ -3470,7 +3095,7 @@
     </p:spTree>
     <p:extLst>
       <p:ext uri="{BB962C8B-B14F-4D97-AF65-F5344CB8AC3E}">
-        <p14:creationId xmlns:p14="http://schemas.microsoft.com/office/powerpoint/2010/main" val="1032029879"/>
+        <p14:creationId xmlns:p14="http://schemas.microsoft.com/office/powerpoint/2010/main" val="2039316735"/>
       </p:ext>
     </p:extLst>
   </p:cSld>
@@ -3501,7 +3126,7 @@
           <p:cNvPr id="8" name="slide-title">
             <a:extLst xmlns:a="http://schemas.openxmlformats.org/drawingml/2006/main">
               <a:ext uri="{FF2B5EF4-FFF2-40B4-BE49-F238E27FC236}">
-                <a16:creationId xmlns:a16="http://schemas.microsoft.com/office/drawing/2014/main" id="{1F79086F-5600-4073-912E-E42CB18E4F2B}"/>
+                <a16:creationId xmlns:a16="http://schemas.microsoft.com/office/drawing/2014/main" id="{D3124837-3F22-4673-B549-10372C670444}"/>
               </a:ext>
             </a:extLst>
           </p:cNvPr>
@@ -3558,7 +3183,7 @@
           <p:cNvPr id="2" name="slide-subtitle">
             <a:extLst xmlns:a="http://schemas.openxmlformats.org/drawingml/2006/main">
               <a:ext uri="{FF2B5EF4-FFF2-40B4-BE49-F238E27FC236}">
-                <a16:creationId xmlns:a16="http://schemas.microsoft.com/office/drawing/2014/main" id="{0E650A18-004C-45A0-898C-F0F308FF2386}"/>
+                <a16:creationId xmlns:a16="http://schemas.microsoft.com/office/drawing/2014/main" id="{85AB3CCF-57B6-4B6B-88DD-9CCB5DBFB01C}"/>
               </a:ext>
             </a:extLst>
           </p:cNvPr>
@@ -3615,7 +3240,7 @@
           <p:cNvPr id="3" name="">
             <a:extLst xmlns:a="http://schemas.openxmlformats.org/drawingml/2006/main">
               <a:ext uri="{FF2B5EF4-FFF2-40B4-BE49-F238E27FC236}">
-                <a16:creationId xmlns:a16="http://schemas.microsoft.com/office/drawing/2014/main" id="{E0F1618D-6E31-4572-8020-DADFE93F8FF8}"/>
+                <a16:creationId xmlns:a16="http://schemas.microsoft.com/office/drawing/2014/main" id="{B75264BC-347A-40FB-AF41-C6CF1EE41D69}"/>
               </a:ext>
             </a:extLst>
           </p:cNvPr>
@@ -3676,7 +3301,7 @@
           <p:cNvPr id="4" name="">
             <a:extLst xmlns:a="http://schemas.openxmlformats.org/drawingml/2006/main">
               <a:ext uri="{FF2B5EF4-FFF2-40B4-BE49-F238E27FC236}">
-                <a16:creationId xmlns:a16="http://schemas.microsoft.com/office/drawing/2014/main" id="{AE20C4E7-C792-4A3D-83AE-E188C25F3E17}"/>
+                <a16:creationId xmlns:a16="http://schemas.microsoft.com/office/drawing/2014/main" id="{989E9A8E-C4E1-48A2-8E9E-9688218A42B0}"/>
               </a:ext>
             </a:extLst>
           </p:cNvPr>
@@ -4717,7 +4342,7 @@
           <p:cNvPr id="6" name="">
             <a:extLst xmlns:a="http://schemas.openxmlformats.org/drawingml/2006/main">
               <a:ext uri="{FF2B5EF4-FFF2-40B4-BE49-F238E27FC236}">
-                <a16:creationId xmlns:a16="http://schemas.microsoft.com/office/drawing/2014/main" id="{1F6EE849-AD0B-40B7-9706-7249164C5827}"/>
+                <a16:creationId xmlns:a16="http://schemas.microsoft.com/office/drawing/2014/main" id="{1B07DCC3-9F79-4F01-82E7-7F3EDD3DD07B}"/>
               </a:ext>
             </a:extLst>
           </p:cNvPr>
@@ -4774,7 +4399,7 @@
           <p:cNvPr id="7" name="">
             <a:extLst xmlns:a="http://schemas.openxmlformats.org/drawingml/2006/main">
               <a:ext uri="{FF2B5EF4-FFF2-40B4-BE49-F238E27FC236}">
-                <a16:creationId xmlns:a16="http://schemas.microsoft.com/office/drawing/2014/main" id="{C0DD8B33-CCB1-4105-8F43-71F8023D1C4F}"/>
+                <a16:creationId xmlns:a16="http://schemas.microsoft.com/office/drawing/2014/main" id="{7A9E6B29-E48A-4224-B7DB-6924751A08C0}"/>
               </a:ext>
             </a:extLst>
           </p:cNvPr>
@@ -4829,7 +4454,7 @@
     </p:spTree>
     <p:extLst>
       <p:ext uri="{BB962C8B-B14F-4D97-AF65-F5344CB8AC3E}">
-        <p14:creationId xmlns:p14="http://schemas.microsoft.com/office/powerpoint/2010/main" val="1193849475"/>
+        <p14:creationId xmlns:p14="http://schemas.microsoft.com/office/powerpoint/2010/main" val="973734667"/>
       </p:ext>
     </p:extLst>
   </p:cSld>
@@ -4857,10 +4482,10 @@
       </p:grpSpPr>
       <p:sp>
         <p:nvSpPr>
-          <p:cNvPr id="11" name="slide-title">
+          <p:cNvPr id="21" name="slide-title">
             <a:extLst xmlns:a="http://schemas.openxmlformats.org/drawingml/2006/main">
               <a:ext uri="{FF2B5EF4-FFF2-40B4-BE49-F238E27FC236}">
-                <a16:creationId xmlns:a16="http://schemas.microsoft.com/office/drawing/2014/main" id="{F0D5B4DA-65B4-4B4C-84BC-3D77839014F3}"/>
+                <a16:creationId xmlns:a16="http://schemas.microsoft.com/office/drawing/2014/main" id="{8EF16273-9E53-4238-91E7-A693AC6D15A6}"/>
               </a:ext>
             </a:extLst>
           </p:cNvPr>
@@ -4884,7 +4509,7 @@
         </p:spPr>
         <p:txBody>
           <a:bodyPr xmlns:a="http://schemas.openxmlformats.org/drawingml/2006/main">
-            <a:normAutofit fontScale="85462"/>
+            <a:normAutofit fontScale="92707"/>
           </a:bodyPr>
           <a:lstStyle xmlns:a="http://schemas.openxmlformats.org/drawingml/2006/main"/>
           <a:p xmlns:a="http://schemas.openxmlformats.org/drawingml/2006/main">
@@ -4907,7 +4532,7 @@
                 <a:ea typeface="Aptos"/>
                 <a:cs typeface="Aptos"/>
               </a:rPr>
-              <a:t>Every model pair has overlapping score ranges on both tests</a:t>
+              <a:t>Saved ranges overlap for every model pair on both tests</a:t>
             </a:r>
           </a:p>
         </p:txBody>
@@ -4917,7 +4542,7 @@
           <p:cNvPr id="2" name="slide-subtitle">
             <a:extLst xmlns:a="http://schemas.openxmlformats.org/drawingml/2006/main">
               <a:ext uri="{FF2B5EF4-FFF2-40B4-BE49-F238E27FC236}">
-                <a16:creationId xmlns:a16="http://schemas.microsoft.com/office/drawing/2014/main" id="{043A3F8D-2BAA-4C5E-BA9A-7CBB0D51A24C}"/>
+                <a16:creationId xmlns:a16="http://schemas.microsoft.com/office/drawing/2014/main" id="{D337D4ED-D378-4998-83D6-90C62D087F1B}"/>
               </a:ext>
             </a:extLst>
           </p:cNvPr>
@@ -4974,7 +4599,7 @@
           <p:cNvPr id="3" name="">
             <a:extLst xmlns:a="http://schemas.openxmlformats.org/drawingml/2006/main">
               <a:ext uri="{FF2B5EF4-FFF2-40B4-BE49-F238E27FC236}">
-                <a16:creationId xmlns:a16="http://schemas.microsoft.com/office/drawing/2014/main" id="{E67F9D4A-3C06-4148-974E-088A412F5D67}"/>
+                <a16:creationId xmlns:a16="http://schemas.microsoft.com/office/drawing/2014/main" id="{A5898259-B746-41C4-AD46-0A8F3D3C17E8}"/>
               </a:ext>
             </a:extLst>
           </p:cNvPr>
@@ -5035,7 +4660,7 @@
           <p:cNvPr id="4" name="">
             <a:extLst xmlns:a="http://schemas.openxmlformats.org/drawingml/2006/main">
               <a:ext uri="{FF2B5EF4-FFF2-40B4-BE49-F238E27FC236}">
-                <a16:creationId xmlns:a16="http://schemas.microsoft.com/office/drawing/2014/main" id="{5428237C-F603-427D-9392-7D9FC890495B}"/>
+                <a16:creationId xmlns:a16="http://schemas.microsoft.com/office/drawing/2014/main" id="{D1242AFC-D0AB-473D-8F4C-C5C2C8F3144C}"/>
               </a:ext>
             </a:extLst>
           </p:cNvPr>
@@ -5066,7 +4691,7 @@
           <p:cNvPr id="5" name="">
             <a:extLst xmlns:a="http://schemas.openxmlformats.org/drawingml/2006/main">
               <a:ext uri="{FF2B5EF4-FFF2-40B4-BE49-F238E27FC236}">
-                <a16:creationId xmlns:a16="http://schemas.microsoft.com/office/drawing/2014/main" id="{9D4FEAFB-3F74-4B8F-8923-EB6B357B8EA6}"/>
+                <a16:creationId xmlns:a16="http://schemas.microsoft.com/office/drawing/2014/main" id="{DD7E59F9-2A7E-428C-B4A0-10C8E3236BE0}"/>
               </a:ext>
             </a:extLst>
           </p:cNvPr>
@@ -5113,33 +4738,52 @@
                 <a:ea typeface="Aptos"/>
                 <a:cs typeface="Aptos"/>
               </a:rPr>
-              <a:t>Each bar = the median full width of saved 95% intervals across available models.</a:t>
+              <a:t>Each card = share of model pairs whose saved marginal 95% ranges overlap.</a:t>
             </a:r>
           </a:p>
         </p:txBody>
       </p:sp>
-      <p:graphicFrame>
-        <p:nvGraphicFramePr>
-          <p:cNvPr id="16" name="Chart"/>
-          <p:cNvGraphicFramePr/>
+      <p:sp>
+        <p:nvSpPr>
+          <p:cNvPr id="6" name="">
+            <a:extLst xmlns:a="http://schemas.openxmlformats.org/drawingml/2006/main">
+              <a:ext uri="{FF2B5EF4-FFF2-40B4-BE49-F238E27FC236}">
+                <a16:creationId xmlns:a16="http://schemas.microsoft.com/office/drawing/2014/main" id="{2CA8D7A7-36F6-42D1-8423-801C47E42239}"/>
+              </a:ext>
+            </a:extLst>
+          </p:cNvPr>
+          <p:cNvSpPr>
+            <a:spLocks xmlns:a="http://schemas.openxmlformats.org/drawingml/2006/main" noGrp="1"/>
+          </p:cNvSpPr>
           <p:nvPr/>
-        </p:nvGraphicFramePr>
-        <p:xfrm>
-          <a:off xmlns:a="http://schemas.openxmlformats.org/drawingml/2006/main" x="1143000" y="1685925"/>
-          <a:ext xmlns:a="http://schemas.openxmlformats.org/drawingml/2006/main" cx="9810750" cy="3209925"/>
-        </p:xfrm>
-        <a:graphic xmlns:a="http://schemas.openxmlformats.org/drawingml/2006/main">
-          <a:graphicData uri="http://schemas.openxmlformats.org/drawingml/2006/chart">
-            <c:chart xmlns:r="http://schemas.openxmlformats.org/officeDocument/2006/relationships" xmlns:c="http://schemas.openxmlformats.org/drawingml/2006/chart" r:id="Rf884f9d7cd8744e8"/>
-          </a:graphicData>
-        </a:graphic>
-      </p:graphicFrame>
+        </p:nvSpPr>
+        <p:spPr>
+          <a:xfrm xmlns:a="http://schemas.openxmlformats.org/drawingml/2006/main">
+            <a:off x="1143000" y="1781175"/>
+            <a:ext cx="4572000" cy="2238375"/>
+          </a:xfrm>
+          <a:prstGeom xmlns:a="http://schemas.openxmlformats.org/drawingml/2006/main" prst="roundRect">
+            <a:avLst>
+              <a:gd name="adj" fmla="val 7660"/>
+            </a:avLst>
+          </a:prstGeom>
+          <a:solidFill xmlns:a="http://schemas.openxmlformats.org/drawingml/2006/main">
+            <a:srgbClr val="F6E5E0"/>
+          </a:solidFill>
+          <a:ln xmlns:a="http://schemas.openxmlformats.org/drawingml/2006/main" w="19050">
+            <a:solidFill>
+              <a:srgbClr val="CF5D4A"/>
+            </a:solidFill>
+            <a:prstDash val="solid"/>
+          </a:ln>
+        </p:spPr>
+      </p:sp>
       <p:sp>
         <p:nvSpPr>
           <p:cNvPr id="7" name="">
             <a:extLst xmlns:a="http://schemas.openxmlformats.org/drawingml/2006/main">
               <a:ext uri="{FF2B5EF4-FFF2-40B4-BE49-F238E27FC236}">
-                <a16:creationId xmlns:a16="http://schemas.microsoft.com/office/drawing/2014/main" id="{72EFB587-8FF3-45B1-912D-12032C1A895E}"/>
+                <a16:creationId xmlns:a16="http://schemas.microsoft.com/office/drawing/2014/main" id="{993D93EC-2842-4C01-BB69-F4ECDFFDB932}"/>
               </a:ext>
             </a:extLst>
           </p:cNvPr>
@@ -5150,8 +4794,8 @@
         </p:nvSpPr>
         <p:spPr>
           <a:xfrm xmlns:a="http://schemas.openxmlformats.org/drawingml/2006/main">
-            <a:off x="1143000" y="5010150"/>
-            <a:ext cx="9810750" cy="285750"/>
+            <a:off x="1428750" y="2000250"/>
+            <a:ext cx="4000500" cy="323850"/>
           </a:xfrm>
           <a:prstGeom xmlns:a="http://schemas.openxmlformats.org/drawingml/2006/main" prst="rect">
             <a:avLst/>
@@ -5163,14 +4807,14 @@
         </p:spPr>
         <p:txBody>
           <a:bodyPr xmlns:a="http://schemas.openxmlformats.org/drawingml/2006/main">
-            <a:normAutofit fontScale="94444"/>
+            <a:normAutofit fontScale="88406"/>
           </a:bodyPr>
           <a:lstStyle xmlns:a="http://schemas.openxmlformats.org/drawingml/2006/main"/>
           <a:p xmlns:a="http://schemas.openxmlformats.org/drawingml/2006/main">
-            <a:pPr algn="l">
-              <a:defRPr sz="1350" b="1">
-                <a:solidFill>
-                  <a:srgbClr val="CF5D4A"/>
+            <a:pPr algn="ctr">
+              <a:defRPr sz="1725" b="1">
+                <a:solidFill>
+                  <a:srgbClr val="17212B"/>
                 </a:solidFill>
                 <a:latin typeface="Aptos"/>
                 <a:ea typeface="Aptos"/>
@@ -5178,15 +4822,15 @@
               </a:defRPr>
             </a:pPr>
             <a:r>
-              <a:rPr sz="1350" b="1">
-                <a:solidFill>
-                  <a:srgbClr val="CF5D4A"/>
+              <a:rPr sz="1725" b="1">
+                <a:solidFill>
+                  <a:srgbClr val="17212B"/>
                 </a:solidFill>
                 <a:latin typeface="Aptos"/>
                 <a:ea typeface="Aptos"/>
                 <a:cs typeface="Aptos"/>
               </a:rPr>
-              <a:t>Marginal ranges overlap for all 28 MFQ and all 45 Vignette model pairs.</a:t>
+              <a:t>MFQ compare</a:t>
             </a:r>
           </a:p>
         </p:txBody>
@@ -5196,7 +4840,7 @@
           <p:cNvPr id="8" name="">
             <a:extLst xmlns:a="http://schemas.openxmlformats.org/drawingml/2006/main">
               <a:ext uri="{FF2B5EF4-FFF2-40B4-BE49-F238E27FC236}">
-                <a16:creationId xmlns:a16="http://schemas.microsoft.com/office/drawing/2014/main" id="{2E41B546-C0E2-4597-9496-BD32945029E1}"/>
+                <a16:creationId xmlns:a16="http://schemas.microsoft.com/office/drawing/2014/main" id="{8F4E957D-8BA9-49B4-8F7E-CB620A156E5B}"/>
               </a:ext>
             </a:extLst>
           </p:cNvPr>
@@ -5207,7 +4851,555 @@
         </p:nvSpPr>
         <p:spPr>
           <a:xfrm xmlns:a="http://schemas.openxmlformats.org/drawingml/2006/main">
-            <a:off x="1143000" y="5324475"/>
+            <a:off x="1428750" y="2381250"/>
+            <a:ext cx="4000500" cy="723900"/>
+          </a:xfrm>
+          <a:prstGeom xmlns:a="http://schemas.openxmlformats.org/drawingml/2006/main" prst="rect">
+            <a:avLst/>
+          </a:prstGeom>
+          <a:noFill xmlns:a="http://schemas.openxmlformats.org/drawingml/2006/main"/>
+          <a:ln xmlns:a="http://schemas.openxmlformats.org/drawingml/2006/main" w="0">
+            <a:noFill/>
+          </a:ln>
+        </p:spPr>
+        <p:txBody>
+          <a:bodyPr xmlns:a="http://schemas.openxmlformats.org/drawingml/2006/main">
+            <a:normAutofit fontScale="100000"/>
+          </a:bodyPr>
+          <a:lstStyle xmlns:a="http://schemas.openxmlformats.org/drawingml/2006/main"/>
+          <a:p xmlns:a="http://schemas.openxmlformats.org/drawingml/2006/main">
+            <a:pPr algn="ctr">
+              <a:defRPr sz="4050" b="1">
+                <a:solidFill>
+                  <a:srgbClr val="CF5D4A"/>
+                </a:solidFill>
+                <a:latin typeface="Aptos"/>
+                <a:ea typeface="Aptos"/>
+                <a:cs typeface="Aptos"/>
+              </a:defRPr>
+            </a:pPr>
+            <a:r>
+              <a:rPr sz="4050" b="1">
+                <a:solidFill>
+                  <a:srgbClr val="CF5D4A"/>
+                </a:solidFill>
+                <a:latin typeface="Aptos"/>
+                <a:ea typeface="Aptos"/>
+                <a:cs typeface="Aptos"/>
+              </a:rPr>
+              <a:t>100%</a:t>
+            </a:r>
+          </a:p>
+        </p:txBody>
+      </p:sp>
+      <p:sp>
+        <p:nvSpPr>
+          <p:cNvPr id="9" name="">
+            <a:extLst xmlns:a="http://schemas.openxmlformats.org/drawingml/2006/main">
+              <a:ext uri="{FF2B5EF4-FFF2-40B4-BE49-F238E27FC236}">
+                <a16:creationId xmlns:a16="http://schemas.microsoft.com/office/drawing/2014/main" id="{ED381BAB-DEE1-4D6B-A41B-40C7775AE75F}"/>
+              </a:ext>
+            </a:extLst>
+          </p:cNvPr>
+          <p:cNvSpPr>
+            <a:spLocks xmlns:a="http://schemas.openxmlformats.org/drawingml/2006/main" noGrp="1"/>
+          </p:cNvSpPr>
+          <p:nvPr/>
+        </p:nvSpPr>
+        <p:spPr>
+          <a:xfrm xmlns:a="http://schemas.openxmlformats.org/drawingml/2006/main">
+            <a:off x="1428750" y="3143250"/>
+            <a:ext cx="4000500" cy="304800"/>
+          </a:xfrm>
+          <a:prstGeom xmlns:a="http://schemas.openxmlformats.org/drawingml/2006/main" prst="rect">
+            <a:avLst/>
+          </a:prstGeom>
+          <a:noFill xmlns:a="http://schemas.openxmlformats.org/drawingml/2006/main"/>
+          <a:ln xmlns:a="http://schemas.openxmlformats.org/drawingml/2006/main" w="0">
+            <a:noFill/>
+          </a:ln>
+        </p:spPr>
+        <p:txBody>
+          <a:bodyPr xmlns:a="http://schemas.openxmlformats.org/drawingml/2006/main">
+            <a:normAutofit fontScale="98246"/>
+          </a:bodyPr>
+          <a:lstStyle xmlns:a="http://schemas.openxmlformats.org/drawingml/2006/main"/>
+          <a:p xmlns:a="http://schemas.openxmlformats.org/drawingml/2006/main">
+            <a:pPr algn="ctr">
+              <a:defRPr sz="1425" b="1">
+                <a:solidFill>
+                  <a:srgbClr val="17212B"/>
+                </a:solidFill>
+                <a:latin typeface="Aptos"/>
+                <a:ea typeface="Aptos"/>
+                <a:cs typeface="Aptos"/>
+              </a:defRPr>
+            </a:pPr>
+            <a:r>
+              <a:rPr sz="1425" b="1">
+                <a:solidFill>
+                  <a:srgbClr val="17212B"/>
+                </a:solidFill>
+                <a:latin typeface="Aptos"/>
+                <a:ea typeface="Aptos"/>
+                <a:cs typeface="Aptos"/>
+              </a:rPr>
+              <a:t>28 of 28 model pairs</a:t>
+            </a:r>
+          </a:p>
+        </p:txBody>
+      </p:sp>
+      <p:sp>
+        <p:nvSpPr>
+          <p:cNvPr id="10" name="">
+            <a:extLst xmlns:a="http://schemas.openxmlformats.org/drawingml/2006/main">
+              <a:ext uri="{FF2B5EF4-FFF2-40B4-BE49-F238E27FC236}">
+                <a16:creationId xmlns:a16="http://schemas.microsoft.com/office/drawing/2014/main" id="{DE3203E7-91D9-4FCA-AB93-3DC959BED55A}"/>
+              </a:ext>
+            </a:extLst>
+          </p:cNvPr>
+          <p:cNvSpPr>
+            <a:spLocks xmlns:a="http://schemas.openxmlformats.org/drawingml/2006/main" noGrp="1"/>
+          </p:cNvSpPr>
+          <p:nvPr/>
+        </p:nvSpPr>
+        <p:spPr>
+          <a:xfrm xmlns:a="http://schemas.openxmlformats.org/drawingml/2006/main">
+            <a:off x="1428750" y="3505200"/>
+            <a:ext cx="4000500" cy="247650"/>
+          </a:xfrm>
+          <a:prstGeom xmlns:a="http://schemas.openxmlformats.org/drawingml/2006/main" prst="rect">
+            <a:avLst/>
+          </a:prstGeom>
+          <a:noFill xmlns:a="http://schemas.openxmlformats.org/drawingml/2006/main"/>
+          <a:ln xmlns:a="http://schemas.openxmlformats.org/drawingml/2006/main" w="0">
+            <a:noFill/>
+          </a:ln>
+        </p:spPr>
+        <p:txBody>
+          <a:bodyPr xmlns:a="http://schemas.openxmlformats.org/drawingml/2006/main">
+            <a:normAutofit fontScale="91111"/>
+          </a:bodyPr>
+          <a:lstStyle xmlns:a="http://schemas.openxmlformats.org/drawingml/2006/main"/>
+          <a:p xmlns:a="http://schemas.openxmlformats.org/drawingml/2006/main">
+            <a:pPr algn="ctr">
+              <a:defRPr sz="1125" b="0">
+                <a:solidFill>
+                  <a:srgbClr val="66727E"/>
+                </a:solidFill>
+                <a:latin typeface="Aptos"/>
+                <a:ea typeface="Aptos"/>
+                <a:cs typeface="Aptos"/>
+              </a:defRPr>
+            </a:pPr>
+            <a:r>
+              <a:rPr sz="1125" b="0">
+                <a:solidFill>
+                  <a:srgbClr val="66727E"/>
+                </a:solidFill>
+                <a:latin typeface="Aptos"/>
+                <a:ea typeface="Aptos"/>
+                <a:cs typeface="Aptos"/>
+              </a:rPr>
+              <a:t>saved marginal ranges overlap</a:t>
+            </a:r>
+          </a:p>
+        </p:txBody>
+      </p:sp>
+      <p:sp>
+        <p:nvSpPr>
+          <p:cNvPr id="11" name="">
+            <a:extLst xmlns:a="http://schemas.openxmlformats.org/drawingml/2006/main">
+              <a:ext uri="{FF2B5EF4-FFF2-40B4-BE49-F238E27FC236}">
+                <a16:creationId xmlns:a16="http://schemas.microsoft.com/office/drawing/2014/main" id="{B672D9A1-5E1D-4E7D-8B94-5FCC3374839E}"/>
+              </a:ext>
+            </a:extLst>
+          </p:cNvPr>
+          <p:cNvSpPr>
+            <a:spLocks xmlns:a="http://schemas.openxmlformats.org/drawingml/2006/main" noGrp="1"/>
+          </p:cNvSpPr>
+          <p:nvPr/>
+        </p:nvSpPr>
+        <p:spPr>
+          <a:xfrm xmlns:a="http://schemas.openxmlformats.org/drawingml/2006/main">
+            <a:off x="6191250" y="1781175"/>
+            <a:ext cx="4572000" cy="2238375"/>
+          </a:xfrm>
+          <a:prstGeom xmlns:a="http://schemas.openxmlformats.org/drawingml/2006/main" prst="roundRect">
+            <a:avLst>
+              <a:gd name="adj" fmla="val 7660"/>
+            </a:avLst>
+          </a:prstGeom>
+          <a:solidFill xmlns:a="http://schemas.openxmlformats.org/drawingml/2006/main">
+            <a:srgbClr val="F6E5E0"/>
+          </a:solidFill>
+          <a:ln xmlns:a="http://schemas.openxmlformats.org/drawingml/2006/main" w="19050">
+            <a:solidFill>
+              <a:srgbClr val="CF5D4A"/>
+            </a:solidFill>
+            <a:prstDash val="solid"/>
+          </a:ln>
+        </p:spPr>
+      </p:sp>
+      <p:sp>
+        <p:nvSpPr>
+          <p:cNvPr id="12" name="">
+            <a:extLst xmlns:a="http://schemas.openxmlformats.org/drawingml/2006/main">
+              <a:ext uri="{FF2B5EF4-FFF2-40B4-BE49-F238E27FC236}">
+                <a16:creationId xmlns:a16="http://schemas.microsoft.com/office/drawing/2014/main" id="{53164EC5-1327-4432-BCD5-31895AE63E9F}"/>
+              </a:ext>
+            </a:extLst>
+          </p:cNvPr>
+          <p:cNvSpPr>
+            <a:spLocks xmlns:a="http://schemas.openxmlformats.org/drawingml/2006/main" noGrp="1"/>
+          </p:cNvSpPr>
+          <p:nvPr/>
+        </p:nvSpPr>
+        <p:spPr>
+          <a:xfrm xmlns:a="http://schemas.openxmlformats.org/drawingml/2006/main">
+            <a:off x="6477000" y="2000250"/>
+            <a:ext cx="4000500" cy="323850"/>
+          </a:xfrm>
+          <a:prstGeom xmlns:a="http://schemas.openxmlformats.org/drawingml/2006/main" prst="rect">
+            <a:avLst/>
+          </a:prstGeom>
+          <a:noFill xmlns:a="http://schemas.openxmlformats.org/drawingml/2006/main"/>
+          <a:ln xmlns:a="http://schemas.openxmlformats.org/drawingml/2006/main" w="0">
+            <a:noFill/>
+          </a:ln>
+        </p:spPr>
+        <p:txBody>
+          <a:bodyPr xmlns:a="http://schemas.openxmlformats.org/drawingml/2006/main">
+            <a:normAutofit fontScale="88406"/>
+          </a:bodyPr>
+          <a:lstStyle xmlns:a="http://schemas.openxmlformats.org/drawingml/2006/main"/>
+          <a:p xmlns:a="http://schemas.openxmlformats.org/drawingml/2006/main">
+            <a:pPr algn="ctr">
+              <a:defRPr sz="1725" b="1">
+                <a:solidFill>
+                  <a:srgbClr val="17212B"/>
+                </a:solidFill>
+                <a:latin typeface="Aptos"/>
+                <a:ea typeface="Aptos"/>
+                <a:cs typeface="Aptos"/>
+              </a:defRPr>
+            </a:pPr>
+            <a:r>
+              <a:rPr sz="1725" b="1">
+                <a:solidFill>
+                  <a:srgbClr val="17212B"/>
+                </a:solidFill>
+                <a:latin typeface="Aptos"/>
+                <a:ea typeface="Aptos"/>
+                <a:cs typeface="Aptos"/>
+              </a:rPr>
+              <a:t>Vignette compare</a:t>
+            </a:r>
+          </a:p>
+        </p:txBody>
+      </p:sp>
+      <p:sp>
+        <p:nvSpPr>
+          <p:cNvPr id="13" name="">
+            <a:extLst xmlns:a="http://schemas.openxmlformats.org/drawingml/2006/main">
+              <a:ext uri="{FF2B5EF4-FFF2-40B4-BE49-F238E27FC236}">
+                <a16:creationId xmlns:a16="http://schemas.microsoft.com/office/drawing/2014/main" id="{4483DEB5-C95E-4648-A67C-9D98C8EC2B65}"/>
+              </a:ext>
+            </a:extLst>
+          </p:cNvPr>
+          <p:cNvSpPr>
+            <a:spLocks xmlns:a="http://schemas.openxmlformats.org/drawingml/2006/main" noGrp="1"/>
+          </p:cNvSpPr>
+          <p:nvPr/>
+        </p:nvSpPr>
+        <p:spPr>
+          <a:xfrm xmlns:a="http://schemas.openxmlformats.org/drawingml/2006/main">
+            <a:off x="6477000" y="2381250"/>
+            <a:ext cx="4000500" cy="723900"/>
+          </a:xfrm>
+          <a:prstGeom xmlns:a="http://schemas.openxmlformats.org/drawingml/2006/main" prst="rect">
+            <a:avLst/>
+          </a:prstGeom>
+          <a:noFill xmlns:a="http://schemas.openxmlformats.org/drawingml/2006/main"/>
+          <a:ln xmlns:a="http://schemas.openxmlformats.org/drawingml/2006/main" w="0">
+            <a:noFill/>
+          </a:ln>
+        </p:spPr>
+        <p:txBody>
+          <a:bodyPr xmlns:a="http://schemas.openxmlformats.org/drawingml/2006/main">
+            <a:normAutofit fontScale="100000"/>
+          </a:bodyPr>
+          <a:lstStyle xmlns:a="http://schemas.openxmlformats.org/drawingml/2006/main"/>
+          <a:p xmlns:a="http://schemas.openxmlformats.org/drawingml/2006/main">
+            <a:pPr algn="ctr">
+              <a:defRPr sz="4050" b="1">
+                <a:solidFill>
+                  <a:srgbClr val="CF5D4A"/>
+                </a:solidFill>
+                <a:latin typeface="Aptos"/>
+                <a:ea typeface="Aptos"/>
+                <a:cs typeface="Aptos"/>
+              </a:defRPr>
+            </a:pPr>
+            <a:r>
+              <a:rPr sz="4050" b="1">
+                <a:solidFill>
+                  <a:srgbClr val="CF5D4A"/>
+                </a:solidFill>
+                <a:latin typeface="Aptos"/>
+                <a:ea typeface="Aptos"/>
+                <a:cs typeface="Aptos"/>
+              </a:rPr>
+              <a:t>100%</a:t>
+            </a:r>
+          </a:p>
+        </p:txBody>
+      </p:sp>
+      <p:sp>
+        <p:nvSpPr>
+          <p:cNvPr id="14" name="">
+            <a:extLst xmlns:a="http://schemas.openxmlformats.org/drawingml/2006/main">
+              <a:ext uri="{FF2B5EF4-FFF2-40B4-BE49-F238E27FC236}">
+                <a16:creationId xmlns:a16="http://schemas.microsoft.com/office/drawing/2014/main" id="{88D765F5-B54E-4C72-9CD3-7EE1C8050B60}"/>
+              </a:ext>
+            </a:extLst>
+          </p:cNvPr>
+          <p:cNvSpPr>
+            <a:spLocks xmlns:a="http://schemas.openxmlformats.org/drawingml/2006/main" noGrp="1"/>
+          </p:cNvSpPr>
+          <p:nvPr/>
+        </p:nvSpPr>
+        <p:spPr>
+          <a:xfrm xmlns:a="http://schemas.openxmlformats.org/drawingml/2006/main">
+            <a:off x="6477000" y="3143250"/>
+            <a:ext cx="4000500" cy="304800"/>
+          </a:xfrm>
+          <a:prstGeom xmlns:a="http://schemas.openxmlformats.org/drawingml/2006/main" prst="rect">
+            <a:avLst/>
+          </a:prstGeom>
+          <a:noFill xmlns:a="http://schemas.openxmlformats.org/drawingml/2006/main"/>
+          <a:ln xmlns:a="http://schemas.openxmlformats.org/drawingml/2006/main" w="0">
+            <a:noFill/>
+          </a:ln>
+        </p:spPr>
+        <p:txBody>
+          <a:bodyPr xmlns:a="http://schemas.openxmlformats.org/drawingml/2006/main">
+            <a:normAutofit fontScale="98246"/>
+          </a:bodyPr>
+          <a:lstStyle xmlns:a="http://schemas.openxmlformats.org/drawingml/2006/main"/>
+          <a:p xmlns:a="http://schemas.openxmlformats.org/drawingml/2006/main">
+            <a:pPr algn="ctr">
+              <a:defRPr sz="1425" b="1">
+                <a:solidFill>
+                  <a:srgbClr val="17212B"/>
+                </a:solidFill>
+                <a:latin typeface="Aptos"/>
+                <a:ea typeface="Aptos"/>
+                <a:cs typeface="Aptos"/>
+              </a:defRPr>
+            </a:pPr>
+            <a:r>
+              <a:rPr sz="1425" b="1">
+                <a:solidFill>
+                  <a:srgbClr val="17212B"/>
+                </a:solidFill>
+                <a:latin typeface="Aptos"/>
+                <a:ea typeface="Aptos"/>
+                <a:cs typeface="Aptos"/>
+              </a:rPr>
+              <a:t>45 of 45 model pairs</a:t>
+            </a:r>
+          </a:p>
+        </p:txBody>
+      </p:sp>
+      <p:sp>
+        <p:nvSpPr>
+          <p:cNvPr id="15" name="">
+            <a:extLst xmlns:a="http://schemas.openxmlformats.org/drawingml/2006/main">
+              <a:ext uri="{FF2B5EF4-FFF2-40B4-BE49-F238E27FC236}">
+                <a16:creationId xmlns:a16="http://schemas.microsoft.com/office/drawing/2014/main" id="{61CA3D7C-40AE-42AF-9B8E-EFD5BF92C7C7}"/>
+              </a:ext>
+            </a:extLst>
+          </p:cNvPr>
+          <p:cNvSpPr>
+            <a:spLocks xmlns:a="http://schemas.openxmlformats.org/drawingml/2006/main" noGrp="1"/>
+          </p:cNvSpPr>
+          <p:nvPr/>
+        </p:nvSpPr>
+        <p:spPr>
+          <a:xfrm xmlns:a="http://schemas.openxmlformats.org/drawingml/2006/main">
+            <a:off x="6477000" y="3505200"/>
+            <a:ext cx="4000500" cy="247650"/>
+          </a:xfrm>
+          <a:prstGeom xmlns:a="http://schemas.openxmlformats.org/drawingml/2006/main" prst="rect">
+            <a:avLst/>
+          </a:prstGeom>
+          <a:noFill xmlns:a="http://schemas.openxmlformats.org/drawingml/2006/main"/>
+          <a:ln xmlns:a="http://schemas.openxmlformats.org/drawingml/2006/main" w="0">
+            <a:noFill/>
+          </a:ln>
+        </p:spPr>
+        <p:txBody>
+          <a:bodyPr xmlns:a="http://schemas.openxmlformats.org/drawingml/2006/main">
+            <a:normAutofit fontScale="91111"/>
+          </a:bodyPr>
+          <a:lstStyle xmlns:a="http://schemas.openxmlformats.org/drawingml/2006/main"/>
+          <a:p xmlns:a="http://schemas.openxmlformats.org/drawingml/2006/main">
+            <a:pPr algn="ctr">
+              <a:defRPr sz="1125" b="0">
+                <a:solidFill>
+                  <a:srgbClr val="66727E"/>
+                </a:solidFill>
+                <a:latin typeface="Aptos"/>
+                <a:ea typeface="Aptos"/>
+                <a:cs typeface="Aptos"/>
+              </a:defRPr>
+            </a:pPr>
+            <a:r>
+              <a:rPr sz="1125" b="0">
+                <a:solidFill>
+                  <a:srgbClr val="66727E"/>
+                </a:solidFill>
+                <a:latin typeface="Aptos"/>
+                <a:ea typeface="Aptos"/>
+                <a:cs typeface="Aptos"/>
+              </a:rPr>
+              <a:t>saved marginal ranges overlap</a:t>
+            </a:r>
+          </a:p>
+        </p:txBody>
+      </p:sp>
+      <p:sp>
+        <p:nvSpPr>
+          <p:cNvPr id="16" name="">
+            <a:extLst xmlns:a="http://schemas.openxmlformats.org/drawingml/2006/main">
+              <a:ext uri="{FF2B5EF4-FFF2-40B4-BE49-F238E27FC236}">
+                <a16:creationId xmlns:a16="http://schemas.microsoft.com/office/drawing/2014/main" id="{CC7CDA9E-D10C-4E90-A244-727867AB5CE2}"/>
+              </a:ext>
+            </a:extLst>
+          </p:cNvPr>
+          <p:cNvSpPr>
+            <a:spLocks xmlns:a="http://schemas.openxmlformats.org/drawingml/2006/main" noGrp="1"/>
+          </p:cNvSpPr>
+          <p:nvPr/>
+        </p:nvSpPr>
+        <p:spPr>
+          <a:xfrm xmlns:a="http://schemas.openxmlformats.org/drawingml/2006/main">
+            <a:off x="1143000" y="4276725"/>
+            <a:ext cx="9810750" cy="304800"/>
+          </a:xfrm>
+          <a:prstGeom xmlns:a="http://schemas.openxmlformats.org/drawingml/2006/main" prst="rect">
+            <a:avLst/>
+          </a:prstGeom>
+          <a:noFill xmlns:a="http://schemas.openxmlformats.org/drawingml/2006/main"/>
+          <a:ln xmlns:a="http://schemas.openxmlformats.org/drawingml/2006/main" w="0">
+            <a:noFill/>
+          </a:ln>
+        </p:spPr>
+        <p:txBody>
+          <a:bodyPr xmlns:a="http://schemas.openxmlformats.org/drawingml/2006/main">
+            <a:normAutofit fontScale="88889"/>
+          </a:bodyPr>
+          <a:lstStyle xmlns:a="http://schemas.openxmlformats.org/drawingml/2006/main"/>
+          <a:p xmlns:a="http://schemas.openxmlformats.org/drawingml/2006/main">
+            <a:pPr algn="l">
+              <a:defRPr sz="1575" b="1">
+                <a:solidFill>
+                  <a:srgbClr val="CF5D4A"/>
+                </a:solidFill>
+                <a:latin typeface="Aptos"/>
+                <a:ea typeface="Aptos"/>
+                <a:cs typeface="Aptos"/>
+              </a:defRPr>
+            </a:pPr>
+            <a:r>
+              <a:rPr sz="1575" b="1">
+                <a:solidFill>
+                  <a:srgbClr val="CF5D4A"/>
+                </a:solidFill>
+                <a:latin typeface="Aptos"/>
+                <a:ea typeface="Aptos"/>
+                <a:cs typeface="Aptos"/>
+              </a:rPr>
+              <a:t>100% of model pairs overlap on both tests. This does not resolve a leader.</a:t>
+            </a:r>
+          </a:p>
+        </p:txBody>
+      </p:sp>
+      <p:sp>
+        <p:nvSpPr>
+          <p:cNvPr id="17" name="">
+            <a:extLst xmlns:a="http://schemas.openxmlformats.org/drawingml/2006/main">
+              <a:ext uri="{FF2B5EF4-FFF2-40B4-BE49-F238E27FC236}">
+                <a16:creationId xmlns:a16="http://schemas.microsoft.com/office/drawing/2014/main" id="{03D39A46-197E-4BEB-94E8-59A0733F1F1D}"/>
+              </a:ext>
+            </a:extLst>
+          </p:cNvPr>
+          <p:cNvSpPr>
+            <a:spLocks xmlns:a="http://schemas.openxmlformats.org/drawingml/2006/main" noGrp="1"/>
+          </p:cNvSpPr>
+          <p:nvPr/>
+        </p:nvSpPr>
+        <p:spPr>
+          <a:xfrm xmlns:a="http://schemas.openxmlformats.org/drawingml/2006/main">
+            <a:off x="1143000" y="4686300"/>
+            <a:ext cx="9810750" cy="247650"/>
+          </a:xfrm>
+          <a:prstGeom xmlns:a="http://schemas.openxmlformats.org/drawingml/2006/main" prst="rect">
+            <a:avLst/>
+          </a:prstGeom>
+          <a:noFill xmlns:a="http://schemas.openxmlformats.org/drawingml/2006/main"/>
+          <a:ln xmlns:a="http://schemas.openxmlformats.org/drawingml/2006/main" w="0">
+            <a:noFill/>
+          </a:ln>
+        </p:spPr>
+        <p:txBody>
+          <a:bodyPr xmlns:a="http://schemas.openxmlformats.org/drawingml/2006/main">
+            <a:normAutofit fontScale="91111"/>
+          </a:bodyPr>
+          <a:lstStyle xmlns:a="http://schemas.openxmlformats.org/drawingml/2006/main"/>
+          <a:p xmlns:a="http://schemas.openxmlformats.org/drawingml/2006/main">
+            <a:pPr algn="l">
+              <a:defRPr sz="1125" b="0">
+                <a:solidFill>
+                  <a:srgbClr val="17212B"/>
+                </a:solidFill>
+                <a:latin typeface="Aptos"/>
+                <a:ea typeface="Aptos"/>
+                <a:cs typeface="Aptos"/>
+              </a:defRPr>
+            </a:pPr>
+            <a:r>
+              <a:rPr sz="1125" b="0">
+                <a:solidFill>
+                  <a:srgbClr val="17212B"/>
+                </a:solidFill>
+                <a:latin typeface="Aptos"/>
+                <a:ea typeface="Aptos"/>
+                <a:cs typeface="Aptos"/>
+              </a:rPr>
+              <a:t>These are marginal ranges, not paired model-difference tests. Question-level results are unavailable.</a:t>
+            </a:r>
+          </a:p>
+        </p:txBody>
+      </p:sp>
+      <p:sp>
+        <p:nvSpPr>
+          <p:cNvPr id="18" name="">
+            <a:extLst xmlns:a="http://schemas.openxmlformats.org/drawingml/2006/main">
+              <a:ext uri="{FF2B5EF4-FFF2-40B4-BE49-F238E27FC236}">
+                <a16:creationId xmlns:a16="http://schemas.microsoft.com/office/drawing/2014/main" id="{5061EDC0-E17E-4A80-9D82-0DC53E1A2C42}"/>
+              </a:ext>
+            </a:extLst>
+          </p:cNvPr>
+          <p:cNvSpPr>
+            <a:spLocks xmlns:a="http://schemas.openxmlformats.org/drawingml/2006/main" noGrp="1"/>
+          </p:cNvSpPr>
+          <p:nvPr/>
+        </p:nvSpPr>
+        <p:spPr>
+          <a:xfrm xmlns:a="http://schemas.openxmlformats.org/drawingml/2006/main">
+            <a:off x="1143000" y="4991100"/>
             <a:ext cx="9810750" cy="228600"/>
           </a:xfrm>
           <a:prstGeom xmlns:a="http://schemas.openxmlformats.org/drawingml/2006/main" prst="rect">
@@ -5220,12 +5412,12 @@
         </p:spPr>
         <p:txBody>
           <a:bodyPr xmlns:a="http://schemas.openxmlformats.org/drawingml/2006/main">
-            <a:normAutofit fontScale="80000"/>
+            <a:normAutofit fontScale="85714"/>
           </a:bodyPr>
           <a:lstStyle xmlns:a="http://schemas.openxmlformats.org/drawingml/2006/main"/>
           <a:p xmlns:a="http://schemas.openxmlformats.org/drawingml/2006/main">
             <a:pPr algn="l">
-              <a:defRPr sz="1125" b="0">
+              <a:defRPr sz="1050" b="0">
                 <a:solidFill>
                   <a:srgbClr val="66727E"/>
                 </a:solidFill>
@@ -5235,7 +5427,7 @@
               </a:defRPr>
             </a:pPr>
             <a:r>
-              <a:rPr sz="1125" b="0">
+              <a:rPr sz="1050" b="0">
                 <a:solidFill>
                   <a:srgbClr val="66727E"/>
                 </a:solidFill>
@@ -5243,17 +5435,17 @@
                 <a:ea typeface="Aptos"/>
                 <a:cs typeface="Aptos"/>
               </a:rPr>
-              <a:t>These ranges look at one model at a time; paired question results are unavailable.</a:t>
+              <a:t>Intervals are nominal; cluster-aware uncertainty is unavailable.</a:t>
             </a:r>
           </a:p>
         </p:txBody>
       </p:sp>
       <p:sp>
         <p:nvSpPr>
-          <p:cNvPr id="9" name="">
+          <p:cNvPr id="19" name="">
             <a:extLst xmlns:a="http://schemas.openxmlformats.org/drawingml/2006/main">
               <a:ext uri="{FF2B5EF4-FFF2-40B4-BE49-F238E27FC236}">
-                <a16:creationId xmlns:a16="http://schemas.microsoft.com/office/drawing/2014/main" id="{A29EC2BC-D2EC-4E18-A068-C6D95053E570}"/>
+                <a16:creationId xmlns:a16="http://schemas.microsoft.com/office/drawing/2014/main" id="{1A6B0A14-D0AB-4045-82D0-1BF0C7CEC022}"/>
               </a:ext>
             </a:extLst>
           </p:cNvPr>
@@ -5264,7 +5456,7 @@
         </p:nvSpPr>
         <p:spPr>
           <a:xfrm xmlns:a="http://schemas.openxmlformats.org/drawingml/2006/main">
-            <a:off x="1143000" y="5638800"/>
+            <a:off x="1143000" y="5524500"/>
             <a:ext cx="9810750" cy="304800"/>
           </a:xfrm>
           <a:prstGeom xmlns:a="http://schemas.openxmlformats.org/drawingml/2006/main" prst="rect">
@@ -5307,10 +5499,10 @@
       </p:sp>
       <p:sp>
         <p:nvSpPr>
-          <p:cNvPr id="10" name="">
+          <p:cNvPr id="20" name="">
             <a:extLst xmlns:a="http://schemas.openxmlformats.org/drawingml/2006/main">
               <a:ext uri="{FF2B5EF4-FFF2-40B4-BE49-F238E27FC236}">
-                <a16:creationId xmlns:a16="http://schemas.microsoft.com/office/drawing/2014/main" id="{9715F10B-3FA7-4AB3-9F18-BE0EF75167E0}"/>
+                <a16:creationId xmlns:a16="http://schemas.microsoft.com/office/drawing/2014/main" id="{0594AE16-D60C-4155-A24C-F072A1E60DA0}"/>
               </a:ext>
             </a:extLst>
           </p:cNvPr>
@@ -5321,7 +5513,7 @@
         </p:nvSpPr>
         <p:spPr>
           <a:xfrm xmlns:a="http://schemas.openxmlformats.org/drawingml/2006/main">
-            <a:off x="1143000" y="5981700"/>
+            <a:off x="1143000" y="5886450"/>
             <a:ext cx="9810750" cy="266700"/>
           </a:xfrm>
           <a:prstGeom xmlns:a="http://schemas.openxmlformats.org/drawingml/2006/main" prst="rect">
@@ -5365,7 +5557,7 @@
     </p:spTree>
     <p:extLst>
       <p:ext uri="{BB962C8B-B14F-4D97-AF65-F5344CB8AC3E}">
-        <p14:creationId xmlns:p14="http://schemas.microsoft.com/office/powerpoint/2010/main" val="1590806344"/>
+        <p14:creationId xmlns:p14="http://schemas.microsoft.com/office/powerpoint/2010/main" val="590019265"/>
       </p:ext>
     </p:extLst>
   </p:cSld>
@@ -5396,7 +5588,7 @@
           <p:cNvPr id="9" name="slide-title">
             <a:extLst xmlns:a="http://schemas.openxmlformats.org/drawingml/2006/main">
               <a:ext uri="{FF2B5EF4-FFF2-40B4-BE49-F238E27FC236}">
-                <a16:creationId xmlns:a16="http://schemas.microsoft.com/office/drawing/2014/main" id="{96C7BED6-114F-4A47-AE17-F4726D07CCC1}"/>
+                <a16:creationId xmlns:a16="http://schemas.microsoft.com/office/drawing/2014/main" id="{BEDA6A99-120F-4FDE-BF7D-1C7CDDFC367A}"/>
               </a:ext>
             </a:extLst>
           </p:cNvPr>
@@ -5453,7 +5645,7 @@
           <p:cNvPr id="2" name="slide-subtitle">
             <a:extLst xmlns:a="http://schemas.openxmlformats.org/drawingml/2006/main">
               <a:ext uri="{FF2B5EF4-FFF2-40B4-BE49-F238E27FC236}">
-                <a16:creationId xmlns:a16="http://schemas.microsoft.com/office/drawing/2014/main" id="{17BC0FEE-5D0E-4401-9A57-3494FE402E4C}"/>
+                <a16:creationId xmlns:a16="http://schemas.microsoft.com/office/drawing/2014/main" id="{43B3336E-E435-40AF-9851-4CD7CEF27AAB}"/>
               </a:ext>
             </a:extLst>
           </p:cNvPr>
@@ -5510,7 +5702,7 @@
           <p:cNvPr id="3" name="">
             <a:extLst xmlns:a="http://schemas.openxmlformats.org/drawingml/2006/main">
               <a:ext uri="{FF2B5EF4-FFF2-40B4-BE49-F238E27FC236}">
-                <a16:creationId xmlns:a16="http://schemas.microsoft.com/office/drawing/2014/main" id="{1ACDDE21-DBEE-49CA-85A6-0D74E5DFCB8B}"/>
+                <a16:creationId xmlns:a16="http://schemas.microsoft.com/office/drawing/2014/main" id="{FBE0FEFE-7EBF-4476-B322-3AC21E32C655}"/>
               </a:ext>
             </a:extLst>
           </p:cNvPr>
@@ -5571,7 +5763,7 @@
           <p:cNvPr id="4" name="">
             <a:extLst xmlns:a="http://schemas.openxmlformats.org/drawingml/2006/main">
               <a:ext uri="{FF2B5EF4-FFF2-40B4-BE49-F238E27FC236}">
-                <a16:creationId xmlns:a16="http://schemas.microsoft.com/office/drawing/2014/main" id="{1EE75887-21A1-4DD9-94CF-259E075EC5D1}"/>
+                <a16:creationId xmlns:a16="http://schemas.microsoft.com/office/drawing/2014/main" id="{B8028C66-C154-41F1-99D9-DF08F6A6D923}"/>
               </a:ext>
             </a:extLst>
           </p:cNvPr>
@@ -5609,7 +5801,7 @@
         </p:xfrm>
         <a:graphic xmlns:a="http://schemas.openxmlformats.org/drawingml/2006/main">
           <a:graphicData uri="http://schemas.openxmlformats.org/drawingml/2006/chart">
-            <c:chart xmlns:r="http://schemas.openxmlformats.org/officeDocument/2006/relationships" xmlns:c="http://schemas.openxmlformats.org/drawingml/2006/chart" r:id="R2aa6bce0eedc4a78"/>
+            <c:chart xmlns:r="http://schemas.openxmlformats.org/officeDocument/2006/relationships" xmlns:c="http://schemas.openxmlformats.org/drawingml/2006/chart" r:id="R11af27ef5a7b4251"/>
           </a:graphicData>
         </a:graphic>
       </p:graphicFrame>
@@ -5618,7 +5810,7 @@
           <p:cNvPr id="6" name="">
             <a:extLst xmlns:a="http://schemas.openxmlformats.org/drawingml/2006/main">
               <a:ext uri="{FF2B5EF4-FFF2-40B4-BE49-F238E27FC236}">
-                <a16:creationId xmlns:a16="http://schemas.microsoft.com/office/drawing/2014/main" id="{F81D1606-7715-4D5D-A3FB-2FC9572C3C58}"/>
+                <a16:creationId xmlns:a16="http://schemas.microsoft.com/office/drawing/2014/main" id="{9FD801AA-6B7F-4F4C-B651-BBB90374F10A}"/>
               </a:ext>
             </a:extLst>
           </p:cNvPr>
@@ -5675,7 +5867,7 @@
           <p:cNvPr id="7" name="">
             <a:extLst xmlns:a="http://schemas.openxmlformats.org/drawingml/2006/main">
               <a:ext uri="{FF2B5EF4-FFF2-40B4-BE49-F238E27FC236}">
-                <a16:creationId xmlns:a16="http://schemas.microsoft.com/office/drawing/2014/main" id="{9955E619-17CA-482B-A4F5-CA49029D1522}"/>
+                <a16:creationId xmlns:a16="http://schemas.microsoft.com/office/drawing/2014/main" id="{83D5D156-7B97-458C-9B65-F49FEEB71ED4}"/>
               </a:ext>
             </a:extLst>
           </p:cNvPr>
@@ -5732,7 +5924,7 @@
           <p:cNvPr id="8" name="">
             <a:extLst xmlns:a="http://schemas.openxmlformats.org/drawingml/2006/main">
               <a:ext uri="{FF2B5EF4-FFF2-40B4-BE49-F238E27FC236}">
-                <a16:creationId xmlns:a16="http://schemas.microsoft.com/office/drawing/2014/main" id="{3D18F694-5776-4C50-A747-195C6766D177}"/>
+                <a16:creationId xmlns:a16="http://schemas.microsoft.com/office/drawing/2014/main" id="{1EEF7116-CCDF-4E7B-A145-C09B6A94261C}"/>
               </a:ext>
             </a:extLst>
           </p:cNvPr>
@@ -5787,7 +5979,7 @@
     </p:spTree>
     <p:extLst>
       <p:ext uri="{BB962C8B-B14F-4D97-AF65-F5344CB8AC3E}">
-        <p14:creationId xmlns:p14="http://schemas.microsoft.com/office/powerpoint/2010/main" val="1377702039"/>
+        <p14:creationId xmlns:p14="http://schemas.microsoft.com/office/powerpoint/2010/main" val="1256336294"/>
       </p:ext>
     </p:extLst>
   </p:cSld>
@@ -5818,7 +6010,7 @@
           <p:cNvPr id="7" name="slide-title">
             <a:extLst xmlns:a="http://schemas.openxmlformats.org/drawingml/2006/main">
               <a:ext uri="{FF2B5EF4-FFF2-40B4-BE49-F238E27FC236}">
-                <a16:creationId xmlns:a16="http://schemas.microsoft.com/office/drawing/2014/main" id="{2376CE92-F826-4400-B1D6-53495439C51E}"/>
+                <a16:creationId xmlns:a16="http://schemas.microsoft.com/office/drawing/2014/main" id="{4067027D-A4DF-443C-978F-35B4A8EF1B52}"/>
               </a:ext>
             </a:extLst>
           </p:cNvPr>
@@ -5875,7 +6067,7 @@
           <p:cNvPr id="2" name="">
             <a:extLst xmlns:a="http://schemas.openxmlformats.org/drawingml/2006/main">
               <a:ext uri="{FF2B5EF4-FFF2-40B4-BE49-F238E27FC236}">
-                <a16:creationId xmlns:a16="http://schemas.microsoft.com/office/drawing/2014/main" id="{6490B9FC-E5CB-4DEB-A5E0-C7EF4DE5326F}"/>
+                <a16:creationId xmlns:a16="http://schemas.microsoft.com/office/drawing/2014/main" id="{082180F6-719E-492B-9B6C-DDD697E67FE6}"/>
               </a:ext>
             </a:extLst>
           </p:cNvPr>
@@ -5936,7 +6128,7 @@
           <p:cNvPr id="3" name="">
             <a:extLst xmlns:a="http://schemas.openxmlformats.org/drawingml/2006/main">
               <a:ext uri="{FF2B5EF4-FFF2-40B4-BE49-F238E27FC236}">
-                <a16:creationId xmlns:a16="http://schemas.microsoft.com/office/drawing/2014/main" id="{A748517A-99BB-4C11-82A2-794325A13A14}"/>
+                <a16:creationId xmlns:a16="http://schemas.microsoft.com/office/drawing/2014/main" id="{816C1B97-D883-4183-AB14-96DABF957347}"/>
               </a:ext>
             </a:extLst>
           </p:cNvPr>
@@ -5974,7 +6166,7 @@
         </p:xfrm>
         <a:graphic xmlns:a="http://schemas.openxmlformats.org/drawingml/2006/main">
           <a:graphicData uri="http://schemas.openxmlformats.org/drawingml/2006/chart">
-            <c:chart xmlns:r="http://schemas.openxmlformats.org/officeDocument/2006/relationships" xmlns:c="http://schemas.openxmlformats.org/drawingml/2006/chart" r:id="R3b1adfa1d3db432e"/>
+            <c:chart xmlns:r="http://schemas.openxmlformats.org/officeDocument/2006/relationships" xmlns:c="http://schemas.openxmlformats.org/drawingml/2006/chart" r:id="R09a9e665b80b4561"/>
           </a:graphicData>
         </a:graphic>
       </p:graphicFrame>
@@ -5983,7 +6175,7 @@
           <p:cNvPr id="5" name="">
             <a:extLst xmlns:a="http://schemas.openxmlformats.org/drawingml/2006/main">
               <a:ext uri="{FF2B5EF4-FFF2-40B4-BE49-F238E27FC236}">
-                <a16:creationId xmlns:a16="http://schemas.microsoft.com/office/drawing/2014/main" id="{5DDE1148-18E8-4C1E-A2AA-1D9FDF5B38E7}"/>
+                <a16:creationId xmlns:a16="http://schemas.microsoft.com/office/drawing/2014/main" id="{5520A0CE-A0B0-45B9-BD23-73180380CFD0}"/>
               </a:ext>
             </a:extLst>
           </p:cNvPr>
@@ -6040,7 +6232,7 @@
           <p:cNvPr id="6" name="">
             <a:extLst xmlns:a="http://schemas.openxmlformats.org/drawingml/2006/main">
               <a:ext uri="{FF2B5EF4-FFF2-40B4-BE49-F238E27FC236}">
-                <a16:creationId xmlns:a16="http://schemas.microsoft.com/office/drawing/2014/main" id="{EBD46545-BB0A-42C8-9119-2140893BF729}"/>
+                <a16:creationId xmlns:a16="http://schemas.microsoft.com/office/drawing/2014/main" id="{F4D46E41-F816-41B1-8DD5-B897384BDD0F}"/>
               </a:ext>
             </a:extLst>
           </p:cNvPr>
@@ -6095,7 +6287,7 @@
     </p:spTree>
     <p:extLst>
       <p:ext uri="{BB962C8B-B14F-4D97-AF65-F5344CB8AC3E}">
-        <p14:creationId xmlns:p14="http://schemas.microsoft.com/office/powerpoint/2010/main" val="425058091"/>
+        <p14:creationId xmlns:p14="http://schemas.microsoft.com/office/powerpoint/2010/main" val="1612931859"/>
       </p:ext>
     </p:extLst>
   </p:cSld>
@@ -6123,10 +6315,10 @@
       </p:grpSpPr>
       <p:sp>
         <p:nvSpPr>
-          <p:cNvPr id="12" name="slide-title">
+          <p:cNvPr id="14" name="slide-title">
             <a:extLst xmlns:a="http://schemas.openxmlformats.org/drawingml/2006/main">
               <a:ext uri="{FF2B5EF4-FFF2-40B4-BE49-F238E27FC236}">
-                <a16:creationId xmlns:a16="http://schemas.microsoft.com/office/drawing/2014/main" id="{257B4F31-A97E-4ED3-AA96-5D42FEEE66EF}"/>
+                <a16:creationId xmlns:a16="http://schemas.microsoft.com/office/drawing/2014/main" id="{F950D8E4-4A41-4B92-90EC-6D068B2479AC}"/>
               </a:ext>
             </a:extLst>
           </p:cNvPr>
@@ -6183,7 +6375,7 @@
           <p:cNvPr id="2" name="slide-subtitle">
             <a:extLst xmlns:a="http://schemas.openxmlformats.org/drawingml/2006/main">
               <a:ext uri="{FF2B5EF4-FFF2-40B4-BE49-F238E27FC236}">
-                <a16:creationId xmlns:a16="http://schemas.microsoft.com/office/drawing/2014/main" id="{8B4B576A-4DB3-4CCB-87DC-F791DBCDC844}"/>
+                <a16:creationId xmlns:a16="http://schemas.microsoft.com/office/drawing/2014/main" id="{7A617DC5-0763-406D-9A55-74EC70035B98}"/>
               </a:ext>
             </a:extLst>
           </p:cNvPr>
@@ -6230,7 +6422,7 @@
                 <a:ea typeface="Aptos"/>
                 <a:cs typeface="Aptos"/>
               </a:rPr>
-              <a:t>Score change on three UniMoral tasks</a:t>
+              <a:t>Accuracy change on three UniMoral tasks; consequence text match stays separate</a:t>
             </a:r>
           </a:p>
         </p:txBody>
@@ -6240,7 +6432,7 @@
           <p:cNvPr id="3" name="">
             <a:extLst xmlns:a="http://schemas.openxmlformats.org/drawingml/2006/main">
               <a:ext uri="{FF2B5EF4-FFF2-40B4-BE49-F238E27FC236}">
-                <a16:creationId xmlns:a16="http://schemas.microsoft.com/office/drawing/2014/main" id="{0B25F986-ABFF-46E7-A001-9DD7C9A83C97}"/>
+                <a16:creationId xmlns:a16="http://schemas.microsoft.com/office/drawing/2014/main" id="{01ACF5C5-C3C1-4274-93CA-717BDFC9D2D1}"/>
               </a:ext>
             </a:extLst>
           </p:cNvPr>
@@ -6301,7 +6493,7 @@
           <p:cNvPr id="4" name="">
             <a:extLst xmlns:a="http://schemas.openxmlformats.org/drawingml/2006/main">
               <a:ext uri="{FF2B5EF4-FFF2-40B4-BE49-F238E27FC236}">
-                <a16:creationId xmlns:a16="http://schemas.microsoft.com/office/drawing/2014/main" id="{6B15676E-2D83-4704-80AA-07ADBA2401AE}"/>
+                <a16:creationId xmlns:a16="http://schemas.microsoft.com/office/drawing/2014/main" id="{29147067-8136-4258-9A7F-608A7CF2CFEC}"/>
               </a:ext>
             </a:extLst>
           </p:cNvPr>
@@ -6332,7 +6524,7 @@
           <p:cNvPr id="5" name="">
             <a:extLst xmlns:a="http://schemas.openxmlformats.org/drawingml/2006/main">
               <a:ext uri="{FF2B5EF4-FFF2-40B4-BE49-F238E27FC236}">
-                <a16:creationId xmlns:a16="http://schemas.microsoft.com/office/drawing/2014/main" id="{D47C89F0-8600-4575-8D85-76B473C5C95D}"/>
+                <a16:creationId xmlns:a16="http://schemas.microsoft.com/office/drawing/2014/main" id="{86C332B5-8F2A-4298-B6B2-04A1D6FA0076}"/>
               </a:ext>
             </a:extLst>
           </p:cNvPr>
@@ -6389,7 +6581,7 @@
           <p:cNvPr id="6" name="">
             <a:extLst xmlns:a="http://schemas.openxmlformats.org/drawingml/2006/main">
               <a:ext uri="{FF2B5EF4-FFF2-40B4-BE49-F238E27FC236}">
-                <a16:creationId xmlns:a16="http://schemas.microsoft.com/office/drawing/2014/main" id="{42FAD62B-7519-4B38-9A06-6220FA79C9A4}"/>
+                <a16:creationId xmlns:a16="http://schemas.microsoft.com/office/drawing/2014/main" id="{456FA5D5-FC3D-4E36-9446-C509D87C9A00}"/>
               </a:ext>
             </a:extLst>
           </p:cNvPr>
@@ -6446,7 +6638,7 @@
           <p:cNvPr id="7" name="">
             <a:extLst xmlns:a="http://schemas.openxmlformats.org/drawingml/2006/main">
               <a:ext uri="{FF2B5EF4-FFF2-40B4-BE49-F238E27FC236}">
-                <a16:creationId xmlns:a16="http://schemas.microsoft.com/office/drawing/2014/main" id="{6E42AD07-999F-418E-A65A-4DC457CED35E}"/>
+                <a16:creationId xmlns:a16="http://schemas.microsoft.com/office/drawing/2014/main" id="{F1CDD148-6876-42A9-B9C7-2032DBD86B46}"/>
               </a:ext>
             </a:extLst>
           </p:cNvPr>
@@ -6500,17 +6692,17 @@
       </p:sp>
       <p:graphicFrame>
         <p:nvGraphicFramePr>
-          <p:cNvPr id="19" name="Chart"/>
+          <p:cNvPr id="21" name="Chart"/>
           <p:cNvGraphicFramePr/>
           <p:nvPr/>
         </p:nvGraphicFramePr>
         <p:xfrm>
           <a:off xmlns:a="http://schemas.openxmlformats.org/drawingml/2006/main" x="1143000" y="2266950"/>
-          <a:ext xmlns:a="http://schemas.openxmlformats.org/drawingml/2006/main" cx="9810750" cy="3152775"/>
+          <a:ext xmlns:a="http://schemas.openxmlformats.org/drawingml/2006/main" cx="9810750" cy="2952750"/>
         </p:xfrm>
         <a:graphic xmlns:a="http://schemas.openxmlformats.org/drawingml/2006/main">
           <a:graphicData uri="http://schemas.openxmlformats.org/drawingml/2006/chart">
-            <c:chart xmlns:r="http://schemas.openxmlformats.org/officeDocument/2006/relationships" xmlns:c="http://schemas.openxmlformats.org/drawingml/2006/chart" r:id="Redf4769112e54f92"/>
+            <c:chart xmlns:r="http://schemas.openxmlformats.org/officeDocument/2006/relationships" xmlns:c="http://schemas.openxmlformats.org/drawingml/2006/chart" r:id="R3e41976407bc48a6"/>
           </a:graphicData>
         </a:graphic>
       </p:graphicFrame>
@@ -6519,7 +6711,7 @@
           <p:cNvPr id="9" name="">
             <a:extLst xmlns:a="http://schemas.openxmlformats.org/drawingml/2006/main">
               <a:ext uri="{FF2B5EF4-FFF2-40B4-BE49-F238E27FC236}">
-                <a16:creationId xmlns:a16="http://schemas.microsoft.com/office/drawing/2014/main" id="{A704D29B-B62F-4B16-BBA4-E527945F58F1}"/>
+                <a16:creationId xmlns:a16="http://schemas.microsoft.com/office/drawing/2014/main" id="{3C97FBF1-DB22-42E5-9FA8-79C3FD5321AD}"/>
               </a:ext>
             </a:extLst>
           </p:cNvPr>
@@ -6530,8 +6722,8 @@
         </p:nvSpPr>
         <p:spPr>
           <a:xfrm xmlns:a="http://schemas.openxmlformats.org/drawingml/2006/main">
-            <a:off x="1143000" y="5657850"/>
-            <a:ext cx="8572500" cy="304800"/>
+            <a:off x="1143000" y="5334000"/>
+            <a:ext cx="9810750" cy="266700"/>
           </a:xfrm>
           <a:prstGeom xmlns:a="http://schemas.openxmlformats.org/drawingml/2006/main" prst="rect">
             <a:avLst/>
@@ -6543,12 +6735,12 @@
         </p:spPr>
         <p:txBody>
           <a:bodyPr xmlns:a="http://schemas.openxmlformats.org/drawingml/2006/main">
-            <a:normAutofit fontScale="93333"/>
+            <a:normAutofit fontScale="85185"/>
           </a:bodyPr>
           <a:lstStyle xmlns:a="http://schemas.openxmlformats.org/drawingml/2006/main"/>
           <a:p xmlns:a="http://schemas.openxmlformats.org/drawingml/2006/main">
             <a:pPr algn="l">
-              <a:defRPr sz="1500" b="1">
+              <a:defRPr sz="1350" b="1">
                 <a:solidFill>
                   <a:srgbClr val="17212B"/>
                 </a:solidFill>
@@ -6558,7 +6750,7 @@
               </a:defRPr>
             </a:pPr>
             <a:r>
-              <a:rPr sz="1500" b="1">
+              <a:rPr sz="1350" b="1">
                 <a:solidFill>
                   <a:srgbClr val="17212B"/>
                 </a:solidFill>
@@ -6566,7 +6758,7 @@
                 <a:ea typeface="Aptos"/>
                 <a:cs typeface="Aptos"/>
               </a:rPr>
-              <a:t>All endpoint runs were evaluated on 28–29 May 2026.</a:t>
+              <a:t>Across all four tasks: Qwen 3 higher / 1 lower · DeepSeek 2 higher / 2 lower</a:t>
             </a:r>
           </a:p>
         </p:txBody>
@@ -6576,7 +6768,7 @@
           <p:cNvPr id="10" name="">
             <a:extLst xmlns:a="http://schemas.openxmlformats.org/drawingml/2006/main">
               <a:ext uri="{FF2B5EF4-FFF2-40B4-BE49-F238E27FC236}">
-                <a16:creationId xmlns:a16="http://schemas.microsoft.com/office/drawing/2014/main" id="{618DD82F-4F89-4511-8D2C-827E907A7EFC}"/>
+                <a16:creationId xmlns:a16="http://schemas.microsoft.com/office/drawing/2014/main" id="{643527FB-B070-455B-B47B-091960FF4664}"/>
               </a:ext>
             </a:extLst>
           </p:cNvPr>
@@ -6587,8 +6779,8 @@
         </p:nvSpPr>
         <p:spPr>
           <a:xfrm xmlns:a="http://schemas.openxmlformats.org/drawingml/2006/main">
-            <a:off x="1143000" y="6000750"/>
-            <a:ext cx="8953500" cy="266700"/>
+            <a:off x="1143000" y="5619750"/>
+            <a:ext cx="9810750" cy="247650"/>
           </a:xfrm>
           <a:prstGeom xmlns:a="http://schemas.openxmlformats.org/drawingml/2006/main" prst="rect">
             <a:avLst/>
@@ -6600,14 +6792,14 @@
         </p:spPr>
         <p:txBody>
           <a:bodyPr xmlns:a="http://schemas.openxmlformats.org/drawingml/2006/main">
-            <a:normAutofit fontScale="100000"/>
+            <a:normAutofit fontScale="85417"/>
           </a:bodyPr>
           <a:lstStyle xmlns:a="http://schemas.openxmlformats.org/drawingml/2006/main"/>
           <a:p xmlns:a="http://schemas.openxmlformats.org/drawingml/2006/main">
             <a:pPr algn="l">
-              <a:defRPr sz="1125" b="0">
-                <a:solidFill>
-                  <a:srgbClr val="66727E"/>
+              <a:defRPr sz="1200" b="1">
+                <a:solidFill>
+                  <a:srgbClr val="CF5D4A"/>
                 </a:solidFill>
                 <a:latin typeface="Aptos"/>
                 <a:ea typeface="Aptos"/>
@@ -6615,15 +6807,15 @@
               </a:defRPr>
             </a:pPr>
             <a:r>
-              <a:rPr sz="1125" b="0">
-                <a:solidFill>
-                  <a:srgbClr val="66727E"/>
+              <a:rPr sz="1200" b="1">
+                <a:solidFill>
+                  <a:srgbClr val="CF5D4A"/>
                 </a:solidFill>
                 <a:latin typeface="Aptos"/>
                 <a:ea typeface="Aptos"/>
                 <a:cs typeface="Aptos"/>
               </a:rPr>
-              <a:t>Release period is model metadata, not a progress timeline; 28–29 May is the evaluation time.</a:t>
+              <a:t>Separate metric · Consequence text match (METEOR): Qwen −.027; DeepSeek +.019</a:t>
             </a:r>
           </a:p>
         </p:txBody>
@@ -6633,7 +6825,7 @@
           <p:cNvPr id="11" name="">
             <a:extLst xmlns:a="http://schemas.openxmlformats.org/drawingml/2006/main">
               <a:ext uri="{FF2B5EF4-FFF2-40B4-BE49-F238E27FC236}">
-                <a16:creationId xmlns:a16="http://schemas.microsoft.com/office/drawing/2014/main" id="{4BE76B02-918C-40C2-A694-DA988C87AA47}"/>
+                <a16:creationId xmlns:a16="http://schemas.microsoft.com/office/drawing/2014/main" id="{A09E0EED-D5EA-463B-94E1-4A8EFE62A986}"/>
               </a:ext>
             </a:extLst>
           </p:cNvPr>
@@ -6644,8 +6836,8 @@
         </p:nvSpPr>
         <p:spPr>
           <a:xfrm xmlns:a="http://schemas.openxmlformats.org/drawingml/2006/main">
-            <a:off x="1143000" y="6296025"/>
-            <a:ext cx="8953500" cy="228600"/>
+            <a:off x="1143000" y="5905500"/>
+            <a:ext cx="8572500" cy="247650"/>
           </a:xfrm>
           <a:prstGeom xmlns:a="http://schemas.openxmlformats.org/drawingml/2006/main" prst="rect">
             <a:avLst/>
@@ -6657,7 +6849,64 @@
         </p:spPr>
         <p:txBody>
           <a:bodyPr xmlns:a="http://schemas.openxmlformats.org/drawingml/2006/main">
-            <a:normAutofit fontScale="92308"/>
+            <a:normAutofit fontScale="80392"/>
+          </a:bodyPr>
+          <a:lstStyle xmlns:a="http://schemas.openxmlformats.org/drawingml/2006/main"/>
+          <a:p xmlns:a="http://schemas.openxmlformats.org/drawingml/2006/main">
+            <a:pPr algn="l">
+              <a:defRPr sz="1275" b="1">
+                <a:solidFill>
+                  <a:srgbClr val="17212B"/>
+                </a:solidFill>
+                <a:latin typeface="Aptos"/>
+                <a:ea typeface="Aptos"/>
+                <a:cs typeface="Aptos"/>
+              </a:defRPr>
+            </a:pPr>
+            <a:r>
+              <a:rPr sz="1275" b="1">
+                <a:solidFill>
+                  <a:srgbClr val="17212B"/>
+                </a:solidFill>
+                <a:latin typeface="Aptos"/>
+                <a:ea typeface="Aptos"/>
+                <a:cs typeface="Aptos"/>
+              </a:rPr>
+              <a:t>All endpoint runs were evaluated on 28–29 May 2026.</a:t>
+            </a:r>
+          </a:p>
+        </p:txBody>
+      </p:sp>
+      <p:sp>
+        <p:nvSpPr>
+          <p:cNvPr id="12" name="">
+            <a:extLst xmlns:a="http://schemas.openxmlformats.org/drawingml/2006/main">
+              <a:ext uri="{FF2B5EF4-FFF2-40B4-BE49-F238E27FC236}">
+                <a16:creationId xmlns:a16="http://schemas.microsoft.com/office/drawing/2014/main" id="{F72FCC50-731F-470B-9CCC-7DC6E481AAA5}"/>
+              </a:ext>
+            </a:extLst>
+          </p:cNvPr>
+          <p:cNvSpPr>
+            <a:spLocks xmlns:a="http://schemas.openxmlformats.org/drawingml/2006/main" noGrp="1"/>
+          </p:cNvSpPr>
+          <p:nvPr/>
+        </p:nvSpPr>
+        <p:spPr>
+          <a:xfrm xmlns:a="http://schemas.openxmlformats.org/drawingml/2006/main">
+            <a:off x="1143000" y="6191250"/>
+            <a:ext cx="8953500" cy="209550"/>
+          </a:xfrm>
+          <a:prstGeom xmlns:a="http://schemas.openxmlformats.org/drawingml/2006/main" prst="rect">
+            <a:avLst/>
+          </a:prstGeom>
+          <a:noFill xmlns:a="http://schemas.openxmlformats.org/drawingml/2006/main"/>
+          <a:ln xmlns:a="http://schemas.openxmlformats.org/drawingml/2006/main" w="0">
+            <a:noFill/>
+          </a:ln>
+        </p:spPr>
+        <p:txBody>
+          <a:bodyPr xmlns:a="http://schemas.openxmlformats.org/drawingml/2006/main">
+            <a:normAutofit fontScale="79487"/>
           </a:bodyPr>
           <a:lstStyle xmlns:a="http://schemas.openxmlformats.org/drawingml/2006/main"/>
           <a:p xmlns:a="http://schemas.openxmlformats.org/drawingml/2006/main">
@@ -6680,7 +6929,64 @@
                 <a:ea typeface="Aptos"/>
                 <a:cs typeface="Aptos"/>
               </a:rPr>
-              <a:t>Exploratory: saved uncertainty is unavailable. Consequence uses a different score and is not shown.</a:t>
+              <a:t>Release period is model metadata, not a progress timeline.</a:t>
+            </a:r>
+          </a:p>
+        </p:txBody>
+      </p:sp>
+      <p:sp>
+        <p:nvSpPr>
+          <p:cNvPr id="13" name="">
+            <a:extLst xmlns:a="http://schemas.openxmlformats.org/drawingml/2006/main">
+              <a:ext uri="{FF2B5EF4-FFF2-40B4-BE49-F238E27FC236}">
+                <a16:creationId xmlns:a16="http://schemas.microsoft.com/office/drawing/2014/main" id="{CA187B54-08E2-4F28-A6E5-A5B343589C57}"/>
+              </a:ext>
+            </a:extLst>
+          </p:cNvPr>
+          <p:cNvSpPr>
+            <a:spLocks xmlns:a="http://schemas.openxmlformats.org/drawingml/2006/main" noGrp="1"/>
+          </p:cNvSpPr>
+          <p:nvPr/>
+        </p:nvSpPr>
+        <p:spPr>
+          <a:xfrm xmlns:a="http://schemas.openxmlformats.org/drawingml/2006/main">
+            <a:off x="1143000" y="6438900"/>
+            <a:ext cx="8953500" cy="190500"/>
+          </a:xfrm>
+          <a:prstGeom xmlns:a="http://schemas.openxmlformats.org/drawingml/2006/main" prst="rect">
+            <a:avLst/>
+          </a:prstGeom>
+          <a:noFill xmlns:a="http://schemas.openxmlformats.org/drawingml/2006/main"/>
+          <a:ln xmlns:a="http://schemas.openxmlformats.org/drawingml/2006/main" w="0">
+            <a:noFill/>
+          </a:ln>
+        </p:spPr>
+        <p:txBody>
+          <a:bodyPr xmlns:a="http://schemas.openxmlformats.org/drawingml/2006/main">
+            <a:normAutofit fontScale="72222"/>
+          </a:bodyPr>
+          <a:lstStyle xmlns:a="http://schemas.openxmlformats.org/drawingml/2006/main"/>
+          <a:p xmlns:a="http://schemas.openxmlformats.org/drawingml/2006/main">
+            <a:pPr algn="l">
+              <a:defRPr sz="900" b="0">
+                <a:solidFill>
+                  <a:srgbClr val="66727E"/>
+                </a:solidFill>
+                <a:latin typeface="Aptos"/>
+                <a:ea typeface="Aptos"/>
+                <a:cs typeface="Aptos"/>
+              </a:defRPr>
+            </a:pPr>
+            <a:r>
+              <a:rPr sz="900" b="0">
+                <a:solidFill>
+                  <a:srgbClr val="66727E"/>
+                </a:solidFill>
+                <a:latin typeface="Aptos"/>
+                <a:ea typeface="Aptos"/>
+                <a:cs typeface="Aptos"/>
+              </a:rPr>
+              <a:t>Exploratory: saved uncertainty is unavailable. METEOR stays separate from accuracy.</a:t>
             </a:r>
           </a:p>
         </p:txBody>
@@ -6688,7 +6994,7 @@
     </p:spTree>
     <p:extLst>
       <p:ext uri="{BB962C8B-B14F-4D97-AF65-F5344CB8AC3E}">
-        <p14:creationId xmlns:p14="http://schemas.microsoft.com/office/powerpoint/2010/main" val="1184862491"/>
+        <p14:creationId xmlns:p14="http://schemas.microsoft.com/office/powerpoint/2010/main" val="1479981797"/>
       </p:ext>
     </p:extLst>
   </p:cSld>
@@ -6719,7 +7025,7 @@
           <p:cNvPr id="10" name="slide-title">
             <a:extLst xmlns:a="http://schemas.openxmlformats.org/drawingml/2006/main">
               <a:ext uri="{FF2B5EF4-FFF2-40B4-BE49-F238E27FC236}">
-                <a16:creationId xmlns:a16="http://schemas.microsoft.com/office/drawing/2014/main" id="{529A7410-2AC4-4837-BEC6-410552849462}"/>
+                <a16:creationId xmlns:a16="http://schemas.microsoft.com/office/drawing/2014/main" id="{16C06B5D-4A1B-4DE5-81A2-7EBC30284F9A}"/>
               </a:ext>
             </a:extLst>
           </p:cNvPr>
@@ -6776,7 +7082,7 @@
           <p:cNvPr id="2" name="slide-subtitle">
             <a:extLst xmlns:a="http://schemas.openxmlformats.org/drawingml/2006/main">
               <a:ext uri="{FF2B5EF4-FFF2-40B4-BE49-F238E27FC236}">
-                <a16:creationId xmlns:a16="http://schemas.microsoft.com/office/drawing/2014/main" id="{9DE74ECF-9DE4-4026-BC98-216AD66A331E}"/>
+                <a16:creationId xmlns:a16="http://schemas.microsoft.com/office/drawing/2014/main" id="{F699FF5F-E0ED-4AAA-AE53-3F2ED9D21BED}"/>
               </a:ext>
             </a:extLst>
           </p:cNvPr>
@@ -6833,7 +7139,7 @@
           <p:cNvPr id="3" name="">
             <a:extLst xmlns:a="http://schemas.openxmlformats.org/drawingml/2006/main">
               <a:ext uri="{FF2B5EF4-FFF2-40B4-BE49-F238E27FC236}">
-                <a16:creationId xmlns:a16="http://schemas.microsoft.com/office/drawing/2014/main" id="{632B875B-A5C7-4741-811C-90192BBDC8CB}"/>
+                <a16:creationId xmlns:a16="http://schemas.microsoft.com/office/drawing/2014/main" id="{3E3FC88B-D26C-48C1-A1E5-B881B72A6E94}"/>
               </a:ext>
             </a:extLst>
           </p:cNvPr>
@@ -6894,7 +7200,7 @@
           <p:cNvPr id="4" name="">
             <a:extLst xmlns:a="http://schemas.openxmlformats.org/drawingml/2006/main">
               <a:ext uri="{FF2B5EF4-FFF2-40B4-BE49-F238E27FC236}">
-                <a16:creationId xmlns:a16="http://schemas.microsoft.com/office/drawing/2014/main" id="{0877D003-2483-4987-B519-D5DB4EF5DFD1}"/>
+                <a16:creationId xmlns:a16="http://schemas.microsoft.com/office/drawing/2014/main" id="{317BC4CC-BDC4-49FD-B896-66E59C817631}"/>
               </a:ext>
             </a:extLst>
           </p:cNvPr>
@@ -6925,7 +7231,7 @@
           <p:cNvPr id="5" name="">
             <a:extLst xmlns:a="http://schemas.openxmlformats.org/drawingml/2006/main">
               <a:ext uri="{FF2B5EF4-FFF2-40B4-BE49-F238E27FC236}">
-                <a16:creationId xmlns:a16="http://schemas.microsoft.com/office/drawing/2014/main" id="{4E1A1B4C-B378-4553-91A9-365CD9FD715A}"/>
+                <a16:creationId xmlns:a16="http://schemas.microsoft.com/office/drawing/2014/main" id="{E1236383-D392-47B1-820C-ACFD057F93DE}"/>
               </a:ext>
             </a:extLst>
           </p:cNvPr>
@@ -6982,7 +7288,7 @@
           <p:cNvPr id="6" name="">
             <a:extLst xmlns:a="http://schemas.openxmlformats.org/drawingml/2006/main">
               <a:ext uri="{FF2B5EF4-FFF2-40B4-BE49-F238E27FC236}">
-                <a16:creationId xmlns:a16="http://schemas.microsoft.com/office/drawing/2014/main" id="{A3C9B203-C4A7-44E8-81D8-758594F0290D}"/>
+                <a16:creationId xmlns:a16="http://schemas.microsoft.com/office/drawing/2014/main" id="{69BD18FA-32A9-4A6B-9FB5-8B965D2D4EE0}"/>
               </a:ext>
             </a:extLst>
           </p:cNvPr>
@@ -7455,7 +7761,7 @@
           <p:cNvPr id="8" name="">
             <a:extLst xmlns:a="http://schemas.openxmlformats.org/drawingml/2006/main">
               <a:ext uri="{FF2B5EF4-FFF2-40B4-BE49-F238E27FC236}">
-                <a16:creationId xmlns:a16="http://schemas.microsoft.com/office/drawing/2014/main" id="{07591309-4742-4C5F-B439-574ECADCDFE4}"/>
+                <a16:creationId xmlns:a16="http://schemas.microsoft.com/office/drawing/2014/main" id="{53316BAD-153D-4A5C-A00B-B7F96735BD29}"/>
               </a:ext>
             </a:extLst>
           </p:cNvPr>
@@ -7512,7 +7818,7 @@
           <p:cNvPr id="9" name="">
             <a:extLst xmlns:a="http://schemas.openxmlformats.org/drawingml/2006/main">
               <a:ext uri="{FF2B5EF4-FFF2-40B4-BE49-F238E27FC236}">
-                <a16:creationId xmlns:a16="http://schemas.microsoft.com/office/drawing/2014/main" id="{DC36197E-179D-422D-9400-7B940F558661}"/>
+                <a16:creationId xmlns:a16="http://schemas.microsoft.com/office/drawing/2014/main" id="{C303B648-B7F3-4067-9522-62C916B12784}"/>
               </a:ext>
             </a:extLst>
           </p:cNvPr>
@@ -7567,7 +7873,7 @@
     </p:spTree>
     <p:extLst>
       <p:ext uri="{BB962C8B-B14F-4D97-AF65-F5344CB8AC3E}">
-        <p14:creationId xmlns:p14="http://schemas.microsoft.com/office/powerpoint/2010/main" val="1824626533"/>
+        <p14:creationId xmlns:p14="http://schemas.microsoft.com/office/powerpoint/2010/main" val="1824483752"/>
       </p:ext>
     </p:extLst>
   </p:cSld>
@@ -7598,7 +7904,7 @@
           <p:cNvPr id="8" name="slide-title">
             <a:extLst xmlns:a="http://schemas.openxmlformats.org/drawingml/2006/main">
               <a:ext uri="{FF2B5EF4-FFF2-40B4-BE49-F238E27FC236}">
-                <a16:creationId xmlns:a16="http://schemas.microsoft.com/office/drawing/2014/main" id="{1D0B1235-B404-48EC-8169-A71F8E09165C}"/>
+                <a16:creationId xmlns:a16="http://schemas.microsoft.com/office/drawing/2014/main" id="{9F739914-15D0-4BD5-B112-73A012BA61B9}"/>
               </a:ext>
             </a:extLst>
           </p:cNvPr>
@@ -7655,7 +7961,7 @@
           <p:cNvPr id="2" name="slide-subtitle">
             <a:extLst xmlns:a="http://schemas.openxmlformats.org/drawingml/2006/main">
               <a:ext uri="{FF2B5EF4-FFF2-40B4-BE49-F238E27FC236}">
-                <a16:creationId xmlns:a16="http://schemas.microsoft.com/office/drawing/2014/main" id="{C2F3482D-930B-4CE2-81EB-07C98C4B17A1}"/>
+                <a16:creationId xmlns:a16="http://schemas.microsoft.com/office/drawing/2014/main" id="{ED32C618-631F-4526-BB4A-70876E1B8BDE}"/>
               </a:ext>
             </a:extLst>
           </p:cNvPr>
@@ -7712,7 +8018,7 @@
           <p:cNvPr id="3" name="">
             <a:extLst xmlns:a="http://schemas.openxmlformats.org/drawingml/2006/main">
               <a:ext uri="{FF2B5EF4-FFF2-40B4-BE49-F238E27FC236}">
-                <a16:creationId xmlns:a16="http://schemas.microsoft.com/office/drawing/2014/main" id="{9D28AE69-85DE-4D9E-81D6-23914B53A153}"/>
+                <a16:creationId xmlns:a16="http://schemas.microsoft.com/office/drawing/2014/main" id="{A3FAF773-72DE-40DD-B4D9-1DFFB2F62EAE}"/>
               </a:ext>
             </a:extLst>
           </p:cNvPr>
@@ -7773,7 +8079,7 @@
           <p:cNvPr id="4" name="">
             <a:extLst xmlns:a="http://schemas.openxmlformats.org/drawingml/2006/main">
               <a:ext uri="{FF2B5EF4-FFF2-40B4-BE49-F238E27FC236}">
-                <a16:creationId xmlns:a16="http://schemas.microsoft.com/office/drawing/2014/main" id="{B442718B-1D0D-407B-B7EE-DE5EC4C3739F}"/>
+                <a16:creationId xmlns:a16="http://schemas.microsoft.com/office/drawing/2014/main" id="{F324F1EB-CAF8-4023-B4C2-168A71479720}"/>
               </a:ext>
             </a:extLst>
           </p:cNvPr>
@@ -8197,7 +8503,7 @@
           <p:cNvPr id="6" name="">
             <a:extLst xmlns:a="http://schemas.openxmlformats.org/drawingml/2006/main">
               <a:ext uri="{FF2B5EF4-FFF2-40B4-BE49-F238E27FC236}">
-                <a16:creationId xmlns:a16="http://schemas.microsoft.com/office/drawing/2014/main" id="{78FB07AC-6F17-44B9-AE95-EB73302A8A63}"/>
+                <a16:creationId xmlns:a16="http://schemas.microsoft.com/office/drawing/2014/main" id="{63266D95-41E5-41BC-B3C8-484BF2679630}"/>
               </a:ext>
             </a:extLst>
           </p:cNvPr>
@@ -8254,7 +8560,7 @@
           <p:cNvPr id="7" name="">
             <a:extLst xmlns:a="http://schemas.openxmlformats.org/drawingml/2006/main">
               <a:ext uri="{FF2B5EF4-FFF2-40B4-BE49-F238E27FC236}">
-                <a16:creationId xmlns:a16="http://schemas.microsoft.com/office/drawing/2014/main" id="{0B7F2157-49E7-4E3C-AC9E-41FFD2397E05}"/>
+                <a16:creationId xmlns:a16="http://schemas.microsoft.com/office/drawing/2014/main" id="{3BD80480-CF37-4ABB-B366-9D32704E09DD}"/>
               </a:ext>
             </a:extLst>
           </p:cNvPr>
@@ -8309,7 +8615,7 @@
     </p:spTree>
     <p:extLst>
       <p:ext uri="{BB962C8B-B14F-4D97-AF65-F5344CB8AC3E}">
-        <p14:creationId xmlns:p14="http://schemas.microsoft.com/office/powerpoint/2010/main" val="458260065"/>
+        <p14:creationId xmlns:p14="http://schemas.microsoft.com/office/powerpoint/2010/main" val="2094009231"/>
       </p:ext>
     </p:extLst>
   </p:cSld>

</xml_diff>

<commit_message>
Add evidence-grounded full results deck
</commit_message>
<xml_diff>
--- a/slides/cei-moral-psychology-results-deck.pptx
+++ b/slides/cei-moral-psychology-results-deck.pptx
@@ -2,20 +2,20 @@
 <file path=ppt/presentation.xml><?xml version="1.0" encoding="utf-8"?>
 <p:presentation xmlns:p="http://schemas.openxmlformats.org/presentationml/2006/main">
   <p:sldMasterIdLst>
-    <p:sldMasterId xmlns:r="http://schemas.openxmlformats.org/officeDocument/2006/relationships" id="2147483648" r:id="Rf9cf5c432cbd451b"/>
+    <p:sldMasterId xmlns:r="http://schemas.openxmlformats.org/officeDocument/2006/relationships" id="2147483648" r:id="R33f090db8080438d"/>
   </p:sldMasterIdLst>
   <p:notesMasterIdLst>
-    <p:notesMasterId xmlns:r="http://schemas.openxmlformats.org/officeDocument/2006/relationships" r:id="R8e5db12ff58f480a"/>
+    <p:notesMasterId xmlns:r="http://schemas.openxmlformats.org/officeDocument/2006/relationships" r:id="R43e310ec63f1434a"/>
   </p:notesMasterIdLst>
   <p:sldIdLst>
-    <p:sldId xmlns:r="http://schemas.openxmlformats.org/officeDocument/2006/relationships" id="256" r:id="R57ecc9c9b3064384"/>
-    <p:sldId xmlns:r="http://schemas.openxmlformats.org/officeDocument/2006/relationships" id="257" r:id="R2b0cc4a35e67476a"/>
-    <p:sldId xmlns:r="http://schemas.openxmlformats.org/officeDocument/2006/relationships" id="258" r:id="Rf2c17c465fd84a51"/>
-    <p:sldId xmlns:r="http://schemas.openxmlformats.org/officeDocument/2006/relationships" id="259" r:id="R3ea47c879adc4f35"/>
-    <p:sldId xmlns:r="http://schemas.openxmlformats.org/officeDocument/2006/relationships" id="260" r:id="Rf4667a02415d42d1"/>
-    <p:sldId xmlns:r="http://schemas.openxmlformats.org/officeDocument/2006/relationships" id="261" r:id="R35bf000902a84c5b"/>
-    <p:sldId xmlns:r="http://schemas.openxmlformats.org/officeDocument/2006/relationships" id="262" r:id="Redfc71dcae534551"/>
-    <p:sldId xmlns:r="http://schemas.openxmlformats.org/officeDocument/2006/relationships" id="263" r:id="R6919750d01ea4456"/>
+    <p:sldId xmlns:r="http://schemas.openxmlformats.org/officeDocument/2006/relationships" id="256" r:id="R376bb1f50c4c4960"/>
+    <p:sldId xmlns:r="http://schemas.openxmlformats.org/officeDocument/2006/relationships" id="257" r:id="R6a6fa43bd6dd47b8"/>
+    <p:sldId xmlns:r="http://schemas.openxmlformats.org/officeDocument/2006/relationships" id="258" r:id="Rabe7afbc6dc3423b"/>
+    <p:sldId xmlns:r="http://schemas.openxmlformats.org/officeDocument/2006/relationships" id="259" r:id="R1c6d28cc7d294840"/>
+    <p:sldId xmlns:r="http://schemas.openxmlformats.org/officeDocument/2006/relationships" id="260" r:id="Rc652fc765851475a"/>
+    <p:sldId xmlns:r="http://schemas.openxmlformats.org/officeDocument/2006/relationships" id="261" r:id="R10961c3f54ac4ede"/>
+    <p:sldId xmlns:r="http://schemas.openxmlformats.org/officeDocument/2006/relationships" id="262" r:id="Ra3dccf69e653411a"/>
+    <p:sldId xmlns:r="http://schemas.openxmlformats.org/officeDocument/2006/relationships" id="263" r:id="Re89ecb56c0284e9c"/>
   </p:sldIdLst>
   <p:sldSz cx="12192000" cy="6858000"/>
   <p:notesSz cx="6858000" cy="9144000"/>
@@ -449,7 +449,7 @@
           <a:lstStyle xmlns:a="http://schemas.openxmlformats.org/drawingml/2006/main"/>
           <a:p xmlns:a="http://schemas.openxmlformats.org/drawingml/2006/main">
             <a:r>
-              <a:t>Claim: publish task-level results, but do not create an overall model ranking.</a:t>
+              <a:t>This is a CEI MoralBench and UniMoral summary for a research lead.</a:t>
             </a:r>
           </a:p>
           <a:p xmlns:a="http://schemas.openxmlformats.org/drawingml/2006/main">
@@ -459,7 +459,12 @@
           </a:p>
           <a:p xmlns:a="http://schemas.openxmlformats.org/drawingml/2006/main">
             <a:r>
-              <a:t>Boundary: current task aggregates and saved uncertainty do not establish human validity, causal effects, or one cross-metric moral score.</a:t>
+              <a:t>No model has the highest saved score on all eight tasks. The MoralBench comparison ranges do not identify a clear leader.</a:t>
+            </a:r>
+          </a:p>
+          <a:p xmlns:a="http://schemas.openxmlformats.org/drawingml/2006/main">
+            <a:r>
+              <a:t>These tasks do not show that one model is morally better or support one overall score.</a:t>
             </a:r>
           </a:p>
         </p:txBody>
@@ -544,22 +549,12 @@
           </a:p>
           <a:p xmlns:a="http://schemas.openxmlformats.org/drawingml/2006/main">
             <a:r>
-              <a:t>Each task cell keeps the formal task name on the first line and explains what it tests on the second.</a:t>
-            </a:r>
-          </a:p>
-          <a:p xmlns:a="http://schemas.openxmlformats.org/drawingml/2006/main">
-            <a:r>
               <a:t>The UniMoral action, typology, and factor rows match saved annotator-specific labels under no-persona prompts; the consequence row matches generated text to saved human references. None infers a person's stable moral identity.</a:t>
             </a:r>
           </a:p>
           <a:p xmlns:a="http://schemas.openxmlformats.org/drawingml/2006/main">
             <a:r>
-              <a:t>Values belong to different metrics. The visible labels translate normalized preference and METEOR into plain language.</a:t>
-            </a:r>
-          </a:p>
-          <a:p xmlns:a="http://schemas.openxmlformats.org/drawingml/2006/main">
-            <a:r>
-              <a:t>Do not average preference, accuracy, and METEOR or treat this table as a moral leaderboard.</a:t>
+              <a:t>Values belong to different metrics. Agreement, accuracy, and text match stay separate and should not be averaged.</a:t>
             </a:r>
           </a:p>
         </p:txBody>
@@ -634,27 +629,17 @@
           </a:p>
           <a:p xmlns:a="http://schemas.openxmlformats.org/drawingml/2006/main">
             <a:r>
-              <a:t>All 18 individual intervals wider than .30 occur in the two MoralBench comparison tasks.</a:t>
-            </a:r>
-          </a:p>
-          <a:p xmlns:a="http://schemas.openxmlformats.org/drawingml/2006/main">
-            <a:r>
-              <a:t>Denominator: all available primary models—8 on MFQ compare and 10 on vignette compare—not the five-model common roster.</a:t>
-            </a:r>
-          </a:p>
-          <a:p xmlns:a="http://schemas.openxmlformats.org/drawingml/2006/main">
-            <a:r>
-              <a:t>Within each comparison task, every model pair has overlapping marginal intervals: 28 of 28 MFQ pairs and 45 of 45 vignette pairs.</a:t>
-            </a:r>
-          </a:p>
-          <a:p xmlns:a="http://schemas.openxmlformats.org/drawingml/2006/main">
-            <a:r>
-              <a:t>This is not a paired model-difference test. The visible cards compare only the two accuracy tasks; they do not rank interval widths across different metrics.</a:t>
-            </a:r>
-          </a:p>
-          <a:p xmlns:a="http://schemas.openxmlformats.org/drawingml/2006/main">
-            <a:r>
-              <a:t>The saved intervals are nominal row-level estimates and do not establish cluster-aware uncertainty or human validity.</a:t>
+              <a:t>The MFQ test has 8 models and 20 questions. The vignette test has 10 models and 24 questions.</a:t>
+            </a:r>
+          </a:p>
+          <a:p xmlns:a="http://schemas.openxmlformats.org/drawingml/2006/main">
+            <a:r>
+              <a:t>For every model pair, the two models' saved 95% score ranges overlap. This covers all 28 MFQ pairs and all 45 vignette pairs.</a:t>
+            </a:r>
+          </a:p>
+          <a:p xmlns:a="http://schemas.openxmlformats.org/drawingml/2006/main">
+            <a:r>
+              <a:t>This is not a paired model-difference test. Question-level scores and stronger uncertainty estimates are missing.</a:t>
             </a:r>
           </a:p>
         </p:txBody>
@@ -729,22 +714,17 @@
           </a:p>
           <a:p xmlns:a="http://schemas.openxmlformats.org/drawingml/2006/main">
             <a:r>
-              <a:t>Denominator: 12 complete paths equals three model families times four UniMoral tasks. Each path contains three named variants.</a:t>
-            </a:r>
-          </a:p>
-          <a:p xmlns:a="http://schemas.openxmlformats.org/drawingml/2006/main">
-            <a:r>
-              <a:t>Counts: 4 rise at both steps, 7 change direction, and 1 falls at both steps.</a:t>
-            </a:r>
-          </a:p>
-          <a:p xmlns:a="http://schemas.openxmlformats.org/drawingml/2006/main">
-            <a:r>
-              <a:t>Accuracy and METEOR stay separate.</a:t>
-            </a:r>
-          </a:p>
-          <a:p xmlns:a="http://schemas.openxmlformats.org/drawingml/2006/main">
-            <a:r>
-              <a:t>This slide counts within-task direction only. It does not average accuracy and METEOR. The selected grid has no saved confidence intervals or raw-log replay.</a:t>
+              <a:t>The 12 checks cover three model families and four UniMoral tasks. Each check follows three model sizes.</a:t>
+            </a:r>
+          </a:p>
+          <a:p xmlns:a="http://schemas.openxmlformats.org/drawingml/2006/main">
+            <a:r>
+              <a:t>Four checks rise twice, seven change direction, and one falls twice.</a:t>
+            </a:r>
+          </a:p>
+          <a:p xmlns:a="http://schemas.openxmlformats.org/drawingml/2006/main">
+            <a:r>
+              <a:t>Accuracy and METEOR stay separate. No saved uncertainty ranges or raw run archive are available.</a:t>
             </a:r>
           </a:p>
         </p:txBody>
@@ -824,17 +804,12 @@
           </a:p>
           <a:p xmlns:a="http://schemas.openxmlformats.org/drawingml/2006/main">
             <a:r>
-              <a:t>Across Qwen, Gemma, and Llama on four UniMoral tasks, 4 of 12 complete paths rise twice, 7 change direction, and 1 falls twice.</a:t>
-            </a:r>
-          </a:p>
-          <a:p xmlns:a="http://schemas.openxmlformats.org/drawingml/2006/main">
-            <a:r>
-              <a:t>No saved intervals or raw-log replay are available for this selected grid.</a:t>
-            </a:r>
-          </a:p>
-          <a:p xmlns:a="http://schemas.openxmlformats.org/drawingml/2006/main">
-            <a:r>
-              <a:t>This is exploratory selected-grid evidence. Parameter tier is descriptive metadata, not a controlled intervention. Qwen and Llama paths also change model generation or release period.</a:t>
+              <a:t>Factor accuracy rises while moral typology accuracy falls as the named Gemma variants get larger.</a:t>
+            </a:r>
+          </a:p>
+          <a:p xmlns:a="http://schemas.openxmlformats.org/drawingml/2006/main">
+            <a:r>
+              <a:t>No saved uncertainty ranges or raw run archive are available. The versions also differ in training.</a:t>
             </a:r>
           </a:p>
         </p:txBody>
@@ -914,12 +889,12 @@
           </a:p>
           <a:p xmlns:a="http://schemas.openxmlformats.org/drawingml/2006/main">
             <a:r>
-              <a:t>Consequence uses METEOR and is not mixed into this accuracy chart. Its endpoint deltas are Qwen -.026780 and DeepSeek +.018985.</a:t>
-            </a:r>
-          </a:p>
-          <a:p xmlns:a="http://schemas.openxmlformats.org/drawingml/2006/main">
-            <a:r>
-              <a:t>Every plotted selected-grid score was evaluated on 28 or 29 May 2026. Release quarter is descriptive model metadata, not observation time or a causal intervention.</a:t>
+              <a:t>Consequence uses a separate text-match score. Its changes are Qwen -.026780 and DeepSeek +.018985.</a:t>
+            </a:r>
+          </a:p>
+          <a:p xmlns:a="http://schemas.openxmlformats.org/drawingml/2006/main">
+            <a:r>
+              <a:t>Every shown score was tested on 28 or 29 May 2026. Release date describes the model and does not show a cause.</a:t>
             </a:r>
           </a:p>
         </p:txBody>
@@ -994,22 +969,17 @@
           </a:p>
           <a:p xmlns:a="http://schemas.openxmlformats.org/drawingml/2006/main">
             <a:r>
-              <a:t>MoralBench and UniMoral share approximate task families with the local evaluator, but model, data, prompt, metric, scorer, or aggregation identities differ.</a:t>
-            </a:r>
-          </a:p>
-          <a:p xmlns:a="http://schemas.openxmlformats.org/drawingml/2006/main">
-            <a:r>
-              <a:t>MoReBench and MoralLens local performance surfaces are proxy-only. Their paper metrics and judges are not reproduced.</a:t>
-            </a:r>
-          </a:p>
-          <a:p xmlns:a="http://schemas.openxmlformats.org/drawingml/2006/main">
-            <a:r>
-              <a:t>They are not direct score baselines. The visible status labels translate the protocol evidence into plain language.</a:t>
-            </a:r>
-          </a:p>
-          <a:p xmlns:a="http://schemas.openxmlformats.org/drawingml/2006/main">
-            <a:r>
-              <a:t>Do not use the canonical 37-row UniMoral and ValuePrism crosswalk as the denominator for all four papers. That ledger covers a different evidence scope.</a:t>
+              <a:t>The five papers ask different questions and use different models, data, prompts, or scores.</a:t>
+            </a:r>
+          </a:p>
+          <a:p xmlns:a="http://schemas.openxmlformats.org/drawingml/2006/main">
+            <a:r>
+              <a:t>None is reproduced exactly by the CEI tests. Paper scores and CEI scores should stay separate.</a:t>
+            </a:r>
+          </a:p>
+          <a:p xmlns:a="http://schemas.openxmlformats.org/drawingml/2006/main">
+            <a:r>
+              <a:t>The 37-row comparison in the full deck covers UniMoral and ValuePrism only.</a:t>
             </a:r>
           </a:p>
         </p:txBody>
@@ -1089,12 +1059,12 @@
           </a:p>
           <a:p xmlns:a="http://schemas.openxmlformats.org/drawingml/2006/main">
             <a:r>
-              <a:t>Benchmark agreement is not human validity. The visible wording translates that evidence boundary into plain language.</a:t>
-            </a:r>
-          </a:p>
-          <a:p xmlns:a="http://schemas.openxmlformats.org/drawingml/2006/main">
-            <a:r>
-              <a:t>The saved evidence still lacks canonical raw archives, clustered uncertainty, complete model and dataset identity, contamination testing, and representative human validation.</a:t>
+              <a:t>Benchmark agreement does not prove that the test matches human judgment.</a:t>
+            </a:r>
+          </a:p>
+          <a:p xmlns:a="http://schemas.openxmlformats.org/drawingml/2006/main">
+            <a:r>
+              <a:t>We still need the original answers and scores, better uncertainty estimates, exact model and dataset records, leakage checks, and representative human review.</a:t>
             </a:r>
           </a:p>
         </p:txBody>
@@ -1162,7 +1132,7 @@
   </p:cSld>
   <p:clrMap bg1="lt1" tx1="dk1" bg2="lt2" tx2="dk2" accent1="accent1" accent2="accent2" accent3="accent3" accent4="accent4" accent5="accent5" accent6="accent6" hlink="hlink" folHlink="folHlink"/>
   <p:sldLayoutIdLst>
-    <p:sldLayoutId xmlns:r="http://schemas.openxmlformats.org/officeDocument/2006/relationships" id="2147483649" r:id="Rd7b06535ddf248c2"/>
+    <p:sldLayoutId xmlns:r="http://schemas.openxmlformats.org/officeDocument/2006/relationships" id="2147483649" r:id="Re3fdf49366cf43ba"/>
   </p:sldLayoutIdLst>
   <p:txStyles>
     <p:titleStyle>
@@ -1871,7 +1841,7 @@
                     <a:ea typeface="Aptos"/>
                     <a:cs typeface="Aptos"/>
                   </a:rPr>
-                  <a:t>Model-family and task cases (12 total)</a:t>
+                  <a:t>Family and task combinations (12 total)</a:t>
                 </a:r>
               </a:p>
             </c:rich>
@@ -2755,10 +2725,10 @@
       </p:grpSpPr>
       <p:sp>
         <p:nvSpPr>
-          <p:cNvPr id="7" name="cover-title">
+          <p:cNvPr id="9" name="cover-title">
             <a:extLst xmlns:a="http://schemas.openxmlformats.org/drawingml/2006/main">
               <a:ext uri="{FF2B5EF4-FFF2-40B4-BE49-F238E27FC236}">
-                <a16:creationId xmlns:a16="http://schemas.microsoft.com/office/drawing/2014/main" id="{51A6F185-9CC8-492C-B20F-EE5A49D9853B}"/>
+                <a16:creationId xmlns:a16="http://schemas.microsoft.com/office/drawing/2014/main" id="{0D736628-41C3-45C8-8E40-1861E2EC334D}"/>
               </a:ext>
             </a:extLst>
           </p:cNvPr>
@@ -2769,8 +2739,65 @@
         </p:nvSpPr>
         <p:spPr>
           <a:xfrm xmlns:a="http://schemas.openxmlformats.org/drawingml/2006/main">
-            <a:off x="838200" y="1257300"/>
-            <a:ext cx="8858250" cy="1695450"/>
+            <a:off x="838200" y="952500"/>
+            <a:ext cx="10287000" cy="666750"/>
+          </a:xfrm>
+          <a:prstGeom xmlns:a="http://schemas.openxmlformats.org/drawingml/2006/main" prst="rect">
+            <a:avLst/>
+          </a:prstGeom>
+          <a:noFill xmlns:a="http://schemas.openxmlformats.org/drawingml/2006/main"/>
+          <a:ln xmlns:a="http://schemas.openxmlformats.org/drawingml/2006/main" w="0">
+            <a:noFill/>
+          </a:ln>
+        </p:spPr>
+        <p:txBody>
+          <a:bodyPr xmlns:a="http://schemas.openxmlformats.org/drawingml/2006/main">
+            <a:normAutofit fontScale="96795"/>
+          </a:bodyPr>
+          <a:lstStyle xmlns:a="http://schemas.openxmlformats.org/drawingml/2006/main"/>
+          <a:p xmlns:a="http://schemas.openxmlformats.org/drawingml/2006/main">
+            <a:pPr algn="l">
+              <a:defRPr sz="3900" b="1">
+                <a:solidFill>
+                  <a:srgbClr val="17212B"/>
+                </a:solidFill>
+                <a:latin typeface="Aptos"/>
+                <a:ea typeface="Aptos"/>
+                <a:cs typeface="Aptos"/>
+              </a:defRPr>
+            </a:pPr>
+            <a:r>
+              <a:rPr sz="3900" b="1">
+                <a:solidFill>
+                  <a:srgbClr val="17212B"/>
+                </a:solidFill>
+                <a:latin typeface="Aptos"/>
+                <a:ea typeface="Aptos"/>
+                <a:cs typeface="Aptos"/>
+              </a:rPr>
+              <a:t>MoralBench + UniMoral</a:t>
+            </a:r>
+          </a:p>
+        </p:txBody>
+      </p:sp>
+      <p:sp>
+        <p:nvSpPr>
+          <p:cNvPr id="2" name="">
+            <a:extLst xmlns:a="http://schemas.openxmlformats.org/drawingml/2006/main">
+              <a:ext uri="{FF2B5EF4-FFF2-40B4-BE49-F238E27FC236}">
+                <a16:creationId xmlns:a16="http://schemas.microsoft.com/office/drawing/2014/main" id="{12D439F8-AB77-4F4D-AB87-825241B95B6C}"/>
+              </a:ext>
+            </a:extLst>
+          </p:cNvPr>
+          <p:cNvSpPr>
+            <a:spLocks xmlns:a="http://schemas.openxmlformats.org/drawingml/2006/main" noGrp="1"/>
+          </p:cNvSpPr>
+          <p:nvPr/>
+        </p:nvSpPr>
+        <p:spPr>
+          <a:xfrm xmlns:a="http://schemas.openxmlformats.org/drawingml/2006/main">
+            <a:off x="876300" y="1905000"/>
+            <a:ext cx="10001250" cy="685800"/>
           </a:xfrm>
           <a:prstGeom xmlns:a="http://schemas.openxmlformats.org/drawingml/2006/main" prst="rect">
             <a:avLst/>
@@ -2787,9 +2814,9 @@
           <a:lstStyle xmlns:a="http://schemas.openxmlformats.org/drawingml/2006/main"/>
           <a:p xmlns:a="http://schemas.openxmlformats.org/drawingml/2006/main">
             <a:pPr algn="l">
-              <a:defRPr sz="4050" b="1">
-                <a:solidFill>
-                  <a:srgbClr val="17212B"/>
+              <a:defRPr sz="2550" b="1">
+                <a:solidFill>
+                  <a:srgbClr val="14856D"/>
                 </a:solidFill>
                 <a:latin typeface="Aptos"/>
                 <a:ea typeface="Aptos"/>
@@ -2797,48 +2824,25 @@
               </a:defRPr>
             </a:pPr>
             <a:r>
-              <a:rPr sz="4050" b="1">
-                <a:solidFill>
-                  <a:srgbClr val="17212B"/>
+              <a:rPr sz="2550" b="1">
+                <a:solidFill>
+                  <a:srgbClr val="14856D"/>
                 </a:solidFill>
                 <a:latin typeface="Aptos"/>
                 <a:ea typeface="Aptos"/>
                 <a:cs typeface="Aptos"/>
               </a:rPr>
-              <a:t>Publish task results.</a:t>
-            </a:r>
-          </a:p>
-          <a:p xmlns:a="http://schemas.openxmlformats.org/drawingml/2006/main">
-            <a:pPr algn="l">
-              <a:defRPr sz="4050" b="1">
-                <a:solidFill>
-                  <a:srgbClr val="17212B"/>
-                </a:solidFill>
-                <a:latin typeface="Aptos"/>
-                <a:ea typeface="Aptos"/>
-                <a:cs typeface="Aptos"/>
-              </a:defRPr>
-            </a:pPr>
-            <a:r>
-              <a:rPr sz="4050" b="1">
-                <a:solidFill>
-                  <a:srgbClr val="17212B"/>
-                </a:solidFill>
-                <a:latin typeface="Aptos"/>
-                <a:ea typeface="Aptos"/>
-                <a:cs typeface="Aptos"/>
-              </a:rPr>
-              <a:t>Do not rank the models.</a:t>
+              <a:t>No model has the highest saved score on all 8 tasks.</a:t>
             </a:r>
           </a:p>
         </p:txBody>
       </p:sp>
       <p:sp>
         <p:nvSpPr>
-          <p:cNvPr id="2" name="">
+          <p:cNvPr id="3" name="">
             <a:extLst xmlns:a="http://schemas.openxmlformats.org/drawingml/2006/main">
               <a:ext uri="{FF2B5EF4-FFF2-40B4-BE49-F238E27FC236}">
-                <a16:creationId xmlns:a16="http://schemas.microsoft.com/office/drawing/2014/main" id="{FF2A1102-37FA-48B5-BE01-3FC194FC3095}"/>
+                <a16:creationId xmlns:a16="http://schemas.microsoft.com/office/drawing/2014/main" id="{7A0F38EA-4B41-4FC7-9DDC-ECF2FA9CEDB5}"/>
               </a:ext>
             </a:extLst>
           </p:cNvPr>
@@ -2849,8 +2853,210 @@
         </p:nvSpPr>
         <p:spPr>
           <a:xfrm xmlns:a="http://schemas.openxmlformats.org/drawingml/2006/main">
-            <a:off x="876300" y="3181350"/>
-            <a:ext cx="6858000" cy="381000"/>
+            <a:off x="876300" y="2895600"/>
+            <a:ext cx="9906000" cy="0"/>
+          </a:xfrm>
+          <a:prstGeom xmlns:a="http://schemas.openxmlformats.org/drawingml/2006/main" prst="line">
+            <a:avLst/>
+          </a:prstGeom>
+          <a:noFill xmlns:a="http://schemas.openxmlformats.org/drawingml/2006/main"/>
+          <a:ln xmlns:a="http://schemas.openxmlformats.org/drawingml/2006/main" w="19050">
+            <a:solidFill>
+              <a:srgbClr val="D8D9D5"/>
+            </a:solidFill>
+            <a:prstDash val="solid"/>
+          </a:ln>
+        </p:spPr>
+      </p:sp>
+      <p:sp>
+        <p:nvSpPr>
+          <p:cNvPr id="4" name="">
+            <a:extLst xmlns:a="http://schemas.openxmlformats.org/drawingml/2006/main">
+              <a:ext uri="{FF2B5EF4-FFF2-40B4-BE49-F238E27FC236}">
+                <a16:creationId xmlns:a16="http://schemas.microsoft.com/office/drawing/2014/main" id="{65FE6ED8-7393-4D70-8D1C-47ECC86AABB0}"/>
+              </a:ext>
+            </a:extLst>
+          </p:cNvPr>
+          <p:cNvSpPr>
+            <a:spLocks xmlns:a="http://schemas.openxmlformats.org/drawingml/2006/main" noGrp="1"/>
+          </p:cNvSpPr>
+          <p:nvPr/>
+        </p:nvSpPr>
+        <p:spPr>
+          <a:xfrm xmlns:a="http://schemas.openxmlformats.org/drawingml/2006/main">
+            <a:off x="876300" y="3276600"/>
+            <a:ext cx="3143250" cy="285750"/>
+          </a:xfrm>
+          <a:prstGeom xmlns:a="http://schemas.openxmlformats.org/drawingml/2006/main" prst="rect">
+            <a:avLst/>
+          </a:prstGeom>
+          <a:noFill xmlns:a="http://schemas.openxmlformats.org/drawingml/2006/main"/>
+          <a:ln xmlns:a="http://schemas.openxmlformats.org/drawingml/2006/main" w="0">
+            <a:noFill/>
+          </a:ln>
+        </p:spPr>
+        <p:txBody>
+          <a:bodyPr xmlns:a="http://schemas.openxmlformats.org/drawingml/2006/main">
+            <a:normAutofit fontScale="94444"/>
+          </a:bodyPr>
+          <a:lstStyle xmlns:a="http://schemas.openxmlformats.org/drawingml/2006/main"/>
+          <a:p xmlns:a="http://schemas.openxmlformats.org/drawingml/2006/main">
+            <a:pPr algn="l">
+              <a:defRPr sz="1350" b="1">
+                <a:solidFill>
+                  <a:srgbClr val="66727E"/>
+                </a:solidFill>
+                <a:latin typeface="Aptos"/>
+                <a:ea typeface="Aptos"/>
+                <a:cs typeface="Aptos"/>
+              </a:defRPr>
+            </a:pPr>
+            <a:r>
+              <a:rPr sz="1350" b="1">
+                <a:solidFill>
+                  <a:srgbClr val="66727E"/>
+                </a:solidFill>
+                <a:latin typeface="Aptos"/>
+                <a:ea typeface="Aptos"/>
+                <a:cs typeface="Aptos"/>
+              </a:rPr>
+              <a:t>MoralBench comparison</a:t>
+            </a:r>
+          </a:p>
+        </p:txBody>
+      </p:sp>
+      <p:sp>
+        <p:nvSpPr>
+          <p:cNvPr id="5" name="">
+            <a:extLst xmlns:a="http://schemas.openxmlformats.org/drawingml/2006/main">
+              <a:ext uri="{FF2B5EF4-FFF2-40B4-BE49-F238E27FC236}">
+                <a16:creationId xmlns:a16="http://schemas.microsoft.com/office/drawing/2014/main" id="{702EB5B7-EA93-481B-8443-B08534691751}"/>
+              </a:ext>
+            </a:extLst>
+          </p:cNvPr>
+          <p:cNvSpPr>
+            <a:spLocks xmlns:a="http://schemas.openxmlformats.org/drawingml/2006/main" noGrp="1"/>
+          </p:cNvSpPr>
+          <p:nvPr/>
+        </p:nvSpPr>
+        <p:spPr>
+          <a:xfrm xmlns:a="http://schemas.openxmlformats.org/drawingml/2006/main">
+            <a:off x="876300" y="3619500"/>
+            <a:ext cx="9620250" cy="495300"/>
+          </a:xfrm>
+          <a:prstGeom xmlns:a="http://schemas.openxmlformats.org/drawingml/2006/main" prst="rect">
+            <a:avLst/>
+          </a:prstGeom>
+          <a:noFill xmlns:a="http://schemas.openxmlformats.org/drawingml/2006/main"/>
+          <a:ln xmlns:a="http://schemas.openxmlformats.org/drawingml/2006/main" w="0">
+            <a:noFill/>
+          </a:ln>
+        </p:spPr>
+        <p:txBody>
+          <a:bodyPr xmlns:a="http://schemas.openxmlformats.org/drawingml/2006/main">
+            <a:normAutofit fontScale="81777"/>
+          </a:bodyPr>
+          <a:lstStyle xmlns:a="http://schemas.openxmlformats.org/drawingml/2006/main"/>
+          <a:p xmlns:a="http://schemas.openxmlformats.org/drawingml/2006/main">
+            <a:pPr algn="l">
+              <a:defRPr sz="1800" b="0">
+                <a:solidFill>
+                  <a:srgbClr val="17212B"/>
+                </a:solidFill>
+                <a:latin typeface="Aptos"/>
+                <a:ea typeface="Aptos"/>
+                <a:cs typeface="Aptos"/>
+              </a:defRPr>
+            </a:pPr>
+            <a:r>
+              <a:rPr sz="1800" b="0">
+                <a:solidFill>
+                  <a:srgbClr val="17212B"/>
+                </a:solidFill>
+                <a:latin typeface="Aptos"/>
+                <a:ea typeface="Aptos"/>
+                <a:cs typeface="Aptos"/>
+              </a:rPr>
+              <a:t>For every model pair, the two models' 95% score ranges overlap: 28 of 28 MFQ pairs and 45 of 45 vignette pairs.</a:t>
+            </a:r>
+          </a:p>
+        </p:txBody>
+      </p:sp>
+      <p:sp>
+        <p:nvSpPr>
+          <p:cNvPr id="6" name="">
+            <a:extLst xmlns:a="http://schemas.openxmlformats.org/drawingml/2006/main">
+              <a:ext uri="{FF2B5EF4-FFF2-40B4-BE49-F238E27FC236}">
+                <a16:creationId xmlns:a16="http://schemas.microsoft.com/office/drawing/2014/main" id="{A6D7192B-0E3A-447F-AA74-D663BE77D6D7}"/>
+              </a:ext>
+            </a:extLst>
+          </p:cNvPr>
+          <p:cNvSpPr>
+            <a:spLocks xmlns:a="http://schemas.openxmlformats.org/drawingml/2006/main" noGrp="1"/>
+          </p:cNvSpPr>
+          <p:nvPr/>
+        </p:nvSpPr>
+        <p:spPr>
+          <a:xfrm xmlns:a="http://schemas.openxmlformats.org/drawingml/2006/main">
+            <a:off x="876300" y="4438650"/>
+            <a:ext cx="3905250" cy="285750"/>
+          </a:xfrm>
+          <a:prstGeom xmlns:a="http://schemas.openxmlformats.org/drawingml/2006/main" prst="rect">
+            <a:avLst/>
+          </a:prstGeom>
+          <a:noFill xmlns:a="http://schemas.openxmlformats.org/drawingml/2006/main"/>
+          <a:ln xmlns:a="http://schemas.openxmlformats.org/drawingml/2006/main" w="0">
+            <a:noFill/>
+          </a:ln>
+        </p:spPr>
+        <p:txBody>
+          <a:bodyPr xmlns:a="http://schemas.openxmlformats.org/drawingml/2006/main">
+            <a:normAutofit fontScale="94444"/>
+          </a:bodyPr>
+          <a:lstStyle xmlns:a="http://schemas.openxmlformats.org/drawingml/2006/main"/>
+          <a:p xmlns:a="http://schemas.openxmlformats.org/drawingml/2006/main">
+            <a:pPr algn="l">
+              <a:defRPr sz="1350" b="1">
+                <a:solidFill>
+                  <a:srgbClr val="66727E"/>
+                </a:solidFill>
+                <a:latin typeface="Aptos"/>
+                <a:ea typeface="Aptos"/>
+                <a:cs typeface="Aptos"/>
+              </a:defRPr>
+            </a:pPr>
+            <a:r>
+              <a:rPr sz="1350" b="1">
+                <a:solidFill>
+                  <a:srgbClr val="66727E"/>
+                </a:solidFill>
+                <a:latin typeface="Aptos"/>
+                <a:ea typeface="Aptos"/>
+                <a:cs typeface="Aptos"/>
+              </a:rPr>
+              <a:t>UniMoral model size and release date</a:t>
+            </a:r>
+          </a:p>
+        </p:txBody>
+      </p:sp>
+      <p:sp>
+        <p:nvSpPr>
+          <p:cNvPr id="7" name="">
+            <a:extLst xmlns:a="http://schemas.openxmlformats.org/drawingml/2006/main">
+              <a:ext uri="{FF2B5EF4-FFF2-40B4-BE49-F238E27FC236}">
+                <a16:creationId xmlns:a16="http://schemas.microsoft.com/office/drawing/2014/main" id="{7565B216-83EE-4937-840B-77F17C314425}"/>
+              </a:ext>
+            </a:extLst>
+          </p:cNvPr>
+          <p:cNvSpPr>
+            <a:spLocks xmlns:a="http://schemas.openxmlformats.org/drawingml/2006/main" noGrp="1"/>
+          </p:cNvSpPr>
+          <p:nvPr/>
+        </p:nvSpPr>
+        <p:spPr>
+          <a:xfrm xmlns:a="http://schemas.openxmlformats.org/drawingml/2006/main">
+            <a:off x="876300" y="4781550"/>
+            <a:ext cx="9620250" cy="495300"/>
           </a:xfrm>
           <a:prstGeom xmlns:a="http://schemas.openxmlformats.org/drawingml/2006/main" prst="rect">
             <a:avLst/>
@@ -2867,9 +3073,9 @@
           <a:lstStyle xmlns:a="http://schemas.openxmlformats.org/drawingml/2006/main"/>
           <a:p xmlns:a="http://schemas.openxmlformats.org/drawingml/2006/main">
             <a:pPr algn="l">
-              <a:defRPr sz="1800" b="1">
-                <a:solidFill>
-                  <a:srgbClr val="14856D"/>
+              <a:defRPr sz="1800" b="0">
+                <a:solidFill>
+                  <a:srgbClr val="17212B"/>
                 </a:solidFill>
                 <a:latin typeface="Aptos"/>
                 <a:ea typeface="Aptos"/>
@@ -2877,25 +3083,25 @@
               </a:defRPr>
             </a:pPr>
             <a:r>
-              <a:rPr sz="1800" b="1">
-                <a:solidFill>
-                  <a:srgbClr val="14856D"/>
+              <a:rPr sz="1800" b="0">
+                <a:solidFill>
+                  <a:srgbClr val="17212B"/>
                 </a:solidFill>
                 <a:latin typeface="Aptos"/>
                 <a:ea typeface="Aptos"/>
                 <a:cs typeface="Aptos"/>
               </a:rPr>
-              <a:t>CEI moral psychology benchmark</a:t>
+              <a:t>Scores move up and down across tasks. Bigger or newer is not consistently higher here.</a:t>
             </a:r>
           </a:p>
         </p:txBody>
       </p:sp>
       <p:sp>
         <p:nvSpPr>
-          <p:cNvPr id="3" name="">
+          <p:cNvPr id="8" name="">
             <a:extLst xmlns:a="http://schemas.openxmlformats.org/drawingml/2006/main">
               <a:ext uri="{FF2B5EF4-FFF2-40B4-BE49-F238E27FC236}">
-                <a16:creationId xmlns:a16="http://schemas.microsoft.com/office/drawing/2014/main" id="{B774F739-3AD5-434E-8109-566E8472B66A}"/>
+                <a16:creationId xmlns:a16="http://schemas.microsoft.com/office/drawing/2014/main" id="{E63FB30F-AD89-4243-B6AA-36879DD1609E}"/>
               </a:ext>
             </a:extLst>
           </p:cNvPr>
@@ -2906,8 +3112,8 @@
         </p:nvSpPr>
         <p:spPr>
           <a:xfrm xmlns:a="http://schemas.openxmlformats.org/drawingml/2006/main">
-            <a:off x="876300" y="3638550"/>
-            <a:ext cx="7239000" cy="323850"/>
+            <a:off x="876300" y="5962650"/>
+            <a:ext cx="7239000" cy="285750"/>
           </a:xfrm>
           <a:prstGeom xmlns:a="http://schemas.openxmlformats.org/drawingml/2006/main" prst="rect">
             <a:avLst/>
@@ -2924,7 +3130,7 @@
           <a:lstStyle xmlns:a="http://schemas.openxmlformats.org/drawingml/2006/main"/>
           <a:p xmlns:a="http://schemas.openxmlformats.org/drawingml/2006/main">
             <a:pPr algn="l">
-              <a:defRPr sz="1350" b="0">
+              <a:defRPr sz="1275" b="0">
                 <a:solidFill>
                   <a:srgbClr val="66727E"/>
                 </a:solidFill>
@@ -2934,7 +3140,7 @@
               </a:defRPr>
             </a:pPr>
             <a:r>
-              <a:rPr sz="1350" b="0">
+              <a:rPr sz="1275" b="0">
                 <a:solidFill>
                   <a:srgbClr val="66727E"/>
                 </a:solidFill>
@@ -2942,152 +3148,7 @@
                 <a:ea typeface="Aptos"/>
                 <a:cs typeface="Aptos"/>
               </a:rPr>
-              <a:t>Research lead readout · 4 September 2026</a:t>
-            </a:r>
-          </a:p>
-        </p:txBody>
-      </p:sp>
-      <p:sp>
-        <p:nvSpPr>
-          <p:cNvPr id="4" name="">
-            <a:extLst xmlns:a="http://schemas.openxmlformats.org/drawingml/2006/main">
-              <a:ext uri="{FF2B5EF4-FFF2-40B4-BE49-F238E27FC236}">
-                <a16:creationId xmlns:a16="http://schemas.microsoft.com/office/drawing/2014/main" id="{B5B6588A-05E0-4E9A-92F1-300E71A9DCEF}"/>
-              </a:ext>
-            </a:extLst>
-          </p:cNvPr>
-          <p:cNvSpPr>
-            <a:spLocks xmlns:a="http://schemas.openxmlformats.org/drawingml/2006/main" noGrp="1"/>
-          </p:cNvSpPr>
-          <p:nvPr/>
-        </p:nvSpPr>
-        <p:spPr>
-          <a:xfrm xmlns:a="http://schemas.openxmlformats.org/drawingml/2006/main">
-            <a:off x="876300" y="4514850"/>
-            <a:ext cx="6858000" cy="0"/>
-          </a:xfrm>
-          <a:prstGeom xmlns:a="http://schemas.openxmlformats.org/drawingml/2006/main" prst="line">
-            <a:avLst/>
-          </a:prstGeom>
-          <a:noFill xmlns:a="http://schemas.openxmlformats.org/drawingml/2006/main"/>
-          <a:ln xmlns:a="http://schemas.openxmlformats.org/drawingml/2006/main" w="19050">
-            <a:solidFill>
-              <a:srgbClr val="D8D9D5"/>
-            </a:solidFill>
-            <a:prstDash val="solid"/>
-          </a:ln>
-        </p:spPr>
-      </p:sp>
-      <p:sp>
-        <p:nvSpPr>
-          <p:cNvPr id="5" name="">
-            <a:extLst xmlns:a="http://schemas.openxmlformats.org/drawingml/2006/main">
-              <a:ext uri="{FF2B5EF4-FFF2-40B4-BE49-F238E27FC236}">
-                <a16:creationId xmlns:a16="http://schemas.microsoft.com/office/drawing/2014/main" id="{48F8E464-E400-4EE3-BE39-2F1AB1675E24}"/>
-              </a:ext>
-            </a:extLst>
-          </p:cNvPr>
-          <p:cNvSpPr>
-            <a:spLocks xmlns:a="http://schemas.openxmlformats.org/drawingml/2006/main" noGrp="1"/>
-          </p:cNvSpPr>
-          <p:nvPr/>
-        </p:nvSpPr>
-        <p:spPr>
-          <a:xfrm xmlns:a="http://schemas.openxmlformats.org/drawingml/2006/main">
-            <a:off x="876300" y="4762500"/>
-            <a:ext cx="9191625" cy="685800"/>
-          </a:xfrm>
-          <a:prstGeom xmlns:a="http://schemas.openxmlformats.org/drawingml/2006/main" prst="rect">
-            <a:avLst/>
-          </a:prstGeom>
-          <a:noFill xmlns:a="http://schemas.openxmlformats.org/drawingml/2006/main"/>
-          <a:ln xmlns:a="http://schemas.openxmlformats.org/drawingml/2006/main" w="0">
-            <a:noFill/>
-          </a:ln>
-        </p:spPr>
-        <p:txBody>
-          <a:bodyPr xmlns:a="http://schemas.openxmlformats.org/drawingml/2006/main">
-            <a:normAutofit fontScale="100000"/>
-          </a:bodyPr>
-          <a:lstStyle xmlns:a="http://schemas.openxmlformats.org/drawingml/2006/main"/>
-          <a:p xmlns:a="http://schemas.openxmlformats.org/drawingml/2006/main">
-            <a:pPr algn="l">
-              <a:defRPr sz="1800" b="0">
-                <a:solidFill>
-                  <a:srgbClr val="17212B"/>
-                </a:solidFill>
-                <a:latin typeface="Aptos"/>
-                <a:ea typeface="Aptos"/>
-                <a:cs typeface="Aptos"/>
-              </a:defRPr>
-            </a:pPr>
-            <a:r>
-              <a:rPr sz="1800" b="0">
-                <a:solidFill>
-                  <a:srgbClr val="17212B"/>
-                </a:solidFill>
-                <a:latin typeface="Aptos"/>
-                <a:ea typeface="Aptos"/>
-                <a:cs typeface="Aptos"/>
-              </a:rPr>
-              <a:t>Why: the highest saved score changes by task, and saved ranges overlap on both comparison tests.</a:t>
-            </a:r>
-          </a:p>
-        </p:txBody>
-      </p:sp>
-      <p:sp>
-        <p:nvSpPr>
-          <p:cNvPr id="6" name="">
-            <a:extLst xmlns:a="http://schemas.openxmlformats.org/drawingml/2006/main">
-              <a:ext uri="{FF2B5EF4-FFF2-40B4-BE49-F238E27FC236}">
-                <a16:creationId xmlns:a16="http://schemas.microsoft.com/office/drawing/2014/main" id="{92E1A050-B217-4957-9B48-58BF4E6D6FDD}"/>
-              </a:ext>
-            </a:extLst>
-          </p:cNvPr>
-          <p:cNvSpPr>
-            <a:spLocks xmlns:a="http://schemas.openxmlformats.org/drawingml/2006/main" noGrp="1"/>
-          </p:cNvSpPr>
-          <p:nvPr/>
-        </p:nvSpPr>
-        <p:spPr>
-          <a:xfrm xmlns:a="http://schemas.openxmlformats.org/drawingml/2006/main">
-            <a:off x="876300" y="5734050"/>
-            <a:ext cx="9334500" cy="342900"/>
-          </a:xfrm>
-          <a:prstGeom xmlns:a="http://schemas.openxmlformats.org/drawingml/2006/main" prst="rect">
-            <a:avLst/>
-          </a:prstGeom>
-          <a:noFill xmlns:a="http://schemas.openxmlformats.org/drawingml/2006/main"/>
-          <a:ln xmlns:a="http://schemas.openxmlformats.org/drawingml/2006/main" w="0">
-            <a:noFill/>
-          </a:ln>
-        </p:spPr>
-        <p:txBody>
-          <a:bodyPr xmlns:a="http://schemas.openxmlformats.org/drawingml/2006/main">
-            <a:normAutofit fontScale="100000"/>
-          </a:bodyPr>
-          <a:lstStyle xmlns:a="http://schemas.openxmlformats.org/drawingml/2006/main"/>
-          <a:p xmlns:a="http://schemas.openxmlformats.org/drawingml/2006/main">
-            <a:pPr algn="l">
-              <a:defRPr sz="1275" b="0">
-                <a:solidFill>
-                  <a:srgbClr val="66727E"/>
-                </a:solidFill>
-                <a:latin typeface="Aptos"/>
-                <a:ea typeface="Aptos"/>
-                <a:cs typeface="Aptos"/>
-              </a:defRPr>
-            </a:pPr>
-            <a:r>
-              <a:rPr sz="1275" b="0">
-                <a:solidFill>
-                  <a:srgbClr val="66727E"/>
-                </a:solidFill>
-                <a:latin typeface="Aptos"/>
-                <a:ea typeface="Aptos"/>
-                <a:cs typeface="Aptos"/>
-              </a:rPr>
-              <a:t>Share the task results with their limits. Size and release slides are early clues, not final answers.</a:t>
+              <a:t>CEI research lead readout · 4 September 2026</a:t>
             </a:r>
           </a:p>
         </p:txBody>
@@ -3095,7 +3156,7 @@
     </p:spTree>
     <p:extLst>
       <p:ext uri="{BB962C8B-B14F-4D97-AF65-F5344CB8AC3E}">
-        <p14:creationId xmlns:p14="http://schemas.microsoft.com/office/powerpoint/2010/main" val="2039316735"/>
+        <p14:creationId xmlns:p14="http://schemas.microsoft.com/office/powerpoint/2010/main" val="174859470"/>
       </p:ext>
     </p:extLst>
   </p:cSld>
@@ -3123,10 +3184,10 @@
       </p:grpSpPr>
       <p:sp>
         <p:nvSpPr>
-          <p:cNvPr id="8" name="slide-title">
+          <p:cNvPr id="7" name="slide-title">
             <a:extLst xmlns:a="http://schemas.openxmlformats.org/drawingml/2006/main">
               <a:ext uri="{FF2B5EF4-FFF2-40B4-BE49-F238E27FC236}">
-                <a16:creationId xmlns:a16="http://schemas.microsoft.com/office/drawing/2014/main" id="{D3124837-3F22-4673-B549-10372C670444}"/>
+                <a16:creationId xmlns:a16="http://schemas.microsoft.com/office/drawing/2014/main" id="{4B7C95B9-15FB-4A31-B477-9634D1EB2DBB}"/>
               </a:ext>
             </a:extLst>
           </p:cNvPr>
@@ -3138,7 +3199,7 @@
         <p:spPr>
           <a:xfrm xmlns:a="http://schemas.openxmlformats.org/drawingml/2006/main">
             <a:off x="685800" y="342900"/>
-            <a:ext cx="8667750" cy="590550"/>
+            <a:ext cx="10820400" cy="590550"/>
           </a:xfrm>
           <a:prstGeom xmlns:a="http://schemas.openxmlformats.org/drawingml/2006/main" prst="rect">
             <a:avLst/>
@@ -3150,7 +3211,7 @@
         </p:spPr>
         <p:txBody>
           <a:bodyPr xmlns:a="http://schemas.openxmlformats.org/drawingml/2006/main">
-            <a:normAutofit fontScale="93121"/>
+            <a:normAutofit fontScale="89937"/>
           </a:bodyPr>
           <a:lstStyle xmlns:a="http://schemas.openxmlformats.org/drawingml/2006/main"/>
           <a:p xmlns:a="http://schemas.openxmlformats.org/drawingml/2006/main">
@@ -3173,7 +3234,7 @@
                 <a:ea typeface="Aptos"/>
                 <a:cs typeface="Aptos"/>
               </a:rPr>
-              <a:t>No model has the highest saved score on all eight tasks</a:t>
+              <a:t>MoralBench + UniMoral: no model has the top saved score on all 8 tasks</a:t>
             </a:r>
           </a:p>
         </p:txBody>
@@ -3183,7 +3244,7 @@
           <p:cNvPr id="2" name="slide-subtitle">
             <a:extLst xmlns:a="http://schemas.openxmlformats.org/drawingml/2006/main">
               <a:ext uri="{FF2B5EF4-FFF2-40B4-BE49-F238E27FC236}">
-                <a16:creationId xmlns:a16="http://schemas.microsoft.com/office/drawing/2014/main" id="{85AB3CCF-57B6-4B6B-88DD-9CCB5DBFB01C}"/>
+                <a16:creationId xmlns:a16="http://schemas.microsoft.com/office/drawing/2014/main" id="{A4FDBF21-2B26-4529-A5DF-ACC035874FE3}"/>
               </a:ext>
             </a:extLst>
           </p:cNvPr>
@@ -3230,7 +3291,7 @@
                 <a:ea typeface="Aptos"/>
                 <a:cs typeface="Aptos"/>
               </a:rPr>
-              <a:t>Highest saved score for each task, using the same five models</a:t>
+              <a:t>CEI local result. Same five models; each row keeps its own score type.</a:t>
             </a:r>
           </a:p>
         </p:txBody>
@@ -3240,68 +3301,7 @@
           <p:cNvPr id="3" name="">
             <a:extLst xmlns:a="http://schemas.openxmlformats.org/drawingml/2006/main">
               <a:ext uri="{FF2B5EF4-FFF2-40B4-BE49-F238E27FC236}">
-                <a16:creationId xmlns:a16="http://schemas.microsoft.com/office/drawing/2014/main" id="{B75264BC-347A-40FB-AF41-C6CF1EE41D69}"/>
-              </a:ext>
-            </a:extLst>
-          </p:cNvPr>
-          <p:cNvSpPr>
-            <a:spLocks xmlns:a="http://schemas.openxmlformats.org/drawingml/2006/main" noGrp="1"/>
-          </p:cNvSpPr>
-          <p:nvPr/>
-        </p:nvSpPr>
-        <p:spPr>
-          <a:xfrm xmlns:a="http://schemas.openxmlformats.org/drawingml/2006/main">
-            <a:off x="9753600" y="381000"/>
-            <a:ext cx="1752600" cy="323850"/>
-          </a:xfrm>
-          <a:prstGeom xmlns:a="http://schemas.openxmlformats.org/drawingml/2006/main" prst="roundRect">
-            <a:avLst>
-              <a:gd name="adj" fmla="val 50000"/>
-            </a:avLst>
-          </a:prstGeom>
-          <a:solidFill xmlns:a="http://schemas.openxmlformats.org/drawingml/2006/main">
-            <a:srgbClr val="E3F0EB"/>
-          </a:solidFill>
-          <a:ln xmlns:a="http://schemas.openxmlformats.org/drawingml/2006/main" w="0">
-            <a:noFill/>
-          </a:ln>
-        </p:spPr>
-        <p:txBody>
-          <a:bodyPr xmlns:a="http://schemas.openxmlformats.org/drawingml/2006/main">
-            <a:normAutofit fontScale="92575"/>
-          </a:bodyPr>
-          <a:lstStyle xmlns:a="http://schemas.openxmlformats.org/drawingml/2006/main"/>
-          <a:p xmlns:a="http://schemas.openxmlformats.org/drawingml/2006/main">
-            <a:pPr algn="ctr">
-              <a:defRPr sz="975" b="1">
-                <a:solidFill>
-                  <a:srgbClr val="14856D"/>
-                </a:solidFill>
-                <a:latin typeface="Aptos"/>
-                <a:ea typeface="Aptos"/>
-                <a:cs typeface="Aptos"/>
-              </a:defRPr>
-            </a:pPr>
-            <a:r>
-              <a:rPr sz="975" b="1">
-                <a:solidFill>
-                  <a:srgbClr val="14856D"/>
-                </a:solidFill>
-                <a:latin typeface="Aptos"/>
-                <a:ea typeface="Aptos"/>
-                <a:cs typeface="Aptos"/>
-              </a:rPr>
-              <a:t>MAIN RESULTS</a:t>
-            </a:r>
-          </a:p>
-        </p:txBody>
-      </p:sp>
-      <p:sp>
-        <p:nvSpPr>
-          <p:cNvPr id="4" name="">
-            <a:extLst xmlns:a="http://schemas.openxmlformats.org/drawingml/2006/main">
-              <a:ext uri="{FF2B5EF4-FFF2-40B4-BE49-F238E27FC236}">
-                <a16:creationId xmlns:a16="http://schemas.microsoft.com/office/drawing/2014/main" id="{989E9A8E-C4E1-48A2-8E9E-9688218A42B0}"/>
+                <a16:creationId xmlns:a16="http://schemas.microsoft.com/office/drawing/2014/main" id="{F300AA86-FB8A-4439-A712-35F3ED7CDFD6}"/>
               </a:ext>
             </a:extLst>
           </p:cNvPr>
@@ -3329,7 +3329,7 @@
       </p:sp>
       <p:graphicFrame>
         <p:nvGraphicFramePr>
-          <p:cNvPr id="12" name=""/>
+          <p:cNvPr id="10" name=""/>
           <p:cNvGraphicFramePr/>
           <p:nvPr/>
         </p:nvGraphicFramePr>
@@ -3539,7 +3539,7 @@
                       <a:r>
                         <a:rPr sz="1275" b="1">
                           <a:solidFill>
-                            <a:srgbClr val="14856D"/>
+                            <a:srgbClr val="17212B"/>
                           </a:solidFill>
                           <a:latin typeface="Aptos"/>
                           <a:ea typeface="Aptos"/>
@@ -3551,7 +3551,7 @@
                   </a:txBody>
                   <a:tcPr marL="114300" marR="114300" marT="66675" marB="66675">
                     <a:solidFill>
-                      <a:srgbClr val="E3F0EB"/>
+                      <a:srgbClr val="FFFFFF"/>
                     </a:solidFill>
                   </a:tcPr>
                 </a:tc>
@@ -3650,7 +3650,7 @@
                       <a:r>
                         <a:rPr sz="1275" b="1">
                           <a:solidFill>
-                            <a:srgbClr val="14856D"/>
+                            <a:srgbClr val="17212B"/>
                           </a:solidFill>
                           <a:latin typeface="Aptos"/>
                           <a:ea typeface="Aptos"/>
@@ -3662,7 +3662,7 @@
                   </a:txBody>
                   <a:tcPr marL="114300" marR="114300" marT="66675" marB="66675">
                     <a:solidFill>
-                      <a:srgbClr val="E3F0EB"/>
+                      <a:srgbClr val="FFFFFF"/>
                     </a:solidFill>
                   </a:tcPr>
                 </a:tc>
@@ -3761,7 +3761,7 @@
                       <a:r>
                         <a:rPr sz="1275" b="1">
                           <a:solidFill>
-                            <a:srgbClr val="8B5F00"/>
+                            <a:srgbClr val="17212B"/>
                           </a:solidFill>
                           <a:latin typeface="Aptos"/>
                           <a:ea typeface="Aptos"/>
@@ -3773,7 +3773,7 @@
                   </a:txBody>
                   <a:tcPr marL="114300" marR="114300" marT="66675" marB="66675">
                     <a:solidFill>
-                      <a:srgbClr val="F5EACF"/>
+                      <a:srgbClr val="FFFFFF"/>
                     </a:solidFill>
                   </a:tcPr>
                 </a:tc>
@@ -3872,7 +3872,7 @@
                       <a:r>
                         <a:rPr sz="1275" b="1">
                           <a:solidFill>
-                            <a:srgbClr val="8B5F00"/>
+                            <a:srgbClr val="17212B"/>
                           </a:solidFill>
                           <a:latin typeface="Aptos"/>
                           <a:ea typeface="Aptos"/>
@@ -3884,7 +3884,7 @@
                   </a:txBody>
                   <a:tcPr marL="114300" marR="114300" marT="66675" marB="66675">
                     <a:solidFill>
-                      <a:srgbClr val="F5EACF"/>
+                      <a:srgbClr val="FFFFFF"/>
                     </a:solidFill>
                   </a:tcPr>
                 </a:tc>
@@ -3983,7 +3983,7 @@
                       <a:r>
                         <a:rPr sz="1275" b="1">
                           <a:solidFill>
-                            <a:srgbClr val="6E5AA8"/>
+                            <a:srgbClr val="17212B"/>
                           </a:solidFill>
                           <a:latin typeface="Aptos"/>
                           <a:ea typeface="Aptos"/>
@@ -3995,7 +3995,7 @@
                   </a:txBody>
                   <a:tcPr marL="114300" marR="114300" marT="66675" marB="66675">
                     <a:solidFill>
-                      <a:srgbClr val="EBE6F4"/>
+                      <a:srgbClr val="FFFFFF"/>
                     </a:solidFill>
                   </a:tcPr>
                 </a:tc>
@@ -4094,7 +4094,7 @@
                       <a:r>
                         <a:rPr sz="1275" b="1">
                           <a:solidFill>
-                            <a:srgbClr val="6E5AA8"/>
+                            <a:srgbClr val="17212B"/>
                           </a:solidFill>
                           <a:latin typeface="Aptos"/>
                           <a:ea typeface="Aptos"/>
@@ -4106,7 +4106,7 @@
                   </a:txBody>
                   <a:tcPr marL="114300" marR="114300" marT="66675" marB="66675">
                     <a:solidFill>
-                      <a:srgbClr val="EBE6F4"/>
+                      <a:srgbClr val="FFFFFF"/>
                     </a:solidFill>
                   </a:tcPr>
                 </a:tc>
@@ -4205,7 +4205,7 @@
                       <a:r>
                         <a:rPr sz="1275" b="1">
                           <a:solidFill>
-                            <a:srgbClr val="6E5AA8"/>
+                            <a:srgbClr val="17212B"/>
                           </a:solidFill>
                           <a:latin typeface="Aptos"/>
                           <a:ea typeface="Aptos"/>
@@ -4217,7 +4217,7 @@
                   </a:txBody>
                   <a:tcPr marL="114300" marR="114300" marT="66675" marB="66675">
                     <a:solidFill>
-                      <a:srgbClr val="EBE6F4"/>
+                      <a:srgbClr val="FFFFFF"/>
                     </a:solidFill>
                   </a:tcPr>
                 </a:tc>
@@ -4316,7 +4316,7 @@
                       <a:r>
                         <a:rPr sz="1275" b="1">
                           <a:solidFill>
-                            <a:srgbClr val="6E5AA8"/>
+                            <a:srgbClr val="17212B"/>
                           </a:solidFill>
                           <a:latin typeface="Aptos"/>
                           <a:ea typeface="Aptos"/>
@@ -4328,7 +4328,7 @@
                   </a:txBody>
                   <a:tcPr marL="114300" marR="114300" marT="66675" marB="66675">
                     <a:solidFill>
-                      <a:srgbClr val="EBE6F4"/>
+                      <a:srgbClr val="FFFFFF"/>
                     </a:solidFill>
                   </a:tcPr>
                 </a:tc>
@@ -4339,10 +4339,10 @@
       </p:graphicFrame>
       <p:sp>
         <p:nvSpPr>
-          <p:cNvPr id="6" name="">
+          <p:cNvPr id="5" name="">
             <a:extLst xmlns:a="http://schemas.openxmlformats.org/drawingml/2006/main">
               <a:ext uri="{FF2B5EF4-FFF2-40B4-BE49-F238E27FC236}">
-                <a16:creationId xmlns:a16="http://schemas.microsoft.com/office/drawing/2014/main" id="{1B07DCC3-9F79-4F01-82E7-7F3EDD3DD07B}"/>
+                <a16:creationId xmlns:a16="http://schemas.microsoft.com/office/drawing/2014/main" id="{D8DD7EDE-F52A-41E6-B2E1-5F35C6CB7E7F}"/>
               </a:ext>
             </a:extLst>
           </p:cNvPr>
@@ -4389,17 +4389,17 @@
                 <a:ea typeface="Aptos"/>
                 <a:cs typeface="Aptos"/>
               </a:rPr>
-              <a:t>† Marginal ranges overlap on both comparison tasks; paired question results are unavailable, so no leader is resolved.</a:t>
+              <a:t>† Every 95% range overlaps on both MoralBench comparison tasks. The apparent leaders are unresolved.</a:t>
             </a:r>
           </a:p>
         </p:txBody>
       </p:sp>
       <p:sp>
         <p:nvSpPr>
-          <p:cNvPr id="7" name="">
+          <p:cNvPr id="6" name="">
             <a:extLst xmlns:a="http://schemas.openxmlformats.org/drawingml/2006/main">
               <a:ext uri="{FF2B5EF4-FFF2-40B4-BE49-F238E27FC236}">
-                <a16:creationId xmlns:a16="http://schemas.microsoft.com/office/drawing/2014/main" id="{7A9E6B29-E48A-4224-B7DB-6924751A08C0}"/>
+                <a16:creationId xmlns:a16="http://schemas.microsoft.com/office/drawing/2014/main" id="{47F97706-3849-4E85-95B4-44907F167D9C}"/>
               </a:ext>
             </a:extLst>
           </p:cNvPr>
@@ -4454,7 +4454,7 @@
     </p:spTree>
     <p:extLst>
       <p:ext uri="{BB962C8B-B14F-4D97-AF65-F5344CB8AC3E}">
-        <p14:creationId xmlns:p14="http://schemas.microsoft.com/office/powerpoint/2010/main" val="973734667"/>
+        <p14:creationId xmlns:p14="http://schemas.microsoft.com/office/powerpoint/2010/main" val="1755956548"/>
       </p:ext>
     </p:extLst>
   </p:cSld>
@@ -4482,10 +4482,10 @@
       </p:grpSpPr>
       <p:sp>
         <p:nvSpPr>
-          <p:cNvPr id="21" name="slide-title">
+          <p:cNvPr id="13" name="slide-title">
             <a:extLst xmlns:a="http://schemas.openxmlformats.org/drawingml/2006/main">
               <a:ext uri="{FF2B5EF4-FFF2-40B4-BE49-F238E27FC236}">
-                <a16:creationId xmlns:a16="http://schemas.microsoft.com/office/drawing/2014/main" id="{8EF16273-9E53-4238-91E7-A693AC6D15A6}"/>
+                <a16:creationId xmlns:a16="http://schemas.microsoft.com/office/drawing/2014/main" id="{2607AA0D-9E2E-4261-9530-FC0825E25E0F}"/>
               </a:ext>
             </a:extLst>
           </p:cNvPr>
@@ -4497,7 +4497,7 @@
         <p:spPr>
           <a:xfrm xmlns:a="http://schemas.openxmlformats.org/drawingml/2006/main">
             <a:off x="685800" y="342900"/>
-            <a:ext cx="8667750" cy="590550"/>
+            <a:ext cx="10820400" cy="590550"/>
           </a:xfrm>
           <a:prstGeom xmlns:a="http://schemas.openxmlformats.org/drawingml/2006/main" prst="rect">
             <a:avLst/>
@@ -4509,7 +4509,7 @@
         </p:spPr>
         <p:txBody>
           <a:bodyPr xmlns:a="http://schemas.openxmlformats.org/drawingml/2006/main">
-            <a:normAutofit fontScale="92707"/>
+            <a:normAutofit fontScale="95546"/>
           </a:bodyPr>
           <a:lstStyle xmlns:a="http://schemas.openxmlformats.org/drawingml/2006/main"/>
           <a:p xmlns:a="http://schemas.openxmlformats.org/drawingml/2006/main">
@@ -4532,7 +4532,7 @@
                 <a:ea typeface="Aptos"/>
                 <a:cs typeface="Aptos"/>
               </a:rPr>
-              <a:t>Saved ranges overlap for every model pair on both tests</a:t>
+              <a:t>MoralBench: each pair of models has overlapping 95% score ranges</a:t>
             </a:r>
           </a:p>
         </p:txBody>
@@ -4542,7 +4542,7 @@
           <p:cNvPr id="2" name="slide-subtitle">
             <a:extLst xmlns:a="http://schemas.openxmlformats.org/drawingml/2006/main">
               <a:ext uri="{FF2B5EF4-FFF2-40B4-BE49-F238E27FC236}">
-                <a16:creationId xmlns:a16="http://schemas.microsoft.com/office/drawing/2014/main" id="{D337D4ED-D378-4998-83D6-90C62D087F1B}"/>
+                <a16:creationId xmlns:a16="http://schemas.microsoft.com/office/drawing/2014/main" id="{85BA3555-5F82-4BC2-B96E-6E7EE4D855E1}"/>
               </a:ext>
             </a:extLst>
           </p:cNvPr>
@@ -4589,7 +4589,7 @@
                 <a:ea typeface="Aptos"/>
                 <a:cs typeface="Aptos"/>
               </a:rPr>
-              <a:t>Full primary panels: MFQ = 8 models × 20 questions; Vignette = 10 × 24.</a:t>
+              <a:t>CEI local result. MFQ uses 8 models and 20 questions. Vignettes use 10 models and 24 questions.</a:t>
             </a:r>
           </a:p>
         </p:txBody>
@@ -4599,68 +4599,7 @@
           <p:cNvPr id="3" name="">
             <a:extLst xmlns:a="http://schemas.openxmlformats.org/drawingml/2006/main">
               <a:ext uri="{FF2B5EF4-FFF2-40B4-BE49-F238E27FC236}">
-                <a16:creationId xmlns:a16="http://schemas.microsoft.com/office/drawing/2014/main" id="{A5898259-B746-41C4-AD46-0A8F3D3C17E8}"/>
-              </a:ext>
-            </a:extLst>
-          </p:cNvPr>
-          <p:cNvSpPr>
-            <a:spLocks xmlns:a="http://schemas.openxmlformats.org/drawingml/2006/main" noGrp="1"/>
-          </p:cNvSpPr>
-          <p:nvPr/>
-        </p:nvSpPr>
-        <p:spPr>
-          <a:xfrm xmlns:a="http://schemas.openxmlformats.org/drawingml/2006/main">
-            <a:off x="9753600" y="381000"/>
-            <a:ext cx="1752600" cy="323850"/>
-          </a:xfrm>
-          <a:prstGeom xmlns:a="http://schemas.openxmlformats.org/drawingml/2006/main" prst="roundRect">
-            <a:avLst>
-              <a:gd name="adj" fmla="val 50000"/>
-            </a:avLst>
-          </a:prstGeom>
-          <a:solidFill xmlns:a="http://schemas.openxmlformats.org/drawingml/2006/main">
-            <a:srgbClr val="E3F0EB"/>
-          </a:solidFill>
-          <a:ln xmlns:a="http://schemas.openxmlformats.org/drawingml/2006/main" w="0">
-            <a:noFill/>
-          </a:ln>
-        </p:spPr>
-        <p:txBody>
-          <a:bodyPr xmlns:a="http://schemas.openxmlformats.org/drawingml/2006/main">
-            <a:normAutofit fontScale="92575"/>
-          </a:bodyPr>
-          <a:lstStyle xmlns:a="http://schemas.openxmlformats.org/drawingml/2006/main"/>
-          <a:p xmlns:a="http://schemas.openxmlformats.org/drawingml/2006/main">
-            <a:pPr algn="ctr">
-              <a:defRPr sz="975" b="1">
-                <a:solidFill>
-                  <a:srgbClr val="14856D"/>
-                </a:solidFill>
-                <a:latin typeface="Aptos"/>
-                <a:ea typeface="Aptos"/>
-                <a:cs typeface="Aptos"/>
-              </a:defRPr>
-            </a:pPr>
-            <a:r>
-              <a:rPr sz="975" b="1">
-                <a:solidFill>
-                  <a:srgbClr val="14856D"/>
-                </a:solidFill>
-                <a:latin typeface="Aptos"/>
-                <a:ea typeface="Aptos"/>
-                <a:cs typeface="Aptos"/>
-              </a:rPr>
-              <a:t>MAIN RESULTS</a:t>
-            </a:r>
-          </a:p>
-        </p:txBody>
-      </p:sp>
-      <p:sp>
-        <p:nvSpPr>
-          <p:cNvPr id="4" name="">
-            <a:extLst xmlns:a="http://schemas.openxmlformats.org/drawingml/2006/main">
-              <a:ext uri="{FF2B5EF4-FFF2-40B4-BE49-F238E27FC236}">
-                <a16:creationId xmlns:a16="http://schemas.microsoft.com/office/drawing/2014/main" id="{D1242AFC-D0AB-473D-8F4C-C5C2C8F3144C}"/>
+                <a16:creationId xmlns:a16="http://schemas.microsoft.com/office/drawing/2014/main" id="{9828ED08-D599-4894-9AC0-2768D8713FE3}"/>
               </a:ext>
             </a:extLst>
           </p:cNvPr>
@@ -4688,10 +4627,10 @@
       </p:sp>
       <p:sp>
         <p:nvSpPr>
-          <p:cNvPr id="5" name="">
+          <p:cNvPr id="4" name="">
             <a:extLst xmlns:a="http://schemas.openxmlformats.org/drawingml/2006/main">
               <a:ext uri="{FF2B5EF4-FFF2-40B4-BE49-F238E27FC236}">
-                <a16:creationId xmlns:a16="http://schemas.microsoft.com/office/drawing/2014/main" id="{DD7E59F9-2A7E-428C-B4A0-10C8E3236BE0}"/>
+                <a16:creationId xmlns:a16="http://schemas.microsoft.com/office/drawing/2014/main" id="{E3262D1B-8147-43B6-89BD-C89509D0B4A1}"/>
               </a:ext>
             </a:extLst>
           </p:cNvPr>
@@ -4702,100 +4641,8 @@
         </p:nvSpPr>
         <p:spPr>
           <a:xfrm xmlns:a="http://schemas.openxmlformats.org/drawingml/2006/main">
-            <a:off x="1143000" y="1419225"/>
-            <a:ext cx="9810750" cy="209550"/>
-          </a:xfrm>
-          <a:prstGeom xmlns:a="http://schemas.openxmlformats.org/drawingml/2006/main" prst="rect">
-            <a:avLst/>
-          </a:prstGeom>
-          <a:noFill xmlns:a="http://schemas.openxmlformats.org/drawingml/2006/main"/>
-          <a:ln xmlns:a="http://schemas.openxmlformats.org/drawingml/2006/main" w="0">
-            <a:noFill/>
-          </a:ln>
-        </p:spPr>
-        <p:txBody>
-          <a:bodyPr xmlns:a="http://schemas.openxmlformats.org/drawingml/2006/main">
-            <a:normAutofit fontScale="68889"/>
-          </a:bodyPr>
-          <a:lstStyle xmlns:a="http://schemas.openxmlformats.org/drawingml/2006/main"/>
-          <a:p xmlns:a="http://schemas.openxmlformats.org/drawingml/2006/main">
-            <a:pPr algn="l">
-              <a:defRPr sz="1125" b="0">
-                <a:solidFill>
-                  <a:srgbClr val="66727E"/>
-                </a:solidFill>
-                <a:latin typeface="Aptos"/>
-                <a:ea typeface="Aptos"/>
-                <a:cs typeface="Aptos"/>
-              </a:defRPr>
-            </a:pPr>
-            <a:r>
-              <a:rPr sz="1125" b="0">
-                <a:solidFill>
-                  <a:srgbClr val="66727E"/>
-                </a:solidFill>
-                <a:latin typeface="Aptos"/>
-                <a:ea typeface="Aptos"/>
-                <a:cs typeface="Aptos"/>
-              </a:rPr>
-              <a:t>Each card = share of model pairs whose saved marginal 95% ranges overlap.</a:t>
-            </a:r>
-          </a:p>
-        </p:txBody>
-      </p:sp>
-      <p:sp>
-        <p:nvSpPr>
-          <p:cNvPr id="6" name="">
-            <a:extLst xmlns:a="http://schemas.openxmlformats.org/drawingml/2006/main">
-              <a:ext uri="{FF2B5EF4-FFF2-40B4-BE49-F238E27FC236}">
-                <a16:creationId xmlns:a16="http://schemas.microsoft.com/office/drawing/2014/main" id="{2CA8D7A7-36F6-42D1-8423-801C47E42239}"/>
-              </a:ext>
-            </a:extLst>
-          </p:cNvPr>
-          <p:cNvSpPr>
-            <a:spLocks xmlns:a="http://schemas.openxmlformats.org/drawingml/2006/main" noGrp="1"/>
-          </p:cNvSpPr>
-          <p:nvPr/>
-        </p:nvSpPr>
-        <p:spPr>
-          <a:xfrm xmlns:a="http://schemas.openxmlformats.org/drawingml/2006/main">
-            <a:off x="1143000" y="1781175"/>
-            <a:ext cx="4572000" cy="2238375"/>
-          </a:xfrm>
-          <a:prstGeom xmlns:a="http://schemas.openxmlformats.org/drawingml/2006/main" prst="roundRect">
-            <a:avLst>
-              <a:gd name="adj" fmla="val 7660"/>
-            </a:avLst>
-          </a:prstGeom>
-          <a:solidFill xmlns:a="http://schemas.openxmlformats.org/drawingml/2006/main">
-            <a:srgbClr val="F6E5E0"/>
-          </a:solidFill>
-          <a:ln xmlns:a="http://schemas.openxmlformats.org/drawingml/2006/main" w="19050">
-            <a:solidFill>
-              <a:srgbClr val="CF5D4A"/>
-            </a:solidFill>
-            <a:prstDash val="solid"/>
-          </a:ln>
-        </p:spPr>
-      </p:sp>
-      <p:sp>
-        <p:nvSpPr>
-          <p:cNvPr id="7" name="">
-            <a:extLst xmlns:a="http://schemas.openxmlformats.org/drawingml/2006/main">
-              <a:ext uri="{FF2B5EF4-FFF2-40B4-BE49-F238E27FC236}">
-                <a16:creationId xmlns:a16="http://schemas.microsoft.com/office/drawing/2014/main" id="{993D93EC-2842-4C01-BB69-F4ECDFFDB932}"/>
-              </a:ext>
-            </a:extLst>
-          </p:cNvPr>
-          <p:cNvSpPr>
-            <a:spLocks xmlns:a="http://schemas.openxmlformats.org/drawingml/2006/main" noGrp="1"/>
-          </p:cNvSpPr>
-          <p:nvPr/>
-        </p:nvSpPr>
-        <p:spPr>
-          <a:xfrm xmlns:a="http://schemas.openxmlformats.org/drawingml/2006/main">
-            <a:off x="1428750" y="2000250"/>
-            <a:ext cx="4000500" cy="323850"/>
+            <a:off x="1047750" y="1905000"/>
+            <a:ext cx="4381500" cy="323850"/>
           </a:xfrm>
           <a:prstGeom xmlns:a="http://schemas.openxmlformats.org/drawingml/2006/main" prst="rect">
             <a:avLst/>
@@ -4830,17 +4677,17 @@
                 <a:ea typeface="Aptos"/>
                 <a:cs typeface="Aptos"/>
               </a:rPr>
-              <a:t>MFQ compare</a:t>
+              <a:t>MFQ value statements</a:t>
             </a:r>
           </a:p>
         </p:txBody>
       </p:sp>
       <p:sp>
         <p:nvSpPr>
-          <p:cNvPr id="8" name="">
+          <p:cNvPr id="5" name="">
             <a:extLst xmlns:a="http://schemas.openxmlformats.org/drawingml/2006/main">
               <a:ext uri="{FF2B5EF4-FFF2-40B4-BE49-F238E27FC236}">
-                <a16:creationId xmlns:a16="http://schemas.microsoft.com/office/drawing/2014/main" id="{8F4E957D-8BA9-49B4-8F7E-CB620A156E5B}"/>
+                <a16:creationId xmlns:a16="http://schemas.microsoft.com/office/drawing/2014/main" id="{6491B9BB-944C-4BDE-BE4F-6B6D80DCA808}"/>
               </a:ext>
             </a:extLst>
           </p:cNvPr>
@@ -4851,8 +4698,8 @@
         </p:nvSpPr>
         <p:spPr>
           <a:xfrm xmlns:a="http://schemas.openxmlformats.org/drawingml/2006/main">
-            <a:off x="1428750" y="2381250"/>
-            <a:ext cx="4000500" cy="723900"/>
+            <a:off x="1047750" y="2400300"/>
+            <a:ext cx="4381500" cy="762000"/>
           </a:xfrm>
           <a:prstGeom xmlns:a="http://schemas.openxmlformats.org/drawingml/2006/main" prst="rect">
             <a:avLst/>
@@ -4869,7 +4716,7 @@
           <a:lstStyle xmlns:a="http://schemas.openxmlformats.org/drawingml/2006/main"/>
           <a:p xmlns:a="http://schemas.openxmlformats.org/drawingml/2006/main">
             <a:pPr algn="ctr">
-              <a:defRPr sz="4050" b="1">
+              <a:defRPr sz="4350" b="1">
                 <a:solidFill>
                   <a:srgbClr val="CF5D4A"/>
                 </a:solidFill>
@@ -4879,7 +4726,7 @@
               </a:defRPr>
             </a:pPr>
             <a:r>
-              <a:rPr sz="4050" b="1">
+              <a:rPr sz="4350" b="1">
                 <a:solidFill>
                   <a:srgbClr val="CF5D4A"/>
                 </a:solidFill>
@@ -4887,17 +4734,17 @@
                 <a:ea typeface="Aptos"/>
                 <a:cs typeface="Aptos"/>
               </a:rPr>
-              <a:t>100%</a:t>
+              <a:t>28 / 28</a:t>
             </a:r>
           </a:p>
         </p:txBody>
       </p:sp>
       <p:sp>
         <p:nvSpPr>
-          <p:cNvPr id="9" name="">
+          <p:cNvPr id="6" name="">
             <a:extLst xmlns:a="http://schemas.openxmlformats.org/drawingml/2006/main">
               <a:ext uri="{FF2B5EF4-FFF2-40B4-BE49-F238E27FC236}">
-                <a16:creationId xmlns:a16="http://schemas.microsoft.com/office/drawing/2014/main" id="{ED381BAB-DEE1-4D6B-A41B-40C7775AE75F}"/>
+                <a16:creationId xmlns:a16="http://schemas.microsoft.com/office/drawing/2014/main" id="{30766F2A-3E88-4AA5-A04A-FFD03B3B5432}"/>
               </a:ext>
             </a:extLst>
           </p:cNvPr>
@@ -4908,8 +4755,8 @@
         </p:nvSpPr>
         <p:spPr>
           <a:xfrm xmlns:a="http://schemas.openxmlformats.org/drawingml/2006/main">
-            <a:off x="1428750" y="3143250"/>
-            <a:ext cx="4000500" cy="304800"/>
+            <a:off x="1047750" y="3257550"/>
+            <a:ext cx="4381500" cy="400050"/>
           </a:xfrm>
           <a:prstGeom xmlns:a="http://schemas.openxmlformats.org/drawingml/2006/main" prst="rect">
             <a:avLst/>
@@ -4921,12 +4768,12 @@
         </p:spPr>
         <p:txBody>
           <a:bodyPr xmlns:a="http://schemas.openxmlformats.org/drawingml/2006/main">
-            <a:normAutofit fontScale="98246"/>
+            <a:normAutofit fontScale="100000"/>
           </a:bodyPr>
           <a:lstStyle xmlns:a="http://schemas.openxmlformats.org/drawingml/2006/main"/>
           <a:p xmlns:a="http://schemas.openxmlformats.org/drawingml/2006/main">
             <a:pPr algn="ctr">
-              <a:defRPr sz="1425" b="1">
+              <a:defRPr sz="1350" b="0">
                 <a:solidFill>
                   <a:srgbClr val="17212B"/>
                 </a:solidFill>
@@ -4936,7 +4783,7 @@
               </a:defRPr>
             </a:pPr>
             <a:r>
-              <a:rPr sz="1425" b="1">
+              <a:rPr sz="1350" b="0">
                 <a:solidFill>
                   <a:srgbClr val="17212B"/>
                 </a:solidFill>
@@ -4944,17 +4791,17 @@
                 <a:ea typeface="Aptos"/>
                 <a:cs typeface="Aptos"/>
               </a:rPr>
-              <a:t>28 of 28 model pairs</a:t>
+              <a:t>model pairs have overlapping 95% score ranges</a:t>
             </a:r>
           </a:p>
         </p:txBody>
       </p:sp>
       <p:sp>
         <p:nvSpPr>
-          <p:cNvPr id="10" name="">
+          <p:cNvPr id="7" name="">
             <a:extLst xmlns:a="http://schemas.openxmlformats.org/drawingml/2006/main">
               <a:ext uri="{FF2B5EF4-FFF2-40B4-BE49-F238E27FC236}">
-                <a16:creationId xmlns:a16="http://schemas.microsoft.com/office/drawing/2014/main" id="{DE3203E7-91D9-4FCA-AB93-3DC959BED55A}"/>
+                <a16:creationId xmlns:a16="http://schemas.microsoft.com/office/drawing/2014/main" id="{1F72F27C-4F6B-4C5A-9116-416F6EAF9A4C}"/>
               </a:ext>
             </a:extLst>
           </p:cNvPr>
@@ -4965,100 +4812,8 @@
         </p:nvSpPr>
         <p:spPr>
           <a:xfrm xmlns:a="http://schemas.openxmlformats.org/drawingml/2006/main">
-            <a:off x="1428750" y="3505200"/>
-            <a:ext cx="4000500" cy="247650"/>
-          </a:xfrm>
-          <a:prstGeom xmlns:a="http://schemas.openxmlformats.org/drawingml/2006/main" prst="rect">
-            <a:avLst/>
-          </a:prstGeom>
-          <a:noFill xmlns:a="http://schemas.openxmlformats.org/drawingml/2006/main"/>
-          <a:ln xmlns:a="http://schemas.openxmlformats.org/drawingml/2006/main" w="0">
-            <a:noFill/>
-          </a:ln>
-        </p:spPr>
-        <p:txBody>
-          <a:bodyPr xmlns:a="http://schemas.openxmlformats.org/drawingml/2006/main">
-            <a:normAutofit fontScale="91111"/>
-          </a:bodyPr>
-          <a:lstStyle xmlns:a="http://schemas.openxmlformats.org/drawingml/2006/main"/>
-          <a:p xmlns:a="http://schemas.openxmlformats.org/drawingml/2006/main">
-            <a:pPr algn="ctr">
-              <a:defRPr sz="1125" b="0">
-                <a:solidFill>
-                  <a:srgbClr val="66727E"/>
-                </a:solidFill>
-                <a:latin typeface="Aptos"/>
-                <a:ea typeface="Aptos"/>
-                <a:cs typeface="Aptos"/>
-              </a:defRPr>
-            </a:pPr>
-            <a:r>
-              <a:rPr sz="1125" b="0">
-                <a:solidFill>
-                  <a:srgbClr val="66727E"/>
-                </a:solidFill>
-                <a:latin typeface="Aptos"/>
-                <a:ea typeface="Aptos"/>
-                <a:cs typeface="Aptos"/>
-              </a:rPr>
-              <a:t>saved marginal ranges overlap</a:t>
-            </a:r>
-          </a:p>
-        </p:txBody>
-      </p:sp>
-      <p:sp>
-        <p:nvSpPr>
-          <p:cNvPr id="11" name="">
-            <a:extLst xmlns:a="http://schemas.openxmlformats.org/drawingml/2006/main">
-              <a:ext uri="{FF2B5EF4-FFF2-40B4-BE49-F238E27FC236}">
-                <a16:creationId xmlns:a16="http://schemas.microsoft.com/office/drawing/2014/main" id="{B672D9A1-5E1D-4E7D-8B94-5FCC3374839E}"/>
-              </a:ext>
-            </a:extLst>
-          </p:cNvPr>
-          <p:cNvSpPr>
-            <a:spLocks xmlns:a="http://schemas.openxmlformats.org/drawingml/2006/main" noGrp="1"/>
-          </p:cNvSpPr>
-          <p:nvPr/>
-        </p:nvSpPr>
-        <p:spPr>
-          <a:xfrm xmlns:a="http://schemas.openxmlformats.org/drawingml/2006/main">
-            <a:off x="6191250" y="1781175"/>
-            <a:ext cx="4572000" cy="2238375"/>
-          </a:xfrm>
-          <a:prstGeom xmlns:a="http://schemas.openxmlformats.org/drawingml/2006/main" prst="roundRect">
-            <a:avLst>
-              <a:gd name="adj" fmla="val 7660"/>
-            </a:avLst>
-          </a:prstGeom>
-          <a:solidFill xmlns:a="http://schemas.openxmlformats.org/drawingml/2006/main">
-            <a:srgbClr val="F6E5E0"/>
-          </a:solidFill>
-          <a:ln xmlns:a="http://schemas.openxmlformats.org/drawingml/2006/main" w="19050">
-            <a:solidFill>
-              <a:srgbClr val="CF5D4A"/>
-            </a:solidFill>
-            <a:prstDash val="solid"/>
-          </a:ln>
-        </p:spPr>
-      </p:sp>
-      <p:sp>
-        <p:nvSpPr>
-          <p:cNvPr id="12" name="">
-            <a:extLst xmlns:a="http://schemas.openxmlformats.org/drawingml/2006/main">
-              <a:ext uri="{FF2B5EF4-FFF2-40B4-BE49-F238E27FC236}">
-                <a16:creationId xmlns:a16="http://schemas.microsoft.com/office/drawing/2014/main" id="{53164EC5-1327-4432-BCD5-31895AE63E9F}"/>
-              </a:ext>
-            </a:extLst>
-          </p:cNvPr>
-          <p:cNvSpPr>
-            <a:spLocks xmlns:a="http://schemas.openxmlformats.org/drawingml/2006/main" noGrp="1"/>
-          </p:cNvSpPr>
-          <p:nvPr/>
-        </p:nvSpPr>
-        <p:spPr>
-          <a:xfrm xmlns:a="http://schemas.openxmlformats.org/drawingml/2006/main">
-            <a:off x="6477000" y="2000250"/>
-            <a:ext cx="4000500" cy="323850"/>
+            <a:off x="6762750" y="1905000"/>
+            <a:ext cx="4381500" cy="323850"/>
           </a:xfrm>
           <a:prstGeom xmlns:a="http://schemas.openxmlformats.org/drawingml/2006/main" prst="rect">
             <a:avLst/>
@@ -5093,17 +4848,17 @@
                 <a:ea typeface="Aptos"/>
                 <a:cs typeface="Aptos"/>
               </a:rPr>
-              <a:t>Vignette compare</a:t>
+              <a:t>Moral vignettes</a:t>
             </a:r>
           </a:p>
         </p:txBody>
       </p:sp>
       <p:sp>
         <p:nvSpPr>
-          <p:cNvPr id="13" name="">
+          <p:cNvPr id="8" name="">
             <a:extLst xmlns:a="http://schemas.openxmlformats.org/drawingml/2006/main">
               <a:ext uri="{FF2B5EF4-FFF2-40B4-BE49-F238E27FC236}">
-                <a16:creationId xmlns:a16="http://schemas.microsoft.com/office/drawing/2014/main" id="{4483DEB5-C95E-4648-A67C-9D98C8EC2B65}"/>
+                <a16:creationId xmlns:a16="http://schemas.microsoft.com/office/drawing/2014/main" id="{D2D11D44-17E2-41F8-B0A4-C6F57EF85DC9}"/>
               </a:ext>
             </a:extLst>
           </p:cNvPr>
@@ -5114,8 +4869,8 @@
         </p:nvSpPr>
         <p:spPr>
           <a:xfrm xmlns:a="http://schemas.openxmlformats.org/drawingml/2006/main">
-            <a:off x="6477000" y="2381250"/>
-            <a:ext cx="4000500" cy="723900"/>
+            <a:off x="6762750" y="2400300"/>
+            <a:ext cx="4381500" cy="762000"/>
           </a:xfrm>
           <a:prstGeom xmlns:a="http://schemas.openxmlformats.org/drawingml/2006/main" prst="rect">
             <a:avLst/>
@@ -5132,7 +4887,7 @@
           <a:lstStyle xmlns:a="http://schemas.openxmlformats.org/drawingml/2006/main"/>
           <a:p xmlns:a="http://schemas.openxmlformats.org/drawingml/2006/main">
             <a:pPr algn="ctr">
-              <a:defRPr sz="4050" b="1">
+              <a:defRPr sz="4350" b="1">
                 <a:solidFill>
                   <a:srgbClr val="CF5D4A"/>
                 </a:solidFill>
@@ -5142,7 +4897,7 @@
               </a:defRPr>
             </a:pPr>
             <a:r>
-              <a:rPr sz="4050" b="1">
+              <a:rPr sz="4350" b="1">
                 <a:solidFill>
                   <a:srgbClr val="CF5D4A"/>
                 </a:solidFill>
@@ -5150,17 +4905,17 @@
                 <a:ea typeface="Aptos"/>
                 <a:cs typeface="Aptos"/>
               </a:rPr>
-              <a:t>100%</a:t>
+              <a:t>45 / 45</a:t>
             </a:r>
           </a:p>
         </p:txBody>
       </p:sp>
       <p:sp>
         <p:nvSpPr>
-          <p:cNvPr id="14" name="">
+          <p:cNvPr id="9" name="">
             <a:extLst xmlns:a="http://schemas.openxmlformats.org/drawingml/2006/main">
               <a:ext uri="{FF2B5EF4-FFF2-40B4-BE49-F238E27FC236}">
-                <a16:creationId xmlns:a16="http://schemas.microsoft.com/office/drawing/2014/main" id="{88D765F5-B54E-4C72-9CD3-7EE1C8050B60}"/>
+                <a16:creationId xmlns:a16="http://schemas.microsoft.com/office/drawing/2014/main" id="{96DA6278-CFBA-41B7-B7A1-6431C1174514}"/>
               </a:ext>
             </a:extLst>
           </p:cNvPr>
@@ -5171,8 +4926,8 @@
         </p:nvSpPr>
         <p:spPr>
           <a:xfrm xmlns:a="http://schemas.openxmlformats.org/drawingml/2006/main">
-            <a:off x="6477000" y="3143250"/>
-            <a:ext cx="4000500" cy="304800"/>
+            <a:off x="6762750" y="3257550"/>
+            <a:ext cx="4381500" cy="400050"/>
           </a:xfrm>
           <a:prstGeom xmlns:a="http://schemas.openxmlformats.org/drawingml/2006/main" prst="rect">
             <a:avLst/>
@@ -5184,12 +4939,12 @@
         </p:spPr>
         <p:txBody>
           <a:bodyPr xmlns:a="http://schemas.openxmlformats.org/drawingml/2006/main">
-            <a:normAutofit fontScale="98246"/>
+            <a:normAutofit fontScale="100000"/>
           </a:bodyPr>
           <a:lstStyle xmlns:a="http://schemas.openxmlformats.org/drawingml/2006/main"/>
           <a:p xmlns:a="http://schemas.openxmlformats.org/drawingml/2006/main">
             <a:pPr algn="ctr">
-              <a:defRPr sz="1425" b="1">
+              <a:defRPr sz="1350" b="0">
                 <a:solidFill>
                   <a:srgbClr val="17212B"/>
                 </a:solidFill>
@@ -5199,7 +4954,7 @@
               </a:defRPr>
             </a:pPr>
             <a:r>
-              <a:rPr sz="1425" b="1">
+              <a:rPr sz="1350" b="0">
                 <a:solidFill>
                   <a:srgbClr val="17212B"/>
                 </a:solidFill>
@@ -5207,17 +4962,17 @@
                 <a:ea typeface="Aptos"/>
                 <a:cs typeface="Aptos"/>
               </a:rPr>
-              <a:t>45 of 45 model pairs</a:t>
+              <a:t>model pairs have overlapping 95% score ranges</a:t>
             </a:r>
           </a:p>
         </p:txBody>
       </p:sp>
       <p:sp>
         <p:nvSpPr>
-          <p:cNvPr id="15" name="">
+          <p:cNvPr id="10" name="">
             <a:extLst xmlns:a="http://schemas.openxmlformats.org/drawingml/2006/main">
               <a:ext uri="{FF2B5EF4-FFF2-40B4-BE49-F238E27FC236}">
-                <a16:creationId xmlns:a16="http://schemas.microsoft.com/office/drawing/2014/main" id="{61CA3D7C-40AE-42AF-9B8E-EFD5BF92C7C7}"/>
+                <a16:creationId xmlns:a16="http://schemas.microsoft.com/office/drawing/2014/main" id="{5C45DAAF-6647-44F1-8487-24A5DBBC59B6}"/>
               </a:ext>
             </a:extLst>
           </p:cNvPr>
@@ -5228,8 +4983,39 @@
         </p:nvSpPr>
         <p:spPr>
           <a:xfrm xmlns:a="http://schemas.openxmlformats.org/drawingml/2006/main">
-            <a:off x="6477000" y="3505200"/>
-            <a:ext cx="4000500" cy="247650"/>
+            <a:off x="6096000" y="1952625"/>
+            <a:ext cx="0" cy="1666875"/>
+          </a:xfrm>
+          <a:prstGeom xmlns:a="http://schemas.openxmlformats.org/drawingml/2006/main" prst="line">
+            <a:avLst/>
+          </a:prstGeom>
+          <a:noFill xmlns:a="http://schemas.openxmlformats.org/drawingml/2006/main"/>
+          <a:ln xmlns:a="http://schemas.openxmlformats.org/drawingml/2006/main" w="19050">
+            <a:solidFill>
+              <a:srgbClr val="D8D9D5"/>
+            </a:solidFill>
+            <a:prstDash val="solid"/>
+          </a:ln>
+        </p:spPr>
+      </p:sp>
+      <p:sp>
+        <p:nvSpPr>
+          <p:cNvPr id="11" name="">
+            <a:extLst xmlns:a="http://schemas.openxmlformats.org/drawingml/2006/main">
+              <a:ext uri="{FF2B5EF4-FFF2-40B4-BE49-F238E27FC236}">
+                <a16:creationId xmlns:a16="http://schemas.microsoft.com/office/drawing/2014/main" id="{314274BA-EACF-4D10-AAD2-2A46F9E24190}"/>
+              </a:ext>
+            </a:extLst>
+          </p:cNvPr>
+          <p:cNvSpPr>
+            <a:spLocks xmlns:a="http://schemas.openxmlformats.org/drawingml/2006/main" noGrp="1"/>
+          </p:cNvSpPr>
+          <p:nvPr/>
+        </p:nvSpPr>
+        <p:spPr>
+          <a:xfrm xmlns:a="http://schemas.openxmlformats.org/drawingml/2006/main">
+            <a:off x="1143000" y="4343400"/>
+            <a:ext cx="9906000" cy="400050"/>
           </a:xfrm>
           <a:prstGeom xmlns:a="http://schemas.openxmlformats.org/drawingml/2006/main" prst="rect">
             <a:avLst/>
@@ -5241,14 +5027,14 @@
         </p:spPr>
         <p:txBody>
           <a:bodyPr xmlns:a="http://schemas.openxmlformats.org/drawingml/2006/main">
-            <a:normAutofit fontScale="91111"/>
+            <a:normAutofit fontScale="100000"/>
           </a:bodyPr>
           <a:lstStyle xmlns:a="http://schemas.openxmlformats.org/drawingml/2006/main"/>
           <a:p xmlns:a="http://schemas.openxmlformats.org/drawingml/2006/main">
             <a:pPr algn="ctr">
-              <a:defRPr sz="1125" b="0">
-                <a:solidFill>
-                  <a:srgbClr val="66727E"/>
+              <a:defRPr sz="2025" b="1">
+                <a:solidFill>
+                  <a:srgbClr val="17212B"/>
                 </a:solidFill>
                 <a:latin typeface="Aptos"/>
                 <a:ea typeface="Aptos"/>
@@ -5256,25 +5042,25 @@
               </a:defRPr>
             </a:pPr>
             <a:r>
-              <a:rPr sz="1125" b="0">
-                <a:solidFill>
-                  <a:srgbClr val="66727E"/>
+              <a:rPr sz="2025" b="1">
+                <a:solidFill>
+                  <a:srgbClr val="17212B"/>
                 </a:solidFill>
                 <a:latin typeface="Aptos"/>
                 <a:ea typeface="Aptos"/>
                 <a:cs typeface="Aptos"/>
               </a:rPr>
-              <a:t>saved marginal ranges overlap</a:t>
+              <a:t>These saved results do not separate a leader.</a:t>
             </a:r>
           </a:p>
         </p:txBody>
       </p:sp>
       <p:sp>
         <p:nvSpPr>
-          <p:cNvPr id="16" name="">
+          <p:cNvPr id="12" name="">
             <a:extLst xmlns:a="http://schemas.openxmlformats.org/drawingml/2006/main">
               <a:ext uri="{FF2B5EF4-FFF2-40B4-BE49-F238E27FC236}">
-                <a16:creationId xmlns:a16="http://schemas.microsoft.com/office/drawing/2014/main" id="{CC7CDA9E-D10C-4E90-A244-727867AB5CE2}"/>
+                <a16:creationId xmlns:a16="http://schemas.microsoft.com/office/drawing/2014/main" id="{DB85B8C8-A80F-4148-91CF-15B59C1C9A11}"/>
               </a:ext>
             </a:extLst>
           </p:cNvPr>
@@ -5285,8 +5071,8 @@
         </p:nvSpPr>
         <p:spPr>
           <a:xfrm xmlns:a="http://schemas.openxmlformats.org/drawingml/2006/main">
-            <a:off x="1143000" y="4276725"/>
-            <a:ext cx="9810750" cy="304800"/>
+            <a:off x="1143000" y="4972050"/>
+            <a:ext cx="9906000" cy="428625"/>
           </a:xfrm>
           <a:prstGeom xmlns:a="http://schemas.openxmlformats.org/drawingml/2006/main" prst="rect">
             <a:avLst/>
@@ -5298,14 +5084,14 @@
         </p:spPr>
         <p:txBody>
           <a:bodyPr xmlns:a="http://schemas.openxmlformats.org/drawingml/2006/main">
-            <a:normAutofit fontScale="88889"/>
+            <a:normAutofit fontScale="100000"/>
           </a:bodyPr>
           <a:lstStyle xmlns:a="http://schemas.openxmlformats.org/drawingml/2006/main"/>
           <a:p xmlns:a="http://schemas.openxmlformats.org/drawingml/2006/main">
-            <a:pPr algn="l">
-              <a:defRPr sz="1575" b="1">
-                <a:solidFill>
-                  <a:srgbClr val="CF5D4A"/>
+            <a:pPr algn="ctr">
+              <a:defRPr sz="1200" b="0">
+                <a:solidFill>
+                  <a:srgbClr val="66727E"/>
                 </a:solidFill>
                 <a:latin typeface="Aptos"/>
                 <a:ea typeface="Aptos"/>
@@ -5313,243 +5099,15 @@
               </a:defRPr>
             </a:pPr>
             <a:r>
-              <a:rPr sz="1575" b="1">
-                <a:solidFill>
-                  <a:srgbClr val="CF5D4A"/>
+              <a:rPr sz="1200" b="0">
+                <a:solidFill>
+                  <a:srgbClr val="66727E"/>
                 </a:solidFill>
                 <a:latin typeface="Aptos"/>
                 <a:ea typeface="Aptos"/>
                 <a:cs typeface="Aptos"/>
               </a:rPr>
-              <a:t>100% of model pairs overlap on both tests. This does not resolve a leader.</a:t>
-            </a:r>
-          </a:p>
-        </p:txBody>
-      </p:sp>
-      <p:sp>
-        <p:nvSpPr>
-          <p:cNvPr id="17" name="">
-            <a:extLst xmlns:a="http://schemas.openxmlformats.org/drawingml/2006/main">
-              <a:ext uri="{FF2B5EF4-FFF2-40B4-BE49-F238E27FC236}">
-                <a16:creationId xmlns:a16="http://schemas.microsoft.com/office/drawing/2014/main" id="{03D39A46-197E-4BEB-94E8-59A0733F1F1D}"/>
-              </a:ext>
-            </a:extLst>
-          </p:cNvPr>
-          <p:cNvSpPr>
-            <a:spLocks xmlns:a="http://schemas.openxmlformats.org/drawingml/2006/main" noGrp="1"/>
-          </p:cNvSpPr>
-          <p:nvPr/>
-        </p:nvSpPr>
-        <p:spPr>
-          <a:xfrm xmlns:a="http://schemas.openxmlformats.org/drawingml/2006/main">
-            <a:off x="1143000" y="4686300"/>
-            <a:ext cx="9810750" cy="247650"/>
-          </a:xfrm>
-          <a:prstGeom xmlns:a="http://schemas.openxmlformats.org/drawingml/2006/main" prst="rect">
-            <a:avLst/>
-          </a:prstGeom>
-          <a:noFill xmlns:a="http://schemas.openxmlformats.org/drawingml/2006/main"/>
-          <a:ln xmlns:a="http://schemas.openxmlformats.org/drawingml/2006/main" w="0">
-            <a:noFill/>
-          </a:ln>
-        </p:spPr>
-        <p:txBody>
-          <a:bodyPr xmlns:a="http://schemas.openxmlformats.org/drawingml/2006/main">
-            <a:normAutofit fontScale="91111"/>
-          </a:bodyPr>
-          <a:lstStyle xmlns:a="http://schemas.openxmlformats.org/drawingml/2006/main"/>
-          <a:p xmlns:a="http://schemas.openxmlformats.org/drawingml/2006/main">
-            <a:pPr algn="l">
-              <a:defRPr sz="1125" b="0">
-                <a:solidFill>
-                  <a:srgbClr val="17212B"/>
-                </a:solidFill>
-                <a:latin typeface="Aptos"/>
-                <a:ea typeface="Aptos"/>
-                <a:cs typeface="Aptos"/>
-              </a:defRPr>
-            </a:pPr>
-            <a:r>
-              <a:rPr sz="1125" b="0">
-                <a:solidFill>
-                  <a:srgbClr val="17212B"/>
-                </a:solidFill>
-                <a:latin typeface="Aptos"/>
-                <a:ea typeface="Aptos"/>
-                <a:cs typeface="Aptos"/>
-              </a:rPr>
-              <a:t>These are marginal ranges, not paired model-difference tests. Question-level results are unavailable.</a:t>
-            </a:r>
-          </a:p>
-        </p:txBody>
-      </p:sp>
-      <p:sp>
-        <p:nvSpPr>
-          <p:cNvPr id="18" name="">
-            <a:extLst xmlns:a="http://schemas.openxmlformats.org/drawingml/2006/main">
-              <a:ext uri="{FF2B5EF4-FFF2-40B4-BE49-F238E27FC236}">
-                <a16:creationId xmlns:a16="http://schemas.microsoft.com/office/drawing/2014/main" id="{5061EDC0-E17E-4A80-9D82-0DC53E1A2C42}"/>
-              </a:ext>
-            </a:extLst>
-          </p:cNvPr>
-          <p:cNvSpPr>
-            <a:spLocks xmlns:a="http://schemas.openxmlformats.org/drawingml/2006/main" noGrp="1"/>
-          </p:cNvSpPr>
-          <p:nvPr/>
-        </p:nvSpPr>
-        <p:spPr>
-          <a:xfrm xmlns:a="http://schemas.openxmlformats.org/drawingml/2006/main">
-            <a:off x="1143000" y="4991100"/>
-            <a:ext cx="9810750" cy="228600"/>
-          </a:xfrm>
-          <a:prstGeom xmlns:a="http://schemas.openxmlformats.org/drawingml/2006/main" prst="rect">
-            <a:avLst/>
-          </a:prstGeom>
-          <a:noFill xmlns:a="http://schemas.openxmlformats.org/drawingml/2006/main"/>
-          <a:ln xmlns:a="http://schemas.openxmlformats.org/drawingml/2006/main" w="0">
-            <a:noFill/>
-          </a:ln>
-        </p:spPr>
-        <p:txBody>
-          <a:bodyPr xmlns:a="http://schemas.openxmlformats.org/drawingml/2006/main">
-            <a:normAutofit fontScale="85714"/>
-          </a:bodyPr>
-          <a:lstStyle xmlns:a="http://schemas.openxmlformats.org/drawingml/2006/main"/>
-          <a:p xmlns:a="http://schemas.openxmlformats.org/drawingml/2006/main">
-            <a:pPr algn="l">
-              <a:defRPr sz="1050" b="0">
-                <a:solidFill>
-                  <a:srgbClr val="66727E"/>
-                </a:solidFill>
-                <a:latin typeface="Aptos"/>
-                <a:ea typeface="Aptos"/>
-                <a:cs typeface="Aptos"/>
-              </a:defRPr>
-            </a:pPr>
-            <a:r>
-              <a:rPr sz="1050" b="0">
-                <a:solidFill>
-                  <a:srgbClr val="66727E"/>
-                </a:solidFill>
-                <a:latin typeface="Aptos"/>
-                <a:ea typeface="Aptos"/>
-                <a:cs typeface="Aptos"/>
-              </a:rPr>
-              <a:t>Intervals are nominal; cluster-aware uncertainty is unavailable.</a:t>
-            </a:r>
-          </a:p>
-        </p:txBody>
-      </p:sp>
-      <p:sp>
-        <p:nvSpPr>
-          <p:cNvPr id="19" name="">
-            <a:extLst xmlns:a="http://schemas.openxmlformats.org/drawingml/2006/main">
-              <a:ext uri="{FF2B5EF4-FFF2-40B4-BE49-F238E27FC236}">
-                <a16:creationId xmlns:a16="http://schemas.microsoft.com/office/drawing/2014/main" id="{1A6B0A14-D0AB-4045-82D0-1BF0C7CEC022}"/>
-              </a:ext>
-            </a:extLst>
-          </p:cNvPr>
-          <p:cNvSpPr>
-            <a:spLocks xmlns:a="http://schemas.openxmlformats.org/drawingml/2006/main" noGrp="1"/>
-          </p:cNvSpPr>
-          <p:nvPr/>
-        </p:nvSpPr>
-        <p:spPr>
-          <a:xfrm xmlns:a="http://schemas.openxmlformats.org/drawingml/2006/main">
-            <a:off x="1143000" y="5524500"/>
-            <a:ext cx="9810750" cy="304800"/>
-          </a:xfrm>
-          <a:prstGeom xmlns:a="http://schemas.openxmlformats.org/drawingml/2006/main" prst="rect">
-            <a:avLst/>
-          </a:prstGeom>
-          <a:noFill xmlns:a="http://schemas.openxmlformats.org/drawingml/2006/main"/>
-          <a:ln xmlns:a="http://schemas.openxmlformats.org/drawingml/2006/main" w="0">
-            <a:noFill/>
-          </a:ln>
-        </p:spPr>
-        <p:txBody>
-          <a:bodyPr xmlns:a="http://schemas.openxmlformats.org/drawingml/2006/main">
-            <a:normAutofit fontScale="93333"/>
-          </a:bodyPr>
-          <a:lstStyle xmlns:a="http://schemas.openxmlformats.org/drawingml/2006/main"/>
-          <a:p xmlns:a="http://schemas.openxmlformats.org/drawingml/2006/main">
-            <a:pPr algn="l">
-              <a:defRPr sz="1500" b="1">
-                <a:solidFill>
-                  <a:srgbClr val="17212B"/>
-                </a:solidFill>
-                <a:latin typeface="Aptos"/>
-                <a:ea typeface="Aptos"/>
-                <a:cs typeface="Aptos"/>
-              </a:defRPr>
-            </a:pPr>
-            <a:r>
-              <a:rPr sz="1500" b="1">
-                <a:solidFill>
-                  <a:srgbClr val="17212B"/>
-                </a:solidFill>
-                <a:latin typeface="Aptos"/>
-                <a:ea typeface="Aptos"/>
-                <a:cs typeface="Aptos"/>
-              </a:rPr>
-              <a:t>Next: restore every model's answer and score for each question.</a:t>
-            </a:r>
-          </a:p>
-        </p:txBody>
-      </p:sp>
-      <p:sp>
-        <p:nvSpPr>
-          <p:cNvPr id="20" name="">
-            <a:extLst xmlns:a="http://schemas.openxmlformats.org/drawingml/2006/main">
-              <a:ext uri="{FF2B5EF4-FFF2-40B4-BE49-F238E27FC236}">
-                <a16:creationId xmlns:a16="http://schemas.microsoft.com/office/drawing/2014/main" id="{0594AE16-D60C-4155-A24C-F072A1E60DA0}"/>
-              </a:ext>
-            </a:extLst>
-          </p:cNvPr>
-          <p:cNvSpPr>
-            <a:spLocks xmlns:a="http://schemas.openxmlformats.org/drawingml/2006/main" noGrp="1"/>
-          </p:cNvSpPr>
-          <p:nvPr/>
-        </p:nvSpPr>
-        <p:spPr>
-          <a:xfrm xmlns:a="http://schemas.openxmlformats.org/drawingml/2006/main">
-            <a:off x="1143000" y="5886450"/>
-            <a:ext cx="9810750" cy="266700"/>
-          </a:xfrm>
-          <a:prstGeom xmlns:a="http://schemas.openxmlformats.org/drawingml/2006/main" prst="rect">
-            <a:avLst/>
-          </a:prstGeom>
-          <a:noFill xmlns:a="http://schemas.openxmlformats.org/drawingml/2006/main"/>
-          <a:ln xmlns:a="http://schemas.openxmlformats.org/drawingml/2006/main" w="0">
-            <a:noFill/>
-          </a:ln>
-        </p:spPr>
-        <p:txBody>
-          <a:bodyPr xmlns:a="http://schemas.openxmlformats.org/drawingml/2006/main">
-            <a:normAutofit fontScale="95833"/>
-          </a:bodyPr>
-          <a:lstStyle xmlns:a="http://schemas.openxmlformats.org/drawingml/2006/main"/>
-          <a:p xmlns:a="http://schemas.openxmlformats.org/drawingml/2006/main">
-            <a:pPr algn="l">
-              <a:defRPr sz="1200" b="0">
-                <a:solidFill>
-                  <a:srgbClr val="66727E"/>
-                </a:solidFill>
-                <a:latin typeface="Aptos"/>
-                <a:ea typeface="Aptos"/>
-                <a:cs typeface="Aptos"/>
-              </a:defRPr>
-            </a:pPr>
-            <a:r>
-              <a:rPr sz="1200" b="0">
-                <a:solidFill>
-                  <a:srgbClr val="66727E"/>
-                </a:solidFill>
-                <a:latin typeface="Aptos"/>
-                <a:ea typeface="Aptos"/>
-                <a:cs typeface="Aptos"/>
-              </a:rPr>
-              <a:t>Check scoring and labels. Then compare models and have people review the test.</a:t>
+              <a:t>The ranges are not a direct model-pair test. Question-level scores and stronger uncertainty estimates are unavailable.</a:t>
             </a:r>
           </a:p>
         </p:txBody>
@@ -5557,7 +5115,7 @@
     </p:spTree>
     <p:extLst>
       <p:ext uri="{BB962C8B-B14F-4D97-AF65-F5344CB8AC3E}">
-        <p14:creationId xmlns:p14="http://schemas.microsoft.com/office/powerpoint/2010/main" val="590019265"/>
+        <p14:creationId xmlns:p14="http://schemas.microsoft.com/office/powerpoint/2010/main" val="2095798075"/>
       </p:ext>
     </p:extLst>
   </p:cSld>
@@ -5585,10 +5143,10 @@
       </p:grpSpPr>
       <p:sp>
         <p:nvSpPr>
-          <p:cNvPr id="9" name="slide-title">
+          <p:cNvPr id="8" name="slide-title">
             <a:extLst xmlns:a="http://schemas.openxmlformats.org/drawingml/2006/main">
               <a:ext uri="{FF2B5EF4-FFF2-40B4-BE49-F238E27FC236}">
-                <a16:creationId xmlns:a16="http://schemas.microsoft.com/office/drawing/2014/main" id="{BEDA6A99-120F-4FDE-BF7D-1C7CDDFC367A}"/>
+                <a16:creationId xmlns:a16="http://schemas.microsoft.com/office/drawing/2014/main" id="{7904BB10-7F8C-4BF1-A4D6-3ACD80AF3E39}"/>
               </a:ext>
             </a:extLst>
           </p:cNvPr>
@@ -5600,7 +5158,7 @@
         <p:spPr>
           <a:xfrm xmlns:a="http://schemas.openxmlformats.org/drawingml/2006/main">
             <a:off x="685800" y="342900"/>
-            <a:ext cx="8667750" cy="590550"/>
+            <a:ext cx="10820400" cy="590550"/>
           </a:xfrm>
           <a:prstGeom xmlns:a="http://schemas.openxmlformats.org/drawingml/2006/main" prst="rect">
             <a:avLst/>
@@ -5635,7 +5193,7 @@
                 <a:ea typeface="Aptos"/>
                 <a:cs typeface="Aptos"/>
               </a:rPr>
-              <a:t>Only 4 of 12 model-and-task cases rise twice</a:t>
+              <a:t>UniMoral: only 4 of 12 family and task comparisons rise twice</a:t>
             </a:r>
           </a:p>
         </p:txBody>
@@ -5645,7 +5203,7 @@
           <p:cNvPr id="2" name="slide-subtitle">
             <a:extLst xmlns:a="http://schemas.openxmlformats.org/drawingml/2006/main">
               <a:ext uri="{FF2B5EF4-FFF2-40B4-BE49-F238E27FC236}">
-                <a16:creationId xmlns:a16="http://schemas.microsoft.com/office/drawing/2014/main" id="{43B3336E-E435-40AF-9851-4CD7CEF27AAB}"/>
+                <a16:creationId xmlns:a16="http://schemas.microsoft.com/office/drawing/2014/main" id="{75F57E81-46AE-4F96-B4DB-AA32AA51DE26}"/>
               </a:ext>
             </a:extLst>
           </p:cNvPr>
@@ -5692,7 +5250,7 @@
                 <a:ea typeface="Aptos"/>
                 <a:cs typeface="Aptos"/>
               </a:rPr>
-              <a:t>Qwen, Gemma, and Llama × four tasks; model versions differ in more than size</a:t>
+              <a:t>Exploratory CEI result. Each comparison follows one model family on one task across three sizes.</a:t>
             </a:r>
           </a:p>
         </p:txBody>
@@ -5702,68 +5260,7 @@
           <p:cNvPr id="3" name="">
             <a:extLst xmlns:a="http://schemas.openxmlformats.org/drawingml/2006/main">
               <a:ext uri="{FF2B5EF4-FFF2-40B4-BE49-F238E27FC236}">
-                <a16:creationId xmlns:a16="http://schemas.microsoft.com/office/drawing/2014/main" id="{FBE0FEFE-7EBF-4476-B322-3AC21E32C655}"/>
-              </a:ext>
-            </a:extLst>
-          </p:cNvPr>
-          <p:cNvSpPr>
-            <a:spLocks xmlns:a="http://schemas.openxmlformats.org/drawingml/2006/main" noGrp="1"/>
-          </p:cNvSpPr>
-          <p:nvPr/>
-        </p:nvSpPr>
-        <p:spPr>
-          <a:xfrm xmlns:a="http://schemas.openxmlformats.org/drawingml/2006/main">
-            <a:off x="9753600" y="381000"/>
-            <a:ext cx="1752600" cy="323850"/>
-          </a:xfrm>
-          <a:prstGeom xmlns:a="http://schemas.openxmlformats.org/drawingml/2006/main" prst="roundRect">
-            <a:avLst>
-              <a:gd name="adj" fmla="val 50000"/>
-            </a:avLst>
-          </a:prstGeom>
-          <a:solidFill xmlns:a="http://schemas.openxmlformats.org/drawingml/2006/main">
-            <a:srgbClr val="F5EACF"/>
-          </a:solidFill>
-          <a:ln xmlns:a="http://schemas.openxmlformats.org/drawingml/2006/main" w="0">
-            <a:noFill/>
-          </a:ln>
-        </p:spPr>
-        <p:txBody>
-          <a:bodyPr xmlns:a="http://schemas.openxmlformats.org/drawingml/2006/main">
-            <a:normAutofit fontScale="92575"/>
-          </a:bodyPr>
-          <a:lstStyle xmlns:a="http://schemas.openxmlformats.org/drawingml/2006/main"/>
-          <a:p xmlns:a="http://schemas.openxmlformats.org/drawingml/2006/main">
-            <a:pPr algn="ctr">
-              <a:defRPr sz="975" b="1">
-                <a:solidFill>
-                  <a:srgbClr val="8B5F00"/>
-                </a:solidFill>
-                <a:latin typeface="Aptos"/>
-                <a:ea typeface="Aptos"/>
-                <a:cs typeface="Aptos"/>
-              </a:defRPr>
-            </a:pPr>
-            <a:r>
-              <a:rPr sz="975" b="1">
-                <a:solidFill>
-                  <a:srgbClr val="8B5F00"/>
-                </a:solidFill>
-                <a:latin typeface="Aptos"/>
-                <a:ea typeface="Aptos"/>
-                <a:cs typeface="Aptos"/>
-              </a:rPr>
-              <a:t>EXPLORATORY</a:t>
-            </a:r>
-          </a:p>
-        </p:txBody>
-      </p:sp>
-      <p:sp>
-        <p:nvSpPr>
-          <p:cNvPr id="4" name="">
-            <a:extLst xmlns:a="http://schemas.openxmlformats.org/drawingml/2006/main">
-              <a:ext uri="{FF2B5EF4-FFF2-40B4-BE49-F238E27FC236}">
-                <a16:creationId xmlns:a16="http://schemas.microsoft.com/office/drawing/2014/main" id="{B8028C66-C154-41F1-99D9-DF08F6A6D923}"/>
+                <a16:creationId xmlns:a16="http://schemas.microsoft.com/office/drawing/2014/main" id="{615764BE-942B-461C-91DB-1C04D5CFCC97}"/>
               </a:ext>
             </a:extLst>
           </p:cNvPr>
@@ -5791,7 +5288,7 @@
       </p:sp>
       <p:graphicFrame>
         <p:nvGraphicFramePr>
-          <p:cNvPr id="13" name="Chart"/>
+          <p:cNvPr id="11" name="Chart"/>
           <p:cNvGraphicFramePr/>
           <p:nvPr/>
         </p:nvGraphicFramePr>
@@ -5801,16 +5298,16 @@
         </p:xfrm>
         <a:graphic xmlns:a="http://schemas.openxmlformats.org/drawingml/2006/main">
           <a:graphicData uri="http://schemas.openxmlformats.org/drawingml/2006/chart">
-            <c:chart xmlns:r="http://schemas.openxmlformats.org/officeDocument/2006/relationships" xmlns:c="http://schemas.openxmlformats.org/drawingml/2006/chart" r:id="R11af27ef5a7b4251"/>
+            <c:chart xmlns:r="http://schemas.openxmlformats.org/officeDocument/2006/relationships" xmlns:c="http://schemas.openxmlformats.org/drawingml/2006/chart" r:id="Rb531920521f94bde"/>
           </a:graphicData>
         </a:graphic>
       </p:graphicFrame>
       <p:sp>
         <p:nvSpPr>
-          <p:cNvPr id="6" name="">
+          <p:cNvPr id="5" name="">
             <a:extLst xmlns:a="http://schemas.openxmlformats.org/drawingml/2006/main">
               <a:ext uri="{FF2B5EF4-FFF2-40B4-BE49-F238E27FC236}">
-                <a16:creationId xmlns:a16="http://schemas.microsoft.com/office/drawing/2014/main" id="{9FD801AA-6B7F-4F4C-B651-BBB90374F10A}"/>
+                <a16:creationId xmlns:a16="http://schemas.microsoft.com/office/drawing/2014/main" id="{AD02CD9C-3363-47FD-B17A-0F4970721465}"/>
               </a:ext>
             </a:extLst>
           </p:cNvPr>
@@ -5857,17 +5354,17 @@
                 <a:ea typeface="Aptos"/>
                 <a:cs typeface="Aptos"/>
               </a:rPr>
-              <a:t>Each bar counts model-family × task cases (12 total).</a:t>
+              <a:t>Each bar counts one model family on one task across three saved sizes.</a:t>
             </a:r>
           </a:p>
         </p:txBody>
       </p:sp>
       <p:sp>
         <p:nvSpPr>
-          <p:cNvPr id="7" name="">
+          <p:cNvPr id="6" name="">
             <a:extLst xmlns:a="http://schemas.openxmlformats.org/drawingml/2006/main">
               <a:ext uri="{FF2B5EF4-FFF2-40B4-BE49-F238E27FC236}">
-                <a16:creationId xmlns:a16="http://schemas.microsoft.com/office/drawing/2014/main" id="{83D5D156-7B97-458C-9B65-F49FEEB71ED4}"/>
+                <a16:creationId xmlns:a16="http://schemas.microsoft.com/office/drawing/2014/main" id="{ADB7B3AF-8468-40CB-B6F7-13AF532ECDE9}"/>
               </a:ext>
             </a:extLst>
           </p:cNvPr>
@@ -5914,17 +5411,17 @@
                 <a:ea typeface="Aptos"/>
                 <a:cs typeface="Aptos"/>
               </a:rPr>
-              <a:t>Size is one clue, not a general rule.</a:t>
+              <a:t>4 rise twice · 7 change direction · 1 falls twice</a:t>
             </a:r>
           </a:p>
         </p:txBody>
       </p:sp>
       <p:sp>
         <p:nvSpPr>
-          <p:cNvPr id="8" name="">
+          <p:cNvPr id="7" name="">
             <a:extLst xmlns:a="http://schemas.openxmlformats.org/drawingml/2006/main">
               <a:ext uri="{FF2B5EF4-FFF2-40B4-BE49-F238E27FC236}">
-                <a16:creationId xmlns:a16="http://schemas.microsoft.com/office/drawing/2014/main" id="{1EEF7116-CCDF-4E7B-A145-C09B6A94261C}"/>
+                <a16:creationId xmlns:a16="http://schemas.microsoft.com/office/drawing/2014/main" id="{506367B2-FC78-4D09-A8C7-75CEEBD61E1B}"/>
               </a:ext>
             </a:extLst>
           </p:cNvPr>
@@ -5971,7 +5468,7 @@
                 <a:ea typeface="Aptos"/>
                 <a:cs typeface="Aptos"/>
               </a:rPr>
-              <a:t>Each case follows one model family on one task. Different score types stay separate.</a:t>
+              <a:t>This is exploratory. Model versions also differ in training and release, and no confidence ranges were saved.</a:t>
             </a:r>
           </a:p>
         </p:txBody>
@@ -5979,7 +5476,7 @@
     </p:spTree>
     <p:extLst>
       <p:ext uri="{BB962C8B-B14F-4D97-AF65-F5344CB8AC3E}">
-        <p14:creationId xmlns:p14="http://schemas.microsoft.com/office/powerpoint/2010/main" val="1256336294"/>
+        <p14:creationId xmlns:p14="http://schemas.microsoft.com/office/powerpoint/2010/main" val="78929185"/>
       </p:ext>
     </p:extLst>
   </p:cSld>
@@ -6010,7 +5507,7 @@
           <p:cNvPr id="7" name="slide-title">
             <a:extLst xmlns:a="http://schemas.openxmlformats.org/drawingml/2006/main">
               <a:ext uri="{FF2B5EF4-FFF2-40B4-BE49-F238E27FC236}">
-                <a16:creationId xmlns:a16="http://schemas.microsoft.com/office/drawing/2014/main" id="{4067027D-A4DF-443C-978F-35B4A8EF1B52}"/>
+                <a16:creationId xmlns:a16="http://schemas.microsoft.com/office/drawing/2014/main" id="{D3C3173E-9EB5-4005-BA66-C29AB1646E40}"/>
               </a:ext>
             </a:extLst>
           </p:cNvPr>
@@ -6022,7 +5519,7 @@
         <p:spPr>
           <a:xfrm xmlns:a="http://schemas.openxmlformats.org/drawingml/2006/main">
             <a:off x="685800" y="342900"/>
-            <a:ext cx="8667750" cy="590550"/>
+            <a:ext cx="10820400" cy="590550"/>
           </a:xfrm>
           <a:prstGeom xmlns:a="http://schemas.openxmlformats.org/drawingml/2006/main" prst="rect">
             <a:avLst/>
@@ -6057,17 +5554,17 @@
                 <a:ea typeface="Aptos"/>
                 <a:cs typeface="Aptos"/>
               </a:rPr>
-              <a:t>Gemma scores rise on one task and fall on another</a:t>
+              <a:t>UniMoral Gemma: factor rises while typology falls</a:t>
             </a:r>
           </a:p>
         </p:txBody>
       </p:sp>
       <p:sp>
         <p:nvSpPr>
-          <p:cNvPr id="2" name="">
+          <p:cNvPr id="2" name="slide-subtitle">
             <a:extLst xmlns:a="http://schemas.openxmlformats.org/drawingml/2006/main">
               <a:ext uri="{FF2B5EF4-FFF2-40B4-BE49-F238E27FC236}">
-                <a16:creationId xmlns:a16="http://schemas.microsoft.com/office/drawing/2014/main" id="{082180F6-719E-492B-9B6C-DDD697E67FE6}"/>
+                <a16:creationId xmlns:a16="http://schemas.microsoft.com/office/drawing/2014/main" id="{2FED5523-95F7-4DFD-959F-4C645EF4EC17}"/>
               </a:ext>
             </a:extLst>
           </p:cNvPr>
@@ -6078,31 +5575,27 @@
         </p:nvSpPr>
         <p:spPr>
           <a:xfrm xmlns:a="http://schemas.openxmlformats.org/drawingml/2006/main">
-            <a:off x="9753600" y="381000"/>
-            <a:ext cx="1752600" cy="323850"/>
+            <a:off x="781050" y="942975"/>
+            <a:ext cx="10096500" cy="342900"/>
           </a:xfrm>
-          <a:prstGeom xmlns:a="http://schemas.openxmlformats.org/drawingml/2006/main" prst="roundRect">
-            <a:avLst>
-              <a:gd name="adj" fmla="val 50000"/>
-            </a:avLst>
+          <a:prstGeom xmlns:a="http://schemas.openxmlformats.org/drawingml/2006/main" prst="rect">
+            <a:avLst/>
           </a:prstGeom>
-          <a:solidFill xmlns:a="http://schemas.openxmlformats.org/drawingml/2006/main">
-            <a:srgbClr val="F5EACF"/>
-          </a:solidFill>
+          <a:noFill xmlns:a="http://schemas.openxmlformats.org/drawingml/2006/main"/>
           <a:ln xmlns:a="http://schemas.openxmlformats.org/drawingml/2006/main" w="0">
             <a:noFill/>
           </a:ln>
         </p:spPr>
         <p:txBody>
           <a:bodyPr xmlns:a="http://schemas.openxmlformats.org/drawingml/2006/main">
-            <a:normAutofit fontScale="92575"/>
+            <a:normAutofit fontScale="100000"/>
           </a:bodyPr>
           <a:lstStyle xmlns:a="http://schemas.openxmlformats.org/drawingml/2006/main"/>
           <a:p xmlns:a="http://schemas.openxmlformats.org/drawingml/2006/main">
-            <a:pPr algn="ctr">
-              <a:defRPr sz="975" b="1">
-                <a:solidFill>
-                  <a:srgbClr val="8B5F00"/>
+            <a:pPr algn="l">
+              <a:defRPr sz="1350" b="0">
+                <a:solidFill>
+                  <a:srgbClr val="66727E"/>
                 </a:solidFill>
                 <a:latin typeface="Aptos"/>
                 <a:ea typeface="Aptos"/>
@@ -6110,15 +5603,15 @@
               </a:defRPr>
             </a:pPr>
             <a:r>
-              <a:rPr sz="975" b="1">
-                <a:solidFill>
-                  <a:srgbClr val="8B5F00"/>
+              <a:rPr sz="1350" b="0">
+                <a:solidFill>
+                  <a:srgbClr val="66727E"/>
                 </a:solidFill>
                 <a:latin typeface="Aptos"/>
                 <a:ea typeface="Aptos"/>
                 <a:cs typeface="Aptos"/>
               </a:rPr>
-              <a:t>EXPLORATORY</a:t>
+              <a:t>Exploratory CEI result. Gemma 3 at 4B, 12B, and 27B; the vertical axis is zoomed.</a:t>
             </a:r>
           </a:p>
         </p:txBody>
@@ -6128,7 +5621,7 @@
           <p:cNvPr id="3" name="">
             <a:extLst xmlns:a="http://schemas.openxmlformats.org/drawingml/2006/main">
               <a:ext uri="{FF2B5EF4-FFF2-40B4-BE49-F238E27FC236}">
-                <a16:creationId xmlns:a16="http://schemas.microsoft.com/office/drawing/2014/main" id="{816C1B97-D883-4183-AB14-96DABF957347}"/>
+                <a16:creationId xmlns:a16="http://schemas.microsoft.com/office/drawing/2014/main" id="{43630F9E-9906-41A1-BC2A-6F4F57E24534}"/>
               </a:ext>
             </a:extLst>
           </p:cNvPr>
@@ -6166,7 +5659,7 @@
         </p:xfrm>
         <a:graphic xmlns:a="http://schemas.openxmlformats.org/drawingml/2006/main">
           <a:graphicData uri="http://schemas.openxmlformats.org/drawingml/2006/chart">
-            <c:chart xmlns:r="http://schemas.openxmlformats.org/officeDocument/2006/relationships" xmlns:c="http://schemas.openxmlformats.org/drawingml/2006/chart" r:id="R09a9e665b80b4561"/>
+            <c:chart xmlns:r="http://schemas.openxmlformats.org/officeDocument/2006/relationships" xmlns:c="http://schemas.openxmlformats.org/drawingml/2006/chart" r:id="Rf80668fadf964e24"/>
           </a:graphicData>
         </a:graphic>
       </p:graphicFrame>
@@ -6175,7 +5668,7 @@
           <p:cNvPr id="5" name="">
             <a:extLst xmlns:a="http://schemas.openxmlformats.org/drawingml/2006/main">
               <a:ext uri="{FF2B5EF4-FFF2-40B4-BE49-F238E27FC236}">
-                <a16:creationId xmlns:a16="http://schemas.microsoft.com/office/drawing/2014/main" id="{5520A0CE-A0B0-45B9-BD23-73180380CFD0}"/>
+                <a16:creationId xmlns:a16="http://schemas.microsoft.com/office/drawing/2014/main" id="{C3A6855A-702B-4A6F-A7AC-BDC8B83451D7}"/>
               </a:ext>
             </a:extLst>
           </p:cNvPr>
@@ -6199,14 +5692,14 @@
         </p:spPr>
         <p:txBody>
           <a:bodyPr xmlns:a="http://schemas.openxmlformats.org/drawingml/2006/main">
-            <a:normAutofit fontScale="92424"/>
+            <a:normAutofit fontScale="96825"/>
           </a:bodyPr>
           <a:lstStyle xmlns:a="http://schemas.openxmlformats.org/drawingml/2006/main"/>
           <a:p xmlns:a="http://schemas.openxmlformats.org/drawingml/2006/main">
             <a:pPr algn="l">
-              <a:defRPr sz="1650" b="1">
-                <a:solidFill>
-                  <a:srgbClr val="6E5AA8"/>
+              <a:defRPr sz="1575" b="1">
+                <a:solidFill>
+                  <a:srgbClr val="17212B"/>
                 </a:solidFill>
                 <a:latin typeface="Aptos"/>
                 <a:ea typeface="Aptos"/>
@@ -6214,15 +5707,15 @@
               </a:defRPr>
             </a:pPr>
             <a:r>
-              <a:rPr sz="1650" b="1">
-                <a:solidFill>
-                  <a:srgbClr val="6E5AA8"/>
+              <a:rPr sz="1575" b="1">
+                <a:solidFill>
+                  <a:srgbClr val="17212B"/>
                 </a:solidFill>
                 <a:latin typeface="Aptos"/>
                 <a:ea typeface="Aptos"/>
                 <a:cs typeface="Aptos"/>
               </a:rPr>
-              <a:t>The larger named variants do not score higher on both tasks.</a:t>
+              <a:t>4B to 27B: factor accuracy +.034 · moral typology accuracy −.027</a:t>
             </a:r>
           </a:p>
         </p:txBody>
@@ -6232,7 +5725,7 @@
           <p:cNvPr id="6" name="">
             <a:extLst xmlns:a="http://schemas.openxmlformats.org/drawingml/2006/main">
               <a:ext uri="{FF2B5EF4-FFF2-40B4-BE49-F238E27FC236}">
-                <a16:creationId xmlns:a16="http://schemas.microsoft.com/office/drawing/2014/main" id="{F4D46E41-F816-41B1-8DD5-B897384BDD0F}"/>
+                <a16:creationId xmlns:a16="http://schemas.microsoft.com/office/drawing/2014/main" id="{C9F9C676-98FD-4569-AD93-C0BDE1A91FFB}"/>
               </a:ext>
             </a:extLst>
           </p:cNvPr>
@@ -6279,7 +5772,7 @@
                 <a:ea typeface="Aptos"/>
                 <a:cs typeface="Aptos"/>
               </a:rPr>
-              <a:t>Each point is one stored task score. Its uncertainty range and raw run archive are unavailable.</a:t>
+              <a:t>Each point is one saved task score. No uncertainty range or raw run archive is available.</a:t>
             </a:r>
           </a:p>
         </p:txBody>
@@ -6287,7 +5780,7 @@
     </p:spTree>
     <p:extLst>
       <p:ext uri="{BB962C8B-B14F-4D97-AF65-F5344CB8AC3E}">
-        <p14:creationId xmlns:p14="http://schemas.microsoft.com/office/powerpoint/2010/main" val="1612931859"/>
+        <p14:creationId xmlns:p14="http://schemas.microsoft.com/office/powerpoint/2010/main" val="130397183"/>
       </p:ext>
     </p:extLst>
   </p:cSld>
@@ -6315,10 +5808,10 @@
       </p:grpSpPr>
       <p:sp>
         <p:nvSpPr>
-          <p:cNvPr id="14" name="slide-title">
+          <p:cNvPr id="11" name="slide-title">
             <a:extLst xmlns:a="http://schemas.openxmlformats.org/drawingml/2006/main">
               <a:ext uri="{FF2B5EF4-FFF2-40B4-BE49-F238E27FC236}">
-                <a16:creationId xmlns:a16="http://schemas.microsoft.com/office/drawing/2014/main" id="{F950D8E4-4A41-4B92-90EC-6D068B2479AC}"/>
+                <a16:creationId xmlns:a16="http://schemas.microsoft.com/office/drawing/2014/main" id="{B5E11E43-188D-4FE3-B825-47E94818E655}"/>
               </a:ext>
             </a:extLst>
           </p:cNvPr>
@@ -6330,7 +5823,7 @@
         <p:spPr>
           <a:xfrm xmlns:a="http://schemas.openxmlformats.org/drawingml/2006/main">
             <a:off x="685800" y="342900"/>
-            <a:ext cx="8667750" cy="590550"/>
+            <a:ext cx="10820400" cy="590550"/>
           </a:xfrm>
           <a:prstGeom xmlns:a="http://schemas.openxmlformats.org/drawingml/2006/main" prst="rect">
             <a:avLst/>
@@ -6342,7 +5835,7 @@
         </p:spPr>
         <p:txBody>
           <a:bodyPr xmlns:a="http://schemas.openxmlformats.org/drawingml/2006/main">
-            <a:normAutofit fontScale="74349"/>
+            <a:normAutofit fontScale="100000"/>
           </a:bodyPr>
           <a:lstStyle xmlns:a="http://schemas.openxmlformats.org/drawingml/2006/main"/>
           <a:p xmlns:a="http://schemas.openxmlformats.org/drawingml/2006/main">
@@ -6365,7 +5858,7 @@
                 <a:ea typeface="Aptos"/>
                 <a:cs typeface="Aptos"/>
               </a:rPr>
-              <a:t>Later model versions score higher on some tasks and lower on others</a:t>
+              <a:t>UniMoral releases: Qwen rises on 3 tasks, DeepSeek on 2</a:t>
             </a:r>
           </a:p>
         </p:txBody>
@@ -6375,7 +5868,7 @@
           <p:cNvPr id="2" name="slide-subtitle">
             <a:extLst xmlns:a="http://schemas.openxmlformats.org/drawingml/2006/main">
               <a:ext uri="{FF2B5EF4-FFF2-40B4-BE49-F238E27FC236}">
-                <a16:creationId xmlns:a16="http://schemas.microsoft.com/office/drawing/2014/main" id="{7A617DC5-0763-406D-9A55-74EC70035B98}"/>
+                <a16:creationId xmlns:a16="http://schemas.microsoft.com/office/drawing/2014/main" id="{E95607A9-D866-4015-8400-84B7AA5C083B}"/>
               </a:ext>
             </a:extLst>
           </p:cNvPr>
@@ -6422,7 +5915,7 @@
                 <a:ea typeface="Aptos"/>
                 <a:cs typeface="Aptos"/>
               </a:rPr>
-              <a:t>Accuracy change on three UniMoral tasks; consequence text match stays separate</a:t>
+              <a:t>Exploratory CEI result. Later score minus earlier score; consequence uses text match.</a:t>
             </a:r>
           </a:p>
         </p:txBody>
@@ -6432,68 +5925,7 @@
           <p:cNvPr id="3" name="">
             <a:extLst xmlns:a="http://schemas.openxmlformats.org/drawingml/2006/main">
               <a:ext uri="{FF2B5EF4-FFF2-40B4-BE49-F238E27FC236}">
-                <a16:creationId xmlns:a16="http://schemas.microsoft.com/office/drawing/2014/main" id="{01ACF5C5-C3C1-4274-93CA-717BDFC9D2D1}"/>
-              </a:ext>
-            </a:extLst>
-          </p:cNvPr>
-          <p:cNvSpPr>
-            <a:spLocks xmlns:a="http://schemas.openxmlformats.org/drawingml/2006/main" noGrp="1"/>
-          </p:cNvSpPr>
-          <p:nvPr/>
-        </p:nvSpPr>
-        <p:spPr>
-          <a:xfrm xmlns:a="http://schemas.openxmlformats.org/drawingml/2006/main">
-            <a:off x="9753600" y="381000"/>
-            <a:ext cx="1752600" cy="323850"/>
-          </a:xfrm>
-          <a:prstGeom xmlns:a="http://schemas.openxmlformats.org/drawingml/2006/main" prst="roundRect">
-            <a:avLst>
-              <a:gd name="adj" fmla="val 50000"/>
-            </a:avLst>
-          </a:prstGeom>
-          <a:solidFill xmlns:a="http://schemas.openxmlformats.org/drawingml/2006/main">
-            <a:srgbClr val="F5EACF"/>
-          </a:solidFill>
-          <a:ln xmlns:a="http://schemas.openxmlformats.org/drawingml/2006/main" w="0">
-            <a:noFill/>
-          </a:ln>
-        </p:spPr>
-        <p:txBody>
-          <a:bodyPr xmlns:a="http://schemas.openxmlformats.org/drawingml/2006/main">
-            <a:normAutofit fontScale="92575"/>
-          </a:bodyPr>
-          <a:lstStyle xmlns:a="http://schemas.openxmlformats.org/drawingml/2006/main"/>
-          <a:p xmlns:a="http://schemas.openxmlformats.org/drawingml/2006/main">
-            <a:pPr algn="ctr">
-              <a:defRPr sz="975" b="1">
-                <a:solidFill>
-                  <a:srgbClr val="8B5F00"/>
-                </a:solidFill>
-                <a:latin typeface="Aptos"/>
-                <a:ea typeface="Aptos"/>
-                <a:cs typeface="Aptos"/>
-              </a:defRPr>
-            </a:pPr>
-            <a:r>
-              <a:rPr sz="975" b="1">
-                <a:solidFill>
-                  <a:srgbClr val="8B5F00"/>
-                </a:solidFill>
-                <a:latin typeface="Aptos"/>
-                <a:ea typeface="Aptos"/>
-                <a:cs typeface="Aptos"/>
-              </a:rPr>
-              <a:t>EXPLORATORY</a:t>
-            </a:r>
-          </a:p>
-        </p:txBody>
-      </p:sp>
-      <p:sp>
-        <p:nvSpPr>
-          <p:cNvPr id="4" name="">
-            <a:extLst xmlns:a="http://schemas.openxmlformats.org/drawingml/2006/main">
-              <a:ext uri="{FF2B5EF4-FFF2-40B4-BE49-F238E27FC236}">
-                <a16:creationId xmlns:a16="http://schemas.microsoft.com/office/drawing/2014/main" id="{29147067-8136-4258-9A7F-608A7CF2CFEC}"/>
+                <a16:creationId xmlns:a16="http://schemas.microsoft.com/office/drawing/2014/main" id="{116D1F50-E693-4AE9-A27B-C12E10218B74}"/>
               </a:ext>
             </a:extLst>
           </p:cNvPr>
@@ -6521,10 +5953,10 @@
       </p:sp>
       <p:sp>
         <p:nvSpPr>
-          <p:cNvPr id="5" name="">
+          <p:cNvPr id="4" name="">
             <a:extLst xmlns:a="http://schemas.openxmlformats.org/drawingml/2006/main">
               <a:ext uri="{FF2B5EF4-FFF2-40B4-BE49-F238E27FC236}">
-                <a16:creationId xmlns:a16="http://schemas.microsoft.com/office/drawing/2014/main" id="{86C332B5-8F2A-4298-B6B2-04A1D6FA0076}"/>
+                <a16:creationId xmlns:a16="http://schemas.microsoft.com/office/drawing/2014/main" id="{ADE85BB6-1191-4C3B-89B1-85AE145BBCE2}"/>
               </a:ext>
             </a:extLst>
           </p:cNvPr>
@@ -6571,17 +6003,17 @@
                 <a:ea typeface="Aptos"/>
                 <a:cs typeface="Aptos"/>
               </a:rPr>
-              <a:t>Qwen: 2024-Q3 · Qwen2.5 7B Instruct (7.61B) → 2026-Q1 · Qwen3.5 9B (9B)</a:t>
+              <a:t>Qwen: Qwen2.5 7B Instruct · 2024-09-19 · 7.61B total to Qwen3.5 9B · 2026-02-27 · 9B total</a:t>
             </a:r>
           </a:p>
         </p:txBody>
       </p:sp>
       <p:sp>
         <p:nvSpPr>
-          <p:cNvPr id="6" name="">
+          <p:cNvPr id="5" name="">
             <a:extLst xmlns:a="http://schemas.openxmlformats.org/drawingml/2006/main">
               <a:ext uri="{FF2B5EF4-FFF2-40B4-BE49-F238E27FC236}">
-                <a16:creationId xmlns:a16="http://schemas.microsoft.com/office/drawing/2014/main" id="{456FA5D5-FC3D-4E36-9446-C509D87C9A00}"/>
+                <a16:creationId xmlns:a16="http://schemas.microsoft.com/office/drawing/2014/main" id="{D2A7A7D8-D7C1-4144-BC86-DE5546CD4887}"/>
               </a:ext>
             </a:extLst>
           </p:cNvPr>
@@ -6628,17 +6060,17 @@
                 <a:ea typeface="Aptos"/>
                 <a:cs typeface="Aptos"/>
               </a:rPr>
-              <a:t>DeepSeek: 2025-Q1 · V3-0324 (671B main, 37B active) → 2026-Q2 · V4 Flash (284B main, 13B active)</a:t>
+              <a:t>DeepSeek: V3-0324 · 2025-03-24 · 671B main / 37B active to V4 Flash · 2026-04-22 · 284B main / 13B active</a:t>
             </a:r>
           </a:p>
         </p:txBody>
       </p:sp>
       <p:sp>
         <p:nvSpPr>
-          <p:cNvPr id="7" name="">
+          <p:cNvPr id="6" name="">
             <a:extLst xmlns:a="http://schemas.openxmlformats.org/drawingml/2006/main">
               <a:ext uri="{FF2B5EF4-FFF2-40B4-BE49-F238E27FC236}">
-                <a16:creationId xmlns:a16="http://schemas.microsoft.com/office/drawing/2014/main" id="{F1CDD148-6876-42A9-B9C7-2032DBD86B46}"/>
+                <a16:creationId xmlns:a16="http://schemas.microsoft.com/office/drawing/2014/main" id="{3632F23B-0B22-4ECD-9208-F07DA9202F38}"/>
               </a:ext>
             </a:extLst>
           </p:cNvPr>
@@ -6685,14 +6117,14 @@
                 <a:ea typeface="Aptos"/>
                 <a:cs typeface="Aptos"/>
               </a:rPr>
-              <a:t>main = published main-model parameters (auxiliary/MTP excluded); active = parameters used per token</a:t>
+              <a:t>DeepSeek labels show published main-model B and active B used per token.</a:t>
             </a:r>
           </a:p>
         </p:txBody>
       </p:sp>
       <p:graphicFrame>
         <p:nvGraphicFramePr>
-          <p:cNvPr id="21" name="Chart"/>
+          <p:cNvPr id="17" name="Chart"/>
           <p:cNvGraphicFramePr/>
           <p:nvPr/>
         </p:nvGraphicFramePr>
@@ -6702,16 +6134,16 @@
         </p:xfrm>
         <a:graphic xmlns:a="http://schemas.openxmlformats.org/drawingml/2006/main">
           <a:graphicData uri="http://schemas.openxmlformats.org/drawingml/2006/chart">
-            <c:chart xmlns:r="http://schemas.openxmlformats.org/officeDocument/2006/relationships" xmlns:c="http://schemas.openxmlformats.org/drawingml/2006/chart" r:id="R3e41976407bc48a6"/>
+            <c:chart xmlns:r="http://schemas.openxmlformats.org/officeDocument/2006/relationships" xmlns:c="http://schemas.openxmlformats.org/drawingml/2006/chart" r:id="Rbac13fd76fa54d71"/>
           </a:graphicData>
         </a:graphic>
       </p:graphicFrame>
       <p:sp>
         <p:nvSpPr>
-          <p:cNvPr id="9" name="">
+          <p:cNvPr id="8" name="">
             <a:extLst xmlns:a="http://schemas.openxmlformats.org/drawingml/2006/main">
               <a:ext uri="{FF2B5EF4-FFF2-40B4-BE49-F238E27FC236}">
-                <a16:creationId xmlns:a16="http://schemas.microsoft.com/office/drawing/2014/main" id="{3C97FBF1-DB22-42E5-9FA8-79C3FD5321AD}"/>
+                <a16:creationId xmlns:a16="http://schemas.microsoft.com/office/drawing/2014/main" id="{B6674F48-3D20-4027-985B-E3FE99FE0D6E}"/>
               </a:ext>
             </a:extLst>
           </p:cNvPr>
@@ -6758,17 +6190,17 @@
                 <a:ea typeface="Aptos"/>
                 <a:cs typeface="Aptos"/>
               </a:rPr>
-              <a:t>Across all four tasks: Qwen 3 higher / 1 lower · DeepSeek 2 higher / 2 lower</a:t>
+              <a:t>Across all 4 tasks: Qwen is higher on 3 and lower on 1. DeepSeek is higher on 2 and lower on 2.</a:t>
             </a:r>
           </a:p>
         </p:txBody>
       </p:sp>
       <p:sp>
         <p:nvSpPr>
-          <p:cNvPr id="10" name="">
+          <p:cNvPr id="9" name="">
             <a:extLst xmlns:a="http://schemas.openxmlformats.org/drawingml/2006/main">
               <a:ext uri="{FF2B5EF4-FFF2-40B4-BE49-F238E27FC236}">
-                <a16:creationId xmlns:a16="http://schemas.microsoft.com/office/drawing/2014/main" id="{643527FB-B070-455B-B47B-091960FF4664}"/>
+                <a16:creationId xmlns:a16="http://schemas.microsoft.com/office/drawing/2014/main" id="{47258007-1DB2-4EDB-BFA7-064F12D9F4DF}"/>
               </a:ext>
             </a:extLst>
           </p:cNvPr>
@@ -6815,17 +6247,17 @@
                 <a:ea typeface="Aptos"/>
                 <a:cs typeface="Aptos"/>
               </a:rPr>
-              <a:t>Separate metric · Consequence text match (METEOR): Qwen −.027; DeepSeek +.019</a:t>
+              <a:t>Separate metric · Consequence text match (METEOR): Qwen −.027 · DeepSeek +.019</a:t>
             </a:r>
           </a:p>
         </p:txBody>
       </p:sp>
       <p:sp>
         <p:nvSpPr>
-          <p:cNvPr id="11" name="">
+          <p:cNvPr id="10" name="">
             <a:extLst xmlns:a="http://schemas.openxmlformats.org/drawingml/2006/main">
               <a:ext uri="{FF2B5EF4-FFF2-40B4-BE49-F238E27FC236}">
-                <a16:creationId xmlns:a16="http://schemas.microsoft.com/office/drawing/2014/main" id="{A09E0EED-D5EA-463B-94E1-4A8EFE62A986}"/>
+                <a16:creationId xmlns:a16="http://schemas.microsoft.com/office/drawing/2014/main" id="{1214439B-9CCE-4E26-96CC-641D0D6D1C8E}"/>
               </a:ext>
             </a:extLst>
           </p:cNvPr>
@@ -6836,8 +6268,8 @@
         </p:nvSpPr>
         <p:spPr>
           <a:xfrm xmlns:a="http://schemas.openxmlformats.org/drawingml/2006/main">
-            <a:off x="1143000" y="5905500"/>
-            <a:ext cx="8572500" cy="247650"/>
+            <a:off x="1143000" y="5981700"/>
+            <a:ext cx="9810750" cy="285750"/>
           </a:xfrm>
           <a:prstGeom xmlns:a="http://schemas.openxmlformats.org/drawingml/2006/main" prst="rect">
             <a:avLst/>
@@ -6849,14 +6281,14 @@
         </p:spPr>
         <p:txBody>
           <a:bodyPr xmlns:a="http://schemas.openxmlformats.org/drawingml/2006/main">
-            <a:normAutofit fontScale="80392"/>
+            <a:normAutofit fontScale="100000"/>
           </a:bodyPr>
           <a:lstStyle xmlns:a="http://schemas.openxmlformats.org/drawingml/2006/main"/>
           <a:p xmlns:a="http://schemas.openxmlformats.org/drawingml/2006/main">
             <a:pPr algn="l">
-              <a:defRPr sz="1275" b="1">
-                <a:solidFill>
-                  <a:srgbClr val="17212B"/>
+              <a:defRPr sz="1050" b="0">
+                <a:solidFill>
+                  <a:srgbClr val="66727E"/>
                 </a:solidFill>
                 <a:latin typeface="Aptos"/>
                 <a:ea typeface="Aptos"/>
@@ -6864,129 +6296,15 @@
               </a:defRPr>
             </a:pPr>
             <a:r>
-              <a:rPr sz="1275" b="1">
-                <a:solidFill>
-                  <a:srgbClr val="17212B"/>
+              <a:rPr sz="1050" b="0">
+                <a:solidFill>
+                  <a:srgbClr val="66727E"/>
                 </a:solidFill>
                 <a:latin typeface="Aptos"/>
                 <a:ea typeface="Aptos"/>
                 <a:cs typeface="Aptos"/>
               </a:rPr>
-              <a:t>All endpoint runs were evaluated on 28–29 May 2026.</a:t>
-            </a:r>
-          </a:p>
-        </p:txBody>
-      </p:sp>
-      <p:sp>
-        <p:nvSpPr>
-          <p:cNvPr id="12" name="">
-            <a:extLst xmlns:a="http://schemas.openxmlformats.org/drawingml/2006/main">
-              <a:ext uri="{FF2B5EF4-FFF2-40B4-BE49-F238E27FC236}">
-                <a16:creationId xmlns:a16="http://schemas.microsoft.com/office/drawing/2014/main" id="{F72FCC50-731F-470B-9CCC-7DC6E481AAA5}"/>
-              </a:ext>
-            </a:extLst>
-          </p:cNvPr>
-          <p:cNvSpPr>
-            <a:spLocks xmlns:a="http://schemas.openxmlformats.org/drawingml/2006/main" noGrp="1"/>
-          </p:cNvSpPr>
-          <p:nvPr/>
-        </p:nvSpPr>
-        <p:spPr>
-          <a:xfrm xmlns:a="http://schemas.openxmlformats.org/drawingml/2006/main">
-            <a:off x="1143000" y="6191250"/>
-            <a:ext cx="8953500" cy="209550"/>
-          </a:xfrm>
-          <a:prstGeom xmlns:a="http://schemas.openxmlformats.org/drawingml/2006/main" prst="rect">
-            <a:avLst/>
-          </a:prstGeom>
-          <a:noFill xmlns:a="http://schemas.openxmlformats.org/drawingml/2006/main"/>
-          <a:ln xmlns:a="http://schemas.openxmlformats.org/drawingml/2006/main" w="0">
-            <a:noFill/>
-          </a:ln>
-        </p:spPr>
-        <p:txBody>
-          <a:bodyPr xmlns:a="http://schemas.openxmlformats.org/drawingml/2006/main">
-            <a:normAutofit fontScale="79487"/>
-          </a:bodyPr>
-          <a:lstStyle xmlns:a="http://schemas.openxmlformats.org/drawingml/2006/main"/>
-          <a:p xmlns:a="http://schemas.openxmlformats.org/drawingml/2006/main">
-            <a:pPr algn="l">
-              <a:defRPr sz="975" b="0">
-                <a:solidFill>
-                  <a:srgbClr val="66727E"/>
-                </a:solidFill>
-                <a:latin typeface="Aptos"/>
-                <a:ea typeface="Aptos"/>
-                <a:cs typeface="Aptos"/>
-              </a:defRPr>
-            </a:pPr>
-            <a:r>
-              <a:rPr sz="975" b="0">
-                <a:solidFill>
-                  <a:srgbClr val="66727E"/>
-                </a:solidFill>
-                <a:latin typeface="Aptos"/>
-                <a:ea typeface="Aptos"/>
-                <a:cs typeface="Aptos"/>
-              </a:rPr>
-              <a:t>Release period is model metadata, not a progress timeline.</a:t>
-            </a:r>
-          </a:p>
-        </p:txBody>
-      </p:sp>
-      <p:sp>
-        <p:nvSpPr>
-          <p:cNvPr id="13" name="">
-            <a:extLst xmlns:a="http://schemas.openxmlformats.org/drawingml/2006/main">
-              <a:ext uri="{FF2B5EF4-FFF2-40B4-BE49-F238E27FC236}">
-                <a16:creationId xmlns:a16="http://schemas.microsoft.com/office/drawing/2014/main" id="{CA187B54-08E2-4F28-A6E5-A5B343589C57}"/>
-              </a:ext>
-            </a:extLst>
-          </p:cNvPr>
-          <p:cNvSpPr>
-            <a:spLocks xmlns:a="http://schemas.openxmlformats.org/drawingml/2006/main" noGrp="1"/>
-          </p:cNvSpPr>
-          <p:nvPr/>
-        </p:nvSpPr>
-        <p:spPr>
-          <a:xfrm xmlns:a="http://schemas.openxmlformats.org/drawingml/2006/main">
-            <a:off x="1143000" y="6438900"/>
-            <a:ext cx="8953500" cy="190500"/>
-          </a:xfrm>
-          <a:prstGeom xmlns:a="http://schemas.openxmlformats.org/drawingml/2006/main" prst="rect">
-            <a:avLst/>
-          </a:prstGeom>
-          <a:noFill xmlns:a="http://schemas.openxmlformats.org/drawingml/2006/main"/>
-          <a:ln xmlns:a="http://schemas.openxmlformats.org/drawingml/2006/main" w="0">
-            <a:noFill/>
-          </a:ln>
-        </p:spPr>
-        <p:txBody>
-          <a:bodyPr xmlns:a="http://schemas.openxmlformats.org/drawingml/2006/main">
-            <a:normAutofit fontScale="72222"/>
-          </a:bodyPr>
-          <a:lstStyle xmlns:a="http://schemas.openxmlformats.org/drawingml/2006/main"/>
-          <a:p xmlns:a="http://schemas.openxmlformats.org/drawingml/2006/main">
-            <a:pPr algn="l">
-              <a:defRPr sz="900" b="0">
-                <a:solidFill>
-                  <a:srgbClr val="66727E"/>
-                </a:solidFill>
-                <a:latin typeface="Aptos"/>
-                <a:ea typeface="Aptos"/>
-                <a:cs typeface="Aptos"/>
-              </a:defRPr>
-            </a:pPr>
-            <a:r>
-              <a:rPr sz="900" b="0">
-                <a:solidFill>
-                  <a:srgbClr val="66727E"/>
-                </a:solidFill>
-                <a:latin typeface="Aptos"/>
-                <a:ea typeface="Aptos"/>
-                <a:cs typeface="Aptos"/>
-              </a:rPr>
-              <a:t>Exploratory: saved uncertainty is unavailable. METEOR stays separate from accuracy.</a:t>
+              <a:t>All scores were tested 28–29 May 2026. Release date describes the model, not the test date. No uncertainty ranges were saved.</a:t>
             </a:r>
           </a:p>
         </p:txBody>
@@ -6994,7 +6312,7 @@
     </p:spTree>
     <p:extLst>
       <p:ext uri="{BB962C8B-B14F-4D97-AF65-F5344CB8AC3E}">
-        <p14:creationId xmlns:p14="http://schemas.microsoft.com/office/powerpoint/2010/main" val="1479981797"/>
+        <p14:creationId xmlns:p14="http://schemas.microsoft.com/office/powerpoint/2010/main" val="569376836"/>
       </p:ext>
     </p:extLst>
   </p:cSld>
@@ -7022,10 +6340,10 @@
       </p:grpSpPr>
       <p:sp>
         <p:nvSpPr>
-          <p:cNvPr id="10" name="slide-title">
+          <p:cNvPr id="6" name="slide-title">
             <a:extLst xmlns:a="http://schemas.openxmlformats.org/drawingml/2006/main">
               <a:ext uri="{FF2B5EF4-FFF2-40B4-BE49-F238E27FC236}">
-                <a16:creationId xmlns:a16="http://schemas.microsoft.com/office/drawing/2014/main" id="{16C06B5D-4A1B-4DE5-81A2-7EBC30284F9A}"/>
+                <a16:creationId xmlns:a16="http://schemas.microsoft.com/office/drawing/2014/main" id="{DB10F2EB-6CF6-4B1B-9655-7D3641FE0571}"/>
               </a:ext>
             </a:extLst>
           </p:cNvPr>
@@ -7037,7 +6355,7 @@
         <p:spPr>
           <a:xfrm xmlns:a="http://schemas.openxmlformats.org/drawingml/2006/main">
             <a:off x="685800" y="342900"/>
-            <a:ext cx="8667750" cy="590550"/>
+            <a:ext cx="10820400" cy="590550"/>
           </a:xfrm>
           <a:prstGeom xmlns:a="http://schemas.openxmlformats.org/drawingml/2006/main" prst="rect">
             <a:avLst/>
@@ -7072,7 +6390,7 @@
                 <a:ea typeface="Aptos"/>
                 <a:cs typeface="Aptos"/>
               </a:rPr>
-              <a:t>We did not exactly repeat any paper's experiment</a:t>
+              <a:t>How the local tests relate to five papers</a:t>
             </a:r>
           </a:p>
         </p:txBody>
@@ -7082,7 +6400,7 @@
           <p:cNvPr id="2" name="slide-subtitle">
             <a:extLst xmlns:a="http://schemas.openxmlformats.org/drawingml/2006/main">
               <a:ext uri="{FF2B5EF4-FFF2-40B4-BE49-F238E27FC236}">
-                <a16:creationId xmlns:a16="http://schemas.microsoft.com/office/drawing/2014/main" id="{F699FF5F-E0ED-4AAA-AE53-3F2ED9D21BED}"/>
+                <a16:creationId xmlns:a16="http://schemas.microsoft.com/office/drawing/2014/main" id="{3F8257F8-879D-4FEA-9C10-3B648961EB85}"/>
               </a:ext>
             </a:extLst>
           </p:cNvPr>
@@ -7129,7 +6447,7 @@
                 <a:ea typeface="Aptos"/>
                 <a:cs typeface="Aptos"/>
               </a:rPr>
-              <a:t>The papers help explain our questions. Their scores cannot be compared with ours.</a:t>
+              <a:t>MoralBench, UniMoral, MoReBench, MoralLens, and Value Kaleidoscope</a:t>
             </a:r>
           </a:p>
         </p:txBody>
@@ -7139,68 +6457,7 @@
           <p:cNvPr id="3" name="">
             <a:extLst xmlns:a="http://schemas.openxmlformats.org/drawingml/2006/main">
               <a:ext uri="{FF2B5EF4-FFF2-40B4-BE49-F238E27FC236}">
-                <a16:creationId xmlns:a16="http://schemas.microsoft.com/office/drawing/2014/main" id="{3E3FC88B-D26C-48C1-A1E5-B881B72A6E94}"/>
-              </a:ext>
-            </a:extLst>
-          </p:cNvPr>
-          <p:cNvSpPr>
-            <a:spLocks xmlns:a="http://schemas.openxmlformats.org/drawingml/2006/main" noGrp="1"/>
-          </p:cNvSpPr>
-          <p:nvPr/>
-        </p:nvSpPr>
-        <p:spPr>
-          <a:xfrm xmlns:a="http://schemas.openxmlformats.org/drawingml/2006/main">
-            <a:off x="9753600" y="381000"/>
-            <a:ext cx="1752600" cy="323850"/>
-          </a:xfrm>
-          <a:prstGeom xmlns:a="http://schemas.openxmlformats.org/drawingml/2006/main" prst="roundRect">
-            <a:avLst>
-              <a:gd name="adj" fmla="val 50000"/>
-            </a:avLst>
-          </a:prstGeom>
-          <a:solidFill xmlns:a="http://schemas.openxmlformats.org/drawingml/2006/main">
-            <a:srgbClr val="EBE6F4"/>
-          </a:solidFill>
-          <a:ln xmlns:a="http://schemas.openxmlformats.org/drawingml/2006/main" w="0">
-            <a:noFill/>
-          </a:ln>
-        </p:spPr>
-        <p:txBody>
-          <a:bodyPr xmlns:a="http://schemas.openxmlformats.org/drawingml/2006/main">
-            <a:normAutofit fontScale="92575"/>
-          </a:bodyPr>
-          <a:lstStyle xmlns:a="http://schemas.openxmlformats.org/drawingml/2006/main"/>
-          <a:p xmlns:a="http://schemas.openxmlformats.org/drawingml/2006/main">
-            <a:pPr algn="ctr">
-              <a:defRPr sz="975" b="1">
-                <a:solidFill>
-                  <a:srgbClr val="6E5AA8"/>
-                </a:solidFill>
-                <a:latin typeface="Aptos"/>
-                <a:ea typeface="Aptos"/>
-                <a:cs typeface="Aptos"/>
-              </a:defRPr>
-            </a:pPr>
-            <a:r>
-              <a:rPr sz="975" b="1">
-                <a:solidFill>
-                  <a:srgbClr val="6E5AA8"/>
-                </a:solidFill>
-                <a:latin typeface="Aptos"/>
-                <a:ea typeface="Aptos"/>
-                <a:cs typeface="Aptos"/>
-              </a:rPr>
-              <a:t>PAPER REVIEW</a:t>
-            </a:r>
-          </a:p>
-        </p:txBody>
-      </p:sp>
-      <p:sp>
-        <p:nvSpPr>
-          <p:cNvPr id="4" name="">
-            <a:extLst xmlns:a="http://schemas.openxmlformats.org/drawingml/2006/main">
-              <a:ext uri="{FF2B5EF4-FFF2-40B4-BE49-F238E27FC236}">
-                <a16:creationId xmlns:a16="http://schemas.microsoft.com/office/drawing/2014/main" id="{317BC4CC-BDC4-49FD-B896-66E59C817631}"/>
+                <a16:creationId xmlns:a16="http://schemas.microsoft.com/office/drawing/2014/main" id="{1CF00064-7CE6-4798-AE1E-9EA189443E2F}"/>
               </a:ext>
             </a:extLst>
           </p:cNvPr>
@@ -7226,163 +6483,26 @@
           </a:ln>
         </p:spPr>
       </p:sp>
-      <p:sp>
-        <p:nvSpPr>
-          <p:cNvPr id="5" name="">
-            <a:extLst xmlns:a="http://schemas.openxmlformats.org/drawingml/2006/main">
-              <a:ext uri="{FF2B5EF4-FFF2-40B4-BE49-F238E27FC236}">
-                <a16:creationId xmlns:a16="http://schemas.microsoft.com/office/drawing/2014/main" id="{E1236383-D392-47B1-820C-ACFD057F93DE}"/>
-              </a:ext>
-            </a:extLst>
-          </p:cNvPr>
-          <p:cNvSpPr>
-            <a:spLocks xmlns:a="http://schemas.openxmlformats.org/drawingml/2006/main" noGrp="1"/>
-          </p:cNvSpPr>
-          <p:nvPr/>
-        </p:nvSpPr>
-        <p:spPr>
-          <a:xfrm xmlns:a="http://schemas.openxmlformats.org/drawingml/2006/main">
-            <a:off x="838200" y="2190750"/>
-            <a:ext cx="2190750" cy="1000125"/>
-          </a:xfrm>
-          <a:prstGeom xmlns:a="http://schemas.openxmlformats.org/drawingml/2006/main" prst="rect">
-            <a:avLst/>
-          </a:prstGeom>
-          <a:noFill xmlns:a="http://schemas.openxmlformats.org/drawingml/2006/main"/>
-          <a:ln xmlns:a="http://schemas.openxmlformats.org/drawingml/2006/main" w="0">
-            <a:noFill/>
-          </a:ln>
-        </p:spPr>
-        <p:txBody>
-          <a:bodyPr xmlns:a="http://schemas.openxmlformats.org/drawingml/2006/main">
-            <a:normAutofit fontScale="100000"/>
-          </a:bodyPr>
-          <a:lstStyle xmlns:a="http://schemas.openxmlformats.org/drawingml/2006/main"/>
-          <a:p xmlns:a="http://schemas.openxmlformats.org/drawingml/2006/main">
-            <a:pPr algn="ctr">
-              <a:defRPr sz="4500" b="1">
-                <a:solidFill>
-                  <a:srgbClr val="CF5D4A"/>
-                </a:solidFill>
-                <a:latin typeface="Aptos"/>
-                <a:ea typeface="Aptos"/>
-                <a:cs typeface="Aptos"/>
-              </a:defRPr>
-            </a:pPr>
-            <a:r>
-              <a:rPr sz="4500" b="1">
-                <a:solidFill>
-                  <a:srgbClr val="CF5D4A"/>
-                </a:solidFill>
-                <a:latin typeface="Aptos"/>
-                <a:ea typeface="Aptos"/>
-                <a:cs typeface="Aptos"/>
-              </a:rPr>
-              <a:t>0 of 4</a:t>
-            </a:r>
-          </a:p>
-        </p:txBody>
-      </p:sp>
-      <p:sp>
-        <p:nvSpPr>
-          <p:cNvPr id="6" name="">
-            <a:extLst xmlns:a="http://schemas.openxmlformats.org/drawingml/2006/main">
-              <a:ext uri="{FF2B5EF4-FFF2-40B4-BE49-F238E27FC236}">
-                <a16:creationId xmlns:a16="http://schemas.microsoft.com/office/drawing/2014/main" id="{69BD18FA-32A9-4A6B-9FB5-8B965D2D4EE0}"/>
-              </a:ext>
-            </a:extLst>
-          </p:cNvPr>
-          <p:cNvSpPr>
-            <a:spLocks xmlns:a="http://schemas.openxmlformats.org/drawingml/2006/main" noGrp="1"/>
-          </p:cNvSpPr>
-          <p:nvPr/>
-        </p:nvSpPr>
-        <p:spPr>
-          <a:xfrm xmlns:a="http://schemas.openxmlformats.org/drawingml/2006/main">
-            <a:off x="838200" y="3257550"/>
-            <a:ext cx="2190750" cy="762000"/>
-          </a:xfrm>
-          <a:prstGeom xmlns:a="http://schemas.openxmlformats.org/drawingml/2006/main" prst="rect">
-            <a:avLst/>
-          </a:prstGeom>
-          <a:noFill xmlns:a="http://schemas.openxmlformats.org/drawingml/2006/main"/>
-          <a:ln xmlns:a="http://schemas.openxmlformats.org/drawingml/2006/main" w="0">
-            <a:noFill/>
-          </a:ln>
-        </p:spPr>
-        <p:txBody>
-          <a:bodyPr xmlns:a="http://schemas.openxmlformats.org/drawingml/2006/main">
-            <a:normAutofit fontScale="100000"/>
-          </a:bodyPr>
-          <a:lstStyle xmlns:a="http://schemas.openxmlformats.org/drawingml/2006/main"/>
-          <a:p xmlns:a="http://schemas.openxmlformats.org/drawingml/2006/main">
-            <a:pPr algn="ctr">
-              <a:defRPr sz="1800" b="1">
-                <a:solidFill>
-                  <a:srgbClr val="17212B"/>
-                </a:solidFill>
-                <a:latin typeface="Aptos"/>
-                <a:ea typeface="Aptos"/>
-                <a:cs typeface="Aptos"/>
-              </a:defRPr>
-            </a:pPr>
-            <a:r>
-              <a:rPr sz="1800" b="1">
-                <a:solidFill>
-                  <a:srgbClr val="17212B"/>
-                </a:solidFill>
-                <a:latin typeface="Aptos"/>
-                <a:ea typeface="Aptos"/>
-                <a:cs typeface="Aptos"/>
-              </a:rPr>
-              <a:t>papers repeated</a:t>
-            </a:r>
-          </a:p>
-          <a:p xmlns:a="http://schemas.openxmlformats.org/drawingml/2006/main">
-            <a:pPr algn="ctr">
-              <a:defRPr sz="1800" b="1">
-                <a:solidFill>
-                  <a:srgbClr val="17212B"/>
-                </a:solidFill>
-                <a:latin typeface="Aptos"/>
-                <a:ea typeface="Aptos"/>
-                <a:cs typeface="Aptos"/>
-              </a:defRPr>
-            </a:pPr>
-            <a:r>
-              <a:rPr sz="1800" b="1">
-                <a:solidFill>
-                  <a:srgbClr val="17212B"/>
-                </a:solidFill>
-                <a:latin typeface="Aptos"/>
-                <a:ea typeface="Aptos"/>
-                <a:cs typeface="Aptos"/>
-              </a:rPr>
-              <a:t>exactly</a:t>
-            </a:r>
-          </a:p>
-        </p:txBody>
-      </p:sp>
       <p:graphicFrame>
         <p:nvGraphicFramePr>
-          <p:cNvPr id="16" name=""/>
+          <p:cNvPr id="9" name=""/>
           <p:cNvGraphicFramePr/>
           <p:nvPr/>
         </p:nvGraphicFramePr>
         <p:xfrm>
-          <a:off xmlns:a="http://schemas.openxmlformats.org/drawingml/2006/main" x="3381375" y="1714500"/>
-          <a:ext xmlns:a="http://schemas.openxmlformats.org/drawingml/2006/main" cx="8048625" cy="3429000"/>
+          <a:off xmlns:a="http://schemas.openxmlformats.org/drawingml/2006/main" x="781050" y="1657350"/>
+          <a:ext xmlns:a="http://schemas.openxmlformats.org/drawingml/2006/main" cx="10629900" cy="3829050"/>
         </p:xfrm>
         <a:graphic xmlns:a="http://schemas.openxmlformats.org/drawingml/2006/main">
           <a:graphicData uri="http://schemas.openxmlformats.org/drawingml/2006/table">
             <a:tbl>
               <a:tblPr/>
               <a:tblGrid>
-                <a:gridCol w="1666875"/>
-                <a:gridCol w="4476750"/>
-                <a:gridCol w="1905000"/>
+                <a:gridCol w="2000250"/>
+                <a:gridCol w="5619750"/>
+                <a:gridCol w="3009900"/>
               </a:tblGrid>
-              <a:tr h="685800">
+              <a:tr h="638175">
                 <a:tc>
                   <a:txBody>
                     <a:bodyPr/>
@@ -7421,7 +6541,7 @@
                           <a:ea typeface="Aptos"/>
                           <a:cs typeface="Aptos"/>
                         </a:rPr>
-                        <a:t>Plain-language question</a:t>
+                        <a:t>What it asks</a:t>
                       </a:r>
                     </a:p>
                   </a:txBody>
@@ -7445,7 +6565,7 @@
                           <a:ea typeface="Aptos"/>
                           <a:cs typeface="Aptos"/>
                         </a:rPr>
-                        <a:t>How close is our test?</a:t>
+                        <a:t>Closest local evidence</a:t>
                       </a:r>
                     </a:p>
                   </a:txBody>
@@ -7456,14 +6576,14 @@
                   </a:tcPr>
                 </a:tc>
               </a:tr>
-              <a:tr h="685800">
+              <a:tr h="638175">
                 <a:tc>
                   <a:txBody>
                     <a:bodyPr/>
                     <a:lstStyle/>
                     <a:p>
                       <a:r>
-                        <a:rPr sz="1275">
+                        <a:rPr sz="1200" b="1">
                           <a:solidFill>
                             <a:srgbClr val="17212B"/>
                           </a:solidFill>
@@ -7487,7 +6607,7 @@
                     <a:lstStyle/>
                     <a:p>
                       <a:r>
-                        <a:rPr sz="1275">
+                        <a:rPr sz="1200">
                           <a:solidFill>
                             <a:srgbClr val="17212B"/>
                           </a:solidFill>
@@ -7511,7 +6631,7 @@
                     <a:lstStyle/>
                     <a:p>
                       <a:r>
-                        <a:rPr sz="1275" b="1">
+                        <a:rPr sz="1200">
                           <a:solidFill>
                             <a:srgbClr val="17212B"/>
                           </a:solidFill>
@@ -7519,7 +6639,7 @@
                           <a:ea typeface="Aptos"/>
                           <a:cs typeface="Aptos"/>
                         </a:rPr>
-                        <a:t>Similar question</a:t>
+                        <a:t>Related tasks, different setup</a:t>
                       </a:r>
                     </a:p>
                   </a:txBody>
@@ -7530,14 +6650,14 @@
                   </a:tcPr>
                 </a:tc>
               </a:tr>
-              <a:tr h="685800">
+              <a:tr h="638175">
                 <a:tc>
                   <a:txBody>
                     <a:bodyPr/>
                     <a:lstStyle/>
                     <a:p>
                       <a:r>
-                        <a:rPr sz="1275">
+                        <a:rPr sz="1200" b="1">
                           <a:solidFill>
                             <a:srgbClr val="17212B"/>
                           </a:solidFill>
@@ -7561,7 +6681,7 @@
                     <a:lstStyle/>
                     <a:p>
                       <a:r>
-                        <a:rPr sz="1275">
+                        <a:rPr sz="1200">
                           <a:solidFill>
                             <a:srgbClr val="17212B"/>
                           </a:solidFill>
@@ -7569,7 +6689,7 @@
                           <a:ea typeface="Aptos"/>
                           <a:cs typeface="Aptos"/>
                         </a:rPr>
-                        <a:t>Can models predict choices, moral categories, influences, and what happens next?</a:t>
+                        <a:t>Can models predict actions, types, factors, and consequences?</a:t>
                       </a:r>
                     </a:p>
                   </a:txBody>
@@ -7585,7 +6705,7 @@
                     <a:lstStyle/>
                     <a:p>
                       <a:r>
-                        <a:rPr sz="1275" b="1">
+                        <a:rPr sz="1200">
                           <a:solidFill>
                             <a:srgbClr val="17212B"/>
                           </a:solidFill>
@@ -7593,7 +6713,7 @@
                           <a:ea typeface="Aptos"/>
                           <a:cs typeface="Aptos"/>
                         </a:rPr>
-                        <a:t>Some similar tasks</a:t>
+                        <a:t>Narrower versions of four tasks</a:t>
                       </a:r>
                     </a:p>
                   </a:txBody>
@@ -7604,14 +6724,14 @@
                   </a:tcPr>
                 </a:tc>
               </a:tr>
-              <a:tr h="685800">
+              <a:tr h="638175">
                 <a:tc>
                   <a:txBody>
                     <a:bodyPr/>
                     <a:lstStyle/>
                     <a:p>
                       <a:r>
-                        <a:rPr sz="1275">
+                        <a:rPr sz="1200" b="1">
                           <a:solidFill>
                             <a:srgbClr val="17212B"/>
                           </a:solidFill>
@@ -7635,7 +6755,7 @@
                     <a:lstStyle/>
                     <a:p>
                       <a:r>
-                        <a:rPr sz="1275">
+                        <a:rPr sz="1200">
                           <a:solidFill>
                             <a:srgbClr val="17212B"/>
                           </a:solidFill>
@@ -7643,7 +6763,7 @@
                           <a:ea typeface="Aptos"/>
                           <a:cs typeface="Aptos"/>
                         </a:rPr>
-                        <a:t>Does reasoning cover expert criteria?</a:t>
+                        <a:t>Does reasoning meet expert criteria?</a:t>
                       </a:r>
                     </a:p>
                   </a:txBody>
@@ -7659,7 +6779,7 @@
                     <a:lstStyle/>
                     <a:p>
                       <a:r>
-                        <a:rPr sz="1275" b="1">
+                        <a:rPr sz="1200">
                           <a:solidFill>
                             <a:srgbClr val="17212B"/>
                           </a:solidFill>
@@ -7667,7 +6787,7 @@
                           <a:ea typeface="Aptos"/>
                           <a:cs typeface="Aptos"/>
                         </a:rPr>
-                        <a:t>Related question, different test</a:t>
+                        <a:t>Keyword check only</a:t>
                       </a:r>
                     </a:p>
                   </a:txBody>
@@ -7678,14 +6798,14 @@
                   </a:tcPr>
                 </a:tc>
               </a:tr>
-              <a:tr h="685800">
+              <a:tr h="638175">
                 <a:tc>
                   <a:txBody>
                     <a:bodyPr/>
                     <a:lstStyle/>
                     <a:p>
                       <a:r>
-                        <a:rPr sz="1275">
+                        <a:rPr sz="1200" b="1">
                           <a:solidFill>
                             <a:srgbClr val="17212B"/>
                           </a:solidFill>
@@ -7709,7 +6829,7 @@
                     <a:lstStyle/>
                     <a:p>
                       <a:r>
-                        <a:rPr sz="1275">
+                        <a:rPr sz="1200">
                           <a:solidFill>
                             <a:srgbClr val="17212B"/>
                           </a:solidFill>
@@ -7717,7 +6837,7 @@
                           <a:ea typeface="Aptos"/>
                           <a:cs typeface="Aptos"/>
                         </a:rPr>
-                        <a:t>Do reasons change when a model explains before or after choosing?</a:t>
+                        <a:t>Does reasoning order change reasons and choices?</a:t>
                       </a:r>
                     </a:p>
                   </a:txBody>
@@ -7733,7 +6853,7 @@
                     <a:lstStyle/>
                     <a:p>
                       <a:r>
-                        <a:rPr sz="1275" b="1">
+                        <a:rPr sz="1200">
                           <a:solidFill>
                             <a:srgbClr val="17212B"/>
                           </a:solidFill>
@@ -7741,7 +6861,81 @@
                           <a:ea typeface="Aptos"/>
                           <a:cs typeface="Aptos"/>
                         </a:rPr>
-                        <a:t>Related question, different test</a:t>
+                        <a:t>Keyword check only</a:t>
+                      </a:r>
+                    </a:p>
+                  </a:txBody>
+                  <a:tcPr marL="114300" marR="114300" marT="66675" marB="66675">
+                    <a:solidFill>
+                      <a:srgbClr val="FFFFFF"/>
+                    </a:solidFill>
+                  </a:tcPr>
+                </a:tc>
+              </a:tr>
+              <a:tr h="638175">
+                <a:tc>
+                  <a:txBody>
+                    <a:bodyPr/>
+                    <a:lstStyle/>
+                    <a:p>
+                      <a:r>
+                        <a:rPr sz="1200" b="1">
+                          <a:solidFill>
+                            <a:srgbClr val="17212B"/>
+                          </a:solidFill>
+                          <a:latin typeface="Aptos"/>
+                          <a:ea typeface="Aptos"/>
+                          <a:cs typeface="Aptos"/>
+                        </a:rPr>
+                        <a:t>Value Kaleidoscope</a:t>
+                      </a:r>
+                    </a:p>
+                  </a:txBody>
+                  <a:tcPr marL="114300" marR="114300" marT="66675" marB="66675">
+                    <a:solidFill>
+                      <a:srgbClr val="FFFFFF"/>
+                    </a:solidFill>
+                  </a:tcPr>
+                </a:tc>
+                <a:tc>
+                  <a:txBody>
+                    <a:bodyPr/>
+                    <a:lstStyle/>
+                    <a:p>
+                      <a:r>
+                        <a:rPr sz="1200">
+                          <a:solidFill>
+                            <a:srgbClr val="17212B"/>
+                          </a:solidFill>
+                          <a:latin typeface="Aptos"/>
+                          <a:ea typeface="Aptos"/>
+                          <a:cs typeface="Aptos"/>
+                        </a:rPr>
+                        <a:t>How do value tasks change with model size?</a:t>
+                      </a:r>
+                    </a:p>
+                  </a:txBody>
+                  <a:tcPr marL="114300" marR="114300" marT="66675" marB="66675">
+                    <a:solidFill>
+                      <a:srgbClr val="FFFFFF"/>
+                    </a:solidFill>
+                  </a:tcPr>
+                </a:tc>
+                <a:tc>
+                  <a:txBody>
+                    <a:bodyPr/>
+                    <a:lstStyle/>
+                    <a:p>
+                      <a:r>
+                        <a:rPr sz="1200">
+                          <a:solidFill>
+                            <a:srgbClr val="17212B"/>
+                          </a:solidFill>
+                          <a:latin typeface="Aptos"/>
+                          <a:ea typeface="Aptos"/>
+                          <a:cs typeface="Aptos"/>
+                        </a:rPr>
+                        <a:t>Different models and scoring</a:t>
                       </a:r>
                     </a:p>
                   </a:txBody>
@@ -7758,10 +6952,10 @@
       </p:graphicFrame>
       <p:sp>
         <p:nvSpPr>
-          <p:cNvPr id="8" name="">
+          <p:cNvPr id="5" name="">
             <a:extLst xmlns:a="http://schemas.openxmlformats.org/drawingml/2006/main">
               <a:ext uri="{FF2B5EF4-FFF2-40B4-BE49-F238E27FC236}">
-                <a16:creationId xmlns:a16="http://schemas.microsoft.com/office/drawing/2014/main" id="{53316BAD-153D-4A5C-A00B-B7F96735BD29}"/>
+                <a16:creationId xmlns:a16="http://schemas.microsoft.com/office/drawing/2014/main" id="{A53E4184-9E5A-4794-B031-6328E2A4F4E0}"/>
               </a:ext>
             </a:extLst>
           </p:cNvPr>
@@ -7772,8 +6966,8 @@
         </p:nvSpPr>
         <p:spPr>
           <a:xfrm xmlns:a="http://schemas.openxmlformats.org/drawingml/2006/main">
-            <a:off x="3381375" y="5429250"/>
-            <a:ext cx="8048625" cy="381000"/>
+            <a:off x="876300" y="5810250"/>
+            <a:ext cx="10439400" cy="323850"/>
           </a:xfrm>
           <a:prstGeom xmlns:a="http://schemas.openxmlformats.org/drawingml/2006/main" prst="rect">
             <a:avLst/>
@@ -7789,10 +6983,10 @@
           </a:bodyPr>
           <a:lstStyle xmlns:a="http://schemas.openxmlformats.org/drawingml/2006/main"/>
           <a:p xmlns:a="http://schemas.openxmlformats.org/drawingml/2006/main">
-            <a:pPr algn="l">
-              <a:defRPr sz="1575" b="1">
-                <a:solidFill>
-                  <a:srgbClr val="6E5AA8"/>
+            <a:pPr algn="ctr">
+              <a:defRPr sz="1500" b="1">
+                <a:solidFill>
+                  <a:srgbClr val="17212B"/>
                 </a:solidFill>
                 <a:latin typeface="Aptos"/>
                 <a:ea typeface="Aptos"/>
@@ -7800,72 +6994,15 @@
               </a:defRPr>
             </a:pPr>
             <a:r>
-              <a:rPr sz="1575" b="1">
-                <a:solidFill>
-                  <a:srgbClr val="6E5AA8"/>
+              <a:rPr sz="1500" b="1">
+                <a:solidFill>
+                  <a:srgbClr val="17212B"/>
                 </a:solidFill>
                 <a:latin typeface="Aptos"/>
                 <a:ea typeface="Aptos"/>
                 <a:cs typeface="Aptos"/>
               </a:rPr>
-              <a:t>Use the papers to explain our questions—not to compare scores.</a:t>
-            </a:r>
-          </a:p>
-        </p:txBody>
-      </p:sp>
-      <p:sp>
-        <p:nvSpPr>
-          <p:cNvPr id="9" name="">
-            <a:extLst xmlns:a="http://schemas.openxmlformats.org/drawingml/2006/main">
-              <a:ext uri="{FF2B5EF4-FFF2-40B4-BE49-F238E27FC236}">
-                <a16:creationId xmlns:a16="http://schemas.microsoft.com/office/drawing/2014/main" id="{C303B648-B7F3-4067-9522-62C916B12784}"/>
-              </a:ext>
-            </a:extLst>
-          </p:cNvPr>
-          <p:cNvSpPr>
-            <a:spLocks xmlns:a="http://schemas.openxmlformats.org/drawingml/2006/main" noGrp="1"/>
-          </p:cNvSpPr>
-          <p:nvPr/>
-        </p:nvSpPr>
-        <p:spPr>
-          <a:xfrm xmlns:a="http://schemas.openxmlformats.org/drawingml/2006/main">
-            <a:off x="3381375" y="5886450"/>
-            <a:ext cx="8048625" cy="266700"/>
-          </a:xfrm>
-          <a:prstGeom xmlns:a="http://schemas.openxmlformats.org/drawingml/2006/main" prst="rect">
-            <a:avLst/>
-          </a:prstGeom>
-          <a:noFill xmlns:a="http://schemas.openxmlformats.org/drawingml/2006/main"/>
-          <a:ln xmlns:a="http://schemas.openxmlformats.org/drawingml/2006/main" w="0">
-            <a:noFill/>
-          </a:ln>
-        </p:spPr>
-        <p:txBody>
-          <a:bodyPr xmlns:a="http://schemas.openxmlformats.org/drawingml/2006/main">
-            <a:normAutofit fontScale="100000"/>
-          </a:bodyPr>
-          <a:lstStyle xmlns:a="http://schemas.openxmlformats.org/drawingml/2006/main"/>
-          <a:p xmlns:a="http://schemas.openxmlformats.org/drawingml/2006/main">
-            <a:pPr algn="l">
-              <a:defRPr sz="1125" b="0">
-                <a:solidFill>
-                  <a:srgbClr val="66727E"/>
-                </a:solidFill>
-                <a:latin typeface="Aptos"/>
-                <a:ea typeface="Aptos"/>
-                <a:cs typeface="Aptos"/>
-              </a:defRPr>
-            </a:pPr>
-            <a:r>
-              <a:rPr sz="1125" b="0">
-                <a:solidFill>
-                  <a:srgbClr val="66727E"/>
-                </a:solidFill>
-                <a:latin typeface="Aptos"/>
-                <a:ea typeface="Aptos"/>
-                <a:cs typeface="Aptos"/>
-              </a:rPr>
-              <a:t>Our UniMoral run does not test prompt hints, language differences, or where the stories came from.</a:t>
+              <a:t>None of the five is reproduced exactly. Paper scores and local scores stay separate.</a:t>
             </a:r>
           </a:p>
         </p:txBody>
@@ -7873,7 +7010,7 @@
     </p:spTree>
     <p:extLst>
       <p:ext uri="{BB962C8B-B14F-4D97-AF65-F5344CB8AC3E}">
-        <p14:creationId xmlns:p14="http://schemas.microsoft.com/office/powerpoint/2010/main" val="1824483752"/>
+        <p14:creationId xmlns:p14="http://schemas.microsoft.com/office/powerpoint/2010/main" val="303030376"/>
       </p:ext>
     </p:extLst>
   </p:cSld>
@@ -7901,10 +7038,10 @@
       </p:grpSpPr>
       <p:sp>
         <p:nvSpPr>
-          <p:cNvPr id="8" name="slide-title">
+          <p:cNvPr id="6" name="slide-title">
             <a:extLst xmlns:a="http://schemas.openxmlformats.org/drawingml/2006/main">
               <a:ext uri="{FF2B5EF4-FFF2-40B4-BE49-F238E27FC236}">
-                <a16:creationId xmlns:a16="http://schemas.microsoft.com/office/drawing/2014/main" id="{9F739914-15D0-4BD5-B112-73A012BA61B9}"/>
+                <a16:creationId xmlns:a16="http://schemas.microsoft.com/office/drawing/2014/main" id="{F2D1AE2A-EBDD-4270-BA54-D971CDC955C3}"/>
               </a:ext>
             </a:extLst>
           </p:cNvPr>
@@ -7916,7 +7053,7 @@
         <p:spPr>
           <a:xfrm xmlns:a="http://schemas.openxmlformats.org/drawingml/2006/main">
             <a:off x="685800" y="342900"/>
-            <a:ext cx="8667750" cy="590550"/>
+            <a:ext cx="10820400" cy="590550"/>
           </a:xfrm>
           <a:prstGeom xmlns:a="http://schemas.openxmlformats.org/drawingml/2006/main" prst="rect">
             <a:avLst/>
@@ -7951,7 +7088,7 @@
                 <a:ea typeface="Aptos"/>
                 <a:cs typeface="Aptos"/>
               </a:rPr>
-              <a:t>Share task results now. Strengthen the test next.</a:t>
+              <a:t>MoralBench and UniMoral: what we can report now</a:t>
             </a:r>
           </a:p>
         </p:txBody>
@@ -7961,7 +7098,7 @@
           <p:cNvPr id="2" name="slide-subtitle">
             <a:extLst xmlns:a="http://schemas.openxmlformats.org/drawingml/2006/main">
               <a:ext uri="{FF2B5EF4-FFF2-40B4-BE49-F238E27FC236}">
-                <a16:creationId xmlns:a16="http://schemas.microsoft.com/office/drawing/2014/main" id="{ED32C618-631F-4526-BB4A-70876E1B8BDE}"/>
+                <a16:creationId xmlns:a16="http://schemas.microsoft.com/office/drawing/2014/main" id="{CAF61687-0441-481E-BA7D-205FBA5331D4}"/>
               </a:ext>
             </a:extLst>
           </p:cNvPr>
@@ -8008,7 +7145,7 @@
                 <a:ea typeface="Aptos"/>
                 <a:cs typeface="Aptos"/>
               </a:rPr>
-              <a:t>Better evidence makes the current results more useful</a:t>
+              <a:t>Report the 8 task results now. Do not publish one overall model rank.</a:t>
             </a:r>
           </a:p>
         </p:txBody>
@@ -8018,68 +7155,7 @@
           <p:cNvPr id="3" name="">
             <a:extLst xmlns:a="http://schemas.openxmlformats.org/drawingml/2006/main">
               <a:ext uri="{FF2B5EF4-FFF2-40B4-BE49-F238E27FC236}">
-                <a16:creationId xmlns:a16="http://schemas.microsoft.com/office/drawing/2014/main" id="{A3FAF773-72DE-40DD-B4D9-1DFFB2F62EAE}"/>
-              </a:ext>
-            </a:extLst>
-          </p:cNvPr>
-          <p:cNvSpPr>
-            <a:spLocks xmlns:a="http://schemas.openxmlformats.org/drawingml/2006/main" noGrp="1"/>
-          </p:cNvSpPr>
-          <p:nvPr/>
-        </p:nvSpPr>
-        <p:spPr>
-          <a:xfrm xmlns:a="http://schemas.openxmlformats.org/drawingml/2006/main">
-            <a:off x="9753600" y="381000"/>
-            <a:ext cx="1752600" cy="323850"/>
-          </a:xfrm>
-          <a:prstGeom xmlns:a="http://schemas.openxmlformats.org/drawingml/2006/main" prst="roundRect">
-            <a:avLst>
-              <a:gd name="adj" fmla="val 50000"/>
-            </a:avLst>
-          </a:prstGeom>
-          <a:solidFill xmlns:a="http://schemas.openxmlformats.org/drawingml/2006/main">
-            <a:srgbClr val="F6E5E0"/>
-          </a:solidFill>
-          <a:ln xmlns:a="http://schemas.openxmlformats.org/drawingml/2006/main" w="0">
-            <a:noFill/>
-          </a:ln>
-        </p:spPr>
-        <p:txBody>
-          <a:bodyPr xmlns:a="http://schemas.openxmlformats.org/drawingml/2006/main">
-            <a:normAutofit fontScale="92575"/>
-          </a:bodyPr>
-          <a:lstStyle xmlns:a="http://schemas.openxmlformats.org/drawingml/2006/main"/>
-          <a:p xmlns:a="http://schemas.openxmlformats.org/drawingml/2006/main">
-            <a:pPr algn="ctr">
-              <a:defRPr sz="975" b="1">
-                <a:solidFill>
-                  <a:srgbClr val="CF5D4A"/>
-                </a:solidFill>
-                <a:latin typeface="Aptos"/>
-                <a:ea typeface="Aptos"/>
-                <a:cs typeface="Aptos"/>
-              </a:defRPr>
-            </a:pPr>
-            <a:r>
-              <a:rPr sz="975" b="1">
-                <a:solidFill>
-                  <a:srgbClr val="CF5D4A"/>
-                </a:solidFill>
-                <a:latin typeface="Aptos"/>
-                <a:ea typeface="Aptos"/>
-                <a:cs typeface="Aptos"/>
-              </a:rPr>
-              <a:t>DECISION</a:t>
-            </a:r>
-          </a:p>
-        </p:txBody>
-      </p:sp>
-      <p:sp>
-        <p:nvSpPr>
-          <p:cNvPr id="4" name="">
-            <a:extLst xmlns:a="http://schemas.openxmlformats.org/drawingml/2006/main">
-              <a:ext uri="{FF2B5EF4-FFF2-40B4-BE49-F238E27FC236}">
-                <a16:creationId xmlns:a16="http://schemas.microsoft.com/office/drawing/2014/main" id="{F324F1EB-CAF8-4023-B4C2-168A71479720}"/>
+                <a16:creationId xmlns:a16="http://schemas.microsoft.com/office/drawing/2014/main" id="{2E812F55-67A6-4E03-958F-1987BAF4C262}"/>
               </a:ext>
             </a:extLst>
           </p:cNvPr>
@@ -8107,7 +7183,7 @@
       </p:sp>
       <p:graphicFrame>
         <p:nvGraphicFramePr>
-          <p:cNvPr id="12" name=""/>
+          <p:cNvPr id="9" name=""/>
           <p:cNvGraphicFramePr/>
           <p:nvPr/>
         </p:nvGraphicFramePr>
@@ -8500,10 +7576,10 @@
       </p:graphicFrame>
       <p:sp>
         <p:nvSpPr>
-          <p:cNvPr id="6" name="">
+          <p:cNvPr id="5" name="">
             <a:extLst xmlns:a="http://schemas.openxmlformats.org/drawingml/2006/main">
               <a:ext uri="{FF2B5EF4-FFF2-40B4-BE49-F238E27FC236}">
-                <a16:creationId xmlns:a16="http://schemas.microsoft.com/office/drawing/2014/main" id="{63266D95-41E5-41BC-B3C8-484BF2679630}"/>
+                <a16:creationId xmlns:a16="http://schemas.microsoft.com/office/drawing/2014/main" id="{428D2625-3B31-44B9-8D82-161980ED88A0}"/>
               </a:ext>
             </a:extLst>
           </p:cNvPr>
@@ -8514,8 +7590,8 @@
         </p:nvSpPr>
         <p:spPr>
           <a:xfrm xmlns:a="http://schemas.openxmlformats.org/drawingml/2006/main">
-            <a:off x="876300" y="5543550"/>
-            <a:ext cx="2857500" cy="285750"/>
+            <a:off x="876300" y="5715000"/>
+            <a:ext cx="10439400" cy="438150"/>
           </a:xfrm>
           <a:prstGeom xmlns:a="http://schemas.openxmlformats.org/drawingml/2006/main" prst="rect">
             <a:avLst/>
@@ -8532,9 +7608,9 @@
           <a:lstStyle xmlns:a="http://schemas.openxmlformats.org/drawingml/2006/main"/>
           <a:p xmlns:a="http://schemas.openxmlformats.org/drawingml/2006/main">
             <a:pPr algn="l">
-              <a:defRPr sz="1275" b="1">
-                <a:solidFill>
-                  <a:srgbClr val="66727E"/>
+              <a:defRPr sz="1800" b="1">
+                <a:solidFill>
+                  <a:srgbClr val="17212B"/>
                 </a:solidFill>
                 <a:latin typeface="Aptos"/>
                 <a:ea typeface="Aptos"/>
@@ -8542,72 +7618,15 @@
               </a:defRPr>
             </a:pPr>
             <a:r>
-              <a:rPr sz="1275" b="1">
-                <a:solidFill>
-                  <a:srgbClr val="66727E"/>
+              <a:rPr sz="1800" b="1">
+                <a:solidFill>
+                  <a:srgbClr val="17212B"/>
                 </a:solidFill>
                 <a:latin typeface="Aptos"/>
                 <a:ea typeface="Aptos"/>
                 <a:cs typeface="Aptos"/>
               </a:rPr>
-              <a:t>Best research next move</a:t>
-            </a:r>
-          </a:p>
-        </p:txBody>
-      </p:sp>
-      <p:sp>
-        <p:nvSpPr>
-          <p:cNvPr id="7" name="">
-            <a:extLst xmlns:a="http://schemas.openxmlformats.org/drawingml/2006/main">
-              <a:ext uri="{FF2B5EF4-FFF2-40B4-BE49-F238E27FC236}">
-                <a16:creationId xmlns:a16="http://schemas.microsoft.com/office/drawing/2014/main" id="{3BD80480-CF37-4ABB-B366-9D32704E09DD}"/>
-              </a:ext>
-            </a:extLst>
-          </p:cNvPr>
-          <p:cNvSpPr>
-            <a:spLocks xmlns:a="http://schemas.openxmlformats.org/drawingml/2006/main" noGrp="1"/>
-          </p:cNvSpPr>
-          <p:nvPr/>
-        </p:nvSpPr>
-        <p:spPr>
-          <a:xfrm xmlns:a="http://schemas.openxmlformats.org/drawingml/2006/main">
-            <a:off x="876300" y="5848350"/>
-            <a:ext cx="10439400" cy="438150"/>
-          </a:xfrm>
-          <a:prstGeom xmlns:a="http://schemas.openxmlformats.org/drawingml/2006/main" prst="rect">
-            <a:avLst/>
-          </a:prstGeom>
-          <a:noFill xmlns:a="http://schemas.openxmlformats.org/drawingml/2006/main"/>
-          <a:ln xmlns:a="http://schemas.openxmlformats.org/drawingml/2006/main" w="0">
-            <a:noFill/>
-          </a:ln>
-        </p:spPr>
-        <p:txBody>
-          <a:bodyPr xmlns:a="http://schemas.openxmlformats.org/drawingml/2006/main">
-            <a:normAutofit fontScale="87244"/>
-          </a:bodyPr>
-          <a:lstStyle xmlns:a="http://schemas.openxmlformats.org/drawingml/2006/main"/>
-          <a:p xmlns:a="http://schemas.openxmlformats.org/drawingml/2006/main">
-            <a:pPr algn="l">
-              <a:defRPr sz="1800" b="1">
-                <a:solidFill>
-                  <a:srgbClr val="17212B"/>
-                </a:solidFill>
-                <a:latin typeface="Aptos"/>
-                <a:ea typeface="Aptos"/>
-                <a:cs typeface="Aptos"/>
-              </a:defRPr>
-            </a:pPr>
-            <a:r>
-              <a:rPr sz="1800" b="1">
-                <a:solidFill>
-                  <a:srgbClr val="17212B"/>
-                </a:solidFill>
-                <a:latin typeface="Aptos"/>
-                <a:ea typeface="Aptos"/>
-                <a:cs typeface="Aptos"/>
-              </a:rPr>
-              <a:t>Restore answers and scores. Check scoring and labels. Compare models. Then have people review the test.</a:t>
+              <a:t>Next: restore answers and scores, check scoring, compare models, and get human review.</a:t>
             </a:r>
           </a:p>
         </p:txBody>
@@ -8615,7 +7634,7 @@
     </p:spTree>
     <p:extLst>
       <p:ext uri="{BB962C8B-B14F-4D97-AF65-F5344CB8AC3E}">
-        <p14:creationId xmlns:p14="http://schemas.microsoft.com/office/powerpoint/2010/main" val="2094009231"/>
+        <p14:creationId xmlns:p14="http://schemas.microsoft.com/office/powerpoint/2010/main" val="1852628922"/>
       </p:ext>
     </p:extLst>
   </p:cSld>

</xml_diff>

<commit_message>
Simplify public results structure
</commit_message>
<xml_diff>
--- a/slides/cei-moral-psychology-results-deck.pptx
+++ b/slides/cei-moral-psychology-results-deck.pptx
@@ -2,20 +2,20 @@
 <file path=ppt/presentation.xml><?xml version="1.0" encoding="utf-8"?>
 <p:presentation xmlns:p="http://schemas.openxmlformats.org/presentationml/2006/main">
   <p:sldMasterIdLst>
-    <p:sldMasterId xmlns:r="http://schemas.openxmlformats.org/officeDocument/2006/relationships" id="2147483648" r:id="R33f090db8080438d"/>
+    <p:sldMasterId xmlns:r="http://schemas.openxmlformats.org/officeDocument/2006/relationships" id="2147483648" r:id="Rac750c37d0e44a79"/>
   </p:sldMasterIdLst>
   <p:notesMasterIdLst>
-    <p:notesMasterId xmlns:r="http://schemas.openxmlformats.org/officeDocument/2006/relationships" r:id="R43e310ec63f1434a"/>
+    <p:notesMasterId xmlns:r="http://schemas.openxmlformats.org/officeDocument/2006/relationships" r:id="Rc60fa2dc173146de"/>
   </p:notesMasterIdLst>
   <p:sldIdLst>
-    <p:sldId xmlns:r="http://schemas.openxmlformats.org/officeDocument/2006/relationships" id="256" r:id="R376bb1f50c4c4960"/>
-    <p:sldId xmlns:r="http://schemas.openxmlformats.org/officeDocument/2006/relationships" id="257" r:id="R6a6fa43bd6dd47b8"/>
-    <p:sldId xmlns:r="http://schemas.openxmlformats.org/officeDocument/2006/relationships" id="258" r:id="Rabe7afbc6dc3423b"/>
-    <p:sldId xmlns:r="http://schemas.openxmlformats.org/officeDocument/2006/relationships" id="259" r:id="R1c6d28cc7d294840"/>
-    <p:sldId xmlns:r="http://schemas.openxmlformats.org/officeDocument/2006/relationships" id="260" r:id="Rc652fc765851475a"/>
-    <p:sldId xmlns:r="http://schemas.openxmlformats.org/officeDocument/2006/relationships" id="261" r:id="R10961c3f54ac4ede"/>
-    <p:sldId xmlns:r="http://schemas.openxmlformats.org/officeDocument/2006/relationships" id="262" r:id="Ra3dccf69e653411a"/>
-    <p:sldId xmlns:r="http://schemas.openxmlformats.org/officeDocument/2006/relationships" id="263" r:id="Re89ecb56c0284e9c"/>
+    <p:sldId xmlns:r="http://schemas.openxmlformats.org/officeDocument/2006/relationships" id="256" r:id="Rda8936e4b15e4d8e"/>
+    <p:sldId xmlns:r="http://schemas.openxmlformats.org/officeDocument/2006/relationships" id="257" r:id="Re43c5aab86614952"/>
+    <p:sldId xmlns:r="http://schemas.openxmlformats.org/officeDocument/2006/relationships" id="258" r:id="R702af694b4734536"/>
+    <p:sldId xmlns:r="http://schemas.openxmlformats.org/officeDocument/2006/relationships" id="259" r:id="R591c991e4ebf4416"/>
+    <p:sldId xmlns:r="http://schemas.openxmlformats.org/officeDocument/2006/relationships" id="260" r:id="Rd9212e26a41a4350"/>
+    <p:sldId xmlns:r="http://schemas.openxmlformats.org/officeDocument/2006/relationships" id="261" r:id="R09e3b459a5014ba0"/>
+    <p:sldId xmlns:r="http://schemas.openxmlformats.org/officeDocument/2006/relationships" id="262" r:id="Rbcd6cbd722864403"/>
+    <p:sldId xmlns:r="http://schemas.openxmlformats.org/officeDocument/2006/relationships" id="263" r:id="Re43127a565574d5f"/>
   </p:sldIdLst>
   <p:sldSz cx="12192000" cy="6858000"/>
   <p:notesSz cx="6858000" cy="9144000"/>
@@ -539,7 +539,7 @@
           </a:p>
           <a:p xmlns:a="http://schemas.openxmlformats.org/drawingml/2006/main">
             <a:r>
-              <a:t>Sources: data/results/common_roster_primary.csv; docs/RESULTS_READOUT.md section 1; docs/PAPER_REVIEW.md protocol comparison; evidence/canonical-audit/CLAIM_BOUNDARIES.md.</a:t>
+              <a:t>Sources: data/results/common_roster_primary.csv; docs/PAPER_REVIEW.md protocol comparison; evidence/canonical-audit/CLAIM_BOUNDARIES.md.</a:t>
             </a:r>
           </a:p>
           <a:p xmlns:a="http://schemas.openxmlformats.org/drawingml/2006/main">
@@ -1132,7 +1132,7 @@
   </p:cSld>
   <p:clrMap bg1="lt1" tx1="dk1" bg2="lt2" tx2="dk2" accent1="accent1" accent2="accent2" accent3="accent3" accent4="accent4" accent5="accent5" accent6="accent6" hlink="hlink" folHlink="folHlink"/>
   <p:sldLayoutIdLst>
-    <p:sldLayoutId xmlns:r="http://schemas.openxmlformats.org/officeDocument/2006/relationships" id="2147483649" r:id="Re3fdf49366cf43ba"/>
+    <p:sldLayoutId xmlns:r="http://schemas.openxmlformats.org/officeDocument/2006/relationships" id="2147483649" r:id="R576340c0df66435f"/>
   </p:sldLayoutIdLst>
   <p:txStyles>
     <p:titleStyle>
@@ -2728,7 +2728,7 @@
           <p:cNvPr id="9" name="cover-title">
             <a:extLst xmlns:a="http://schemas.openxmlformats.org/drawingml/2006/main">
               <a:ext uri="{FF2B5EF4-FFF2-40B4-BE49-F238E27FC236}">
-                <a16:creationId xmlns:a16="http://schemas.microsoft.com/office/drawing/2014/main" id="{0D736628-41C3-45C8-8E40-1861E2EC334D}"/>
+                <a16:creationId xmlns:a16="http://schemas.microsoft.com/office/drawing/2014/main" id="{E6C39593-561B-46AE-A728-F8A49AACC6AA}"/>
               </a:ext>
             </a:extLst>
           </p:cNvPr>
@@ -2785,7 +2785,7 @@
           <p:cNvPr id="2" name="">
             <a:extLst xmlns:a="http://schemas.openxmlformats.org/drawingml/2006/main">
               <a:ext uri="{FF2B5EF4-FFF2-40B4-BE49-F238E27FC236}">
-                <a16:creationId xmlns:a16="http://schemas.microsoft.com/office/drawing/2014/main" id="{12D439F8-AB77-4F4D-AB87-825241B95B6C}"/>
+                <a16:creationId xmlns:a16="http://schemas.microsoft.com/office/drawing/2014/main" id="{859217C0-0062-464A-B316-14260293C0E9}"/>
               </a:ext>
             </a:extLst>
           </p:cNvPr>
@@ -2842,7 +2842,7 @@
           <p:cNvPr id="3" name="">
             <a:extLst xmlns:a="http://schemas.openxmlformats.org/drawingml/2006/main">
               <a:ext uri="{FF2B5EF4-FFF2-40B4-BE49-F238E27FC236}">
-                <a16:creationId xmlns:a16="http://schemas.microsoft.com/office/drawing/2014/main" id="{7A0F38EA-4B41-4FC7-9DDC-ECF2FA9CEDB5}"/>
+                <a16:creationId xmlns:a16="http://schemas.microsoft.com/office/drawing/2014/main" id="{F443BD4F-3504-44F3-B48C-8754AECFC861}"/>
               </a:ext>
             </a:extLst>
           </p:cNvPr>
@@ -2873,7 +2873,7 @@
           <p:cNvPr id="4" name="">
             <a:extLst xmlns:a="http://schemas.openxmlformats.org/drawingml/2006/main">
               <a:ext uri="{FF2B5EF4-FFF2-40B4-BE49-F238E27FC236}">
-                <a16:creationId xmlns:a16="http://schemas.microsoft.com/office/drawing/2014/main" id="{65FE6ED8-7393-4D70-8D1C-47ECC86AABB0}"/>
+                <a16:creationId xmlns:a16="http://schemas.microsoft.com/office/drawing/2014/main" id="{F43AD88E-1DDB-44CB-9C34-15276FF4653F}"/>
               </a:ext>
             </a:extLst>
           </p:cNvPr>
@@ -2930,7 +2930,7 @@
           <p:cNvPr id="5" name="">
             <a:extLst xmlns:a="http://schemas.openxmlformats.org/drawingml/2006/main">
               <a:ext uri="{FF2B5EF4-FFF2-40B4-BE49-F238E27FC236}">
-                <a16:creationId xmlns:a16="http://schemas.microsoft.com/office/drawing/2014/main" id="{702EB5B7-EA93-481B-8443-B08534691751}"/>
+                <a16:creationId xmlns:a16="http://schemas.microsoft.com/office/drawing/2014/main" id="{021FDD5B-89E5-4A27-A87F-D2EC820FB2E6}"/>
               </a:ext>
             </a:extLst>
           </p:cNvPr>
@@ -2987,7 +2987,7 @@
           <p:cNvPr id="6" name="">
             <a:extLst xmlns:a="http://schemas.openxmlformats.org/drawingml/2006/main">
               <a:ext uri="{FF2B5EF4-FFF2-40B4-BE49-F238E27FC236}">
-                <a16:creationId xmlns:a16="http://schemas.microsoft.com/office/drawing/2014/main" id="{A6D7192B-0E3A-447F-AA74-D663BE77D6D7}"/>
+                <a16:creationId xmlns:a16="http://schemas.microsoft.com/office/drawing/2014/main" id="{618DF272-6C49-46B4-B6CC-5FEF04A96681}"/>
               </a:ext>
             </a:extLst>
           </p:cNvPr>
@@ -3044,7 +3044,7 @@
           <p:cNvPr id="7" name="">
             <a:extLst xmlns:a="http://schemas.openxmlformats.org/drawingml/2006/main">
               <a:ext uri="{FF2B5EF4-FFF2-40B4-BE49-F238E27FC236}">
-                <a16:creationId xmlns:a16="http://schemas.microsoft.com/office/drawing/2014/main" id="{7565B216-83EE-4937-840B-77F17C314425}"/>
+                <a16:creationId xmlns:a16="http://schemas.microsoft.com/office/drawing/2014/main" id="{4EA8E010-0A1F-49BA-9516-8D8DE393763B}"/>
               </a:ext>
             </a:extLst>
           </p:cNvPr>
@@ -3101,7 +3101,7 @@
           <p:cNvPr id="8" name="">
             <a:extLst xmlns:a="http://schemas.openxmlformats.org/drawingml/2006/main">
               <a:ext uri="{FF2B5EF4-FFF2-40B4-BE49-F238E27FC236}">
-                <a16:creationId xmlns:a16="http://schemas.microsoft.com/office/drawing/2014/main" id="{E63FB30F-AD89-4243-B6AA-36879DD1609E}"/>
+                <a16:creationId xmlns:a16="http://schemas.microsoft.com/office/drawing/2014/main" id="{A6A64797-096A-4D6F-928A-8CDD415AB8B9}"/>
               </a:ext>
             </a:extLst>
           </p:cNvPr>
@@ -3156,7 +3156,7 @@
     </p:spTree>
     <p:extLst>
       <p:ext uri="{BB962C8B-B14F-4D97-AF65-F5344CB8AC3E}">
-        <p14:creationId xmlns:p14="http://schemas.microsoft.com/office/powerpoint/2010/main" val="174859470"/>
+        <p14:creationId xmlns:p14="http://schemas.microsoft.com/office/powerpoint/2010/main" val="686677914"/>
       </p:ext>
     </p:extLst>
   </p:cSld>
@@ -3187,7 +3187,7 @@
           <p:cNvPr id="7" name="slide-title">
             <a:extLst xmlns:a="http://schemas.openxmlformats.org/drawingml/2006/main">
               <a:ext uri="{FF2B5EF4-FFF2-40B4-BE49-F238E27FC236}">
-                <a16:creationId xmlns:a16="http://schemas.microsoft.com/office/drawing/2014/main" id="{4B7C95B9-15FB-4A31-B477-9634D1EB2DBB}"/>
+                <a16:creationId xmlns:a16="http://schemas.microsoft.com/office/drawing/2014/main" id="{85CA00F6-67D7-4148-BF5D-D79C3A0336BE}"/>
               </a:ext>
             </a:extLst>
           </p:cNvPr>
@@ -3244,7 +3244,7 @@
           <p:cNvPr id="2" name="slide-subtitle">
             <a:extLst xmlns:a="http://schemas.openxmlformats.org/drawingml/2006/main">
               <a:ext uri="{FF2B5EF4-FFF2-40B4-BE49-F238E27FC236}">
-                <a16:creationId xmlns:a16="http://schemas.microsoft.com/office/drawing/2014/main" id="{A4FDBF21-2B26-4529-A5DF-ACC035874FE3}"/>
+                <a16:creationId xmlns:a16="http://schemas.microsoft.com/office/drawing/2014/main" id="{1147F5EC-C825-47C7-AF20-B77AD09688A1}"/>
               </a:ext>
             </a:extLst>
           </p:cNvPr>
@@ -3301,7 +3301,7 @@
           <p:cNvPr id="3" name="">
             <a:extLst xmlns:a="http://schemas.openxmlformats.org/drawingml/2006/main">
               <a:ext uri="{FF2B5EF4-FFF2-40B4-BE49-F238E27FC236}">
-                <a16:creationId xmlns:a16="http://schemas.microsoft.com/office/drawing/2014/main" id="{F300AA86-FB8A-4439-A712-35F3ED7CDFD6}"/>
+                <a16:creationId xmlns:a16="http://schemas.microsoft.com/office/drawing/2014/main" id="{B92953DF-E0DE-4E37-8540-A521763B3492}"/>
               </a:ext>
             </a:extLst>
           </p:cNvPr>
@@ -4342,7 +4342,7 @@
           <p:cNvPr id="5" name="">
             <a:extLst xmlns:a="http://schemas.openxmlformats.org/drawingml/2006/main">
               <a:ext uri="{FF2B5EF4-FFF2-40B4-BE49-F238E27FC236}">
-                <a16:creationId xmlns:a16="http://schemas.microsoft.com/office/drawing/2014/main" id="{D8DD7EDE-F52A-41E6-B2E1-5F35C6CB7E7F}"/>
+                <a16:creationId xmlns:a16="http://schemas.microsoft.com/office/drawing/2014/main" id="{37530EDC-59F2-4187-A0BC-BBB1220B3692}"/>
               </a:ext>
             </a:extLst>
           </p:cNvPr>
@@ -4399,7 +4399,7 @@
           <p:cNvPr id="6" name="">
             <a:extLst xmlns:a="http://schemas.openxmlformats.org/drawingml/2006/main">
               <a:ext uri="{FF2B5EF4-FFF2-40B4-BE49-F238E27FC236}">
-                <a16:creationId xmlns:a16="http://schemas.microsoft.com/office/drawing/2014/main" id="{47F97706-3849-4E85-95B4-44907F167D9C}"/>
+                <a16:creationId xmlns:a16="http://schemas.microsoft.com/office/drawing/2014/main" id="{A3465B95-7F6D-4296-90FF-A7EB875F13A2}"/>
               </a:ext>
             </a:extLst>
           </p:cNvPr>
@@ -4454,7 +4454,7 @@
     </p:spTree>
     <p:extLst>
       <p:ext uri="{BB962C8B-B14F-4D97-AF65-F5344CB8AC3E}">
-        <p14:creationId xmlns:p14="http://schemas.microsoft.com/office/powerpoint/2010/main" val="1755956548"/>
+        <p14:creationId xmlns:p14="http://schemas.microsoft.com/office/powerpoint/2010/main" val="1180080214"/>
       </p:ext>
     </p:extLst>
   </p:cSld>
@@ -4485,7 +4485,7 @@
           <p:cNvPr id="13" name="slide-title">
             <a:extLst xmlns:a="http://schemas.openxmlformats.org/drawingml/2006/main">
               <a:ext uri="{FF2B5EF4-FFF2-40B4-BE49-F238E27FC236}">
-                <a16:creationId xmlns:a16="http://schemas.microsoft.com/office/drawing/2014/main" id="{2607AA0D-9E2E-4261-9530-FC0825E25E0F}"/>
+                <a16:creationId xmlns:a16="http://schemas.microsoft.com/office/drawing/2014/main" id="{3FBC9B6A-618F-4805-81C5-ABA1448E5B9B}"/>
               </a:ext>
             </a:extLst>
           </p:cNvPr>
@@ -4542,7 +4542,7 @@
           <p:cNvPr id="2" name="slide-subtitle">
             <a:extLst xmlns:a="http://schemas.openxmlformats.org/drawingml/2006/main">
               <a:ext uri="{FF2B5EF4-FFF2-40B4-BE49-F238E27FC236}">
-                <a16:creationId xmlns:a16="http://schemas.microsoft.com/office/drawing/2014/main" id="{85BA3555-5F82-4BC2-B96E-6E7EE4D855E1}"/>
+                <a16:creationId xmlns:a16="http://schemas.microsoft.com/office/drawing/2014/main" id="{06466415-85A2-4926-93E7-EBD631ABE9E0}"/>
               </a:ext>
             </a:extLst>
           </p:cNvPr>
@@ -4599,7 +4599,7 @@
           <p:cNvPr id="3" name="">
             <a:extLst xmlns:a="http://schemas.openxmlformats.org/drawingml/2006/main">
               <a:ext uri="{FF2B5EF4-FFF2-40B4-BE49-F238E27FC236}">
-                <a16:creationId xmlns:a16="http://schemas.microsoft.com/office/drawing/2014/main" id="{9828ED08-D599-4894-9AC0-2768D8713FE3}"/>
+                <a16:creationId xmlns:a16="http://schemas.microsoft.com/office/drawing/2014/main" id="{1BEB54DB-B730-46A2-9180-ABAF3CBD2684}"/>
               </a:ext>
             </a:extLst>
           </p:cNvPr>
@@ -4630,7 +4630,7 @@
           <p:cNvPr id="4" name="">
             <a:extLst xmlns:a="http://schemas.openxmlformats.org/drawingml/2006/main">
               <a:ext uri="{FF2B5EF4-FFF2-40B4-BE49-F238E27FC236}">
-                <a16:creationId xmlns:a16="http://schemas.microsoft.com/office/drawing/2014/main" id="{E3262D1B-8147-43B6-89BD-C89509D0B4A1}"/>
+                <a16:creationId xmlns:a16="http://schemas.microsoft.com/office/drawing/2014/main" id="{722F6B2B-C852-447C-BFE2-E70E6E7BF45A}"/>
               </a:ext>
             </a:extLst>
           </p:cNvPr>
@@ -4687,7 +4687,7 @@
           <p:cNvPr id="5" name="">
             <a:extLst xmlns:a="http://schemas.openxmlformats.org/drawingml/2006/main">
               <a:ext uri="{FF2B5EF4-FFF2-40B4-BE49-F238E27FC236}">
-                <a16:creationId xmlns:a16="http://schemas.microsoft.com/office/drawing/2014/main" id="{6491B9BB-944C-4BDE-BE4F-6B6D80DCA808}"/>
+                <a16:creationId xmlns:a16="http://schemas.microsoft.com/office/drawing/2014/main" id="{D2869D67-DE77-408B-A803-826966BDC510}"/>
               </a:ext>
             </a:extLst>
           </p:cNvPr>
@@ -4744,7 +4744,7 @@
           <p:cNvPr id="6" name="">
             <a:extLst xmlns:a="http://schemas.openxmlformats.org/drawingml/2006/main">
               <a:ext uri="{FF2B5EF4-FFF2-40B4-BE49-F238E27FC236}">
-                <a16:creationId xmlns:a16="http://schemas.microsoft.com/office/drawing/2014/main" id="{30766F2A-3E88-4AA5-A04A-FFD03B3B5432}"/>
+                <a16:creationId xmlns:a16="http://schemas.microsoft.com/office/drawing/2014/main" id="{D4F02E64-6EDD-429C-A1AA-8FBB61BD8647}"/>
               </a:ext>
             </a:extLst>
           </p:cNvPr>
@@ -4801,7 +4801,7 @@
           <p:cNvPr id="7" name="">
             <a:extLst xmlns:a="http://schemas.openxmlformats.org/drawingml/2006/main">
               <a:ext uri="{FF2B5EF4-FFF2-40B4-BE49-F238E27FC236}">
-                <a16:creationId xmlns:a16="http://schemas.microsoft.com/office/drawing/2014/main" id="{1F72F27C-4F6B-4C5A-9116-416F6EAF9A4C}"/>
+                <a16:creationId xmlns:a16="http://schemas.microsoft.com/office/drawing/2014/main" id="{D46D5A5B-506E-4F74-9661-7C30324D2791}"/>
               </a:ext>
             </a:extLst>
           </p:cNvPr>
@@ -4858,7 +4858,7 @@
           <p:cNvPr id="8" name="">
             <a:extLst xmlns:a="http://schemas.openxmlformats.org/drawingml/2006/main">
               <a:ext uri="{FF2B5EF4-FFF2-40B4-BE49-F238E27FC236}">
-                <a16:creationId xmlns:a16="http://schemas.microsoft.com/office/drawing/2014/main" id="{D2D11D44-17E2-41F8-B0A4-C6F57EF85DC9}"/>
+                <a16:creationId xmlns:a16="http://schemas.microsoft.com/office/drawing/2014/main" id="{D580027A-79BD-497E-AD1B-1C63937E3EA3}"/>
               </a:ext>
             </a:extLst>
           </p:cNvPr>
@@ -4915,7 +4915,7 @@
           <p:cNvPr id="9" name="">
             <a:extLst xmlns:a="http://schemas.openxmlformats.org/drawingml/2006/main">
               <a:ext uri="{FF2B5EF4-FFF2-40B4-BE49-F238E27FC236}">
-                <a16:creationId xmlns:a16="http://schemas.microsoft.com/office/drawing/2014/main" id="{96DA6278-CFBA-41B7-B7A1-6431C1174514}"/>
+                <a16:creationId xmlns:a16="http://schemas.microsoft.com/office/drawing/2014/main" id="{72BA4522-DD9B-4588-B8E2-38356957C133}"/>
               </a:ext>
             </a:extLst>
           </p:cNvPr>
@@ -4972,7 +4972,7 @@
           <p:cNvPr id="10" name="">
             <a:extLst xmlns:a="http://schemas.openxmlformats.org/drawingml/2006/main">
               <a:ext uri="{FF2B5EF4-FFF2-40B4-BE49-F238E27FC236}">
-                <a16:creationId xmlns:a16="http://schemas.microsoft.com/office/drawing/2014/main" id="{5C45DAAF-6647-44F1-8487-24A5DBBC59B6}"/>
+                <a16:creationId xmlns:a16="http://schemas.microsoft.com/office/drawing/2014/main" id="{884F51FA-6E9E-4D99-928F-2A62EA224D27}"/>
               </a:ext>
             </a:extLst>
           </p:cNvPr>
@@ -5003,7 +5003,7 @@
           <p:cNvPr id="11" name="">
             <a:extLst xmlns:a="http://schemas.openxmlformats.org/drawingml/2006/main">
               <a:ext uri="{FF2B5EF4-FFF2-40B4-BE49-F238E27FC236}">
-                <a16:creationId xmlns:a16="http://schemas.microsoft.com/office/drawing/2014/main" id="{314274BA-EACF-4D10-AAD2-2A46F9E24190}"/>
+                <a16:creationId xmlns:a16="http://schemas.microsoft.com/office/drawing/2014/main" id="{21F3F211-0C73-432C-B44C-64D6CF88D48B}"/>
               </a:ext>
             </a:extLst>
           </p:cNvPr>
@@ -5060,7 +5060,7 @@
           <p:cNvPr id="12" name="">
             <a:extLst xmlns:a="http://schemas.openxmlformats.org/drawingml/2006/main">
               <a:ext uri="{FF2B5EF4-FFF2-40B4-BE49-F238E27FC236}">
-                <a16:creationId xmlns:a16="http://schemas.microsoft.com/office/drawing/2014/main" id="{DB85B8C8-A80F-4148-91CF-15B59C1C9A11}"/>
+                <a16:creationId xmlns:a16="http://schemas.microsoft.com/office/drawing/2014/main" id="{5DCAE1D1-4260-4374-B094-BE0027276EE4}"/>
               </a:ext>
             </a:extLst>
           </p:cNvPr>
@@ -5115,7 +5115,7 @@
     </p:spTree>
     <p:extLst>
       <p:ext uri="{BB962C8B-B14F-4D97-AF65-F5344CB8AC3E}">
-        <p14:creationId xmlns:p14="http://schemas.microsoft.com/office/powerpoint/2010/main" val="2095798075"/>
+        <p14:creationId xmlns:p14="http://schemas.microsoft.com/office/powerpoint/2010/main" val="207153861"/>
       </p:ext>
     </p:extLst>
   </p:cSld>
@@ -5146,7 +5146,7 @@
           <p:cNvPr id="8" name="slide-title">
             <a:extLst xmlns:a="http://schemas.openxmlformats.org/drawingml/2006/main">
               <a:ext uri="{FF2B5EF4-FFF2-40B4-BE49-F238E27FC236}">
-                <a16:creationId xmlns:a16="http://schemas.microsoft.com/office/drawing/2014/main" id="{7904BB10-7F8C-4BF1-A4D6-3ACD80AF3E39}"/>
+                <a16:creationId xmlns:a16="http://schemas.microsoft.com/office/drawing/2014/main" id="{FB9B15CD-8EAC-4A30-A94D-35A90726B477}"/>
               </a:ext>
             </a:extLst>
           </p:cNvPr>
@@ -5203,7 +5203,7 @@
           <p:cNvPr id="2" name="slide-subtitle">
             <a:extLst xmlns:a="http://schemas.openxmlformats.org/drawingml/2006/main">
               <a:ext uri="{FF2B5EF4-FFF2-40B4-BE49-F238E27FC236}">
-                <a16:creationId xmlns:a16="http://schemas.microsoft.com/office/drawing/2014/main" id="{75F57E81-46AE-4F96-B4DB-AA32AA51DE26}"/>
+                <a16:creationId xmlns:a16="http://schemas.microsoft.com/office/drawing/2014/main" id="{7417EE3D-948E-46BF-9CDF-3035D4906C50}"/>
               </a:ext>
             </a:extLst>
           </p:cNvPr>
@@ -5260,7 +5260,7 @@
           <p:cNvPr id="3" name="">
             <a:extLst xmlns:a="http://schemas.openxmlformats.org/drawingml/2006/main">
               <a:ext uri="{FF2B5EF4-FFF2-40B4-BE49-F238E27FC236}">
-                <a16:creationId xmlns:a16="http://schemas.microsoft.com/office/drawing/2014/main" id="{615764BE-942B-461C-91DB-1C04D5CFCC97}"/>
+                <a16:creationId xmlns:a16="http://schemas.microsoft.com/office/drawing/2014/main" id="{BEA58F87-A1A5-4830-A032-F8798C9F565D}"/>
               </a:ext>
             </a:extLst>
           </p:cNvPr>
@@ -5298,7 +5298,7 @@
         </p:xfrm>
         <a:graphic xmlns:a="http://schemas.openxmlformats.org/drawingml/2006/main">
           <a:graphicData uri="http://schemas.openxmlformats.org/drawingml/2006/chart">
-            <c:chart xmlns:r="http://schemas.openxmlformats.org/officeDocument/2006/relationships" xmlns:c="http://schemas.openxmlformats.org/drawingml/2006/chart" r:id="Rb531920521f94bde"/>
+            <c:chart xmlns:r="http://schemas.openxmlformats.org/officeDocument/2006/relationships" xmlns:c="http://schemas.openxmlformats.org/drawingml/2006/chart" r:id="R10966a37921c4798"/>
           </a:graphicData>
         </a:graphic>
       </p:graphicFrame>
@@ -5307,7 +5307,7 @@
           <p:cNvPr id="5" name="">
             <a:extLst xmlns:a="http://schemas.openxmlformats.org/drawingml/2006/main">
               <a:ext uri="{FF2B5EF4-FFF2-40B4-BE49-F238E27FC236}">
-                <a16:creationId xmlns:a16="http://schemas.microsoft.com/office/drawing/2014/main" id="{AD02CD9C-3363-47FD-B17A-0F4970721465}"/>
+                <a16:creationId xmlns:a16="http://schemas.microsoft.com/office/drawing/2014/main" id="{FBF51B59-9AAF-442E-9B24-5B6F160FFFE6}"/>
               </a:ext>
             </a:extLst>
           </p:cNvPr>
@@ -5364,7 +5364,7 @@
           <p:cNvPr id="6" name="">
             <a:extLst xmlns:a="http://schemas.openxmlformats.org/drawingml/2006/main">
               <a:ext uri="{FF2B5EF4-FFF2-40B4-BE49-F238E27FC236}">
-                <a16:creationId xmlns:a16="http://schemas.microsoft.com/office/drawing/2014/main" id="{ADB7B3AF-8468-40CB-B6F7-13AF532ECDE9}"/>
+                <a16:creationId xmlns:a16="http://schemas.microsoft.com/office/drawing/2014/main" id="{E92A1362-59F3-4F99-B6F8-4D1D0902DC17}"/>
               </a:ext>
             </a:extLst>
           </p:cNvPr>
@@ -5421,7 +5421,7 @@
           <p:cNvPr id="7" name="">
             <a:extLst xmlns:a="http://schemas.openxmlformats.org/drawingml/2006/main">
               <a:ext uri="{FF2B5EF4-FFF2-40B4-BE49-F238E27FC236}">
-                <a16:creationId xmlns:a16="http://schemas.microsoft.com/office/drawing/2014/main" id="{506367B2-FC78-4D09-A8C7-75CEEBD61E1B}"/>
+                <a16:creationId xmlns:a16="http://schemas.microsoft.com/office/drawing/2014/main" id="{8E6A0FB0-9572-40FF-A833-AFF2238E4417}"/>
               </a:ext>
             </a:extLst>
           </p:cNvPr>
@@ -5476,7 +5476,7 @@
     </p:spTree>
     <p:extLst>
       <p:ext uri="{BB962C8B-B14F-4D97-AF65-F5344CB8AC3E}">
-        <p14:creationId xmlns:p14="http://schemas.microsoft.com/office/powerpoint/2010/main" val="78929185"/>
+        <p14:creationId xmlns:p14="http://schemas.microsoft.com/office/powerpoint/2010/main" val="878978556"/>
       </p:ext>
     </p:extLst>
   </p:cSld>
@@ -5507,7 +5507,7 @@
           <p:cNvPr id="7" name="slide-title">
             <a:extLst xmlns:a="http://schemas.openxmlformats.org/drawingml/2006/main">
               <a:ext uri="{FF2B5EF4-FFF2-40B4-BE49-F238E27FC236}">
-                <a16:creationId xmlns:a16="http://schemas.microsoft.com/office/drawing/2014/main" id="{D3C3173E-9EB5-4005-BA66-C29AB1646E40}"/>
+                <a16:creationId xmlns:a16="http://schemas.microsoft.com/office/drawing/2014/main" id="{5C3957C9-CE36-471E-81C9-FFCDF23D9188}"/>
               </a:ext>
             </a:extLst>
           </p:cNvPr>
@@ -5564,7 +5564,7 @@
           <p:cNvPr id="2" name="slide-subtitle">
             <a:extLst xmlns:a="http://schemas.openxmlformats.org/drawingml/2006/main">
               <a:ext uri="{FF2B5EF4-FFF2-40B4-BE49-F238E27FC236}">
-                <a16:creationId xmlns:a16="http://schemas.microsoft.com/office/drawing/2014/main" id="{2FED5523-95F7-4DFD-959F-4C645EF4EC17}"/>
+                <a16:creationId xmlns:a16="http://schemas.microsoft.com/office/drawing/2014/main" id="{103518FE-ECF8-4916-B89E-78AB666A7008}"/>
               </a:ext>
             </a:extLst>
           </p:cNvPr>
@@ -5621,7 +5621,7 @@
           <p:cNvPr id="3" name="">
             <a:extLst xmlns:a="http://schemas.openxmlformats.org/drawingml/2006/main">
               <a:ext uri="{FF2B5EF4-FFF2-40B4-BE49-F238E27FC236}">
-                <a16:creationId xmlns:a16="http://schemas.microsoft.com/office/drawing/2014/main" id="{43630F9E-9906-41A1-BC2A-6F4F57E24534}"/>
+                <a16:creationId xmlns:a16="http://schemas.microsoft.com/office/drawing/2014/main" id="{C1C5C997-4902-447A-9318-64476C944A3B}"/>
               </a:ext>
             </a:extLst>
           </p:cNvPr>
@@ -5659,7 +5659,7 @@
         </p:xfrm>
         <a:graphic xmlns:a="http://schemas.openxmlformats.org/drawingml/2006/main">
           <a:graphicData uri="http://schemas.openxmlformats.org/drawingml/2006/chart">
-            <c:chart xmlns:r="http://schemas.openxmlformats.org/officeDocument/2006/relationships" xmlns:c="http://schemas.openxmlformats.org/drawingml/2006/chart" r:id="Rf80668fadf964e24"/>
+            <c:chart xmlns:r="http://schemas.openxmlformats.org/officeDocument/2006/relationships" xmlns:c="http://schemas.openxmlformats.org/drawingml/2006/chart" r:id="Rcfa12d0d4f244264"/>
           </a:graphicData>
         </a:graphic>
       </p:graphicFrame>
@@ -5668,7 +5668,7 @@
           <p:cNvPr id="5" name="">
             <a:extLst xmlns:a="http://schemas.openxmlformats.org/drawingml/2006/main">
               <a:ext uri="{FF2B5EF4-FFF2-40B4-BE49-F238E27FC236}">
-                <a16:creationId xmlns:a16="http://schemas.microsoft.com/office/drawing/2014/main" id="{C3A6855A-702B-4A6F-A7AC-BDC8B83451D7}"/>
+                <a16:creationId xmlns:a16="http://schemas.microsoft.com/office/drawing/2014/main" id="{F02B055D-8924-48DD-91D3-F9E868FC392B}"/>
               </a:ext>
             </a:extLst>
           </p:cNvPr>
@@ -5725,7 +5725,7 @@
           <p:cNvPr id="6" name="">
             <a:extLst xmlns:a="http://schemas.openxmlformats.org/drawingml/2006/main">
               <a:ext uri="{FF2B5EF4-FFF2-40B4-BE49-F238E27FC236}">
-                <a16:creationId xmlns:a16="http://schemas.microsoft.com/office/drawing/2014/main" id="{C9F9C676-98FD-4569-AD93-C0BDE1A91FFB}"/>
+                <a16:creationId xmlns:a16="http://schemas.microsoft.com/office/drawing/2014/main" id="{569B6255-B2B2-44DC-9EC1-F89BC60A36AB}"/>
               </a:ext>
             </a:extLst>
           </p:cNvPr>
@@ -5780,7 +5780,7 @@
     </p:spTree>
     <p:extLst>
       <p:ext uri="{BB962C8B-B14F-4D97-AF65-F5344CB8AC3E}">
-        <p14:creationId xmlns:p14="http://schemas.microsoft.com/office/powerpoint/2010/main" val="130397183"/>
+        <p14:creationId xmlns:p14="http://schemas.microsoft.com/office/powerpoint/2010/main" val="700151074"/>
       </p:ext>
     </p:extLst>
   </p:cSld>
@@ -5811,7 +5811,7 @@
           <p:cNvPr id="11" name="slide-title">
             <a:extLst xmlns:a="http://schemas.openxmlformats.org/drawingml/2006/main">
               <a:ext uri="{FF2B5EF4-FFF2-40B4-BE49-F238E27FC236}">
-                <a16:creationId xmlns:a16="http://schemas.microsoft.com/office/drawing/2014/main" id="{B5E11E43-188D-4FE3-B825-47E94818E655}"/>
+                <a16:creationId xmlns:a16="http://schemas.microsoft.com/office/drawing/2014/main" id="{47B43494-66A8-48E1-B68E-B79B3E5FD629}"/>
               </a:ext>
             </a:extLst>
           </p:cNvPr>
@@ -5868,7 +5868,7 @@
           <p:cNvPr id="2" name="slide-subtitle">
             <a:extLst xmlns:a="http://schemas.openxmlformats.org/drawingml/2006/main">
               <a:ext uri="{FF2B5EF4-FFF2-40B4-BE49-F238E27FC236}">
-                <a16:creationId xmlns:a16="http://schemas.microsoft.com/office/drawing/2014/main" id="{E95607A9-D866-4015-8400-84B7AA5C083B}"/>
+                <a16:creationId xmlns:a16="http://schemas.microsoft.com/office/drawing/2014/main" id="{0226D9A2-CBDC-43BF-BAA2-592D3E775886}"/>
               </a:ext>
             </a:extLst>
           </p:cNvPr>
@@ -5925,7 +5925,7 @@
           <p:cNvPr id="3" name="">
             <a:extLst xmlns:a="http://schemas.openxmlformats.org/drawingml/2006/main">
               <a:ext uri="{FF2B5EF4-FFF2-40B4-BE49-F238E27FC236}">
-                <a16:creationId xmlns:a16="http://schemas.microsoft.com/office/drawing/2014/main" id="{116D1F50-E693-4AE9-A27B-C12E10218B74}"/>
+                <a16:creationId xmlns:a16="http://schemas.microsoft.com/office/drawing/2014/main" id="{2C5577E8-619A-4F83-87E1-14F1CBA7166F}"/>
               </a:ext>
             </a:extLst>
           </p:cNvPr>
@@ -5956,7 +5956,7 @@
           <p:cNvPr id="4" name="">
             <a:extLst xmlns:a="http://schemas.openxmlformats.org/drawingml/2006/main">
               <a:ext uri="{FF2B5EF4-FFF2-40B4-BE49-F238E27FC236}">
-                <a16:creationId xmlns:a16="http://schemas.microsoft.com/office/drawing/2014/main" id="{ADE85BB6-1191-4C3B-89B1-85AE145BBCE2}"/>
+                <a16:creationId xmlns:a16="http://schemas.microsoft.com/office/drawing/2014/main" id="{F2D09061-E82E-4E6C-AC1D-9390CCA14FF8}"/>
               </a:ext>
             </a:extLst>
           </p:cNvPr>
@@ -6013,7 +6013,7 @@
           <p:cNvPr id="5" name="">
             <a:extLst xmlns:a="http://schemas.openxmlformats.org/drawingml/2006/main">
               <a:ext uri="{FF2B5EF4-FFF2-40B4-BE49-F238E27FC236}">
-                <a16:creationId xmlns:a16="http://schemas.microsoft.com/office/drawing/2014/main" id="{D2A7A7D8-D7C1-4144-BC86-DE5546CD4887}"/>
+                <a16:creationId xmlns:a16="http://schemas.microsoft.com/office/drawing/2014/main" id="{9B9F0766-64DE-4CDD-AE3B-0DEE053EAB5F}"/>
               </a:ext>
             </a:extLst>
           </p:cNvPr>
@@ -6070,7 +6070,7 @@
           <p:cNvPr id="6" name="">
             <a:extLst xmlns:a="http://schemas.openxmlformats.org/drawingml/2006/main">
               <a:ext uri="{FF2B5EF4-FFF2-40B4-BE49-F238E27FC236}">
-                <a16:creationId xmlns:a16="http://schemas.microsoft.com/office/drawing/2014/main" id="{3632F23B-0B22-4ECD-9208-F07DA9202F38}"/>
+                <a16:creationId xmlns:a16="http://schemas.microsoft.com/office/drawing/2014/main" id="{A49FA83E-A977-48F5-8245-885335276E43}"/>
               </a:ext>
             </a:extLst>
           </p:cNvPr>
@@ -6134,7 +6134,7 @@
         </p:xfrm>
         <a:graphic xmlns:a="http://schemas.openxmlformats.org/drawingml/2006/main">
           <a:graphicData uri="http://schemas.openxmlformats.org/drawingml/2006/chart">
-            <c:chart xmlns:r="http://schemas.openxmlformats.org/officeDocument/2006/relationships" xmlns:c="http://schemas.openxmlformats.org/drawingml/2006/chart" r:id="Rbac13fd76fa54d71"/>
+            <c:chart xmlns:r="http://schemas.openxmlformats.org/officeDocument/2006/relationships" xmlns:c="http://schemas.openxmlformats.org/drawingml/2006/chart" r:id="Rfdda370f4b384927"/>
           </a:graphicData>
         </a:graphic>
       </p:graphicFrame>
@@ -6143,7 +6143,7 @@
           <p:cNvPr id="8" name="">
             <a:extLst xmlns:a="http://schemas.openxmlformats.org/drawingml/2006/main">
               <a:ext uri="{FF2B5EF4-FFF2-40B4-BE49-F238E27FC236}">
-                <a16:creationId xmlns:a16="http://schemas.microsoft.com/office/drawing/2014/main" id="{B6674F48-3D20-4027-985B-E3FE99FE0D6E}"/>
+                <a16:creationId xmlns:a16="http://schemas.microsoft.com/office/drawing/2014/main" id="{81D61A0A-49E5-41C5-BD18-DC05FACC29AF}"/>
               </a:ext>
             </a:extLst>
           </p:cNvPr>
@@ -6200,7 +6200,7 @@
           <p:cNvPr id="9" name="">
             <a:extLst xmlns:a="http://schemas.openxmlformats.org/drawingml/2006/main">
               <a:ext uri="{FF2B5EF4-FFF2-40B4-BE49-F238E27FC236}">
-                <a16:creationId xmlns:a16="http://schemas.microsoft.com/office/drawing/2014/main" id="{47258007-1DB2-4EDB-BFA7-064F12D9F4DF}"/>
+                <a16:creationId xmlns:a16="http://schemas.microsoft.com/office/drawing/2014/main" id="{64E36356-CE73-4FEC-8F18-F6EC44BECD04}"/>
               </a:ext>
             </a:extLst>
           </p:cNvPr>
@@ -6257,7 +6257,7 @@
           <p:cNvPr id="10" name="">
             <a:extLst xmlns:a="http://schemas.openxmlformats.org/drawingml/2006/main">
               <a:ext uri="{FF2B5EF4-FFF2-40B4-BE49-F238E27FC236}">
-                <a16:creationId xmlns:a16="http://schemas.microsoft.com/office/drawing/2014/main" id="{1214439B-9CCE-4E26-96CC-641D0D6D1C8E}"/>
+                <a16:creationId xmlns:a16="http://schemas.microsoft.com/office/drawing/2014/main" id="{1D22B9D0-BA6D-410A-9580-0CE97E471B7F}"/>
               </a:ext>
             </a:extLst>
           </p:cNvPr>
@@ -6312,7 +6312,7 @@
     </p:spTree>
     <p:extLst>
       <p:ext uri="{BB962C8B-B14F-4D97-AF65-F5344CB8AC3E}">
-        <p14:creationId xmlns:p14="http://schemas.microsoft.com/office/powerpoint/2010/main" val="569376836"/>
+        <p14:creationId xmlns:p14="http://schemas.microsoft.com/office/powerpoint/2010/main" val="540011131"/>
       </p:ext>
     </p:extLst>
   </p:cSld>
@@ -6343,7 +6343,7 @@
           <p:cNvPr id="6" name="slide-title">
             <a:extLst xmlns:a="http://schemas.openxmlformats.org/drawingml/2006/main">
               <a:ext uri="{FF2B5EF4-FFF2-40B4-BE49-F238E27FC236}">
-                <a16:creationId xmlns:a16="http://schemas.microsoft.com/office/drawing/2014/main" id="{DB10F2EB-6CF6-4B1B-9655-7D3641FE0571}"/>
+                <a16:creationId xmlns:a16="http://schemas.microsoft.com/office/drawing/2014/main" id="{5C0C0871-53BB-4429-A832-1A21110ECA2E}"/>
               </a:ext>
             </a:extLst>
           </p:cNvPr>
@@ -6400,7 +6400,7 @@
           <p:cNvPr id="2" name="slide-subtitle">
             <a:extLst xmlns:a="http://schemas.openxmlformats.org/drawingml/2006/main">
               <a:ext uri="{FF2B5EF4-FFF2-40B4-BE49-F238E27FC236}">
-                <a16:creationId xmlns:a16="http://schemas.microsoft.com/office/drawing/2014/main" id="{3F8257F8-879D-4FEA-9C10-3B648961EB85}"/>
+                <a16:creationId xmlns:a16="http://schemas.microsoft.com/office/drawing/2014/main" id="{F2E44D98-BC6D-4A05-A5E1-3165BA8DAAEC}"/>
               </a:ext>
             </a:extLst>
           </p:cNvPr>
@@ -6457,7 +6457,7 @@
           <p:cNvPr id="3" name="">
             <a:extLst xmlns:a="http://schemas.openxmlformats.org/drawingml/2006/main">
               <a:ext uri="{FF2B5EF4-FFF2-40B4-BE49-F238E27FC236}">
-                <a16:creationId xmlns:a16="http://schemas.microsoft.com/office/drawing/2014/main" id="{1CF00064-7CE6-4798-AE1E-9EA189443E2F}"/>
+                <a16:creationId xmlns:a16="http://schemas.microsoft.com/office/drawing/2014/main" id="{8DC1D459-23DB-4C57-A5B5-4A4900C8B346}"/>
               </a:ext>
             </a:extLst>
           </p:cNvPr>
@@ -6955,7 +6955,7 @@
           <p:cNvPr id="5" name="">
             <a:extLst xmlns:a="http://schemas.openxmlformats.org/drawingml/2006/main">
               <a:ext uri="{FF2B5EF4-FFF2-40B4-BE49-F238E27FC236}">
-                <a16:creationId xmlns:a16="http://schemas.microsoft.com/office/drawing/2014/main" id="{A53E4184-9E5A-4794-B031-6328E2A4F4E0}"/>
+                <a16:creationId xmlns:a16="http://schemas.microsoft.com/office/drawing/2014/main" id="{22F707F2-12F1-408D-A55C-02B1B47C598E}"/>
               </a:ext>
             </a:extLst>
           </p:cNvPr>
@@ -7010,7 +7010,7 @@
     </p:spTree>
     <p:extLst>
       <p:ext uri="{BB962C8B-B14F-4D97-AF65-F5344CB8AC3E}">
-        <p14:creationId xmlns:p14="http://schemas.microsoft.com/office/powerpoint/2010/main" val="303030376"/>
+        <p14:creationId xmlns:p14="http://schemas.microsoft.com/office/powerpoint/2010/main" val="305623607"/>
       </p:ext>
     </p:extLst>
   </p:cSld>
@@ -7041,7 +7041,7 @@
           <p:cNvPr id="6" name="slide-title">
             <a:extLst xmlns:a="http://schemas.openxmlformats.org/drawingml/2006/main">
               <a:ext uri="{FF2B5EF4-FFF2-40B4-BE49-F238E27FC236}">
-                <a16:creationId xmlns:a16="http://schemas.microsoft.com/office/drawing/2014/main" id="{F2D1AE2A-EBDD-4270-BA54-D971CDC955C3}"/>
+                <a16:creationId xmlns:a16="http://schemas.microsoft.com/office/drawing/2014/main" id="{C0891787-D0AE-44E8-ABEC-B0E524340141}"/>
               </a:ext>
             </a:extLst>
           </p:cNvPr>
@@ -7098,7 +7098,7 @@
           <p:cNvPr id="2" name="slide-subtitle">
             <a:extLst xmlns:a="http://schemas.openxmlformats.org/drawingml/2006/main">
               <a:ext uri="{FF2B5EF4-FFF2-40B4-BE49-F238E27FC236}">
-                <a16:creationId xmlns:a16="http://schemas.microsoft.com/office/drawing/2014/main" id="{CAF61687-0441-481E-BA7D-205FBA5331D4}"/>
+                <a16:creationId xmlns:a16="http://schemas.microsoft.com/office/drawing/2014/main" id="{989ACE09-8D44-4795-AFF8-D555DF69568E}"/>
               </a:ext>
             </a:extLst>
           </p:cNvPr>
@@ -7155,7 +7155,7 @@
           <p:cNvPr id="3" name="">
             <a:extLst xmlns:a="http://schemas.openxmlformats.org/drawingml/2006/main">
               <a:ext uri="{FF2B5EF4-FFF2-40B4-BE49-F238E27FC236}">
-                <a16:creationId xmlns:a16="http://schemas.microsoft.com/office/drawing/2014/main" id="{2E812F55-67A6-4E03-958F-1987BAF4C262}"/>
+                <a16:creationId xmlns:a16="http://schemas.microsoft.com/office/drawing/2014/main" id="{9E262B76-9456-4C54-8680-C70E5FE680EB}"/>
               </a:ext>
             </a:extLst>
           </p:cNvPr>
@@ -7579,7 +7579,7 @@
           <p:cNvPr id="5" name="">
             <a:extLst xmlns:a="http://schemas.openxmlformats.org/drawingml/2006/main">
               <a:ext uri="{FF2B5EF4-FFF2-40B4-BE49-F238E27FC236}">
-                <a16:creationId xmlns:a16="http://schemas.microsoft.com/office/drawing/2014/main" id="{428D2625-3B31-44B9-8D82-161980ED88A0}"/>
+                <a16:creationId xmlns:a16="http://schemas.microsoft.com/office/drawing/2014/main" id="{2A8B910A-EBD8-4C2A-843A-6433B4E746A9}"/>
               </a:ext>
             </a:extLst>
           </p:cNvPr>
@@ -7634,7 +7634,7 @@
     </p:spTree>
     <p:extLst>
       <p:ext uri="{BB962C8B-B14F-4D97-AF65-F5344CB8AC3E}">
-        <p14:creationId xmlns:p14="http://schemas.microsoft.com/office/powerpoint/2010/main" val="1852628922"/>
+        <p14:creationId xmlns:p14="http://schemas.microsoft.com/office/powerpoint/2010/main" val="1210827763"/>
       </p:ext>
     </p:extLst>
   </p:cSld>

</xml_diff>